<commit_message>
Visualize centering in Session 0 slides
</commit_message>
<xml_diff>
--- a/public/slides/session-0-least-squares-foundations.pptx
+++ b/public/slides/session-0-least-squares-foundations.pptx
@@ -2,34 +2,34 @@
 <file path=ppt/presentation.xml><?xml version="1.0" encoding="utf-8"?>
 <p:presentation xmlns:p="http://schemas.openxmlformats.org/presentationml/2006/main">
   <p:sldMasterIdLst>
-    <p:sldMasterId xmlns:r="http://schemas.openxmlformats.org/officeDocument/2006/relationships" id="2147483648" r:id="R66d4fc33df5147dd"/>
+    <p:sldMasterId xmlns:r="http://schemas.openxmlformats.org/officeDocument/2006/relationships" id="2147483648" r:id="R28a14f6ccc694d6a"/>
   </p:sldMasterIdLst>
   <p:notesMasterIdLst>
-    <p:notesMasterId xmlns:r="http://schemas.openxmlformats.org/officeDocument/2006/relationships" r:id="R03d8f04f4dad4598"/>
+    <p:notesMasterId xmlns:r="http://schemas.openxmlformats.org/officeDocument/2006/relationships" r:id="Rd39e7b3b34d04ee3"/>
   </p:notesMasterIdLst>
   <p:sldIdLst>
-    <p:sldId xmlns:r="http://schemas.openxmlformats.org/officeDocument/2006/relationships" id="256" r:id="Rceb1a74b07c0420c"/>
-    <p:sldId xmlns:r="http://schemas.openxmlformats.org/officeDocument/2006/relationships" id="257" r:id="R58da8a011f324e55"/>
-    <p:sldId xmlns:r="http://schemas.openxmlformats.org/officeDocument/2006/relationships" id="258" r:id="R8a235b2bd7f24e67"/>
-    <p:sldId xmlns:r="http://schemas.openxmlformats.org/officeDocument/2006/relationships" id="259" r:id="Rae3d7dc270ad401f"/>
-    <p:sldId xmlns:r="http://schemas.openxmlformats.org/officeDocument/2006/relationships" id="260" r:id="Ra0dbb849ed06427e"/>
-    <p:sldId xmlns:r="http://schemas.openxmlformats.org/officeDocument/2006/relationships" id="261" r:id="R625fbc5eb5334f73"/>
-    <p:sldId xmlns:r="http://schemas.openxmlformats.org/officeDocument/2006/relationships" id="262" r:id="R1f7647313e864b82"/>
-    <p:sldId xmlns:r="http://schemas.openxmlformats.org/officeDocument/2006/relationships" id="263" r:id="R757acdbba3974928"/>
-    <p:sldId xmlns:r="http://schemas.openxmlformats.org/officeDocument/2006/relationships" id="264" r:id="R4bc557d240d943fd"/>
-    <p:sldId xmlns:r="http://schemas.openxmlformats.org/officeDocument/2006/relationships" id="265" r:id="R87f21f4e2a3141b7"/>
-    <p:sldId xmlns:r="http://schemas.openxmlformats.org/officeDocument/2006/relationships" id="266" r:id="R5030df3e3e8f4073"/>
-    <p:sldId xmlns:r="http://schemas.openxmlformats.org/officeDocument/2006/relationships" id="267" r:id="R9d6ef8528701472f"/>
-    <p:sldId xmlns:r="http://schemas.openxmlformats.org/officeDocument/2006/relationships" id="268" r:id="R0fed4f98f6e648de"/>
-    <p:sldId xmlns:r="http://schemas.openxmlformats.org/officeDocument/2006/relationships" id="269" r:id="R2bd47d2653224201"/>
-    <p:sldId xmlns:r="http://schemas.openxmlformats.org/officeDocument/2006/relationships" id="270" r:id="R8d1542d3b8db483e"/>
-    <p:sldId xmlns:r="http://schemas.openxmlformats.org/officeDocument/2006/relationships" id="271" r:id="R83431be06756493e"/>
-    <p:sldId xmlns:r="http://schemas.openxmlformats.org/officeDocument/2006/relationships" id="272" r:id="R79a4020ec5114aab"/>
-    <p:sldId xmlns:r="http://schemas.openxmlformats.org/officeDocument/2006/relationships" id="273" r:id="R0fc8d8e442234afd"/>
-    <p:sldId xmlns:r="http://schemas.openxmlformats.org/officeDocument/2006/relationships" id="274" r:id="R701b54d126044c44"/>
-    <p:sldId xmlns:r="http://schemas.openxmlformats.org/officeDocument/2006/relationships" id="275" r:id="R924b620a7c86453b"/>
-    <p:sldId xmlns:r="http://schemas.openxmlformats.org/officeDocument/2006/relationships" id="276" r:id="R9634964be0b44f8c"/>
-    <p:sldId xmlns:r="http://schemas.openxmlformats.org/officeDocument/2006/relationships" id="277" r:id="Rfbcd55e67e854832"/>
+    <p:sldId xmlns:r="http://schemas.openxmlformats.org/officeDocument/2006/relationships" id="256" r:id="Re05e16e0392143e3"/>
+    <p:sldId xmlns:r="http://schemas.openxmlformats.org/officeDocument/2006/relationships" id="257" r:id="R3dbf2cb637124415"/>
+    <p:sldId xmlns:r="http://schemas.openxmlformats.org/officeDocument/2006/relationships" id="258" r:id="R56f762442ff34c5e"/>
+    <p:sldId xmlns:r="http://schemas.openxmlformats.org/officeDocument/2006/relationships" id="259" r:id="R04ee9186caf346f4"/>
+    <p:sldId xmlns:r="http://schemas.openxmlformats.org/officeDocument/2006/relationships" id="260" r:id="R931f3dd00840413d"/>
+    <p:sldId xmlns:r="http://schemas.openxmlformats.org/officeDocument/2006/relationships" id="261" r:id="Re54c23bf69244837"/>
+    <p:sldId xmlns:r="http://schemas.openxmlformats.org/officeDocument/2006/relationships" id="262" r:id="R40641f7db1e44955"/>
+    <p:sldId xmlns:r="http://schemas.openxmlformats.org/officeDocument/2006/relationships" id="263" r:id="R0993c7a33cfc4db1"/>
+    <p:sldId xmlns:r="http://schemas.openxmlformats.org/officeDocument/2006/relationships" id="264" r:id="Rb31372ef47af4faa"/>
+    <p:sldId xmlns:r="http://schemas.openxmlformats.org/officeDocument/2006/relationships" id="265" r:id="R481d1ca9036d4685"/>
+    <p:sldId xmlns:r="http://schemas.openxmlformats.org/officeDocument/2006/relationships" id="266" r:id="R42bbf1f5c9e7463b"/>
+    <p:sldId xmlns:r="http://schemas.openxmlformats.org/officeDocument/2006/relationships" id="267" r:id="R421141db1393474e"/>
+    <p:sldId xmlns:r="http://schemas.openxmlformats.org/officeDocument/2006/relationships" id="268" r:id="Rfb91bc74841845ee"/>
+    <p:sldId xmlns:r="http://schemas.openxmlformats.org/officeDocument/2006/relationships" id="269" r:id="Red1a1c187ded4344"/>
+    <p:sldId xmlns:r="http://schemas.openxmlformats.org/officeDocument/2006/relationships" id="270" r:id="Rc446235bb0624abb"/>
+    <p:sldId xmlns:r="http://schemas.openxmlformats.org/officeDocument/2006/relationships" id="271" r:id="R8169b713375149f2"/>
+    <p:sldId xmlns:r="http://schemas.openxmlformats.org/officeDocument/2006/relationships" id="272" r:id="R6fc8c5e4787e4d41"/>
+    <p:sldId xmlns:r="http://schemas.openxmlformats.org/officeDocument/2006/relationships" id="273" r:id="Rffef3c094d794679"/>
+    <p:sldId xmlns:r="http://schemas.openxmlformats.org/officeDocument/2006/relationships" id="274" r:id="R77fafa47b56f4667"/>
+    <p:sldId xmlns:r="http://schemas.openxmlformats.org/officeDocument/2006/relationships" id="275" r:id="R0d2e6486c63d421c"/>
+    <p:sldId xmlns:r="http://schemas.openxmlformats.org/officeDocument/2006/relationships" id="276" r:id="Rd8ffb4c8f9c04194"/>
+    <p:sldId xmlns:r="http://schemas.openxmlformats.org/officeDocument/2006/relationships" id="277" r:id="R34426b30f6434239"/>
   </p:sldIdLst>
   <p:sldSz cx="12192000" cy="6858000"/>
   <p:notesSz cx="6858000" cy="9144000"/>
@@ -1723,7 +1723,7 @@
           <a:lstStyle xmlns:a="http://schemas.openxmlformats.org/drawingml/2006/main"/>
           <a:p xmlns:a="http://schemas.openxmlformats.org/drawingml/2006/main">
             <a:r>
-              <a:t>[3 min] Explain why the intercept does not disappear from the original problem. Centering changes coordinates. It lets the paper focus on coefficient geometry without repeatedly carrying the intercept term.</a:t>
+              <a:t>[5 min] Use weight and fuel consumption as a two dimensional example. The gold dot is the sample mean. Subtract the same mean vector from every observation. Ask students to compare the two clouds: pairwise distances, relative positions, and the fitted slope stay unchanged. Only the origin changes. The centered fitted line passes through (0, 0), so its intercept is zero. Stress that both X and Y must be centered. Recover the original intercept with beta zero hat equals y bar minus x bar transpose beta hat.</a:t>
             </a:r>
           </a:p>
         </p:txBody>
@@ -2001,7 +2001,7 @@
   </p:cSld>
   <p:clrMap bg1="lt1" tx1="dk1" bg2="lt2" tx2="dk2" accent1="accent1" accent2="accent2" accent3="accent3" accent4="accent4" accent5="accent5" accent6="accent6" hlink="hlink" folHlink="folHlink"/>
   <p:sldLayoutIdLst>
-    <p:sldLayoutId xmlns:r="http://schemas.openxmlformats.org/officeDocument/2006/relationships" id="2147483649" r:id="Rc748471e7c1a4d87"/>
+    <p:sldLayoutId xmlns:r="http://schemas.openxmlformats.org/officeDocument/2006/relationships" id="2147483649" r:id="Rb017a24b82cf4f1d"/>
   </p:sldLayoutIdLst>
   <p:txStyles>
     <p:titleStyle>
@@ -2552,7 +2552,7 @@
           <p:cNvPr id="8" name="">
             <a:extLst xmlns:a="http://schemas.openxmlformats.org/drawingml/2006/main">
               <a:ext uri="{FF2B5EF4-FFF2-40B4-BE49-F238E27FC236}">
-                <a16:creationId xmlns:a16="http://schemas.microsoft.com/office/drawing/2014/main" id="{9E9260F5-F877-42ED-9959-5146D9FDAC0D}"/>
+                <a16:creationId xmlns:a16="http://schemas.microsoft.com/office/drawing/2014/main" id="{EFF0D749-D536-4AE4-B446-1881AD89D5E4}"/>
               </a:ext>
             </a:extLst>
           </p:cNvPr>
@@ -2582,7 +2582,7 @@
           <p:cNvPr id="2" name="">
             <a:extLst xmlns:a="http://schemas.openxmlformats.org/drawingml/2006/main">
               <a:ext uri="{FF2B5EF4-FFF2-40B4-BE49-F238E27FC236}">
-                <a16:creationId xmlns:a16="http://schemas.microsoft.com/office/drawing/2014/main" id="{04A62E31-8207-4840-B963-23DFE4AABEA7}"/>
+                <a16:creationId xmlns:a16="http://schemas.microsoft.com/office/drawing/2014/main" id="{170CCC8E-F644-4909-8E0B-F687234F6EFD}"/>
               </a:ext>
             </a:extLst>
           </p:cNvPr>
@@ -2643,7 +2643,7 @@
           <p:cNvPr id="3" name="">
             <a:extLst xmlns:a="http://schemas.openxmlformats.org/drawingml/2006/main">
               <a:ext uri="{FF2B5EF4-FFF2-40B4-BE49-F238E27FC236}">
-                <a16:creationId xmlns:a16="http://schemas.microsoft.com/office/drawing/2014/main" id="{26AA5735-1DC6-4540-9D83-6FF4F4FE2D5C}"/>
+                <a16:creationId xmlns:a16="http://schemas.microsoft.com/office/drawing/2014/main" id="{2ADFABEC-77E8-4F12-92F9-1909EFD79DE4}"/>
               </a:ext>
             </a:extLst>
           </p:cNvPr>
@@ -2731,7 +2731,7 @@
           <p:cNvPr id="4" name="">
             <a:extLst xmlns:a="http://schemas.openxmlformats.org/drawingml/2006/main">
               <a:ext uri="{FF2B5EF4-FFF2-40B4-BE49-F238E27FC236}">
-                <a16:creationId xmlns:a16="http://schemas.microsoft.com/office/drawing/2014/main" id="{BBFC4C6C-3D62-4146-985D-3578FD91A6FB}"/>
+                <a16:creationId xmlns:a16="http://schemas.microsoft.com/office/drawing/2014/main" id="{43722CA1-4B14-436F-AA93-F8A6DF93361E}"/>
               </a:ext>
             </a:extLst>
           </p:cNvPr>
@@ -2792,7 +2792,7 @@
           <p:cNvPr id="5" name="">
             <a:extLst xmlns:a="http://schemas.openxmlformats.org/drawingml/2006/main">
               <a:ext uri="{FF2B5EF4-FFF2-40B4-BE49-F238E27FC236}">
-                <a16:creationId xmlns:a16="http://schemas.microsoft.com/office/drawing/2014/main" id="{7AEA2947-7FDE-4080-A356-6332D82F4627}"/>
+                <a16:creationId xmlns:a16="http://schemas.microsoft.com/office/drawing/2014/main" id="{3E7EAAB3-C5C9-48C6-A3A4-678FEFB30B0A}"/>
               </a:ext>
             </a:extLst>
           </p:cNvPr>
@@ -2853,7 +2853,7 @@
           <p:cNvPr id="6" name="">
             <a:extLst xmlns:a="http://schemas.openxmlformats.org/drawingml/2006/main">
               <a:ext uri="{FF2B5EF4-FFF2-40B4-BE49-F238E27FC236}">
-                <a16:creationId xmlns:a16="http://schemas.microsoft.com/office/drawing/2014/main" id="{75604961-02AC-4A4B-A4FA-F232D9F2C993}"/>
+                <a16:creationId xmlns:a16="http://schemas.microsoft.com/office/drawing/2014/main" id="{A9A1A9CB-37DA-4FA5-8A23-517D0C87EC11}"/>
               </a:ext>
             </a:extLst>
           </p:cNvPr>
@@ -2914,7 +2914,7 @@
           <p:cNvPr id="7" name="">
             <a:extLst xmlns:a="http://schemas.openxmlformats.org/drawingml/2006/main">
               <a:ext uri="{FF2B5EF4-FFF2-40B4-BE49-F238E27FC236}">
-                <a16:creationId xmlns:a16="http://schemas.microsoft.com/office/drawing/2014/main" id="{02ACE63A-7437-4642-B68A-4BAADA8415F9}"/>
+                <a16:creationId xmlns:a16="http://schemas.microsoft.com/office/drawing/2014/main" id="{4959223B-7C7F-4584-801A-3D1FEA7B8C77}"/>
               </a:ext>
             </a:extLst>
           </p:cNvPr>
@@ -2973,7 +2973,7 @@
     </p:spTree>
     <p:extLst>
       <p:ext uri="{BB962C8B-B14F-4D97-AF65-F5344CB8AC3E}">
-        <p14:creationId xmlns:p14="http://schemas.microsoft.com/office/powerpoint/2010/main" val="1225594042"/>
+        <p14:creationId xmlns:p14="http://schemas.microsoft.com/office/powerpoint/2010/main" val="114829995"/>
       </p:ext>
     </p:extLst>
   </p:cSld>
@@ -3004,7 +3004,7 @@
           <p:cNvPr id="9" name="">
             <a:extLst xmlns:a="http://schemas.openxmlformats.org/drawingml/2006/main">
               <a:ext uri="{FF2B5EF4-FFF2-40B4-BE49-F238E27FC236}">
-                <a16:creationId xmlns:a16="http://schemas.microsoft.com/office/drawing/2014/main" id="{BDB293F4-71D4-44E4-B2C3-9C17A544D5D0}"/>
+                <a16:creationId xmlns:a16="http://schemas.microsoft.com/office/drawing/2014/main" id="{0EE43E4C-5063-410D-88EF-01E00FFC811D}"/>
               </a:ext>
             </a:extLst>
           </p:cNvPr>
@@ -3065,7 +3065,7 @@
           <p:cNvPr id="2" name="">
             <a:extLst xmlns:a="http://schemas.openxmlformats.org/drawingml/2006/main">
               <a:ext uri="{FF2B5EF4-FFF2-40B4-BE49-F238E27FC236}">
-                <a16:creationId xmlns:a16="http://schemas.microsoft.com/office/drawing/2014/main" id="{8AC07675-74DB-41B2-ABCA-B3EC93F9F915}"/>
+                <a16:creationId xmlns:a16="http://schemas.microsoft.com/office/drawing/2014/main" id="{406F26F0-6C7E-4CE0-88FA-F816E4F37A36}"/>
               </a:ext>
             </a:extLst>
           </p:cNvPr>
@@ -3126,7 +3126,7 @@
           <p:cNvPr id="3" name="">
             <a:extLst xmlns:a="http://schemas.openxmlformats.org/drawingml/2006/main">
               <a:ext uri="{FF2B5EF4-FFF2-40B4-BE49-F238E27FC236}">
-                <a16:creationId xmlns:a16="http://schemas.microsoft.com/office/drawing/2014/main" id="{3A650708-2F2F-4C74-BA61-AA83122C237C}"/>
+                <a16:creationId xmlns:a16="http://schemas.microsoft.com/office/drawing/2014/main" id="{60F3A6DF-5011-4DF9-BAA7-0F4731849249}"/>
               </a:ext>
             </a:extLst>
           </p:cNvPr>
@@ -3187,7 +3187,7 @@
           <p:cNvPr id="4" name="">
             <a:extLst xmlns:a="http://schemas.openxmlformats.org/drawingml/2006/main">
               <a:ext uri="{FF2B5EF4-FFF2-40B4-BE49-F238E27FC236}">
-                <a16:creationId xmlns:a16="http://schemas.microsoft.com/office/drawing/2014/main" id="{AA30B25E-F165-497B-BDC8-A88C37267BC7}"/>
+                <a16:creationId xmlns:a16="http://schemas.microsoft.com/office/drawing/2014/main" id="{984D0D23-8C93-421F-943A-6CDDFAA604F6}"/>
               </a:ext>
             </a:extLst>
           </p:cNvPr>
@@ -3252,7 +3252,7 @@
           <p:cNvPr id="5" name="">
             <a:extLst xmlns:a="http://schemas.openxmlformats.org/drawingml/2006/main">
               <a:ext uri="{FF2B5EF4-FFF2-40B4-BE49-F238E27FC236}">
-                <a16:creationId xmlns:a16="http://schemas.microsoft.com/office/drawing/2014/main" id="{84BFE48A-6157-4809-9EC7-05F046608D5A}"/>
+                <a16:creationId xmlns:a16="http://schemas.microsoft.com/office/drawing/2014/main" id="{FBA00496-EF99-4ADB-AD09-96E1069C0EFF}"/>
               </a:ext>
             </a:extLst>
           </p:cNvPr>
@@ -3313,7 +3313,7 @@
           <p:cNvPr id="6" name="">
             <a:extLst xmlns:a="http://schemas.openxmlformats.org/drawingml/2006/main">
               <a:ext uri="{FF2B5EF4-FFF2-40B4-BE49-F238E27FC236}">
-                <a16:creationId xmlns:a16="http://schemas.microsoft.com/office/drawing/2014/main" id="{696FAAF5-3668-4D96-AC56-E0B6C94F0A98}"/>
+                <a16:creationId xmlns:a16="http://schemas.microsoft.com/office/drawing/2014/main" id="{D145EA77-4770-42EC-BE88-BF6031000296}"/>
               </a:ext>
             </a:extLst>
           </p:cNvPr>
@@ -3374,7 +3374,7 @@
           <p:cNvPr id="7" name="">
             <a:extLst xmlns:a="http://schemas.openxmlformats.org/drawingml/2006/main">
               <a:ext uri="{FF2B5EF4-FFF2-40B4-BE49-F238E27FC236}">
-                <a16:creationId xmlns:a16="http://schemas.microsoft.com/office/drawing/2014/main" id="{3FD5A308-6A43-4999-AB50-A534273D7744}"/>
+                <a16:creationId xmlns:a16="http://schemas.microsoft.com/office/drawing/2014/main" id="{ABDD438C-6E4B-46D0-A0BF-749C817053C7}"/>
               </a:ext>
             </a:extLst>
           </p:cNvPr>
@@ -3435,7 +3435,7 @@
           <p:cNvPr id="8" name="">
             <a:extLst xmlns:a="http://schemas.openxmlformats.org/drawingml/2006/main">
               <a:ext uri="{FF2B5EF4-FFF2-40B4-BE49-F238E27FC236}">
-                <a16:creationId xmlns:a16="http://schemas.microsoft.com/office/drawing/2014/main" id="{25D794DB-06BC-442E-9ABF-C0C737696373}"/>
+                <a16:creationId xmlns:a16="http://schemas.microsoft.com/office/drawing/2014/main" id="{688573C8-FF66-4702-86A8-EA503110FC4C}"/>
               </a:ext>
             </a:extLst>
           </p:cNvPr>
@@ -3494,7 +3494,7 @@
     </p:spTree>
     <p:extLst>
       <p:ext uri="{BB962C8B-B14F-4D97-AF65-F5344CB8AC3E}">
-        <p14:creationId xmlns:p14="http://schemas.microsoft.com/office/powerpoint/2010/main" val="1734128783"/>
+        <p14:creationId xmlns:p14="http://schemas.microsoft.com/office/powerpoint/2010/main" val="851870996"/>
       </p:ext>
     </p:extLst>
   </p:cSld>
@@ -3525,7 +3525,7 @@
           <p:cNvPr id="9" name="">
             <a:extLst xmlns:a="http://schemas.openxmlformats.org/drawingml/2006/main">
               <a:ext uri="{FF2B5EF4-FFF2-40B4-BE49-F238E27FC236}">
-                <a16:creationId xmlns:a16="http://schemas.microsoft.com/office/drawing/2014/main" id="{F880CD24-AE76-498B-952F-6B70922E8E54}"/>
+                <a16:creationId xmlns:a16="http://schemas.microsoft.com/office/drawing/2014/main" id="{33C80F7A-5BA9-435A-9EFC-515E57572632}"/>
               </a:ext>
             </a:extLst>
           </p:cNvPr>
@@ -3586,7 +3586,7 @@
           <p:cNvPr id="2" name="">
             <a:extLst xmlns:a="http://schemas.openxmlformats.org/drawingml/2006/main">
               <a:ext uri="{FF2B5EF4-FFF2-40B4-BE49-F238E27FC236}">
-                <a16:creationId xmlns:a16="http://schemas.microsoft.com/office/drawing/2014/main" id="{D9B39FEE-4056-414B-966B-C28DED55FC00}"/>
+                <a16:creationId xmlns:a16="http://schemas.microsoft.com/office/drawing/2014/main" id="{CC6DBB91-C5A6-43AE-A3EE-371FA0676AE7}"/>
               </a:ext>
             </a:extLst>
           </p:cNvPr>
@@ -3647,7 +3647,7 @@
           <p:cNvPr id="3" name="">
             <a:extLst xmlns:a="http://schemas.openxmlformats.org/drawingml/2006/main">
               <a:ext uri="{FF2B5EF4-FFF2-40B4-BE49-F238E27FC236}">
-                <a16:creationId xmlns:a16="http://schemas.microsoft.com/office/drawing/2014/main" id="{90C502A9-3262-460C-A94D-533C0AB02E6B}"/>
+                <a16:creationId xmlns:a16="http://schemas.microsoft.com/office/drawing/2014/main" id="{233D4F4B-8C2F-4163-9D1D-A92AA1D239AE}"/>
               </a:ext>
             </a:extLst>
           </p:cNvPr>
@@ -3715,7 +3715,7 @@
           <p:cNvPr id="4" name="">
             <a:extLst xmlns:a="http://schemas.openxmlformats.org/drawingml/2006/main">
               <a:ext uri="{FF2B5EF4-FFF2-40B4-BE49-F238E27FC236}">
-                <a16:creationId xmlns:a16="http://schemas.microsoft.com/office/drawing/2014/main" id="{7A8FEBCD-7C80-44F1-BCEB-D8ECBAA26306}"/>
+                <a16:creationId xmlns:a16="http://schemas.microsoft.com/office/drawing/2014/main" id="{B27CC990-2BBB-4B34-BA0E-C56D9F998A71}"/>
               </a:ext>
             </a:extLst>
           </p:cNvPr>
@@ -3776,7 +3776,7 @@
           <p:cNvPr id="5" name="">
             <a:extLst xmlns:a="http://schemas.openxmlformats.org/drawingml/2006/main">
               <a:ext uri="{FF2B5EF4-FFF2-40B4-BE49-F238E27FC236}">
-                <a16:creationId xmlns:a16="http://schemas.microsoft.com/office/drawing/2014/main" id="{1F73C9E6-5082-4B46-8EDE-F67D50ACFCFD}"/>
+                <a16:creationId xmlns:a16="http://schemas.microsoft.com/office/drawing/2014/main" id="{FC82F842-E536-4A72-81A6-EC1C2B509C2E}"/>
               </a:ext>
             </a:extLst>
           </p:cNvPr>
@@ -3844,7 +3844,7 @@
           <p:cNvPr id="6" name="">
             <a:extLst xmlns:a="http://schemas.openxmlformats.org/drawingml/2006/main">
               <a:ext uri="{FF2B5EF4-FFF2-40B4-BE49-F238E27FC236}">
-                <a16:creationId xmlns:a16="http://schemas.microsoft.com/office/drawing/2014/main" id="{005B66F6-F062-4259-B52F-524221627232}"/>
+                <a16:creationId xmlns:a16="http://schemas.microsoft.com/office/drawing/2014/main" id="{555C2107-87F5-41E0-986A-2A73B643DCA3}"/>
               </a:ext>
             </a:extLst>
           </p:cNvPr>
@@ -3905,7 +3905,7 @@
           <p:cNvPr id="7" name="">
             <a:extLst xmlns:a="http://schemas.openxmlformats.org/drawingml/2006/main">
               <a:ext uri="{FF2B5EF4-FFF2-40B4-BE49-F238E27FC236}">
-                <a16:creationId xmlns:a16="http://schemas.microsoft.com/office/drawing/2014/main" id="{486771D0-A7B0-41D6-A1C5-4FF7FD2F49F3}"/>
+                <a16:creationId xmlns:a16="http://schemas.microsoft.com/office/drawing/2014/main" id="{E6609874-A739-4BAD-B5CD-8F607A0D0600}"/>
               </a:ext>
             </a:extLst>
           </p:cNvPr>
@@ -3935,7 +3935,7 @@
           <p:cNvPr id="8" name="">
             <a:extLst xmlns:a="http://schemas.openxmlformats.org/drawingml/2006/main">
               <a:ext uri="{FF2B5EF4-FFF2-40B4-BE49-F238E27FC236}">
-                <a16:creationId xmlns:a16="http://schemas.microsoft.com/office/drawing/2014/main" id="{0F7B2222-4C58-413C-944C-8EE056A7340B}"/>
+                <a16:creationId xmlns:a16="http://schemas.microsoft.com/office/drawing/2014/main" id="{814991E1-9FBE-465D-A589-0249FDB0B165}"/>
               </a:ext>
             </a:extLst>
           </p:cNvPr>
@@ -3994,7 +3994,7 @@
     </p:spTree>
     <p:extLst>
       <p:ext uri="{BB962C8B-B14F-4D97-AF65-F5344CB8AC3E}">
-        <p14:creationId xmlns:p14="http://schemas.microsoft.com/office/powerpoint/2010/main" val="508508019"/>
+        <p14:creationId xmlns:p14="http://schemas.microsoft.com/office/powerpoint/2010/main" val="745733492"/>
       </p:ext>
     </p:extLst>
   </p:cSld>
@@ -4025,7 +4025,7 @@
           <p:cNvPr id="10" name="">
             <a:extLst xmlns:a="http://schemas.openxmlformats.org/drawingml/2006/main">
               <a:ext uri="{FF2B5EF4-FFF2-40B4-BE49-F238E27FC236}">
-                <a16:creationId xmlns:a16="http://schemas.microsoft.com/office/drawing/2014/main" id="{2F79BAC9-31C0-4CBF-96AE-18F7C41CC236}"/>
+                <a16:creationId xmlns:a16="http://schemas.microsoft.com/office/drawing/2014/main" id="{7A06C9B2-9962-42B8-8813-868F89717E9D}"/>
               </a:ext>
             </a:extLst>
           </p:cNvPr>
@@ -4086,7 +4086,7 @@
           <p:cNvPr id="2" name="">
             <a:extLst xmlns:a="http://schemas.openxmlformats.org/drawingml/2006/main">
               <a:ext uri="{FF2B5EF4-FFF2-40B4-BE49-F238E27FC236}">
-                <a16:creationId xmlns:a16="http://schemas.microsoft.com/office/drawing/2014/main" id="{EE71D02A-C516-4926-A576-5CA7A99B7E15}"/>
+                <a16:creationId xmlns:a16="http://schemas.microsoft.com/office/drawing/2014/main" id="{885D2D08-6691-450D-9CB8-337F7C22AE5B}"/>
               </a:ext>
             </a:extLst>
           </p:cNvPr>
@@ -4147,7 +4147,7 @@
           <p:cNvPr id="3" name="">
             <a:extLst xmlns:a="http://schemas.openxmlformats.org/drawingml/2006/main">
               <a:ext uri="{FF2B5EF4-FFF2-40B4-BE49-F238E27FC236}">
-                <a16:creationId xmlns:a16="http://schemas.microsoft.com/office/drawing/2014/main" id="{AF2EA0BF-5485-4836-9722-95ED8689314F}"/>
+                <a16:creationId xmlns:a16="http://schemas.microsoft.com/office/drawing/2014/main" id="{41EE352E-C942-42CD-A8F4-16B02FDE26FD}"/>
               </a:ext>
             </a:extLst>
           </p:cNvPr>
@@ -4208,7 +4208,7 @@
           <p:cNvPr id="4" name="">
             <a:extLst xmlns:a="http://schemas.openxmlformats.org/drawingml/2006/main">
               <a:ext uri="{FF2B5EF4-FFF2-40B4-BE49-F238E27FC236}">
-                <a16:creationId xmlns:a16="http://schemas.microsoft.com/office/drawing/2014/main" id="{60DF91CF-FEBF-4116-B892-AD070FE81ABC}"/>
+                <a16:creationId xmlns:a16="http://schemas.microsoft.com/office/drawing/2014/main" id="{D7714484-8BA5-4976-ADE6-EA821E0833D9}"/>
               </a:ext>
             </a:extLst>
           </p:cNvPr>
@@ -4269,7 +4269,7 @@
           <p:cNvPr id="5" name="">
             <a:extLst xmlns:a="http://schemas.openxmlformats.org/drawingml/2006/main">
               <a:ext uri="{FF2B5EF4-FFF2-40B4-BE49-F238E27FC236}">
-                <a16:creationId xmlns:a16="http://schemas.microsoft.com/office/drawing/2014/main" id="{FE9A9915-8EA0-47E5-AEC6-49A51818F8E8}"/>
+                <a16:creationId xmlns:a16="http://schemas.microsoft.com/office/drawing/2014/main" id="{7DB53322-3DA4-41B9-A838-F19F2F5C1C7E}"/>
               </a:ext>
             </a:extLst>
           </p:cNvPr>
@@ -4330,7 +4330,7 @@
           <p:cNvPr id="6" name="">
             <a:extLst xmlns:a="http://schemas.openxmlformats.org/drawingml/2006/main">
               <a:ext uri="{FF2B5EF4-FFF2-40B4-BE49-F238E27FC236}">
-                <a16:creationId xmlns:a16="http://schemas.microsoft.com/office/drawing/2014/main" id="{7A238FCD-E705-4A2C-A9F6-498F4E717320}"/>
+                <a16:creationId xmlns:a16="http://schemas.microsoft.com/office/drawing/2014/main" id="{3682680C-2F95-4579-930F-508F5FAC8C74}"/>
               </a:ext>
             </a:extLst>
           </p:cNvPr>
@@ -4360,7 +4360,7 @@
           <p:cNvPr id="7" name="">
             <a:extLst xmlns:a="http://schemas.openxmlformats.org/drawingml/2006/main">
               <a:ext uri="{FF2B5EF4-FFF2-40B4-BE49-F238E27FC236}">
-                <a16:creationId xmlns:a16="http://schemas.microsoft.com/office/drawing/2014/main" id="{9741DDAE-701E-4F8F-BA06-36373C7D1C06}"/>
+                <a16:creationId xmlns:a16="http://schemas.microsoft.com/office/drawing/2014/main" id="{654779FD-648B-4A50-A792-52826BFBA3CF}"/>
               </a:ext>
             </a:extLst>
           </p:cNvPr>
@@ -4421,7 +4421,7 @@
           <p:cNvPr id="8" name="">
             <a:extLst xmlns:a="http://schemas.openxmlformats.org/drawingml/2006/main">
               <a:ext uri="{FF2B5EF4-FFF2-40B4-BE49-F238E27FC236}">
-                <a16:creationId xmlns:a16="http://schemas.microsoft.com/office/drawing/2014/main" id="{523737DC-C626-4EEE-9ACF-A2C7617AFE39}"/>
+                <a16:creationId xmlns:a16="http://schemas.microsoft.com/office/drawing/2014/main" id="{6C6181C5-B3F4-4A68-A722-1CCEC6C29DD6}"/>
               </a:ext>
             </a:extLst>
           </p:cNvPr>
@@ -4482,7 +4482,7 @@
           <p:cNvPr id="9" name="">
             <a:extLst xmlns:a="http://schemas.openxmlformats.org/drawingml/2006/main">
               <a:ext uri="{FF2B5EF4-FFF2-40B4-BE49-F238E27FC236}">
-                <a16:creationId xmlns:a16="http://schemas.microsoft.com/office/drawing/2014/main" id="{9BD7C93B-5E2D-4CE0-8ADD-D008487A73F1}"/>
+                <a16:creationId xmlns:a16="http://schemas.microsoft.com/office/drawing/2014/main" id="{C8D27295-E990-4292-9274-3E240EB9EEBF}"/>
               </a:ext>
             </a:extLst>
           </p:cNvPr>
@@ -4541,7 +4541,7 @@
     </p:spTree>
     <p:extLst>
       <p:ext uri="{BB962C8B-B14F-4D97-AF65-F5344CB8AC3E}">
-        <p14:creationId xmlns:p14="http://schemas.microsoft.com/office/powerpoint/2010/main" val="740531370"/>
+        <p14:creationId xmlns:p14="http://schemas.microsoft.com/office/powerpoint/2010/main" val="1805201897"/>
       </p:ext>
     </p:extLst>
   </p:cSld>
@@ -4572,7 +4572,7 @@
           <p:cNvPr id="8" name="">
             <a:extLst xmlns:a="http://schemas.openxmlformats.org/drawingml/2006/main">
               <a:ext uri="{FF2B5EF4-FFF2-40B4-BE49-F238E27FC236}">
-                <a16:creationId xmlns:a16="http://schemas.microsoft.com/office/drawing/2014/main" id="{7881E8CC-96F5-4E79-9189-A01B3A6F2A4F}"/>
+                <a16:creationId xmlns:a16="http://schemas.microsoft.com/office/drawing/2014/main" id="{5B9BF030-445E-4C5D-A2D1-2858E141F8DA}"/>
               </a:ext>
             </a:extLst>
           </p:cNvPr>
@@ -4633,7 +4633,7 @@
           <p:cNvPr id="2" name="">
             <a:extLst xmlns:a="http://schemas.openxmlformats.org/drawingml/2006/main">
               <a:ext uri="{FF2B5EF4-FFF2-40B4-BE49-F238E27FC236}">
-                <a16:creationId xmlns:a16="http://schemas.microsoft.com/office/drawing/2014/main" id="{46290D57-B221-476B-826C-CCF66BA35698}"/>
+                <a16:creationId xmlns:a16="http://schemas.microsoft.com/office/drawing/2014/main" id="{5DED51F7-A10B-449A-8F05-15E8093EB0B8}"/>
               </a:ext>
             </a:extLst>
           </p:cNvPr>
@@ -4694,7 +4694,7 @@
           <p:cNvPr id="3" name="">
             <a:extLst xmlns:a="http://schemas.openxmlformats.org/drawingml/2006/main">
               <a:ext uri="{FF2B5EF4-FFF2-40B4-BE49-F238E27FC236}">
-                <a16:creationId xmlns:a16="http://schemas.microsoft.com/office/drawing/2014/main" id="{1053B2E4-CF1E-4C6F-BA92-E4BFB8822C49}"/>
+                <a16:creationId xmlns:a16="http://schemas.microsoft.com/office/drawing/2014/main" id="{02958F1A-6E42-40EE-BE01-61180EB3B4B4}"/>
               </a:ext>
             </a:extLst>
           </p:cNvPr>
@@ -4755,7 +4755,7 @@
           <p:cNvPr id="4" name="">
             <a:extLst xmlns:a="http://schemas.openxmlformats.org/drawingml/2006/main">
               <a:ext uri="{FF2B5EF4-FFF2-40B4-BE49-F238E27FC236}">
-                <a16:creationId xmlns:a16="http://schemas.microsoft.com/office/drawing/2014/main" id="{0D715F39-C207-4732-BA46-38088E61DCC8}"/>
+                <a16:creationId xmlns:a16="http://schemas.microsoft.com/office/drawing/2014/main" id="{6774003E-B994-4551-9285-3D62CA6B1FA1}"/>
               </a:ext>
             </a:extLst>
           </p:cNvPr>
@@ -4816,7 +4816,7 @@
           <p:cNvPr id="5" name="">
             <a:extLst xmlns:a="http://schemas.openxmlformats.org/drawingml/2006/main">
               <a:ext uri="{FF2B5EF4-FFF2-40B4-BE49-F238E27FC236}">
-                <a16:creationId xmlns:a16="http://schemas.microsoft.com/office/drawing/2014/main" id="{2BB456BB-BED7-41B5-9ED3-D721AFECF55E}"/>
+                <a16:creationId xmlns:a16="http://schemas.microsoft.com/office/drawing/2014/main" id="{B2F3F3B5-96E3-490C-A38E-A2FEF461FC7E}"/>
               </a:ext>
             </a:extLst>
           </p:cNvPr>
@@ -4877,7 +4877,7 @@
           <p:cNvPr id="6" name="">
             <a:extLst xmlns:a="http://schemas.openxmlformats.org/drawingml/2006/main">
               <a:ext uri="{FF2B5EF4-FFF2-40B4-BE49-F238E27FC236}">
-                <a16:creationId xmlns:a16="http://schemas.microsoft.com/office/drawing/2014/main" id="{3329F212-0A35-4A3A-A671-8E9F95B1F270}"/>
+                <a16:creationId xmlns:a16="http://schemas.microsoft.com/office/drawing/2014/main" id="{1C7451F4-DE5E-490E-83FA-055172B9C7B7}"/>
               </a:ext>
             </a:extLst>
           </p:cNvPr>
@@ -4942,7 +4942,7 @@
           <p:cNvPr id="7" name="">
             <a:extLst xmlns:a="http://schemas.openxmlformats.org/drawingml/2006/main">
               <a:ext uri="{FF2B5EF4-FFF2-40B4-BE49-F238E27FC236}">
-                <a16:creationId xmlns:a16="http://schemas.microsoft.com/office/drawing/2014/main" id="{F3B4AFEB-B93B-488B-935A-0B95221B33A0}"/>
+                <a16:creationId xmlns:a16="http://schemas.microsoft.com/office/drawing/2014/main" id="{3953E0D8-01A0-4DEF-9F55-9F5865A4E4E1}"/>
               </a:ext>
             </a:extLst>
           </p:cNvPr>
@@ -5001,7 +5001,7 @@
     </p:spTree>
     <p:extLst>
       <p:ext uri="{BB962C8B-B14F-4D97-AF65-F5344CB8AC3E}">
-        <p14:creationId xmlns:p14="http://schemas.microsoft.com/office/powerpoint/2010/main" val="1290206972"/>
+        <p14:creationId xmlns:p14="http://schemas.microsoft.com/office/powerpoint/2010/main" val="1900090220"/>
       </p:ext>
     </p:extLst>
   </p:cSld>
@@ -5032,7 +5032,7 @@
           <p:cNvPr id="14" name="">
             <a:extLst xmlns:a="http://schemas.openxmlformats.org/drawingml/2006/main">
               <a:ext uri="{FF2B5EF4-FFF2-40B4-BE49-F238E27FC236}">
-                <a16:creationId xmlns:a16="http://schemas.microsoft.com/office/drawing/2014/main" id="{4F96251D-9C2F-4089-B42C-8F93FA5571C3}"/>
+                <a16:creationId xmlns:a16="http://schemas.microsoft.com/office/drawing/2014/main" id="{1D5FF31F-A786-4B5D-9D17-EF40BDDC28AB}"/>
               </a:ext>
             </a:extLst>
           </p:cNvPr>
@@ -5093,7 +5093,7 @@
           <p:cNvPr id="2" name="">
             <a:extLst xmlns:a="http://schemas.openxmlformats.org/drawingml/2006/main">
               <a:ext uri="{FF2B5EF4-FFF2-40B4-BE49-F238E27FC236}">
-                <a16:creationId xmlns:a16="http://schemas.microsoft.com/office/drawing/2014/main" id="{73F15B26-484A-4F9B-AF9B-539D99D8145C}"/>
+                <a16:creationId xmlns:a16="http://schemas.microsoft.com/office/drawing/2014/main" id="{4276CB01-6C54-4004-8556-8ED0561AFBDF}"/>
               </a:ext>
             </a:extLst>
           </p:cNvPr>
@@ -5154,7 +5154,7 @@
           <p:cNvPr id="3" name="">
             <a:extLst xmlns:a="http://schemas.openxmlformats.org/drawingml/2006/main">
               <a:ext uri="{FF2B5EF4-FFF2-40B4-BE49-F238E27FC236}">
-                <a16:creationId xmlns:a16="http://schemas.microsoft.com/office/drawing/2014/main" id="{6A94A927-4ED9-487D-9FC1-D507D6B2EC5B}"/>
+                <a16:creationId xmlns:a16="http://schemas.microsoft.com/office/drawing/2014/main" id="{C0F22E6E-5486-4C4A-BAE1-ECF18BAE9E08}"/>
               </a:ext>
             </a:extLst>
           </p:cNvPr>
@@ -5185,7 +5185,7 @@
           <p:cNvPr id="4" name="">
             <a:extLst xmlns:a="http://schemas.openxmlformats.org/drawingml/2006/main">
               <a:ext uri="{FF2B5EF4-FFF2-40B4-BE49-F238E27FC236}">
-                <a16:creationId xmlns:a16="http://schemas.microsoft.com/office/drawing/2014/main" id="{A9D904E6-65CA-4180-9A46-1279B9E7044C}"/>
+                <a16:creationId xmlns:a16="http://schemas.microsoft.com/office/drawing/2014/main" id="{F974FE16-15E5-4F2D-A8D2-F4FAAB09C2A2}"/>
               </a:ext>
             </a:extLst>
           </p:cNvPr>
@@ -5216,7 +5216,7 @@
           <p:cNvPr id="5" name="">
             <a:extLst xmlns:a="http://schemas.openxmlformats.org/drawingml/2006/main">
               <a:ext uri="{FF2B5EF4-FFF2-40B4-BE49-F238E27FC236}">
-                <a16:creationId xmlns:a16="http://schemas.microsoft.com/office/drawing/2014/main" id="{514D219B-A584-4190-943F-A3F1DD9F11EC}"/>
+                <a16:creationId xmlns:a16="http://schemas.microsoft.com/office/drawing/2014/main" id="{8C6818A4-1BA5-4A8C-9004-F77F6A4AE2F3}"/>
               </a:ext>
             </a:extLst>
           </p:cNvPr>
@@ -5246,7 +5246,7 @@
           <p:cNvPr id="6" name="">
             <a:extLst xmlns:a="http://schemas.openxmlformats.org/drawingml/2006/main">
               <a:ext uri="{FF2B5EF4-FFF2-40B4-BE49-F238E27FC236}">
-                <a16:creationId xmlns:a16="http://schemas.microsoft.com/office/drawing/2014/main" id="{BBB708CF-2C24-4F27-872E-782F31633739}"/>
+                <a16:creationId xmlns:a16="http://schemas.microsoft.com/office/drawing/2014/main" id="{62FF9B23-8AC8-4E58-A36E-35328B4E3B30}"/>
               </a:ext>
             </a:extLst>
           </p:cNvPr>
@@ -5307,7 +5307,7 @@
           <p:cNvPr id="7" name="">
             <a:extLst xmlns:a="http://schemas.openxmlformats.org/drawingml/2006/main">
               <a:ext uri="{FF2B5EF4-FFF2-40B4-BE49-F238E27FC236}">
-                <a16:creationId xmlns:a16="http://schemas.microsoft.com/office/drawing/2014/main" id="{4FC2F67F-F872-42B0-8C09-560737BC6143}"/>
+                <a16:creationId xmlns:a16="http://schemas.microsoft.com/office/drawing/2014/main" id="{B4644D12-0045-4939-A2CD-EA3F871E6475}"/>
               </a:ext>
             </a:extLst>
           </p:cNvPr>
@@ -5368,7 +5368,7 @@
           <p:cNvPr id="8" name="">
             <a:extLst xmlns:a="http://schemas.openxmlformats.org/drawingml/2006/main">
               <a:ext uri="{FF2B5EF4-FFF2-40B4-BE49-F238E27FC236}">
-                <a16:creationId xmlns:a16="http://schemas.microsoft.com/office/drawing/2014/main" id="{68EA204D-CEC0-454F-BB18-EF69E5AC1C69}"/>
+                <a16:creationId xmlns:a16="http://schemas.microsoft.com/office/drawing/2014/main" id="{B25F5358-CFDC-4E77-9F7D-9E531916989C}"/>
               </a:ext>
             </a:extLst>
           </p:cNvPr>
@@ -5429,7 +5429,7 @@
           <p:cNvPr id="9" name="">
             <a:extLst xmlns:a="http://schemas.openxmlformats.org/drawingml/2006/main">
               <a:ext uri="{FF2B5EF4-FFF2-40B4-BE49-F238E27FC236}">
-                <a16:creationId xmlns:a16="http://schemas.microsoft.com/office/drawing/2014/main" id="{8F1636A3-4FE9-4D66-A261-67D00FCC1BC6}"/>
+                <a16:creationId xmlns:a16="http://schemas.microsoft.com/office/drawing/2014/main" id="{81EA4954-E880-4975-B79C-1B877D5961B5}"/>
               </a:ext>
             </a:extLst>
           </p:cNvPr>
@@ -5490,7 +5490,7 @@
           <p:cNvPr id="10" name="">
             <a:extLst xmlns:a="http://schemas.openxmlformats.org/drawingml/2006/main">
               <a:ext uri="{FF2B5EF4-FFF2-40B4-BE49-F238E27FC236}">
-                <a16:creationId xmlns:a16="http://schemas.microsoft.com/office/drawing/2014/main" id="{62DF4E32-EF6D-4F5B-9C58-42F8E62C662E}"/>
+                <a16:creationId xmlns:a16="http://schemas.microsoft.com/office/drawing/2014/main" id="{29CF9A0D-94E5-4F1A-B1CC-3477515E216A}"/>
               </a:ext>
             </a:extLst>
           </p:cNvPr>
@@ -5555,7 +5555,7 @@
           <p:cNvPr id="11" name="">
             <a:extLst xmlns:a="http://schemas.openxmlformats.org/drawingml/2006/main">
               <a:ext uri="{FF2B5EF4-FFF2-40B4-BE49-F238E27FC236}">
-                <a16:creationId xmlns:a16="http://schemas.microsoft.com/office/drawing/2014/main" id="{5B43F2D6-A908-4522-9E95-49D63B579536}"/>
+                <a16:creationId xmlns:a16="http://schemas.microsoft.com/office/drawing/2014/main" id="{4A1B5069-90BF-4F47-AF9A-A66DFDEFA2C1}"/>
               </a:ext>
             </a:extLst>
           </p:cNvPr>
@@ -5616,7 +5616,7 @@
           <p:cNvPr id="12" name="">
             <a:extLst xmlns:a="http://schemas.openxmlformats.org/drawingml/2006/main">
               <a:ext uri="{FF2B5EF4-FFF2-40B4-BE49-F238E27FC236}">
-                <a16:creationId xmlns:a16="http://schemas.microsoft.com/office/drawing/2014/main" id="{FB27831E-A95F-4DE7-A11C-4F037E7EEF51}"/>
+                <a16:creationId xmlns:a16="http://schemas.microsoft.com/office/drawing/2014/main" id="{EBB9EDE7-54F1-4CFE-AC40-179174531EC9}"/>
               </a:ext>
             </a:extLst>
           </p:cNvPr>
@@ -5677,7 +5677,7 @@
           <p:cNvPr id="13" name="">
             <a:extLst xmlns:a="http://schemas.openxmlformats.org/drawingml/2006/main">
               <a:ext uri="{FF2B5EF4-FFF2-40B4-BE49-F238E27FC236}">
-                <a16:creationId xmlns:a16="http://schemas.microsoft.com/office/drawing/2014/main" id="{0B56016F-6A4F-432E-8958-FAB175CEDD25}"/>
+                <a16:creationId xmlns:a16="http://schemas.microsoft.com/office/drawing/2014/main" id="{FD4A2C91-86EF-4074-9562-FF292FF009CC}"/>
               </a:ext>
             </a:extLst>
           </p:cNvPr>
@@ -5736,7 +5736,7 @@
     </p:spTree>
     <p:extLst>
       <p:ext uri="{BB962C8B-B14F-4D97-AF65-F5344CB8AC3E}">
-        <p14:creationId xmlns:p14="http://schemas.microsoft.com/office/powerpoint/2010/main" val="804891550"/>
+        <p14:creationId xmlns:p14="http://schemas.microsoft.com/office/powerpoint/2010/main" val="1564641934"/>
       </p:ext>
     </p:extLst>
   </p:cSld>
@@ -5767,7 +5767,7 @@
           <p:cNvPr id="11" name="">
             <a:extLst xmlns:a="http://schemas.openxmlformats.org/drawingml/2006/main">
               <a:ext uri="{FF2B5EF4-FFF2-40B4-BE49-F238E27FC236}">
-                <a16:creationId xmlns:a16="http://schemas.microsoft.com/office/drawing/2014/main" id="{D9617D44-7CA7-4297-9249-116750F63093}"/>
+                <a16:creationId xmlns:a16="http://schemas.microsoft.com/office/drawing/2014/main" id="{CA198C45-8A5A-446B-AC1D-B8785300AB8D}"/>
               </a:ext>
             </a:extLst>
           </p:cNvPr>
@@ -5828,7 +5828,7 @@
           <p:cNvPr id="2" name="">
             <a:extLst xmlns:a="http://schemas.openxmlformats.org/drawingml/2006/main">
               <a:ext uri="{FF2B5EF4-FFF2-40B4-BE49-F238E27FC236}">
-                <a16:creationId xmlns:a16="http://schemas.microsoft.com/office/drawing/2014/main" id="{72DA8137-8D70-4281-A126-E1045CBC6A5B}"/>
+                <a16:creationId xmlns:a16="http://schemas.microsoft.com/office/drawing/2014/main" id="{60DD320C-C8B4-49AA-89F6-3B6683E28475}"/>
               </a:ext>
             </a:extLst>
           </p:cNvPr>
@@ -5889,7 +5889,7 @@
           <p:cNvPr id="3" name="">
             <a:extLst xmlns:a="http://schemas.openxmlformats.org/drawingml/2006/main">
               <a:ext uri="{FF2B5EF4-FFF2-40B4-BE49-F238E27FC236}">
-                <a16:creationId xmlns:a16="http://schemas.microsoft.com/office/drawing/2014/main" id="{4C8C8B23-FF07-4C12-85F5-1F394E554E4D}"/>
+                <a16:creationId xmlns:a16="http://schemas.microsoft.com/office/drawing/2014/main" id="{0AEE1410-A412-4719-8422-10E40F5FE221}"/>
               </a:ext>
             </a:extLst>
           </p:cNvPr>
@@ -6011,7 +6011,7 @@
           <p:cNvPr id="4" name="">
             <a:extLst xmlns:a="http://schemas.openxmlformats.org/drawingml/2006/main">
               <a:ext uri="{FF2B5EF4-FFF2-40B4-BE49-F238E27FC236}">
-                <a16:creationId xmlns:a16="http://schemas.microsoft.com/office/drawing/2014/main" id="{05A4880E-4598-4033-A713-C2000BB14894}"/>
+                <a16:creationId xmlns:a16="http://schemas.microsoft.com/office/drawing/2014/main" id="{A202D934-6063-4BED-B099-4B408AC32DDB}"/>
               </a:ext>
             </a:extLst>
           </p:cNvPr>
@@ -6041,7 +6041,7 @@
           <p:cNvPr id="5" name="">
             <a:extLst xmlns:a="http://schemas.openxmlformats.org/drawingml/2006/main">
               <a:ext uri="{FF2B5EF4-FFF2-40B4-BE49-F238E27FC236}">
-                <a16:creationId xmlns:a16="http://schemas.microsoft.com/office/drawing/2014/main" id="{9816FE79-9D6A-4880-B8BE-E344281F2646}"/>
+                <a16:creationId xmlns:a16="http://schemas.microsoft.com/office/drawing/2014/main" id="{1C169A7B-3262-41EA-AE38-F5899A4A01EF}"/>
               </a:ext>
             </a:extLst>
           </p:cNvPr>
@@ -6102,7 +6102,7 @@
           <p:cNvPr id="6" name="">
             <a:extLst xmlns:a="http://schemas.openxmlformats.org/drawingml/2006/main">
               <a:ext uri="{FF2B5EF4-FFF2-40B4-BE49-F238E27FC236}">
-                <a16:creationId xmlns:a16="http://schemas.microsoft.com/office/drawing/2014/main" id="{F10D6702-C824-4B06-92B0-61D936C53271}"/>
+                <a16:creationId xmlns:a16="http://schemas.microsoft.com/office/drawing/2014/main" id="{CA02EFC6-F8B4-408B-8792-5B9EC810A419}"/>
               </a:ext>
             </a:extLst>
           </p:cNvPr>
@@ -6163,7 +6163,7 @@
           <p:cNvPr id="7" name="">
             <a:extLst xmlns:a="http://schemas.openxmlformats.org/drawingml/2006/main">
               <a:ext uri="{FF2B5EF4-FFF2-40B4-BE49-F238E27FC236}">
-                <a16:creationId xmlns:a16="http://schemas.microsoft.com/office/drawing/2014/main" id="{CCED0B9C-FE3F-4117-A799-4832E7D04250}"/>
+                <a16:creationId xmlns:a16="http://schemas.microsoft.com/office/drawing/2014/main" id="{282AFF64-3C8E-45BF-80B5-B3D13610E922}"/>
               </a:ext>
             </a:extLst>
           </p:cNvPr>
@@ -6224,7 +6224,7 @@
           <p:cNvPr id="8" name="">
             <a:extLst xmlns:a="http://schemas.openxmlformats.org/drawingml/2006/main">
               <a:ext uri="{FF2B5EF4-FFF2-40B4-BE49-F238E27FC236}">
-                <a16:creationId xmlns:a16="http://schemas.microsoft.com/office/drawing/2014/main" id="{36131326-3556-40B0-B241-1021DC689F1C}"/>
+                <a16:creationId xmlns:a16="http://schemas.microsoft.com/office/drawing/2014/main" id="{36BFCC50-BEAA-4EE0-98A0-91FD0B7C822A}"/>
               </a:ext>
             </a:extLst>
           </p:cNvPr>
@@ -6285,7 +6285,7 @@
           <p:cNvPr id="9" name="">
             <a:extLst xmlns:a="http://schemas.openxmlformats.org/drawingml/2006/main">
               <a:ext uri="{FF2B5EF4-FFF2-40B4-BE49-F238E27FC236}">
-                <a16:creationId xmlns:a16="http://schemas.microsoft.com/office/drawing/2014/main" id="{CB9F6454-795F-49B8-976C-19B487CF2524}"/>
+                <a16:creationId xmlns:a16="http://schemas.microsoft.com/office/drawing/2014/main" id="{7977E1C8-A648-4EBA-AE98-42EE9A4DA386}"/>
               </a:ext>
             </a:extLst>
           </p:cNvPr>
@@ -6346,7 +6346,7 @@
           <p:cNvPr id="10" name="">
             <a:extLst xmlns:a="http://schemas.openxmlformats.org/drawingml/2006/main">
               <a:ext uri="{FF2B5EF4-FFF2-40B4-BE49-F238E27FC236}">
-                <a16:creationId xmlns:a16="http://schemas.microsoft.com/office/drawing/2014/main" id="{FAC2F24A-BA60-4D70-BE5B-7714415FC426}"/>
+                <a16:creationId xmlns:a16="http://schemas.microsoft.com/office/drawing/2014/main" id="{89D96646-F625-43E7-A54C-466134926CB9}"/>
               </a:ext>
             </a:extLst>
           </p:cNvPr>
@@ -6405,7 +6405,7 @@
     </p:spTree>
     <p:extLst>
       <p:ext uri="{BB962C8B-B14F-4D97-AF65-F5344CB8AC3E}">
-        <p14:creationId xmlns:p14="http://schemas.microsoft.com/office/powerpoint/2010/main" val="497810941"/>
+        <p14:creationId xmlns:p14="http://schemas.microsoft.com/office/powerpoint/2010/main" val="1382775548"/>
       </p:ext>
     </p:extLst>
   </p:cSld>
@@ -6436,7 +6436,7 @@
           <p:cNvPr id="13" name="">
             <a:extLst xmlns:a="http://schemas.openxmlformats.org/drawingml/2006/main">
               <a:ext uri="{FF2B5EF4-FFF2-40B4-BE49-F238E27FC236}">
-                <a16:creationId xmlns:a16="http://schemas.microsoft.com/office/drawing/2014/main" id="{125733A0-3BBA-421B-9A82-83019414EECA}"/>
+                <a16:creationId xmlns:a16="http://schemas.microsoft.com/office/drawing/2014/main" id="{71ECCC22-4273-42C2-895F-132FDCF198F7}"/>
               </a:ext>
             </a:extLst>
           </p:cNvPr>
@@ -6497,7 +6497,7 @@
           <p:cNvPr id="2" name="">
             <a:extLst xmlns:a="http://schemas.openxmlformats.org/drawingml/2006/main">
               <a:ext uri="{FF2B5EF4-FFF2-40B4-BE49-F238E27FC236}">
-                <a16:creationId xmlns:a16="http://schemas.microsoft.com/office/drawing/2014/main" id="{1CF4215F-CBA8-4CCD-85D5-AE573E7EF7D8}"/>
+                <a16:creationId xmlns:a16="http://schemas.microsoft.com/office/drawing/2014/main" id="{4474C685-E7F1-4833-A9E9-2C941F0EBC01}"/>
               </a:ext>
             </a:extLst>
           </p:cNvPr>
@@ -6558,7 +6558,7 @@
           <p:cNvPr id="3" name="">
             <a:extLst xmlns:a="http://schemas.openxmlformats.org/drawingml/2006/main">
               <a:ext uri="{FF2B5EF4-FFF2-40B4-BE49-F238E27FC236}">
-                <a16:creationId xmlns:a16="http://schemas.microsoft.com/office/drawing/2014/main" id="{50781FC8-16C9-4EDD-AB2A-2D8181810B1E}"/>
+                <a16:creationId xmlns:a16="http://schemas.microsoft.com/office/drawing/2014/main" id="{717BF4C2-C186-4F11-8CB8-799F3021FDB2}"/>
               </a:ext>
             </a:extLst>
           </p:cNvPr>
@@ -6619,7 +6619,7 @@
           <p:cNvPr id="4" name="">
             <a:extLst xmlns:a="http://schemas.openxmlformats.org/drawingml/2006/main">
               <a:ext uri="{FF2B5EF4-FFF2-40B4-BE49-F238E27FC236}">
-                <a16:creationId xmlns:a16="http://schemas.microsoft.com/office/drawing/2014/main" id="{8EB8EF09-AE50-4E41-BD73-830F8F77A21F}"/>
+                <a16:creationId xmlns:a16="http://schemas.microsoft.com/office/drawing/2014/main" id="{6A111C45-9D21-4B06-94A3-127376222F71}"/>
               </a:ext>
             </a:extLst>
           </p:cNvPr>
@@ -6680,7 +6680,7 @@
           <p:cNvPr id="5" name="">
             <a:extLst xmlns:a="http://schemas.openxmlformats.org/drawingml/2006/main">
               <a:ext uri="{FF2B5EF4-FFF2-40B4-BE49-F238E27FC236}">
-                <a16:creationId xmlns:a16="http://schemas.microsoft.com/office/drawing/2014/main" id="{962E628B-DC06-45A4-9366-BF2905F0AFB4}"/>
+                <a16:creationId xmlns:a16="http://schemas.microsoft.com/office/drawing/2014/main" id="{135AA546-8DC4-4187-99C1-0C485989DAC8}"/>
               </a:ext>
             </a:extLst>
           </p:cNvPr>
@@ -6712,7 +6712,7 @@
           <p:cNvPr id="6" name="">
             <a:extLst xmlns:a="http://schemas.openxmlformats.org/drawingml/2006/main">
               <a:ext uri="{FF2B5EF4-FFF2-40B4-BE49-F238E27FC236}">
-                <a16:creationId xmlns:a16="http://schemas.microsoft.com/office/drawing/2014/main" id="{4E7B9483-5FC7-4C2C-A1B8-7A10005FD472}"/>
+                <a16:creationId xmlns:a16="http://schemas.microsoft.com/office/drawing/2014/main" id="{EB2DFEB1-40E6-457D-A362-3C18AF29C4E6}"/>
               </a:ext>
             </a:extLst>
           </p:cNvPr>
@@ -6744,7 +6744,7 @@
           <p:cNvPr id="7" name="">
             <a:extLst xmlns:a="http://schemas.openxmlformats.org/drawingml/2006/main">
               <a:ext uri="{FF2B5EF4-FFF2-40B4-BE49-F238E27FC236}">
-                <a16:creationId xmlns:a16="http://schemas.microsoft.com/office/drawing/2014/main" id="{24CAFBB3-9983-4F93-9998-BBA62D219909}"/>
+                <a16:creationId xmlns:a16="http://schemas.microsoft.com/office/drawing/2014/main" id="{16464D98-E8DC-4421-80E2-B7DF292143AD}"/>
               </a:ext>
             </a:extLst>
           </p:cNvPr>
@@ -6776,7 +6776,7 @@
           <p:cNvPr id="8" name="">
             <a:extLst xmlns:a="http://schemas.openxmlformats.org/drawingml/2006/main">
               <a:ext uri="{FF2B5EF4-FFF2-40B4-BE49-F238E27FC236}">
-                <a16:creationId xmlns:a16="http://schemas.microsoft.com/office/drawing/2014/main" id="{C83D141F-81FF-48D3-8EC5-92C67999E5B8}"/>
+                <a16:creationId xmlns:a16="http://schemas.microsoft.com/office/drawing/2014/main" id="{F443B9AA-A198-4E27-A372-54AC501572C6}"/>
               </a:ext>
             </a:extLst>
           </p:cNvPr>
@@ -6837,7 +6837,7 @@
           <p:cNvPr id="9" name="">
             <a:extLst xmlns:a="http://schemas.openxmlformats.org/drawingml/2006/main">
               <a:ext uri="{FF2B5EF4-FFF2-40B4-BE49-F238E27FC236}">
-                <a16:creationId xmlns:a16="http://schemas.microsoft.com/office/drawing/2014/main" id="{5CD6C42F-4C7D-4EDC-9A30-BDDF0A8E0206}"/>
+                <a16:creationId xmlns:a16="http://schemas.microsoft.com/office/drawing/2014/main" id="{DC50E332-DB30-4FFC-B611-ADA0B97484DC}"/>
               </a:ext>
             </a:extLst>
           </p:cNvPr>
@@ -6925,7 +6925,7 @@
           <p:cNvPr id="10" name="">
             <a:extLst xmlns:a="http://schemas.openxmlformats.org/drawingml/2006/main">
               <a:ext uri="{FF2B5EF4-FFF2-40B4-BE49-F238E27FC236}">
-                <a16:creationId xmlns:a16="http://schemas.microsoft.com/office/drawing/2014/main" id="{EF1EB717-FB68-4D01-B9E0-46479DBCFB66}"/>
+                <a16:creationId xmlns:a16="http://schemas.microsoft.com/office/drawing/2014/main" id="{4AFA2661-7147-433A-8EC0-615637E1E497}"/>
               </a:ext>
             </a:extLst>
           </p:cNvPr>
@@ -6986,7 +6986,7 @@
           <p:cNvPr id="11" name="">
             <a:extLst xmlns:a="http://schemas.openxmlformats.org/drawingml/2006/main">
               <a:ext uri="{FF2B5EF4-FFF2-40B4-BE49-F238E27FC236}">
-                <a16:creationId xmlns:a16="http://schemas.microsoft.com/office/drawing/2014/main" id="{D5700F16-B0B2-41DC-ACC0-22E34655F8C4}"/>
+                <a16:creationId xmlns:a16="http://schemas.microsoft.com/office/drawing/2014/main" id="{02856795-CA21-46FA-B441-94C7C143BF2E}"/>
               </a:ext>
             </a:extLst>
           </p:cNvPr>
@@ -7074,7 +7074,7 @@
           <p:cNvPr id="12" name="">
             <a:extLst xmlns:a="http://schemas.openxmlformats.org/drawingml/2006/main">
               <a:ext uri="{FF2B5EF4-FFF2-40B4-BE49-F238E27FC236}">
-                <a16:creationId xmlns:a16="http://schemas.microsoft.com/office/drawing/2014/main" id="{9826ABAB-F4FE-4C95-8766-0EFF7FA27A1B}"/>
+                <a16:creationId xmlns:a16="http://schemas.microsoft.com/office/drawing/2014/main" id="{535A70E8-F89B-49B7-8A2F-B86DA86CC8EC}"/>
               </a:ext>
             </a:extLst>
           </p:cNvPr>
@@ -7133,7 +7133,7 @@
     </p:spTree>
     <p:extLst>
       <p:ext uri="{BB962C8B-B14F-4D97-AF65-F5344CB8AC3E}">
-        <p14:creationId xmlns:p14="http://schemas.microsoft.com/office/powerpoint/2010/main" val="739812780"/>
+        <p14:creationId xmlns:p14="http://schemas.microsoft.com/office/powerpoint/2010/main" val="1665718494"/>
       </p:ext>
     </p:extLst>
   </p:cSld>
@@ -7164,7 +7164,7 @@
           <p:cNvPr id="10" name="">
             <a:extLst xmlns:a="http://schemas.openxmlformats.org/drawingml/2006/main">
               <a:ext uri="{FF2B5EF4-FFF2-40B4-BE49-F238E27FC236}">
-                <a16:creationId xmlns:a16="http://schemas.microsoft.com/office/drawing/2014/main" id="{90156A52-C0DE-449C-8F1F-DB1402BBB31C}"/>
+                <a16:creationId xmlns:a16="http://schemas.microsoft.com/office/drawing/2014/main" id="{15719034-9B5E-4CE1-B283-6DC4D9164FA8}"/>
               </a:ext>
             </a:extLst>
           </p:cNvPr>
@@ -7225,7 +7225,7 @@
           <p:cNvPr id="2" name="">
             <a:extLst xmlns:a="http://schemas.openxmlformats.org/drawingml/2006/main">
               <a:ext uri="{FF2B5EF4-FFF2-40B4-BE49-F238E27FC236}">
-                <a16:creationId xmlns:a16="http://schemas.microsoft.com/office/drawing/2014/main" id="{6D4035FC-B2DB-4B40-86B4-F6D89841B1C6}"/>
+                <a16:creationId xmlns:a16="http://schemas.microsoft.com/office/drawing/2014/main" id="{908A57E3-9A6B-4D18-ABB3-DE08E4B3D275}"/>
               </a:ext>
             </a:extLst>
           </p:cNvPr>
@@ -7286,7 +7286,7 @@
           <p:cNvPr id="3" name="">
             <a:extLst xmlns:a="http://schemas.openxmlformats.org/drawingml/2006/main">
               <a:ext uri="{FF2B5EF4-FFF2-40B4-BE49-F238E27FC236}">
-                <a16:creationId xmlns:a16="http://schemas.microsoft.com/office/drawing/2014/main" id="{7E095B83-B9E7-4224-8D88-2748E88385A9}"/>
+                <a16:creationId xmlns:a16="http://schemas.microsoft.com/office/drawing/2014/main" id="{8D145E1C-D732-4AE9-9693-49437C45429E}"/>
               </a:ext>
             </a:extLst>
           </p:cNvPr>
@@ -7347,7 +7347,7 @@
           <p:cNvPr id="4" name="">
             <a:extLst xmlns:a="http://schemas.openxmlformats.org/drawingml/2006/main">
               <a:ext uri="{FF2B5EF4-FFF2-40B4-BE49-F238E27FC236}">
-                <a16:creationId xmlns:a16="http://schemas.microsoft.com/office/drawing/2014/main" id="{F6D209D4-A886-451F-A6D2-BC446A726B20}"/>
+                <a16:creationId xmlns:a16="http://schemas.microsoft.com/office/drawing/2014/main" id="{DE630E7B-EF49-4F2D-906E-93A92ADF8ED8}"/>
               </a:ext>
             </a:extLst>
           </p:cNvPr>
@@ -7408,7 +7408,7 @@
           <p:cNvPr id="5" name="">
             <a:extLst xmlns:a="http://schemas.openxmlformats.org/drawingml/2006/main">
               <a:ext uri="{FF2B5EF4-FFF2-40B4-BE49-F238E27FC236}">
-                <a16:creationId xmlns:a16="http://schemas.microsoft.com/office/drawing/2014/main" id="{F9483DA7-B777-4E03-BD27-F3CA01999DE5}"/>
+                <a16:creationId xmlns:a16="http://schemas.microsoft.com/office/drawing/2014/main" id="{1081F04D-7249-44B8-A2E4-88DA5956F488}"/>
               </a:ext>
             </a:extLst>
           </p:cNvPr>
@@ -7438,7 +7438,7 @@
           <p:cNvPr id="6" name="">
             <a:extLst xmlns:a="http://schemas.openxmlformats.org/drawingml/2006/main">
               <a:ext uri="{FF2B5EF4-FFF2-40B4-BE49-F238E27FC236}">
-                <a16:creationId xmlns:a16="http://schemas.microsoft.com/office/drawing/2014/main" id="{9DB9DB9B-C7E9-44F6-9604-46A481E7C457}"/>
+                <a16:creationId xmlns:a16="http://schemas.microsoft.com/office/drawing/2014/main" id="{6ECB7DF9-A72E-4C9C-AE0D-EA3B2C457F5F}"/>
               </a:ext>
             </a:extLst>
           </p:cNvPr>
@@ -7499,7 +7499,7 @@
           <p:cNvPr id="7" name="">
             <a:extLst xmlns:a="http://schemas.openxmlformats.org/drawingml/2006/main">
               <a:ext uri="{FF2B5EF4-FFF2-40B4-BE49-F238E27FC236}">
-                <a16:creationId xmlns:a16="http://schemas.microsoft.com/office/drawing/2014/main" id="{88D3127A-21BB-44E2-9D13-75D9E955FB5F}"/>
+                <a16:creationId xmlns:a16="http://schemas.microsoft.com/office/drawing/2014/main" id="{D0C8AAA1-CCC2-41B4-863B-926D77636DE1}"/>
               </a:ext>
             </a:extLst>
           </p:cNvPr>
@@ -7560,7 +7560,7 @@
           <p:cNvPr id="8" name="">
             <a:extLst xmlns:a="http://schemas.openxmlformats.org/drawingml/2006/main">
               <a:ext uri="{FF2B5EF4-FFF2-40B4-BE49-F238E27FC236}">
-                <a16:creationId xmlns:a16="http://schemas.microsoft.com/office/drawing/2014/main" id="{18846336-8DA6-435B-92C2-0707ACC7413E}"/>
+                <a16:creationId xmlns:a16="http://schemas.microsoft.com/office/drawing/2014/main" id="{6F383AE9-0A4B-4A8C-894D-C06B41FC2681}"/>
               </a:ext>
             </a:extLst>
           </p:cNvPr>
@@ -7625,7 +7625,7 @@
           <p:cNvPr id="9" name="">
             <a:extLst xmlns:a="http://schemas.openxmlformats.org/drawingml/2006/main">
               <a:ext uri="{FF2B5EF4-FFF2-40B4-BE49-F238E27FC236}">
-                <a16:creationId xmlns:a16="http://schemas.microsoft.com/office/drawing/2014/main" id="{F37040FD-C694-4B10-B8D9-C8D2ED9234AC}"/>
+                <a16:creationId xmlns:a16="http://schemas.microsoft.com/office/drawing/2014/main" id="{FB88CB5D-81CC-401B-BFAC-DF0A3A674130}"/>
               </a:ext>
             </a:extLst>
           </p:cNvPr>
@@ -7684,7 +7684,7 @@
     </p:spTree>
     <p:extLst>
       <p:ext uri="{BB962C8B-B14F-4D97-AF65-F5344CB8AC3E}">
-        <p14:creationId xmlns:p14="http://schemas.microsoft.com/office/powerpoint/2010/main" val="171997612"/>
+        <p14:creationId xmlns:p14="http://schemas.microsoft.com/office/powerpoint/2010/main" val="237071488"/>
       </p:ext>
     </p:extLst>
   </p:cSld>
@@ -7715,7 +7715,7 @@
           <p:cNvPr id="11" name="">
             <a:extLst xmlns:a="http://schemas.openxmlformats.org/drawingml/2006/main">
               <a:ext uri="{FF2B5EF4-FFF2-40B4-BE49-F238E27FC236}">
-                <a16:creationId xmlns:a16="http://schemas.microsoft.com/office/drawing/2014/main" id="{8CA30738-DFB9-4D19-AEC1-40143791648B}"/>
+                <a16:creationId xmlns:a16="http://schemas.microsoft.com/office/drawing/2014/main" id="{5AFB157D-5E82-4B7C-A696-7AB2FBE48B85}"/>
               </a:ext>
             </a:extLst>
           </p:cNvPr>
@@ -7776,7 +7776,7 @@
           <p:cNvPr id="2" name="">
             <a:extLst xmlns:a="http://schemas.openxmlformats.org/drawingml/2006/main">
               <a:ext uri="{FF2B5EF4-FFF2-40B4-BE49-F238E27FC236}">
-                <a16:creationId xmlns:a16="http://schemas.microsoft.com/office/drawing/2014/main" id="{CDEBEE83-AA57-499D-8121-7E6229CBD9BC}"/>
+                <a16:creationId xmlns:a16="http://schemas.microsoft.com/office/drawing/2014/main" id="{9942C34A-2EE6-4AF7-8FC6-B99485281D15}"/>
               </a:ext>
             </a:extLst>
           </p:cNvPr>
@@ -7837,7 +7837,7 @@
           <p:cNvPr id="3" name="">
             <a:extLst xmlns:a="http://schemas.openxmlformats.org/drawingml/2006/main">
               <a:ext uri="{FF2B5EF4-FFF2-40B4-BE49-F238E27FC236}">
-                <a16:creationId xmlns:a16="http://schemas.microsoft.com/office/drawing/2014/main" id="{94548E16-C0C0-47F7-9EA5-79BF86FD420A}"/>
+                <a16:creationId xmlns:a16="http://schemas.microsoft.com/office/drawing/2014/main" id="{4551675E-503A-4BDF-AA27-DEF4E7EAF67A}"/>
               </a:ext>
             </a:extLst>
           </p:cNvPr>
@@ -7898,7 +7898,7 @@
           <p:cNvPr id="4" name="">
             <a:extLst xmlns:a="http://schemas.openxmlformats.org/drawingml/2006/main">
               <a:ext uri="{FF2B5EF4-FFF2-40B4-BE49-F238E27FC236}">
-                <a16:creationId xmlns:a16="http://schemas.microsoft.com/office/drawing/2014/main" id="{78FBD84E-25BD-49AE-B3FD-C3016A9A728A}"/>
+                <a16:creationId xmlns:a16="http://schemas.microsoft.com/office/drawing/2014/main" id="{EA8A55FB-AC76-4AC4-BA15-0E868DF146BD}"/>
               </a:ext>
             </a:extLst>
           </p:cNvPr>
@@ -7959,7 +7959,7 @@
           <p:cNvPr id="5" name="">
             <a:extLst xmlns:a="http://schemas.openxmlformats.org/drawingml/2006/main">
               <a:ext uri="{FF2B5EF4-FFF2-40B4-BE49-F238E27FC236}">
-                <a16:creationId xmlns:a16="http://schemas.microsoft.com/office/drawing/2014/main" id="{A4E423B3-E9D2-4298-A11B-ACCEB690C911}"/>
+                <a16:creationId xmlns:a16="http://schemas.microsoft.com/office/drawing/2014/main" id="{6C987443-6CE0-42CC-B256-A1025636C54A}"/>
               </a:ext>
             </a:extLst>
           </p:cNvPr>
@@ -8020,7 +8020,7 @@
           <p:cNvPr id="6" name="">
             <a:extLst xmlns:a="http://schemas.openxmlformats.org/drawingml/2006/main">
               <a:ext uri="{FF2B5EF4-FFF2-40B4-BE49-F238E27FC236}">
-                <a16:creationId xmlns:a16="http://schemas.microsoft.com/office/drawing/2014/main" id="{00716AAF-BF62-4620-AC0E-EBDFBE1E609C}"/>
+                <a16:creationId xmlns:a16="http://schemas.microsoft.com/office/drawing/2014/main" id="{CB3F1DB4-21E7-4EFF-99BF-759A55787F86}"/>
               </a:ext>
             </a:extLst>
           </p:cNvPr>
@@ -8081,7 +8081,7 @@
           <p:cNvPr id="7" name="">
             <a:extLst xmlns:a="http://schemas.openxmlformats.org/drawingml/2006/main">
               <a:ext uri="{FF2B5EF4-FFF2-40B4-BE49-F238E27FC236}">
-                <a16:creationId xmlns:a16="http://schemas.microsoft.com/office/drawing/2014/main" id="{F71C8F33-DD72-4848-ACEC-86F9714F756D}"/>
+                <a16:creationId xmlns:a16="http://schemas.microsoft.com/office/drawing/2014/main" id="{C458E028-7290-474E-985B-11027946C73C}"/>
               </a:ext>
             </a:extLst>
           </p:cNvPr>
@@ -8142,7 +8142,7 @@
           <p:cNvPr id="8" name="">
             <a:extLst xmlns:a="http://schemas.openxmlformats.org/drawingml/2006/main">
               <a:ext uri="{FF2B5EF4-FFF2-40B4-BE49-F238E27FC236}">
-                <a16:creationId xmlns:a16="http://schemas.microsoft.com/office/drawing/2014/main" id="{1AE3DBC2-F26A-4E4E-8F5A-1EDBA3322D6D}"/>
+                <a16:creationId xmlns:a16="http://schemas.microsoft.com/office/drawing/2014/main" id="{9D5A446C-750B-4A08-961C-3A22DD110970}"/>
               </a:ext>
             </a:extLst>
           </p:cNvPr>
@@ -8207,7 +8207,7 @@
           <p:cNvPr id="9" name="">
             <a:extLst xmlns:a="http://schemas.openxmlformats.org/drawingml/2006/main">
               <a:ext uri="{FF2B5EF4-FFF2-40B4-BE49-F238E27FC236}">
-                <a16:creationId xmlns:a16="http://schemas.microsoft.com/office/drawing/2014/main" id="{DFA83DAF-063C-498F-80BD-B9C94BEC4708}"/>
+                <a16:creationId xmlns:a16="http://schemas.microsoft.com/office/drawing/2014/main" id="{1A551B07-1CA1-4E89-A068-419243D503E7}"/>
               </a:ext>
             </a:extLst>
           </p:cNvPr>
@@ -8237,7 +8237,7 @@
           <p:cNvPr id="10" name="">
             <a:extLst xmlns:a="http://schemas.openxmlformats.org/drawingml/2006/main">
               <a:ext uri="{FF2B5EF4-FFF2-40B4-BE49-F238E27FC236}">
-                <a16:creationId xmlns:a16="http://schemas.microsoft.com/office/drawing/2014/main" id="{0C92AE42-C618-4E63-8625-BE3BCC4A20C9}"/>
+                <a16:creationId xmlns:a16="http://schemas.microsoft.com/office/drawing/2014/main" id="{1D3F5E08-89A0-4C77-B5C1-A309741EC0EB}"/>
               </a:ext>
             </a:extLst>
           </p:cNvPr>
@@ -8296,7 +8296,7 @@
     </p:spTree>
     <p:extLst>
       <p:ext uri="{BB962C8B-B14F-4D97-AF65-F5344CB8AC3E}">
-        <p14:creationId xmlns:p14="http://schemas.microsoft.com/office/powerpoint/2010/main" val="1320522193"/>
+        <p14:creationId xmlns:p14="http://schemas.microsoft.com/office/powerpoint/2010/main" val="1353726075"/>
       </p:ext>
     </p:extLst>
   </p:cSld>
@@ -8327,7 +8327,7 @@
           <p:cNvPr id="11" name="">
             <a:extLst xmlns:a="http://schemas.openxmlformats.org/drawingml/2006/main">
               <a:ext uri="{FF2B5EF4-FFF2-40B4-BE49-F238E27FC236}">
-                <a16:creationId xmlns:a16="http://schemas.microsoft.com/office/drawing/2014/main" id="{3DAC663B-E01A-49F5-916F-BAF03E411D36}"/>
+                <a16:creationId xmlns:a16="http://schemas.microsoft.com/office/drawing/2014/main" id="{59F90FCD-A3DB-408D-B05F-77A60AC0A94F}"/>
               </a:ext>
             </a:extLst>
           </p:cNvPr>
@@ -8388,7 +8388,7 @@
           <p:cNvPr id="2" name="">
             <a:extLst xmlns:a="http://schemas.openxmlformats.org/drawingml/2006/main">
               <a:ext uri="{FF2B5EF4-FFF2-40B4-BE49-F238E27FC236}">
-                <a16:creationId xmlns:a16="http://schemas.microsoft.com/office/drawing/2014/main" id="{6B925A1A-1D9A-4899-BCF8-67DD328E6225}"/>
+                <a16:creationId xmlns:a16="http://schemas.microsoft.com/office/drawing/2014/main" id="{EC599D7C-0234-4103-8236-97566136BC11}"/>
               </a:ext>
             </a:extLst>
           </p:cNvPr>
@@ -8449,7 +8449,7 @@
           <p:cNvPr id="3" name="">
             <a:extLst xmlns:a="http://schemas.openxmlformats.org/drawingml/2006/main">
               <a:ext uri="{FF2B5EF4-FFF2-40B4-BE49-F238E27FC236}">
-                <a16:creationId xmlns:a16="http://schemas.microsoft.com/office/drawing/2014/main" id="{5B0ED21B-63D6-4CFD-9157-6C42AAAFB1B8}"/>
+                <a16:creationId xmlns:a16="http://schemas.microsoft.com/office/drawing/2014/main" id="{E3227514-A0F1-4428-B63B-A0C6A21FD219}"/>
               </a:ext>
             </a:extLst>
           </p:cNvPr>
@@ -8510,7 +8510,7 @@
           <p:cNvPr id="4" name="">
             <a:extLst xmlns:a="http://schemas.openxmlformats.org/drawingml/2006/main">
               <a:ext uri="{FF2B5EF4-FFF2-40B4-BE49-F238E27FC236}">
-                <a16:creationId xmlns:a16="http://schemas.microsoft.com/office/drawing/2014/main" id="{3CEFD9E9-796F-4CBF-A0D4-F59E26EE98F2}"/>
+                <a16:creationId xmlns:a16="http://schemas.microsoft.com/office/drawing/2014/main" id="{95DC753B-56C7-4700-A83D-ED65C1ACAD20}"/>
               </a:ext>
             </a:extLst>
           </p:cNvPr>
@@ -8575,7 +8575,7 @@
           <p:cNvPr id="5" name="">
             <a:extLst xmlns:a="http://schemas.openxmlformats.org/drawingml/2006/main">
               <a:ext uri="{FF2B5EF4-FFF2-40B4-BE49-F238E27FC236}">
-                <a16:creationId xmlns:a16="http://schemas.microsoft.com/office/drawing/2014/main" id="{02635BB8-94B2-4E37-814D-9D927B816758}"/>
+                <a16:creationId xmlns:a16="http://schemas.microsoft.com/office/drawing/2014/main" id="{1546D25F-EC70-40B7-A9F2-F4B900952592}"/>
               </a:ext>
             </a:extLst>
           </p:cNvPr>
@@ -8636,7 +8636,7 @@
           <p:cNvPr id="6" name="">
             <a:extLst xmlns:a="http://schemas.openxmlformats.org/drawingml/2006/main">
               <a:ext uri="{FF2B5EF4-FFF2-40B4-BE49-F238E27FC236}">
-                <a16:creationId xmlns:a16="http://schemas.microsoft.com/office/drawing/2014/main" id="{6BCF5712-AE47-4C82-9CD6-44932858E906}"/>
+                <a16:creationId xmlns:a16="http://schemas.microsoft.com/office/drawing/2014/main" id="{BA9836A4-74F1-45A8-A387-BA8CEA7081B2}"/>
               </a:ext>
             </a:extLst>
           </p:cNvPr>
@@ -8701,7 +8701,7 @@
           <p:cNvPr id="7" name="">
             <a:extLst xmlns:a="http://schemas.openxmlformats.org/drawingml/2006/main">
               <a:ext uri="{FF2B5EF4-FFF2-40B4-BE49-F238E27FC236}">
-                <a16:creationId xmlns:a16="http://schemas.microsoft.com/office/drawing/2014/main" id="{DE36CB9C-EB75-46A8-8DC5-01B39E085958}"/>
+                <a16:creationId xmlns:a16="http://schemas.microsoft.com/office/drawing/2014/main" id="{B3D55130-EC70-4C7F-AE46-6BCA04C6D6D9}"/>
               </a:ext>
             </a:extLst>
           </p:cNvPr>
@@ -8731,7 +8731,7 @@
           <p:cNvPr id="8" name="">
             <a:extLst xmlns:a="http://schemas.openxmlformats.org/drawingml/2006/main">
               <a:ext uri="{FF2B5EF4-FFF2-40B4-BE49-F238E27FC236}">
-                <a16:creationId xmlns:a16="http://schemas.microsoft.com/office/drawing/2014/main" id="{2B47886A-53D2-4AA6-85E7-A27B44C38A75}"/>
+                <a16:creationId xmlns:a16="http://schemas.microsoft.com/office/drawing/2014/main" id="{23C650F7-7FBB-459C-A979-899A96E1413E}"/>
               </a:ext>
             </a:extLst>
           </p:cNvPr>
@@ -8792,7 +8792,7 @@
           <p:cNvPr id="9" name="">
             <a:extLst xmlns:a="http://schemas.openxmlformats.org/drawingml/2006/main">
               <a:ext uri="{FF2B5EF4-FFF2-40B4-BE49-F238E27FC236}">
-                <a16:creationId xmlns:a16="http://schemas.microsoft.com/office/drawing/2014/main" id="{F91BE6DE-359A-4B5D-A855-DA7ABEDEFF63}"/>
+                <a16:creationId xmlns:a16="http://schemas.microsoft.com/office/drawing/2014/main" id="{5DAA1BA0-C1AE-4BF3-9A39-80E38CB74C32}"/>
               </a:ext>
             </a:extLst>
           </p:cNvPr>
@@ -8853,7 +8853,7 @@
           <p:cNvPr id="10" name="">
             <a:extLst xmlns:a="http://schemas.openxmlformats.org/drawingml/2006/main">
               <a:ext uri="{FF2B5EF4-FFF2-40B4-BE49-F238E27FC236}">
-                <a16:creationId xmlns:a16="http://schemas.microsoft.com/office/drawing/2014/main" id="{1C706020-ACBA-43C8-8D41-ADFDAF314DC3}"/>
+                <a16:creationId xmlns:a16="http://schemas.microsoft.com/office/drawing/2014/main" id="{47A71B80-DAC8-47B3-99EB-230047E20A79}"/>
               </a:ext>
             </a:extLst>
           </p:cNvPr>
@@ -8912,7 +8912,7 @@
     </p:spTree>
     <p:extLst>
       <p:ext uri="{BB962C8B-B14F-4D97-AF65-F5344CB8AC3E}">
-        <p14:creationId xmlns:p14="http://schemas.microsoft.com/office/powerpoint/2010/main" val="113350276"/>
+        <p14:creationId xmlns:p14="http://schemas.microsoft.com/office/powerpoint/2010/main" val="25978558"/>
       </p:ext>
     </p:extLst>
   </p:cSld>
@@ -8943,7 +8943,7 @@
           <p:cNvPr id="13" name="">
             <a:extLst xmlns:a="http://schemas.openxmlformats.org/drawingml/2006/main">
               <a:ext uri="{FF2B5EF4-FFF2-40B4-BE49-F238E27FC236}">
-                <a16:creationId xmlns:a16="http://schemas.microsoft.com/office/drawing/2014/main" id="{270DFEEE-0324-40D7-B571-2A890B122B19}"/>
+                <a16:creationId xmlns:a16="http://schemas.microsoft.com/office/drawing/2014/main" id="{06999A42-03F9-46CE-83A3-5E9CFC718D20}"/>
               </a:ext>
             </a:extLst>
           </p:cNvPr>
@@ -9004,7 +9004,7 @@
           <p:cNvPr id="2" name="">
             <a:extLst xmlns:a="http://schemas.openxmlformats.org/drawingml/2006/main">
               <a:ext uri="{FF2B5EF4-FFF2-40B4-BE49-F238E27FC236}">
-                <a16:creationId xmlns:a16="http://schemas.microsoft.com/office/drawing/2014/main" id="{089FB8E3-08A1-4C4A-B3BD-C55C99F2E69F}"/>
+                <a16:creationId xmlns:a16="http://schemas.microsoft.com/office/drawing/2014/main" id="{56F53011-D6CC-48EE-94C8-6F5B77BF4364}"/>
               </a:ext>
             </a:extLst>
           </p:cNvPr>
@@ -9065,7 +9065,7 @@
           <p:cNvPr id="3" name="">
             <a:extLst xmlns:a="http://schemas.openxmlformats.org/drawingml/2006/main">
               <a:ext uri="{FF2B5EF4-FFF2-40B4-BE49-F238E27FC236}">
-                <a16:creationId xmlns:a16="http://schemas.microsoft.com/office/drawing/2014/main" id="{8AA8378B-2098-4688-A5BA-15CC42697616}"/>
+                <a16:creationId xmlns:a16="http://schemas.microsoft.com/office/drawing/2014/main" id="{2BAD3DD4-FD2D-42E1-AB4C-A1B02898C426}"/>
               </a:ext>
             </a:extLst>
           </p:cNvPr>
@@ -9126,7 +9126,7 @@
           <p:cNvPr id="4" name="">
             <a:extLst xmlns:a="http://schemas.openxmlformats.org/drawingml/2006/main">
               <a:ext uri="{FF2B5EF4-FFF2-40B4-BE49-F238E27FC236}">
-                <a16:creationId xmlns:a16="http://schemas.microsoft.com/office/drawing/2014/main" id="{E3D57745-5400-4721-A85F-6BC7B774CA7D}"/>
+                <a16:creationId xmlns:a16="http://schemas.microsoft.com/office/drawing/2014/main" id="{2A3B462F-B7A7-4F83-A6E9-387472567DF8}"/>
               </a:ext>
             </a:extLst>
           </p:cNvPr>
@@ -9187,7 +9187,7 @@
           <p:cNvPr id="5" name="">
             <a:extLst xmlns:a="http://schemas.openxmlformats.org/drawingml/2006/main">
               <a:ext uri="{FF2B5EF4-FFF2-40B4-BE49-F238E27FC236}">
-                <a16:creationId xmlns:a16="http://schemas.microsoft.com/office/drawing/2014/main" id="{EE53AAAF-9E47-4488-9EB9-89C64D4EB062}"/>
+                <a16:creationId xmlns:a16="http://schemas.microsoft.com/office/drawing/2014/main" id="{14120CD4-CC8C-4344-B30F-EC931EA2C38B}"/>
               </a:ext>
             </a:extLst>
           </p:cNvPr>
@@ -9248,7 +9248,7 @@
           <p:cNvPr id="6" name="">
             <a:extLst xmlns:a="http://schemas.openxmlformats.org/drawingml/2006/main">
               <a:ext uri="{FF2B5EF4-FFF2-40B4-BE49-F238E27FC236}">
-                <a16:creationId xmlns:a16="http://schemas.microsoft.com/office/drawing/2014/main" id="{882330B4-9995-41CD-9150-1FB66599F0EB}"/>
+                <a16:creationId xmlns:a16="http://schemas.microsoft.com/office/drawing/2014/main" id="{4D250EBA-5925-4908-8030-9A3AD9CCE630}"/>
               </a:ext>
             </a:extLst>
           </p:cNvPr>
@@ -9309,7 +9309,7 @@
           <p:cNvPr id="7" name="">
             <a:extLst xmlns:a="http://schemas.openxmlformats.org/drawingml/2006/main">
               <a:ext uri="{FF2B5EF4-FFF2-40B4-BE49-F238E27FC236}">
-                <a16:creationId xmlns:a16="http://schemas.microsoft.com/office/drawing/2014/main" id="{BEE1CB86-66DD-44EF-8B74-A46101F06403}"/>
+                <a16:creationId xmlns:a16="http://schemas.microsoft.com/office/drawing/2014/main" id="{DB712A57-E42D-4C30-B526-B42ADCF0558A}"/>
               </a:ext>
             </a:extLst>
           </p:cNvPr>
@@ -9339,7 +9339,7 @@
           <p:cNvPr id="8" name="">
             <a:extLst xmlns:a="http://schemas.openxmlformats.org/drawingml/2006/main">
               <a:ext uri="{FF2B5EF4-FFF2-40B4-BE49-F238E27FC236}">
-                <a16:creationId xmlns:a16="http://schemas.microsoft.com/office/drawing/2014/main" id="{CC9B3B90-031B-4606-820F-342BCF6CAA85}"/>
+                <a16:creationId xmlns:a16="http://schemas.microsoft.com/office/drawing/2014/main" id="{9C2B623C-9D27-445E-A978-209ED531EF26}"/>
               </a:ext>
             </a:extLst>
           </p:cNvPr>
@@ -9400,7 +9400,7 @@
           <p:cNvPr id="9" name="">
             <a:extLst xmlns:a="http://schemas.openxmlformats.org/drawingml/2006/main">
               <a:ext uri="{FF2B5EF4-FFF2-40B4-BE49-F238E27FC236}">
-                <a16:creationId xmlns:a16="http://schemas.microsoft.com/office/drawing/2014/main" id="{66A32F58-0F3D-4231-BD31-E932868AFE31}"/>
+                <a16:creationId xmlns:a16="http://schemas.microsoft.com/office/drawing/2014/main" id="{037FCE09-46A8-4809-9EBE-25B068F44667}"/>
               </a:ext>
             </a:extLst>
           </p:cNvPr>
@@ -9461,7 +9461,7 @@
           <p:cNvPr id="10" name="">
             <a:extLst xmlns:a="http://schemas.openxmlformats.org/drawingml/2006/main">
               <a:ext uri="{FF2B5EF4-FFF2-40B4-BE49-F238E27FC236}">
-                <a16:creationId xmlns:a16="http://schemas.microsoft.com/office/drawing/2014/main" id="{B2C116FA-602B-4BF9-BC18-8E8232359E0C}"/>
+                <a16:creationId xmlns:a16="http://schemas.microsoft.com/office/drawing/2014/main" id="{2EB15438-1E94-4A0D-B74C-AE09358C41E3}"/>
               </a:ext>
             </a:extLst>
           </p:cNvPr>
@@ -9522,7 +9522,7 @@
           <p:cNvPr id="11" name="">
             <a:extLst xmlns:a="http://schemas.openxmlformats.org/drawingml/2006/main">
               <a:ext uri="{FF2B5EF4-FFF2-40B4-BE49-F238E27FC236}">
-                <a16:creationId xmlns:a16="http://schemas.microsoft.com/office/drawing/2014/main" id="{7DF6ADD4-C724-4A8B-8F2F-0DD643360AF6}"/>
+                <a16:creationId xmlns:a16="http://schemas.microsoft.com/office/drawing/2014/main" id="{547888F6-CC2B-4EBE-874B-28865CC94C1A}"/>
               </a:ext>
             </a:extLst>
           </p:cNvPr>
@@ -9583,7 +9583,7 @@
           <p:cNvPr id="12" name="">
             <a:extLst xmlns:a="http://schemas.openxmlformats.org/drawingml/2006/main">
               <a:ext uri="{FF2B5EF4-FFF2-40B4-BE49-F238E27FC236}">
-                <a16:creationId xmlns:a16="http://schemas.microsoft.com/office/drawing/2014/main" id="{749ACE2C-EF02-4206-974E-AF301AC7A2AF}"/>
+                <a16:creationId xmlns:a16="http://schemas.microsoft.com/office/drawing/2014/main" id="{4E494F64-5DAA-44EA-8F74-9FB75244BF9F}"/>
               </a:ext>
             </a:extLst>
           </p:cNvPr>
@@ -9642,7 +9642,7 @@
     </p:spTree>
     <p:extLst>
       <p:ext uri="{BB962C8B-B14F-4D97-AF65-F5344CB8AC3E}">
-        <p14:creationId xmlns:p14="http://schemas.microsoft.com/office/powerpoint/2010/main" val="911322587"/>
+        <p14:creationId xmlns:p14="http://schemas.microsoft.com/office/powerpoint/2010/main" val="622263546"/>
       </p:ext>
     </p:extLst>
   </p:cSld>
@@ -9673,7 +9673,7 @@
           <p:cNvPr id="13" name="">
             <a:extLst xmlns:a="http://schemas.openxmlformats.org/drawingml/2006/main">
               <a:ext uri="{FF2B5EF4-FFF2-40B4-BE49-F238E27FC236}">
-                <a16:creationId xmlns:a16="http://schemas.microsoft.com/office/drawing/2014/main" id="{B0A531EE-A7E1-45F7-9219-0570F7B7F5D2}"/>
+                <a16:creationId xmlns:a16="http://schemas.microsoft.com/office/drawing/2014/main" id="{EBFD042D-1719-4E39-A45A-23FABB28179D}"/>
               </a:ext>
             </a:extLst>
           </p:cNvPr>
@@ -9734,7 +9734,7 @@
           <p:cNvPr id="2" name="">
             <a:extLst xmlns:a="http://schemas.openxmlformats.org/drawingml/2006/main">
               <a:ext uri="{FF2B5EF4-FFF2-40B4-BE49-F238E27FC236}">
-                <a16:creationId xmlns:a16="http://schemas.microsoft.com/office/drawing/2014/main" id="{E11FA788-80A8-45A2-815C-D6ABC4B112DF}"/>
+                <a16:creationId xmlns:a16="http://schemas.microsoft.com/office/drawing/2014/main" id="{CEAC0518-0C54-4B39-A485-0B3DD5077BCF}"/>
               </a:ext>
             </a:extLst>
           </p:cNvPr>
@@ -9795,7 +9795,7 @@
           <p:cNvPr id="3" name="">
             <a:extLst xmlns:a="http://schemas.openxmlformats.org/drawingml/2006/main">
               <a:ext uri="{FF2B5EF4-FFF2-40B4-BE49-F238E27FC236}">
-                <a16:creationId xmlns:a16="http://schemas.microsoft.com/office/drawing/2014/main" id="{A2B534FB-09D7-4ECB-A053-1275F6DB5970}"/>
+                <a16:creationId xmlns:a16="http://schemas.microsoft.com/office/drawing/2014/main" id="{5E452FED-CA11-4F7C-8404-4723A9D2DB72}"/>
               </a:ext>
             </a:extLst>
           </p:cNvPr>
@@ -9856,7 +9856,7 @@
           <p:cNvPr id="4" name="">
             <a:extLst xmlns:a="http://schemas.openxmlformats.org/drawingml/2006/main">
               <a:ext uri="{FF2B5EF4-FFF2-40B4-BE49-F238E27FC236}">
-                <a16:creationId xmlns:a16="http://schemas.microsoft.com/office/drawing/2014/main" id="{B147FD16-FE29-412E-BBB7-B488BFD9E4B7}"/>
+                <a16:creationId xmlns:a16="http://schemas.microsoft.com/office/drawing/2014/main" id="{8DF5935B-B8D5-484A-92AC-14FF88E68F4A}"/>
               </a:ext>
             </a:extLst>
           </p:cNvPr>
@@ -9917,7 +9917,7 @@
           <p:cNvPr id="5" name="">
             <a:extLst xmlns:a="http://schemas.openxmlformats.org/drawingml/2006/main">
               <a:ext uri="{FF2B5EF4-FFF2-40B4-BE49-F238E27FC236}">
-                <a16:creationId xmlns:a16="http://schemas.microsoft.com/office/drawing/2014/main" id="{3BF39345-15AC-4846-9F8B-F83498481736}"/>
+                <a16:creationId xmlns:a16="http://schemas.microsoft.com/office/drawing/2014/main" id="{CA43A419-D3D0-4990-AC83-1AE009FA9EDE}"/>
               </a:ext>
             </a:extLst>
           </p:cNvPr>
@@ -9978,7 +9978,7 @@
           <p:cNvPr id="6" name="">
             <a:extLst xmlns:a="http://schemas.openxmlformats.org/drawingml/2006/main">
               <a:ext uri="{FF2B5EF4-FFF2-40B4-BE49-F238E27FC236}">
-                <a16:creationId xmlns:a16="http://schemas.microsoft.com/office/drawing/2014/main" id="{30D6D43D-5C5F-4DAC-BF0F-F2F508D3B898}"/>
+                <a16:creationId xmlns:a16="http://schemas.microsoft.com/office/drawing/2014/main" id="{737A4C0D-4CD5-4CED-B25F-8A777766B8B3}"/>
               </a:ext>
             </a:extLst>
           </p:cNvPr>
@@ -10039,7 +10039,7 @@
           <p:cNvPr id="7" name="">
             <a:extLst xmlns:a="http://schemas.openxmlformats.org/drawingml/2006/main">
               <a:ext uri="{FF2B5EF4-FFF2-40B4-BE49-F238E27FC236}">
-                <a16:creationId xmlns:a16="http://schemas.microsoft.com/office/drawing/2014/main" id="{E124CADB-7C72-4D0E-BA5E-708B34BA01F1}"/>
+                <a16:creationId xmlns:a16="http://schemas.microsoft.com/office/drawing/2014/main" id="{AFB32F10-2A05-46BE-8FBE-406D09A9D685}"/>
               </a:ext>
             </a:extLst>
           </p:cNvPr>
@@ -10100,7 +10100,7 @@
           <p:cNvPr id="8" name="">
             <a:extLst xmlns:a="http://schemas.openxmlformats.org/drawingml/2006/main">
               <a:ext uri="{FF2B5EF4-FFF2-40B4-BE49-F238E27FC236}">
-                <a16:creationId xmlns:a16="http://schemas.microsoft.com/office/drawing/2014/main" id="{A4FEA3F2-A8DD-49CA-A680-9D3B4C064928}"/>
+                <a16:creationId xmlns:a16="http://schemas.microsoft.com/office/drawing/2014/main" id="{457CE8F5-988D-4BBA-AB70-A2313EBA0AB7}"/>
               </a:ext>
             </a:extLst>
           </p:cNvPr>
@@ -10161,7 +10161,7 @@
           <p:cNvPr id="9" name="">
             <a:extLst xmlns:a="http://schemas.openxmlformats.org/drawingml/2006/main">
               <a:ext uri="{FF2B5EF4-FFF2-40B4-BE49-F238E27FC236}">
-                <a16:creationId xmlns:a16="http://schemas.microsoft.com/office/drawing/2014/main" id="{31D2039B-11DD-4D1C-A738-C0CF50210597}"/>
+                <a16:creationId xmlns:a16="http://schemas.microsoft.com/office/drawing/2014/main" id="{43FF4CD1-E2A3-42EC-AD5D-F9569A65A4F6}"/>
               </a:ext>
             </a:extLst>
           </p:cNvPr>
@@ -10222,7 +10222,7 @@
           <p:cNvPr id="10" name="">
             <a:extLst xmlns:a="http://schemas.openxmlformats.org/drawingml/2006/main">
               <a:ext uri="{FF2B5EF4-FFF2-40B4-BE49-F238E27FC236}">
-                <a16:creationId xmlns:a16="http://schemas.microsoft.com/office/drawing/2014/main" id="{4C3B9CD6-427A-4700-9875-C9EEEE50C7E6}"/>
+                <a16:creationId xmlns:a16="http://schemas.microsoft.com/office/drawing/2014/main" id="{C5942084-EFB3-4916-A9AD-3AE00AF2DBCB}"/>
               </a:ext>
             </a:extLst>
           </p:cNvPr>
@@ -10283,7 +10283,7 @@
           <p:cNvPr id="11" name="">
             <a:extLst xmlns:a="http://schemas.openxmlformats.org/drawingml/2006/main">
               <a:ext uri="{FF2B5EF4-FFF2-40B4-BE49-F238E27FC236}">
-                <a16:creationId xmlns:a16="http://schemas.microsoft.com/office/drawing/2014/main" id="{F465AEA5-FB88-48A2-80FE-FED27C30907A}"/>
+                <a16:creationId xmlns:a16="http://schemas.microsoft.com/office/drawing/2014/main" id="{5DFF30F3-FD6E-461C-8F8F-F8EB8DE53456}"/>
               </a:ext>
             </a:extLst>
           </p:cNvPr>
@@ -10313,7 +10313,7 @@
           <p:cNvPr id="12" name="">
             <a:extLst xmlns:a="http://schemas.openxmlformats.org/drawingml/2006/main">
               <a:ext uri="{FF2B5EF4-FFF2-40B4-BE49-F238E27FC236}">
-                <a16:creationId xmlns:a16="http://schemas.microsoft.com/office/drawing/2014/main" id="{B3059768-03EF-455E-BBF7-3491E0FCDF12}"/>
+                <a16:creationId xmlns:a16="http://schemas.microsoft.com/office/drawing/2014/main" id="{C45A150D-F256-43B5-86C6-4EB780724C70}"/>
               </a:ext>
             </a:extLst>
           </p:cNvPr>
@@ -10372,7 +10372,7 @@
     </p:spTree>
     <p:extLst>
       <p:ext uri="{BB962C8B-B14F-4D97-AF65-F5344CB8AC3E}">
-        <p14:creationId xmlns:p14="http://schemas.microsoft.com/office/powerpoint/2010/main" val="1656866900"/>
+        <p14:creationId xmlns:p14="http://schemas.microsoft.com/office/powerpoint/2010/main" val="679455730"/>
       </p:ext>
     </p:extLst>
   </p:cSld>
@@ -10403,7 +10403,7 @@
           <p:cNvPr id="13" name="">
             <a:extLst xmlns:a="http://schemas.openxmlformats.org/drawingml/2006/main">
               <a:ext uri="{FF2B5EF4-FFF2-40B4-BE49-F238E27FC236}">
-                <a16:creationId xmlns:a16="http://schemas.microsoft.com/office/drawing/2014/main" id="{E5CF3E02-EF7F-4F82-9BBC-5425B2A1BD31}"/>
+                <a16:creationId xmlns:a16="http://schemas.microsoft.com/office/drawing/2014/main" id="{864420A3-9EB9-433D-B141-8B13CCB3D030}"/>
               </a:ext>
             </a:extLst>
           </p:cNvPr>
@@ -10464,7 +10464,7 @@
           <p:cNvPr id="2" name="">
             <a:extLst xmlns:a="http://schemas.openxmlformats.org/drawingml/2006/main">
               <a:ext uri="{FF2B5EF4-FFF2-40B4-BE49-F238E27FC236}">
-                <a16:creationId xmlns:a16="http://schemas.microsoft.com/office/drawing/2014/main" id="{31BC35B2-824D-47D5-9E92-A7965187FEF9}"/>
+                <a16:creationId xmlns:a16="http://schemas.microsoft.com/office/drawing/2014/main" id="{5E703F53-62A0-477A-B9FC-FB3909F169C3}"/>
               </a:ext>
             </a:extLst>
           </p:cNvPr>
@@ -10525,7 +10525,7 @@
           <p:cNvPr id="3" name="">
             <a:extLst xmlns:a="http://schemas.openxmlformats.org/drawingml/2006/main">
               <a:ext uri="{FF2B5EF4-FFF2-40B4-BE49-F238E27FC236}">
-                <a16:creationId xmlns:a16="http://schemas.microsoft.com/office/drawing/2014/main" id="{0B2C49F7-CCCF-466A-A577-2F86CC79FDFC}"/>
+                <a16:creationId xmlns:a16="http://schemas.microsoft.com/office/drawing/2014/main" id="{6BEAFCCD-8952-4ABD-80B4-8F9BEAA1FAB8}"/>
               </a:ext>
             </a:extLst>
           </p:cNvPr>
@@ -10586,7 +10586,7 @@
           <p:cNvPr id="4" name="">
             <a:extLst xmlns:a="http://schemas.openxmlformats.org/drawingml/2006/main">
               <a:ext uri="{FF2B5EF4-FFF2-40B4-BE49-F238E27FC236}">
-                <a16:creationId xmlns:a16="http://schemas.microsoft.com/office/drawing/2014/main" id="{A8B37069-9F99-455D-9514-598B21F84999}"/>
+                <a16:creationId xmlns:a16="http://schemas.microsoft.com/office/drawing/2014/main" id="{201DF4AA-5779-4331-8B83-69919619EF95}"/>
               </a:ext>
             </a:extLst>
           </p:cNvPr>
@@ -10647,7 +10647,7 @@
           <p:cNvPr id="5" name="">
             <a:extLst xmlns:a="http://schemas.openxmlformats.org/drawingml/2006/main">
               <a:ext uri="{FF2B5EF4-FFF2-40B4-BE49-F238E27FC236}">
-                <a16:creationId xmlns:a16="http://schemas.microsoft.com/office/drawing/2014/main" id="{985C3AE0-E94E-447D-93B2-62AB6BEEC3D5}"/>
+                <a16:creationId xmlns:a16="http://schemas.microsoft.com/office/drawing/2014/main" id="{635D6992-7616-49AD-AC60-7990C8CBA69D}"/>
               </a:ext>
             </a:extLst>
           </p:cNvPr>
@@ -10708,7 +10708,7 @@
           <p:cNvPr id="6" name="">
             <a:extLst xmlns:a="http://schemas.openxmlformats.org/drawingml/2006/main">
               <a:ext uri="{FF2B5EF4-FFF2-40B4-BE49-F238E27FC236}">
-                <a16:creationId xmlns:a16="http://schemas.microsoft.com/office/drawing/2014/main" id="{745A1BE6-3EC6-422E-8556-22175F2C32FE}"/>
+                <a16:creationId xmlns:a16="http://schemas.microsoft.com/office/drawing/2014/main" id="{DD720B8A-4572-4DBE-BBA5-61AA8893BDD1}"/>
               </a:ext>
             </a:extLst>
           </p:cNvPr>
@@ -10769,7 +10769,7 @@
           <p:cNvPr id="7" name="">
             <a:extLst xmlns:a="http://schemas.openxmlformats.org/drawingml/2006/main">
               <a:ext uri="{FF2B5EF4-FFF2-40B4-BE49-F238E27FC236}">
-                <a16:creationId xmlns:a16="http://schemas.microsoft.com/office/drawing/2014/main" id="{34CE0F18-2DFB-4CF6-8AB9-BD6EF8A8AB35}"/>
+                <a16:creationId xmlns:a16="http://schemas.microsoft.com/office/drawing/2014/main" id="{0FF03691-D4D6-43B0-A5D9-C010BA2C5422}"/>
               </a:ext>
             </a:extLst>
           </p:cNvPr>
@@ -10830,7 +10830,7 @@
           <p:cNvPr id="8" name="">
             <a:extLst xmlns:a="http://schemas.openxmlformats.org/drawingml/2006/main">
               <a:ext uri="{FF2B5EF4-FFF2-40B4-BE49-F238E27FC236}">
-                <a16:creationId xmlns:a16="http://schemas.microsoft.com/office/drawing/2014/main" id="{525047F6-D170-4D8D-A91F-D7A1B1E9A252}"/>
+                <a16:creationId xmlns:a16="http://schemas.microsoft.com/office/drawing/2014/main" id="{3377886A-AC40-4018-857C-70A1A6BA33F5}"/>
               </a:ext>
             </a:extLst>
           </p:cNvPr>
@@ -10891,7 +10891,7 @@
           <p:cNvPr id="9" name="">
             <a:extLst xmlns:a="http://schemas.openxmlformats.org/drawingml/2006/main">
               <a:ext uri="{FF2B5EF4-FFF2-40B4-BE49-F238E27FC236}">
-                <a16:creationId xmlns:a16="http://schemas.microsoft.com/office/drawing/2014/main" id="{B04597B1-3D8B-4965-B5E7-219A7691CFE2}"/>
+                <a16:creationId xmlns:a16="http://schemas.microsoft.com/office/drawing/2014/main" id="{6DC1A030-C785-479D-B941-64483E08BA48}"/>
               </a:ext>
             </a:extLst>
           </p:cNvPr>
@@ -10952,7 +10952,7 @@
           <p:cNvPr id="10" name="">
             <a:extLst xmlns:a="http://schemas.openxmlformats.org/drawingml/2006/main">
               <a:ext uri="{FF2B5EF4-FFF2-40B4-BE49-F238E27FC236}">
-                <a16:creationId xmlns:a16="http://schemas.microsoft.com/office/drawing/2014/main" id="{1AB9CF30-1569-4DC6-92E8-D576DC22BDF7}"/>
+                <a16:creationId xmlns:a16="http://schemas.microsoft.com/office/drawing/2014/main" id="{8E649B56-0BDD-4835-8997-7A202DE3DB33}"/>
               </a:ext>
             </a:extLst>
           </p:cNvPr>
@@ -11013,7 +11013,7 @@
           <p:cNvPr id="11" name="">
             <a:extLst xmlns:a="http://schemas.openxmlformats.org/drawingml/2006/main">
               <a:ext uri="{FF2B5EF4-FFF2-40B4-BE49-F238E27FC236}">
-                <a16:creationId xmlns:a16="http://schemas.microsoft.com/office/drawing/2014/main" id="{B8AD5257-E4AF-43E4-96EC-52F105E4D143}"/>
+                <a16:creationId xmlns:a16="http://schemas.microsoft.com/office/drawing/2014/main" id="{FFA39116-7F22-4935-81CB-78F9E2220ADA}"/>
               </a:ext>
             </a:extLst>
           </p:cNvPr>
@@ -11043,7 +11043,7 @@
           <p:cNvPr id="12" name="">
             <a:extLst xmlns:a="http://schemas.openxmlformats.org/drawingml/2006/main">
               <a:ext uri="{FF2B5EF4-FFF2-40B4-BE49-F238E27FC236}">
-                <a16:creationId xmlns:a16="http://schemas.microsoft.com/office/drawing/2014/main" id="{95A7A3A4-A132-4A46-8950-74DAA25C2317}"/>
+                <a16:creationId xmlns:a16="http://schemas.microsoft.com/office/drawing/2014/main" id="{34ABA69C-14A0-4270-B17C-E1BBD2CCE8A9}"/>
               </a:ext>
             </a:extLst>
           </p:cNvPr>
@@ -11102,7 +11102,7 @@
     </p:spTree>
     <p:extLst>
       <p:ext uri="{BB962C8B-B14F-4D97-AF65-F5344CB8AC3E}">
-        <p14:creationId xmlns:p14="http://schemas.microsoft.com/office/powerpoint/2010/main" val="1625796617"/>
+        <p14:creationId xmlns:p14="http://schemas.microsoft.com/office/powerpoint/2010/main" val="2013668258"/>
       </p:ext>
     </p:extLst>
   </p:cSld>
@@ -11133,7 +11133,7 @@
           <p:cNvPr id="20" name="">
             <a:extLst xmlns:a="http://schemas.openxmlformats.org/drawingml/2006/main">
               <a:ext uri="{FF2B5EF4-FFF2-40B4-BE49-F238E27FC236}">
-                <a16:creationId xmlns:a16="http://schemas.microsoft.com/office/drawing/2014/main" id="{E8886DF1-6EA7-4150-915B-9C8A6048DDB3}"/>
+                <a16:creationId xmlns:a16="http://schemas.microsoft.com/office/drawing/2014/main" id="{13828390-286E-4BD4-889F-5C1D2AB6F90B}"/>
               </a:ext>
             </a:extLst>
           </p:cNvPr>
@@ -11194,7 +11194,7 @@
           <p:cNvPr id="2" name="">
             <a:extLst xmlns:a="http://schemas.openxmlformats.org/drawingml/2006/main">
               <a:ext uri="{FF2B5EF4-FFF2-40B4-BE49-F238E27FC236}">
-                <a16:creationId xmlns:a16="http://schemas.microsoft.com/office/drawing/2014/main" id="{D14DD685-B714-4501-A76A-1E0018A4E041}"/>
+                <a16:creationId xmlns:a16="http://schemas.microsoft.com/office/drawing/2014/main" id="{8409810B-FA25-43D5-9B71-D62943C6DD5E}"/>
               </a:ext>
             </a:extLst>
           </p:cNvPr>
@@ -11255,7 +11255,7 @@
           <p:cNvPr id="3" name="">
             <a:extLst xmlns:a="http://schemas.openxmlformats.org/drawingml/2006/main">
               <a:ext uri="{FF2B5EF4-FFF2-40B4-BE49-F238E27FC236}">
-                <a16:creationId xmlns:a16="http://schemas.microsoft.com/office/drawing/2014/main" id="{DBC5A1D2-0F88-45E6-A11E-8F15243A6A0B}"/>
+                <a16:creationId xmlns:a16="http://schemas.microsoft.com/office/drawing/2014/main" id="{B8858732-8C8D-4B28-A287-498DBDDF7496}"/>
               </a:ext>
             </a:extLst>
           </p:cNvPr>
@@ -11316,7 +11316,7 @@
           <p:cNvPr id="4" name="">
             <a:extLst xmlns:a="http://schemas.openxmlformats.org/drawingml/2006/main">
               <a:ext uri="{FF2B5EF4-FFF2-40B4-BE49-F238E27FC236}">
-                <a16:creationId xmlns:a16="http://schemas.microsoft.com/office/drawing/2014/main" id="{BA1C2039-AE85-4848-B0F6-080E238CC5D1}"/>
+                <a16:creationId xmlns:a16="http://schemas.microsoft.com/office/drawing/2014/main" id="{FF3FE2D6-E5BB-4768-8D12-CB31835E31E6}"/>
               </a:ext>
             </a:extLst>
           </p:cNvPr>
@@ -11348,7 +11348,7 @@
           <p:cNvPr id="5" name="">
             <a:extLst xmlns:a="http://schemas.openxmlformats.org/drawingml/2006/main">
               <a:ext uri="{FF2B5EF4-FFF2-40B4-BE49-F238E27FC236}">
-                <a16:creationId xmlns:a16="http://schemas.microsoft.com/office/drawing/2014/main" id="{FB3A6ABC-5A5B-4ABC-8CBB-F8D06BAA8D4D}"/>
+                <a16:creationId xmlns:a16="http://schemas.microsoft.com/office/drawing/2014/main" id="{881643E9-E1A9-41D2-BAD7-31DA287BA9E7}"/>
               </a:ext>
             </a:extLst>
           </p:cNvPr>
@@ -11409,7 +11409,7 @@
           <p:cNvPr id="6" name="">
             <a:extLst xmlns:a="http://schemas.openxmlformats.org/drawingml/2006/main">
               <a:ext uri="{FF2B5EF4-FFF2-40B4-BE49-F238E27FC236}">
-                <a16:creationId xmlns:a16="http://schemas.microsoft.com/office/drawing/2014/main" id="{8395A2FC-7EE9-4914-9B93-9F6D0042A8C9}"/>
+                <a16:creationId xmlns:a16="http://schemas.microsoft.com/office/drawing/2014/main" id="{8CBE1AC5-E903-4A77-81C6-756A3F25E714}"/>
               </a:ext>
             </a:extLst>
           </p:cNvPr>
@@ -11441,7 +11441,7 @@
           <p:cNvPr id="7" name="">
             <a:extLst xmlns:a="http://schemas.openxmlformats.org/drawingml/2006/main">
               <a:ext uri="{FF2B5EF4-FFF2-40B4-BE49-F238E27FC236}">
-                <a16:creationId xmlns:a16="http://schemas.microsoft.com/office/drawing/2014/main" id="{19DA494B-E5CE-45D8-9A5E-12DD5F689614}"/>
+                <a16:creationId xmlns:a16="http://schemas.microsoft.com/office/drawing/2014/main" id="{230FA41C-5E27-4CD4-9403-882A459AF52D}"/>
               </a:ext>
             </a:extLst>
           </p:cNvPr>
@@ -11502,7 +11502,7 @@
           <p:cNvPr id="8" name="">
             <a:extLst xmlns:a="http://schemas.openxmlformats.org/drawingml/2006/main">
               <a:ext uri="{FF2B5EF4-FFF2-40B4-BE49-F238E27FC236}">
-                <a16:creationId xmlns:a16="http://schemas.microsoft.com/office/drawing/2014/main" id="{B313C733-62B5-4103-947D-5EE5534800ED}"/>
+                <a16:creationId xmlns:a16="http://schemas.microsoft.com/office/drawing/2014/main" id="{F6F24D3E-CB10-4BBC-8F92-20C38E2FD6A8}"/>
               </a:ext>
             </a:extLst>
           </p:cNvPr>
@@ -11534,7 +11534,7 @@
           <p:cNvPr id="9" name="">
             <a:extLst xmlns:a="http://schemas.openxmlformats.org/drawingml/2006/main">
               <a:ext uri="{FF2B5EF4-FFF2-40B4-BE49-F238E27FC236}">
-                <a16:creationId xmlns:a16="http://schemas.microsoft.com/office/drawing/2014/main" id="{7BB0BD2D-F6CB-4818-A1A6-7458998AA952}"/>
+                <a16:creationId xmlns:a16="http://schemas.microsoft.com/office/drawing/2014/main" id="{4C4460C5-420D-4FE1-9500-3A3CEE5C9287}"/>
               </a:ext>
             </a:extLst>
           </p:cNvPr>
@@ -11595,7 +11595,7 @@
           <p:cNvPr id="10" name="">
             <a:extLst xmlns:a="http://schemas.openxmlformats.org/drawingml/2006/main">
               <a:ext uri="{FF2B5EF4-FFF2-40B4-BE49-F238E27FC236}">
-                <a16:creationId xmlns:a16="http://schemas.microsoft.com/office/drawing/2014/main" id="{9B736734-D854-4317-8190-8DB0C433AA02}"/>
+                <a16:creationId xmlns:a16="http://schemas.microsoft.com/office/drawing/2014/main" id="{41BBBAB0-7196-470B-922E-5233FC81FD88}"/>
               </a:ext>
             </a:extLst>
           </p:cNvPr>
@@ -11627,7 +11627,7 @@
           <p:cNvPr id="11" name="">
             <a:extLst xmlns:a="http://schemas.openxmlformats.org/drawingml/2006/main">
               <a:ext uri="{FF2B5EF4-FFF2-40B4-BE49-F238E27FC236}">
-                <a16:creationId xmlns:a16="http://schemas.microsoft.com/office/drawing/2014/main" id="{6E4A8D6C-5C73-40F9-BD66-DFC6447E8035}"/>
+                <a16:creationId xmlns:a16="http://schemas.microsoft.com/office/drawing/2014/main" id="{55622B99-E1D0-4E0B-BD23-876ABDCF8D4C}"/>
               </a:ext>
             </a:extLst>
           </p:cNvPr>
@@ -11688,7 +11688,7 @@
           <p:cNvPr id="12" name="">
             <a:extLst xmlns:a="http://schemas.openxmlformats.org/drawingml/2006/main">
               <a:ext uri="{FF2B5EF4-FFF2-40B4-BE49-F238E27FC236}">
-                <a16:creationId xmlns:a16="http://schemas.microsoft.com/office/drawing/2014/main" id="{437C409D-E2A9-4673-A774-151B02635926}"/>
+                <a16:creationId xmlns:a16="http://schemas.microsoft.com/office/drawing/2014/main" id="{DE647203-5D16-417E-9F5A-BAE99B9C8ED8}"/>
               </a:ext>
             </a:extLst>
           </p:cNvPr>
@@ -11720,7 +11720,7 @@
           <p:cNvPr id="13" name="">
             <a:extLst xmlns:a="http://schemas.openxmlformats.org/drawingml/2006/main">
               <a:ext uri="{FF2B5EF4-FFF2-40B4-BE49-F238E27FC236}">
-                <a16:creationId xmlns:a16="http://schemas.microsoft.com/office/drawing/2014/main" id="{3A908028-FEC6-46F8-BDE3-235479F6FFFF}"/>
+                <a16:creationId xmlns:a16="http://schemas.microsoft.com/office/drawing/2014/main" id="{D579D774-F1B9-4465-B1F5-E050ADE191CA}"/>
               </a:ext>
             </a:extLst>
           </p:cNvPr>
@@ -11781,7 +11781,7 @@
           <p:cNvPr id="14" name="">
             <a:extLst xmlns:a="http://schemas.openxmlformats.org/drawingml/2006/main">
               <a:ext uri="{FF2B5EF4-FFF2-40B4-BE49-F238E27FC236}">
-                <a16:creationId xmlns:a16="http://schemas.microsoft.com/office/drawing/2014/main" id="{F5412A7A-CC62-4680-83C3-629EB9BFE79B}"/>
+                <a16:creationId xmlns:a16="http://schemas.microsoft.com/office/drawing/2014/main" id="{6A7E909F-C36E-45D5-851A-A051AEF88CDD}"/>
               </a:ext>
             </a:extLst>
           </p:cNvPr>
@@ -11811,7 +11811,7 @@
           <p:cNvPr id="15" name="">
             <a:extLst xmlns:a="http://schemas.openxmlformats.org/drawingml/2006/main">
               <a:ext uri="{FF2B5EF4-FFF2-40B4-BE49-F238E27FC236}">
-                <a16:creationId xmlns:a16="http://schemas.microsoft.com/office/drawing/2014/main" id="{4025E2F6-A852-486D-9D76-3497CB6D05C0}"/>
+                <a16:creationId xmlns:a16="http://schemas.microsoft.com/office/drawing/2014/main" id="{77EE7FA7-1C4C-4B79-B13A-30A69AEB6207}"/>
               </a:ext>
             </a:extLst>
           </p:cNvPr>
@@ -11872,7 +11872,7 @@
           <p:cNvPr id="16" name="">
             <a:extLst xmlns:a="http://schemas.openxmlformats.org/drawingml/2006/main">
               <a:ext uri="{FF2B5EF4-FFF2-40B4-BE49-F238E27FC236}">
-                <a16:creationId xmlns:a16="http://schemas.microsoft.com/office/drawing/2014/main" id="{62530B62-8F28-4F0D-971D-E20537652E4C}"/>
+                <a16:creationId xmlns:a16="http://schemas.microsoft.com/office/drawing/2014/main" id="{0B83B25E-A463-4839-8ADD-02CC15559180}"/>
               </a:ext>
             </a:extLst>
           </p:cNvPr>
@@ -11933,7 +11933,7 @@
           <p:cNvPr id="17" name="">
             <a:extLst xmlns:a="http://schemas.openxmlformats.org/drawingml/2006/main">
               <a:ext uri="{FF2B5EF4-FFF2-40B4-BE49-F238E27FC236}">
-                <a16:creationId xmlns:a16="http://schemas.microsoft.com/office/drawing/2014/main" id="{B6264AEC-BE48-428D-9508-48DC7B5F5DC7}"/>
+                <a16:creationId xmlns:a16="http://schemas.microsoft.com/office/drawing/2014/main" id="{63B83834-B799-41E9-A8A7-2A5AC59C832E}"/>
               </a:ext>
             </a:extLst>
           </p:cNvPr>
@@ -12021,7 +12021,7 @@
           <p:cNvPr id="18" name="">
             <a:extLst xmlns:a="http://schemas.openxmlformats.org/drawingml/2006/main">
               <a:ext uri="{FF2B5EF4-FFF2-40B4-BE49-F238E27FC236}">
-                <a16:creationId xmlns:a16="http://schemas.microsoft.com/office/drawing/2014/main" id="{1E668964-7948-4D5C-959F-12697D2EBDA1}"/>
+                <a16:creationId xmlns:a16="http://schemas.microsoft.com/office/drawing/2014/main" id="{556458B0-BE7E-4CDC-9682-67D7153F4EFB}"/>
               </a:ext>
             </a:extLst>
           </p:cNvPr>
@@ -12071,7 +12071,7 @@
                 <a:latin typeface="Arial"/>
                 <a:ea typeface="Arial"/>
                 <a:cs typeface="Arial"/>
-                <a:hlinkClick xmlns:r="http://schemas.openxmlformats.org/officeDocument/2006/relationships" r:id="Rcc99c93cc7204b83"/>
+                <a:hlinkClick xmlns:r="http://schemas.openxmlformats.org/officeDocument/2006/relationships" r:id="Ra46c8535f2f34423"/>
               </a:rPr>
               <a:t>DOI 10.1080/00401706.1970.10488634</a:t>
             </a:r>
@@ -12083,7 +12083,7 @@
           <p:cNvPr id="19" name="">
             <a:extLst xmlns:a="http://schemas.openxmlformats.org/drawingml/2006/main">
               <a:ext uri="{FF2B5EF4-FFF2-40B4-BE49-F238E27FC236}">
-                <a16:creationId xmlns:a16="http://schemas.microsoft.com/office/drawing/2014/main" id="{3BB62E01-74B3-44FA-846B-5B2A041AFE73}"/>
+                <a16:creationId xmlns:a16="http://schemas.microsoft.com/office/drawing/2014/main" id="{E5ED1080-AEDB-481B-ADAD-C6DAEC34B707}"/>
               </a:ext>
             </a:extLst>
           </p:cNvPr>
@@ -12142,7 +12142,7 @@
     </p:spTree>
     <p:extLst>
       <p:ext uri="{BB962C8B-B14F-4D97-AF65-F5344CB8AC3E}">
-        <p14:creationId xmlns:p14="http://schemas.microsoft.com/office/powerpoint/2010/main" val="550923589"/>
+        <p14:creationId xmlns:p14="http://schemas.microsoft.com/office/powerpoint/2010/main" val="2128609116"/>
       </p:ext>
     </p:extLst>
   </p:cSld>
@@ -12173,7 +12173,7 @@
           <p:cNvPr id="5" name="">
             <a:extLst xmlns:a="http://schemas.openxmlformats.org/drawingml/2006/main">
               <a:ext uri="{FF2B5EF4-FFF2-40B4-BE49-F238E27FC236}">
-                <a16:creationId xmlns:a16="http://schemas.microsoft.com/office/drawing/2014/main" id="{052B426F-061E-4054-B845-5258DDE1DA0C}"/>
+                <a16:creationId xmlns:a16="http://schemas.microsoft.com/office/drawing/2014/main" id="{D36A7B8E-065B-4939-8C8A-47D976C6535C}"/>
               </a:ext>
             </a:extLst>
           </p:cNvPr>
@@ -12234,7 +12234,7 @@
           <p:cNvPr id="2" name="">
             <a:extLst xmlns:a="http://schemas.openxmlformats.org/drawingml/2006/main">
               <a:ext uri="{FF2B5EF4-FFF2-40B4-BE49-F238E27FC236}">
-                <a16:creationId xmlns:a16="http://schemas.microsoft.com/office/drawing/2014/main" id="{2C8CD218-8FBA-475E-A5B8-93719085D15A}"/>
+                <a16:creationId xmlns:a16="http://schemas.microsoft.com/office/drawing/2014/main" id="{58CA04F6-D99C-4C44-B402-C0869AD9821A}"/>
               </a:ext>
             </a:extLst>
           </p:cNvPr>
@@ -12931,7 +12931,7 @@
           <p:cNvPr id="4" name="">
             <a:extLst xmlns:a="http://schemas.openxmlformats.org/drawingml/2006/main">
               <a:ext uri="{FF2B5EF4-FFF2-40B4-BE49-F238E27FC236}">
-                <a16:creationId xmlns:a16="http://schemas.microsoft.com/office/drawing/2014/main" id="{FA22D61A-C73F-4EC2-A893-563871B87B98}"/>
+                <a16:creationId xmlns:a16="http://schemas.microsoft.com/office/drawing/2014/main" id="{FDB8F8BF-B66E-4240-9481-D5DB720F72DC}"/>
               </a:ext>
             </a:extLst>
           </p:cNvPr>
@@ -13023,7 +13023,7 @@
     </p:spTree>
     <p:extLst>
       <p:ext uri="{BB962C8B-B14F-4D97-AF65-F5344CB8AC3E}">
-        <p14:creationId xmlns:p14="http://schemas.microsoft.com/office/powerpoint/2010/main" val="975133322"/>
+        <p14:creationId xmlns:p14="http://schemas.microsoft.com/office/powerpoint/2010/main" val="482976637"/>
       </p:ext>
     </p:extLst>
   </p:cSld>
@@ -13054,7 +13054,7 @@
           <p:cNvPr id="11" name="">
             <a:extLst xmlns:a="http://schemas.openxmlformats.org/drawingml/2006/main">
               <a:ext uri="{FF2B5EF4-FFF2-40B4-BE49-F238E27FC236}">
-                <a16:creationId xmlns:a16="http://schemas.microsoft.com/office/drawing/2014/main" id="{AE575696-3B17-42F0-8997-0651619B7881}"/>
+                <a16:creationId xmlns:a16="http://schemas.microsoft.com/office/drawing/2014/main" id="{A3C7534B-41E5-401E-B7C2-78B8359DD57A}"/>
               </a:ext>
             </a:extLst>
           </p:cNvPr>
@@ -13115,7 +13115,7 @@
           <p:cNvPr id="2" name="">
             <a:extLst xmlns:a="http://schemas.openxmlformats.org/drawingml/2006/main">
               <a:ext uri="{FF2B5EF4-FFF2-40B4-BE49-F238E27FC236}">
-                <a16:creationId xmlns:a16="http://schemas.microsoft.com/office/drawing/2014/main" id="{E1339209-4B22-42AE-8984-BB005422B624}"/>
+                <a16:creationId xmlns:a16="http://schemas.microsoft.com/office/drawing/2014/main" id="{3F38EADA-1654-4017-AE4B-A4623AE4CC33}"/>
               </a:ext>
             </a:extLst>
           </p:cNvPr>
@@ -13176,7 +13176,7 @@
           <p:cNvPr id="3" name="">
             <a:extLst xmlns:a="http://schemas.openxmlformats.org/drawingml/2006/main">
               <a:ext uri="{FF2B5EF4-FFF2-40B4-BE49-F238E27FC236}">
-                <a16:creationId xmlns:a16="http://schemas.microsoft.com/office/drawing/2014/main" id="{6A83946B-18BE-4C08-AB2F-342595303833}"/>
+                <a16:creationId xmlns:a16="http://schemas.microsoft.com/office/drawing/2014/main" id="{E528F358-B8AB-49B9-B707-CC70E2266312}"/>
               </a:ext>
             </a:extLst>
           </p:cNvPr>
@@ -13244,7 +13244,7 @@
           <p:cNvPr id="4" name="">
             <a:extLst xmlns:a="http://schemas.openxmlformats.org/drawingml/2006/main">
               <a:ext uri="{FF2B5EF4-FFF2-40B4-BE49-F238E27FC236}">
-                <a16:creationId xmlns:a16="http://schemas.microsoft.com/office/drawing/2014/main" id="{5F7A58DC-5E5C-4AED-A688-E7B625F3DD91}"/>
+                <a16:creationId xmlns:a16="http://schemas.microsoft.com/office/drawing/2014/main" id="{1D1EC642-0169-4DFE-9002-0C9A70F48D93}"/>
               </a:ext>
             </a:extLst>
           </p:cNvPr>
@@ -13305,7 +13305,7 @@
           <p:cNvPr id="5" name="">
             <a:extLst xmlns:a="http://schemas.openxmlformats.org/drawingml/2006/main">
               <a:ext uri="{FF2B5EF4-FFF2-40B4-BE49-F238E27FC236}">
-                <a16:creationId xmlns:a16="http://schemas.microsoft.com/office/drawing/2014/main" id="{EFE185EA-624C-42AF-804C-135C0F448FEC}"/>
+                <a16:creationId xmlns:a16="http://schemas.microsoft.com/office/drawing/2014/main" id="{CD57B432-192E-4191-B814-6C9DD9394ABA}"/>
               </a:ext>
             </a:extLst>
           </p:cNvPr>
@@ -13366,7 +13366,7 @@
           <p:cNvPr id="6" name="">
             <a:extLst xmlns:a="http://schemas.openxmlformats.org/drawingml/2006/main">
               <a:ext uri="{FF2B5EF4-FFF2-40B4-BE49-F238E27FC236}">
-                <a16:creationId xmlns:a16="http://schemas.microsoft.com/office/drawing/2014/main" id="{E1AFD3FD-0325-45E5-AB1B-5162F18D9967}"/>
+                <a16:creationId xmlns:a16="http://schemas.microsoft.com/office/drawing/2014/main" id="{6ED45C35-F8B3-42DB-8C14-17B2EE1E3241}"/>
               </a:ext>
             </a:extLst>
           </p:cNvPr>
@@ -13427,7 +13427,7 @@
           <p:cNvPr id="7" name="">
             <a:extLst xmlns:a="http://schemas.openxmlformats.org/drawingml/2006/main">
               <a:ext uri="{FF2B5EF4-FFF2-40B4-BE49-F238E27FC236}">
-                <a16:creationId xmlns:a16="http://schemas.microsoft.com/office/drawing/2014/main" id="{82AE2089-E186-420D-B881-365EE4B682C7}"/>
+                <a16:creationId xmlns:a16="http://schemas.microsoft.com/office/drawing/2014/main" id="{95CF3BE5-9D24-420E-97C3-6BD2F2E9E061}"/>
               </a:ext>
             </a:extLst>
           </p:cNvPr>
@@ -13488,7 +13488,7 @@
           <p:cNvPr id="8" name="">
             <a:extLst xmlns:a="http://schemas.openxmlformats.org/drawingml/2006/main">
               <a:ext uri="{FF2B5EF4-FFF2-40B4-BE49-F238E27FC236}">
-                <a16:creationId xmlns:a16="http://schemas.microsoft.com/office/drawing/2014/main" id="{0FC2968E-A789-4FA1-9165-51F994614B2B}"/>
+                <a16:creationId xmlns:a16="http://schemas.microsoft.com/office/drawing/2014/main" id="{4D556086-4AFC-4925-AE32-8BAD1271D849}"/>
               </a:ext>
             </a:extLst>
           </p:cNvPr>
@@ -13549,7 +13549,7 @@
           <p:cNvPr id="9" name="">
             <a:extLst xmlns:a="http://schemas.openxmlformats.org/drawingml/2006/main">
               <a:ext uri="{FF2B5EF4-FFF2-40B4-BE49-F238E27FC236}">
-                <a16:creationId xmlns:a16="http://schemas.microsoft.com/office/drawing/2014/main" id="{87EF02ED-7081-4064-B65A-C5A4F1A80DD5}"/>
+                <a16:creationId xmlns:a16="http://schemas.microsoft.com/office/drawing/2014/main" id="{77C93DB3-1E6B-444B-8B62-AE8048714819}"/>
               </a:ext>
             </a:extLst>
           </p:cNvPr>
@@ -13610,7 +13610,7 @@
           <p:cNvPr id="10" name="">
             <a:extLst xmlns:a="http://schemas.openxmlformats.org/drawingml/2006/main">
               <a:ext uri="{FF2B5EF4-FFF2-40B4-BE49-F238E27FC236}">
-                <a16:creationId xmlns:a16="http://schemas.microsoft.com/office/drawing/2014/main" id="{8D3EC51C-8BDE-4514-9259-BE7058C41C74}"/>
+                <a16:creationId xmlns:a16="http://schemas.microsoft.com/office/drawing/2014/main" id="{5AF278DA-2000-43AF-B790-11E39541EC75}"/>
               </a:ext>
             </a:extLst>
           </p:cNvPr>
@@ -13669,7 +13669,7 @@
     </p:spTree>
     <p:extLst>
       <p:ext uri="{BB962C8B-B14F-4D97-AF65-F5344CB8AC3E}">
-        <p14:creationId xmlns:p14="http://schemas.microsoft.com/office/powerpoint/2010/main" val="543469400"/>
+        <p14:creationId xmlns:p14="http://schemas.microsoft.com/office/powerpoint/2010/main" val="1799602596"/>
       </p:ext>
     </p:extLst>
   </p:cSld>
@@ -13700,7 +13700,7 @@
           <p:cNvPr id="27" name="">
             <a:extLst xmlns:a="http://schemas.openxmlformats.org/drawingml/2006/main">
               <a:ext uri="{FF2B5EF4-FFF2-40B4-BE49-F238E27FC236}">
-                <a16:creationId xmlns:a16="http://schemas.microsoft.com/office/drawing/2014/main" id="{698B9E50-8094-4831-B3D6-AA33FA00AA5E}"/>
+                <a16:creationId xmlns:a16="http://schemas.microsoft.com/office/drawing/2014/main" id="{BE2B55A2-766E-4E71-B557-83BA70E0D13B}"/>
               </a:ext>
             </a:extLst>
           </p:cNvPr>
@@ -13761,7 +13761,7 @@
           <p:cNvPr id="2" name="">
             <a:extLst xmlns:a="http://schemas.openxmlformats.org/drawingml/2006/main">
               <a:ext uri="{FF2B5EF4-FFF2-40B4-BE49-F238E27FC236}">
-                <a16:creationId xmlns:a16="http://schemas.microsoft.com/office/drawing/2014/main" id="{C520CF2A-5731-48E0-B593-9CF951CF7D16}"/>
+                <a16:creationId xmlns:a16="http://schemas.microsoft.com/office/drawing/2014/main" id="{755EEF49-7BC0-4704-BD7D-33AF5E83B4B7}"/>
               </a:ext>
             </a:extLst>
           </p:cNvPr>
@@ -13822,7 +13822,7 @@
           <p:cNvPr id="3" name="">
             <a:extLst xmlns:a="http://schemas.openxmlformats.org/drawingml/2006/main">
               <a:ext uri="{FF2B5EF4-FFF2-40B4-BE49-F238E27FC236}">
-                <a16:creationId xmlns:a16="http://schemas.microsoft.com/office/drawing/2014/main" id="{2CFA8419-419C-4273-9DD7-77F8779F2F18}"/>
+                <a16:creationId xmlns:a16="http://schemas.microsoft.com/office/drawing/2014/main" id="{520134DD-16C3-41D0-A176-9023FD59D225}"/>
               </a:ext>
             </a:extLst>
           </p:cNvPr>
@@ -13883,7 +13883,7 @@
           <p:cNvPr id="4" name="">
             <a:extLst xmlns:a="http://schemas.openxmlformats.org/drawingml/2006/main">
               <a:ext uri="{FF2B5EF4-FFF2-40B4-BE49-F238E27FC236}">
-                <a16:creationId xmlns:a16="http://schemas.microsoft.com/office/drawing/2014/main" id="{F529D825-8DEE-4131-9975-EBD24BBA30A3}"/>
+                <a16:creationId xmlns:a16="http://schemas.microsoft.com/office/drawing/2014/main" id="{A1C7630A-0E64-4778-93B3-B49A7E14D52F}"/>
               </a:ext>
             </a:extLst>
           </p:cNvPr>
@@ -13918,7 +13918,7 @@
           <p:cNvPr id="5" name="">
             <a:extLst xmlns:a="http://schemas.openxmlformats.org/drawingml/2006/main">
               <a:ext uri="{FF2B5EF4-FFF2-40B4-BE49-F238E27FC236}">
-                <a16:creationId xmlns:a16="http://schemas.microsoft.com/office/drawing/2014/main" id="{06DC2538-ADD4-4A7D-9823-0FF187FCCD08}"/>
+                <a16:creationId xmlns:a16="http://schemas.microsoft.com/office/drawing/2014/main" id="{9B2C043E-4326-4D0E-9FF1-7BDBD7BA0329}"/>
               </a:ext>
             </a:extLst>
           </p:cNvPr>
@@ -13953,7 +13953,7 @@
           <p:cNvPr id="6" name="">
             <a:extLst xmlns:a="http://schemas.openxmlformats.org/drawingml/2006/main">
               <a:ext uri="{FF2B5EF4-FFF2-40B4-BE49-F238E27FC236}">
-                <a16:creationId xmlns:a16="http://schemas.microsoft.com/office/drawing/2014/main" id="{2F614C24-4191-4830-8F3B-F41697BECAEE}"/>
+                <a16:creationId xmlns:a16="http://schemas.microsoft.com/office/drawing/2014/main" id="{18912CC3-0A59-46B4-9832-363C6BAFD3C1}"/>
               </a:ext>
             </a:extLst>
           </p:cNvPr>
@@ -14014,7 +14014,7 @@
           <p:cNvPr id="7" name="">
             <a:extLst xmlns:a="http://schemas.openxmlformats.org/drawingml/2006/main">
               <a:ext uri="{FF2B5EF4-FFF2-40B4-BE49-F238E27FC236}">
-                <a16:creationId xmlns:a16="http://schemas.microsoft.com/office/drawing/2014/main" id="{94ADEC5B-F190-4AC0-B348-1188B78045B8}"/>
+                <a16:creationId xmlns:a16="http://schemas.microsoft.com/office/drawing/2014/main" id="{D2F4CA58-2FC6-43E6-B12C-339D076E0D3F}"/>
               </a:ext>
             </a:extLst>
           </p:cNvPr>
@@ -14075,7 +14075,7 @@
           <p:cNvPr id="8" name="">
             <a:extLst xmlns:a="http://schemas.openxmlformats.org/drawingml/2006/main">
               <a:ext uri="{FF2B5EF4-FFF2-40B4-BE49-F238E27FC236}">
-                <a16:creationId xmlns:a16="http://schemas.microsoft.com/office/drawing/2014/main" id="{4A641904-7BDD-4E3E-9001-CF675DB95AB3}"/>
+                <a16:creationId xmlns:a16="http://schemas.microsoft.com/office/drawing/2014/main" id="{10982AD2-CCE4-4800-AE96-373014045F13}"/>
               </a:ext>
             </a:extLst>
           </p:cNvPr>
@@ -14105,7 +14105,7 @@
           <p:cNvPr id="9" name="">
             <a:extLst xmlns:a="http://schemas.openxmlformats.org/drawingml/2006/main">
               <a:ext uri="{FF2B5EF4-FFF2-40B4-BE49-F238E27FC236}">
-                <a16:creationId xmlns:a16="http://schemas.microsoft.com/office/drawing/2014/main" id="{020FA162-6675-41A0-B1E6-40302C3F1E8D}"/>
+                <a16:creationId xmlns:a16="http://schemas.microsoft.com/office/drawing/2014/main" id="{2B5E2BF3-F6A4-4F2E-BD99-3B3DE982848B}"/>
               </a:ext>
             </a:extLst>
           </p:cNvPr>
@@ -14135,7 +14135,7 @@
           <p:cNvPr id="10" name="">
             <a:extLst xmlns:a="http://schemas.openxmlformats.org/drawingml/2006/main">
               <a:ext uri="{FF2B5EF4-FFF2-40B4-BE49-F238E27FC236}">
-                <a16:creationId xmlns:a16="http://schemas.microsoft.com/office/drawing/2014/main" id="{D40D28C8-8AB5-4D4D-8A7D-E2BD21CCD9E8}"/>
+                <a16:creationId xmlns:a16="http://schemas.microsoft.com/office/drawing/2014/main" id="{404EFF9F-921F-4D32-BB96-607057F54A59}"/>
               </a:ext>
             </a:extLst>
           </p:cNvPr>
@@ -14165,7 +14165,7 @@
           <p:cNvPr id="11" name="">
             <a:extLst xmlns:a="http://schemas.openxmlformats.org/drawingml/2006/main">
               <a:ext uri="{FF2B5EF4-FFF2-40B4-BE49-F238E27FC236}">
-                <a16:creationId xmlns:a16="http://schemas.microsoft.com/office/drawing/2014/main" id="{3629A4FC-CFF9-422A-82A9-A631EC211A85}"/>
+                <a16:creationId xmlns:a16="http://schemas.microsoft.com/office/drawing/2014/main" id="{54A80989-A1AD-45D8-8F19-3BCEEA726522}"/>
               </a:ext>
             </a:extLst>
           </p:cNvPr>
@@ -14195,7 +14195,7 @@
           <p:cNvPr id="12" name="">
             <a:extLst xmlns:a="http://schemas.openxmlformats.org/drawingml/2006/main">
               <a:ext uri="{FF2B5EF4-FFF2-40B4-BE49-F238E27FC236}">
-                <a16:creationId xmlns:a16="http://schemas.microsoft.com/office/drawing/2014/main" id="{E5F73855-13AD-4FEB-B6EC-240F6E4EDB7C}"/>
+                <a16:creationId xmlns:a16="http://schemas.microsoft.com/office/drawing/2014/main" id="{648E47B2-382A-4568-8E6E-43281298E350}"/>
               </a:ext>
             </a:extLst>
           </p:cNvPr>
@@ -14225,7 +14225,7 @@
           <p:cNvPr id="13" name="">
             <a:extLst xmlns:a="http://schemas.openxmlformats.org/drawingml/2006/main">
               <a:ext uri="{FF2B5EF4-FFF2-40B4-BE49-F238E27FC236}">
-                <a16:creationId xmlns:a16="http://schemas.microsoft.com/office/drawing/2014/main" id="{3CE35BFB-F775-4926-AD74-8EAB5F1FD547}"/>
+                <a16:creationId xmlns:a16="http://schemas.microsoft.com/office/drawing/2014/main" id="{7A6164E3-01A2-4E22-9DB6-64B02D7EDF9E}"/>
               </a:ext>
             </a:extLst>
           </p:cNvPr>
@@ -14255,7 +14255,7 @@
           <p:cNvPr id="14" name="">
             <a:extLst xmlns:a="http://schemas.openxmlformats.org/drawingml/2006/main">
               <a:ext uri="{FF2B5EF4-FFF2-40B4-BE49-F238E27FC236}">
-                <a16:creationId xmlns:a16="http://schemas.microsoft.com/office/drawing/2014/main" id="{3F801AD4-4941-4988-B1A0-92FE45E87D0D}"/>
+                <a16:creationId xmlns:a16="http://schemas.microsoft.com/office/drawing/2014/main" id="{32ED01B0-3C6B-43B8-9DEA-278A92F03696}"/>
               </a:ext>
             </a:extLst>
           </p:cNvPr>
@@ -14285,7 +14285,7 @@
           <p:cNvPr id="15" name="">
             <a:extLst xmlns:a="http://schemas.openxmlformats.org/drawingml/2006/main">
               <a:ext uri="{FF2B5EF4-FFF2-40B4-BE49-F238E27FC236}">
-                <a16:creationId xmlns:a16="http://schemas.microsoft.com/office/drawing/2014/main" id="{F94E86AC-125C-41FC-BDBA-4DC86B6FA9D2}"/>
+                <a16:creationId xmlns:a16="http://schemas.microsoft.com/office/drawing/2014/main" id="{567CC0B3-5B26-4024-8A15-21A25AD34211}"/>
               </a:ext>
             </a:extLst>
           </p:cNvPr>
@@ -14315,7 +14315,7 @@
           <p:cNvPr id="16" name="">
             <a:extLst xmlns:a="http://schemas.openxmlformats.org/drawingml/2006/main">
               <a:ext uri="{FF2B5EF4-FFF2-40B4-BE49-F238E27FC236}">
-                <a16:creationId xmlns:a16="http://schemas.microsoft.com/office/drawing/2014/main" id="{F841A0CB-FAA8-4E36-8E70-32093626FBB6}"/>
+                <a16:creationId xmlns:a16="http://schemas.microsoft.com/office/drawing/2014/main" id="{A7912238-EF13-4DAD-9630-008158E722F3}"/>
               </a:ext>
             </a:extLst>
           </p:cNvPr>
@@ -14345,7 +14345,7 @@
           <p:cNvPr id="17" name="">
             <a:extLst xmlns:a="http://schemas.openxmlformats.org/drawingml/2006/main">
               <a:ext uri="{FF2B5EF4-FFF2-40B4-BE49-F238E27FC236}">
-                <a16:creationId xmlns:a16="http://schemas.microsoft.com/office/drawing/2014/main" id="{771287D1-39E1-46EE-B391-75BAE5F5127F}"/>
+                <a16:creationId xmlns:a16="http://schemas.microsoft.com/office/drawing/2014/main" id="{854CF73C-F17C-42BB-B4AE-D6407B6D75CB}"/>
               </a:ext>
             </a:extLst>
           </p:cNvPr>
@@ -14375,7 +14375,7 @@
           <p:cNvPr id="18" name="">
             <a:extLst xmlns:a="http://schemas.openxmlformats.org/drawingml/2006/main">
               <a:ext uri="{FF2B5EF4-FFF2-40B4-BE49-F238E27FC236}">
-                <a16:creationId xmlns:a16="http://schemas.microsoft.com/office/drawing/2014/main" id="{05AD9BCA-866F-46A6-8097-952E4A3864EA}"/>
+                <a16:creationId xmlns:a16="http://schemas.microsoft.com/office/drawing/2014/main" id="{55818CA3-6B2F-4B6A-8075-4B9B6BCEE0DB}"/>
               </a:ext>
             </a:extLst>
           </p:cNvPr>
@@ -14436,7 +14436,7 @@
           <p:cNvPr id="19" name="">
             <a:extLst xmlns:a="http://schemas.openxmlformats.org/drawingml/2006/main">
               <a:ext uri="{FF2B5EF4-FFF2-40B4-BE49-F238E27FC236}">
-                <a16:creationId xmlns:a16="http://schemas.microsoft.com/office/drawing/2014/main" id="{1D5F65DF-52FE-4B43-9112-2C8D26871801}"/>
+                <a16:creationId xmlns:a16="http://schemas.microsoft.com/office/drawing/2014/main" id="{FF13A412-B34E-4F8B-806C-8B7C1BAB743B}"/>
               </a:ext>
             </a:extLst>
           </p:cNvPr>
@@ -14466,7 +14466,7 @@
           <p:cNvPr id="20" name="">
             <a:extLst xmlns:a="http://schemas.openxmlformats.org/drawingml/2006/main">
               <a:ext uri="{FF2B5EF4-FFF2-40B4-BE49-F238E27FC236}">
-                <a16:creationId xmlns:a16="http://schemas.microsoft.com/office/drawing/2014/main" id="{41D1EE7E-0C05-4DE8-8FF9-EA4C442D0E84}"/>
+                <a16:creationId xmlns:a16="http://schemas.microsoft.com/office/drawing/2014/main" id="{C2C2AAF6-7839-4423-8956-5FD8079F1C2E}"/>
               </a:ext>
             </a:extLst>
           </p:cNvPr>
@@ -14527,7 +14527,7 @@
           <p:cNvPr id="21" name="">
             <a:extLst xmlns:a="http://schemas.openxmlformats.org/drawingml/2006/main">
               <a:ext uri="{FF2B5EF4-FFF2-40B4-BE49-F238E27FC236}">
-                <a16:creationId xmlns:a16="http://schemas.microsoft.com/office/drawing/2014/main" id="{058BFF85-8E36-4864-B2B0-4979DC7ADAE4}"/>
+                <a16:creationId xmlns:a16="http://schemas.microsoft.com/office/drawing/2014/main" id="{65EF356D-E2E2-4DCA-B763-97C14801660F}"/>
               </a:ext>
             </a:extLst>
           </p:cNvPr>
@@ -14595,7 +14595,7 @@
           <p:cNvPr id="22" name="">
             <a:extLst xmlns:a="http://schemas.openxmlformats.org/drawingml/2006/main">
               <a:ext uri="{FF2B5EF4-FFF2-40B4-BE49-F238E27FC236}">
-                <a16:creationId xmlns:a16="http://schemas.microsoft.com/office/drawing/2014/main" id="{95669EC8-67AD-445E-A372-6DF46D5C706C}"/>
+                <a16:creationId xmlns:a16="http://schemas.microsoft.com/office/drawing/2014/main" id="{EE362F3F-85BD-4605-BD4E-54CF567776F2}"/>
               </a:ext>
             </a:extLst>
           </p:cNvPr>
@@ -14683,7 +14683,7 @@
           <p:cNvPr id="23" name="">
             <a:extLst xmlns:a="http://schemas.openxmlformats.org/drawingml/2006/main">
               <a:ext uri="{FF2B5EF4-FFF2-40B4-BE49-F238E27FC236}">
-                <a16:creationId xmlns:a16="http://schemas.microsoft.com/office/drawing/2014/main" id="{7B1A7D04-4FB5-49D6-A3EB-17F8645C83ED}"/>
+                <a16:creationId xmlns:a16="http://schemas.microsoft.com/office/drawing/2014/main" id="{6EBE4335-96CC-4439-BD65-0DD5FDDDBDEB}"/>
               </a:ext>
             </a:extLst>
           </p:cNvPr>
@@ -14713,7 +14713,7 @@
           <p:cNvPr id="24" name="">
             <a:extLst xmlns:a="http://schemas.openxmlformats.org/drawingml/2006/main">
               <a:ext uri="{FF2B5EF4-FFF2-40B4-BE49-F238E27FC236}">
-                <a16:creationId xmlns:a16="http://schemas.microsoft.com/office/drawing/2014/main" id="{00B8ECE5-AD1E-44FA-B689-C33433932F41}"/>
+                <a16:creationId xmlns:a16="http://schemas.microsoft.com/office/drawing/2014/main" id="{B16A49F3-FF97-44E7-B26F-53BF23482EEF}"/>
               </a:ext>
             </a:extLst>
           </p:cNvPr>
@@ -14774,7 +14774,7 @@
           <p:cNvPr id="25" name="">
             <a:extLst xmlns:a="http://schemas.openxmlformats.org/drawingml/2006/main">
               <a:ext uri="{FF2B5EF4-FFF2-40B4-BE49-F238E27FC236}">
-                <a16:creationId xmlns:a16="http://schemas.microsoft.com/office/drawing/2014/main" id="{870EAE30-200F-4641-A49E-A3B6E20DAC3D}"/>
+                <a16:creationId xmlns:a16="http://schemas.microsoft.com/office/drawing/2014/main" id="{62149BC9-A0F9-4554-AF27-B1C586B045C8}"/>
               </a:ext>
             </a:extLst>
           </p:cNvPr>
@@ -14839,7 +14839,7 @@
           <p:cNvPr id="26" name="">
             <a:extLst xmlns:a="http://schemas.openxmlformats.org/drawingml/2006/main">
               <a:ext uri="{FF2B5EF4-FFF2-40B4-BE49-F238E27FC236}">
-                <a16:creationId xmlns:a16="http://schemas.microsoft.com/office/drawing/2014/main" id="{08FDF982-B64E-40D0-A635-0C242FF5DA25}"/>
+                <a16:creationId xmlns:a16="http://schemas.microsoft.com/office/drawing/2014/main" id="{B51A546B-827C-4023-A8F5-A19066BC3B43}"/>
               </a:ext>
             </a:extLst>
           </p:cNvPr>
@@ -14898,7 +14898,7 @@
     </p:spTree>
     <p:extLst>
       <p:ext uri="{BB962C8B-B14F-4D97-AF65-F5344CB8AC3E}">
-        <p14:creationId xmlns:p14="http://schemas.microsoft.com/office/powerpoint/2010/main" val="1312020135"/>
+        <p14:creationId xmlns:p14="http://schemas.microsoft.com/office/powerpoint/2010/main" val="1927464457"/>
       </p:ext>
     </p:extLst>
   </p:cSld>
@@ -14926,10 +14926,10 @@
       </p:grpSpPr>
       <p:sp>
         <p:nvSpPr>
-          <p:cNvPr id="8" name="">
-            <a:extLst xmlns:a="http://schemas.openxmlformats.org/drawingml/2006/main">
-              <a:ext uri="{FF2B5EF4-FFF2-40B4-BE49-F238E27FC236}">
-                <a16:creationId xmlns:a16="http://schemas.microsoft.com/office/drawing/2014/main" id="{B8F731C6-8E89-4597-AA20-E5624A11AD3A}"/>
+          <p:cNvPr id="37" name="">
+            <a:extLst xmlns:a="http://schemas.openxmlformats.org/drawingml/2006/main">
+              <a:ext uri="{FF2B5EF4-FFF2-40B4-BE49-F238E27FC236}">
+                <a16:creationId xmlns:a16="http://schemas.microsoft.com/office/drawing/2014/main" id="{1B3AA984-C1C8-47FE-B275-0576BE5B6EE5}"/>
               </a:ext>
             </a:extLst>
           </p:cNvPr>
@@ -14990,7 +14990,7 @@
           <p:cNvPr id="2" name="">
             <a:extLst xmlns:a="http://schemas.openxmlformats.org/drawingml/2006/main">
               <a:ext uri="{FF2B5EF4-FFF2-40B4-BE49-F238E27FC236}">
-                <a16:creationId xmlns:a16="http://schemas.microsoft.com/office/drawing/2014/main" id="{A044901F-FA97-41CA-8E63-EE7189D597F5}"/>
+                <a16:creationId xmlns:a16="http://schemas.microsoft.com/office/drawing/2014/main" id="{56778120-698D-46F1-89E8-1880B6FBFAD5}"/>
               </a:ext>
             </a:extLst>
           </p:cNvPr>
@@ -15051,19 +15051,1216 @@
           <p:cNvPr id="3" name="">
             <a:extLst xmlns:a="http://schemas.openxmlformats.org/drawingml/2006/main">
               <a:ext uri="{FF2B5EF4-FFF2-40B4-BE49-F238E27FC236}">
-                <a16:creationId xmlns:a16="http://schemas.microsoft.com/office/drawing/2014/main" id="{7CF2F867-5980-44F6-B34E-188C40F47AA1}"/>
-              </a:ext>
-            </a:extLst>
-          </p:cNvPr>
-          <p:cNvSpPr>
-            <a:spLocks xmlns:a="http://schemas.openxmlformats.org/drawingml/2006/main" noGrp="1"/>
-          </p:cNvSpPr>
-          <p:nvPr/>
-        </p:nvSpPr>
-        <p:spPr>
-          <a:xfrm xmlns:a="http://schemas.openxmlformats.org/drawingml/2006/main" rot="0">
-            <a:off x="1847850" y="1695450"/>
-            <a:ext cx="8496300" cy="742950"/>
+                <a16:creationId xmlns:a16="http://schemas.microsoft.com/office/drawing/2014/main" id="{FB2DC235-233C-4214-8A34-16F976AB56EE}"/>
+              </a:ext>
+            </a:extLst>
+          </p:cNvPr>
+          <p:cNvSpPr>
+            <a:spLocks xmlns:a="http://schemas.openxmlformats.org/drawingml/2006/main" noGrp="1"/>
+          </p:cNvSpPr>
+          <p:nvPr/>
+        </p:nvSpPr>
+        <p:spPr>
+          <a:xfrm xmlns:a="http://schemas.openxmlformats.org/drawingml/2006/main" rot="0">
+            <a:off x="723900" y="1600200"/>
+            <a:ext cx="3848100" cy="228600"/>
+          </a:xfrm>
+          <a:prstGeom xmlns:a="http://schemas.openxmlformats.org/drawingml/2006/main" prst="rect">
+            <a:avLst/>
+          </a:prstGeom>
+          <a:noFill xmlns:a="http://schemas.openxmlformats.org/drawingml/2006/main"/>
+          <a:ln xmlns:a="http://schemas.openxmlformats.org/drawingml/2006/main" w="0">
+            <a:noFill/>
+          </a:ln>
+        </p:spPr>
+        <p:txBody>
+          <a:bodyPr xmlns:a="http://schemas.openxmlformats.org/drawingml/2006/main" wrap="square" lIns="0" tIns="0" rIns="0" bIns="0" anchor="t">
+            <a:noAutofit/>
+          </a:bodyPr>
+          <a:lstStyle xmlns:a="http://schemas.openxmlformats.org/drawingml/2006/main"/>
+          <a:p xmlns:a="http://schemas.openxmlformats.org/drawingml/2006/main">
+            <a:pPr algn="ctr">
+              <a:lnSpc>
+                <a:spcPct val="105000"/>
+              </a:lnSpc>
+              <a:buNone/>
+              <a:defRPr sz="1125" b="1" i="0">
+                <a:solidFill>
+                  <a:srgbClr val="A8710A"/>
+                </a:solidFill>
+                <a:latin typeface="Arial"/>
+                <a:ea typeface="Arial"/>
+                <a:cs typeface="Arial"/>
+              </a:defRPr>
+            </a:pPr>
+            <a:r>
+              <a:rPr sz="1125" b="1" i="0">
+                <a:solidFill>
+                  <a:srgbClr val="A8710A"/>
+                </a:solidFill>
+                <a:latin typeface="Arial"/>
+                <a:ea typeface="Arial"/>
+                <a:cs typeface="Arial"/>
+              </a:rPr>
+              <a:t>ORIGINAL MEASUREMENTS</a:t>
+            </a:r>
+          </a:p>
+        </p:txBody>
+      </p:sp>
+      <p:sp>
+        <p:nvSpPr>
+          <p:cNvPr id="4" name="">
+            <a:extLst xmlns:a="http://schemas.openxmlformats.org/drawingml/2006/main">
+              <a:ext uri="{FF2B5EF4-FFF2-40B4-BE49-F238E27FC236}">
+                <a16:creationId xmlns:a16="http://schemas.microsoft.com/office/drawing/2014/main" id="{133C740D-57F0-411B-9CC1-CE20BDB9BC26}"/>
+              </a:ext>
+            </a:extLst>
+          </p:cNvPr>
+          <p:cNvSpPr>
+            <a:spLocks xmlns:a="http://schemas.openxmlformats.org/drawingml/2006/main" noGrp="1"/>
+          </p:cNvSpPr>
+          <p:nvPr/>
+        </p:nvSpPr>
+        <p:spPr>
+          <a:xfrm xmlns:a="http://schemas.openxmlformats.org/drawingml/2006/main" rot="0">
+            <a:off x="723900" y="1924050"/>
+            <a:ext cx="3848100" cy="2914650"/>
+          </a:xfrm>
+          <a:prstGeom xmlns:a="http://schemas.openxmlformats.org/drawingml/2006/main" prst="roundRect">
+            <a:avLst>
+              <a:gd name="adj" fmla="val 2614"/>
+            </a:avLst>
+          </a:prstGeom>
+          <a:solidFill xmlns:a="http://schemas.openxmlformats.org/drawingml/2006/main">
+            <a:srgbClr val="FFFDF8"/>
+          </a:solidFill>
+          <a:ln xmlns:a="http://schemas.openxmlformats.org/drawingml/2006/main" w="9525">
+            <a:solidFill>
+              <a:srgbClr val="D9D9D3"/>
+            </a:solidFill>
+            <a:prstDash val="solid"/>
+          </a:ln>
+        </p:spPr>
+      </p:sp>
+      <p:sp>
+        <p:nvSpPr>
+          <p:cNvPr id="5" name="">
+            <a:extLst xmlns:a="http://schemas.openxmlformats.org/drawingml/2006/main">
+              <a:ext uri="{FF2B5EF4-FFF2-40B4-BE49-F238E27FC236}">
+                <a16:creationId xmlns:a16="http://schemas.microsoft.com/office/drawing/2014/main" id="{4C6017C6-E342-49B2-AB28-D68AC5FB7EAD}"/>
+              </a:ext>
+            </a:extLst>
+          </p:cNvPr>
+          <p:cNvSpPr>
+            <a:spLocks xmlns:a="http://schemas.openxmlformats.org/drawingml/2006/main" noGrp="1"/>
+          </p:cNvSpPr>
+          <p:nvPr/>
+        </p:nvSpPr>
+        <p:spPr>
+          <a:xfrm xmlns:a="http://schemas.openxmlformats.org/drawingml/2006/main" rot="0">
+            <a:off x="1123950" y="4362450"/>
+            <a:ext cx="3200400" cy="19050"/>
+          </a:xfrm>
+          <a:prstGeom xmlns:a="http://schemas.openxmlformats.org/drawingml/2006/main" prst="rect">
+            <a:avLst/>
+          </a:prstGeom>
+          <a:solidFill xmlns:a="http://schemas.openxmlformats.org/drawingml/2006/main">
+            <a:srgbClr val="68717D"/>
+          </a:solidFill>
+          <a:ln xmlns:a="http://schemas.openxmlformats.org/drawingml/2006/main" w="0">
+            <a:noFill/>
+          </a:ln>
+        </p:spPr>
+      </p:sp>
+      <p:sp>
+        <p:nvSpPr>
+          <p:cNvPr id="6" name="">
+            <a:extLst xmlns:a="http://schemas.openxmlformats.org/drawingml/2006/main">
+              <a:ext uri="{FF2B5EF4-FFF2-40B4-BE49-F238E27FC236}">
+                <a16:creationId xmlns:a16="http://schemas.microsoft.com/office/drawing/2014/main" id="{4CD68C11-B1C7-4136-9027-1F092D01BCB9}"/>
+              </a:ext>
+            </a:extLst>
+          </p:cNvPr>
+          <p:cNvSpPr>
+            <a:spLocks xmlns:a="http://schemas.openxmlformats.org/drawingml/2006/main" noGrp="1"/>
+          </p:cNvSpPr>
+          <p:nvPr/>
+        </p:nvSpPr>
+        <p:spPr>
+          <a:xfrm xmlns:a="http://schemas.openxmlformats.org/drawingml/2006/main" rot="0">
+            <a:off x="1123950" y="2286000"/>
+            <a:ext cx="19050" cy="2076450"/>
+          </a:xfrm>
+          <a:prstGeom xmlns:a="http://schemas.openxmlformats.org/drawingml/2006/main" prst="rect">
+            <a:avLst/>
+          </a:prstGeom>
+          <a:solidFill xmlns:a="http://schemas.openxmlformats.org/drawingml/2006/main">
+            <a:srgbClr val="68717D"/>
+          </a:solidFill>
+          <a:ln xmlns:a="http://schemas.openxmlformats.org/drawingml/2006/main" w="0">
+            <a:noFill/>
+          </a:ln>
+        </p:spPr>
+      </p:sp>
+      <p:sp>
+        <p:nvSpPr>
+          <p:cNvPr id="7" name="">
+            <a:extLst xmlns:a="http://schemas.openxmlformats.org/drawingml/2006/main">
+              <a:ext uri="{FF2B5EF4-FFF2-40B4-BE49-F238E27FC236}">
+                <a16:creationId xmlns:a16="http://schemas.microsoft.com/office/drawing/2014/main" id="{7A0EF348-65DC-4F82-BEF0-01F6F5349BE1}"/>
+              </a:ext>
+            </a:extLst>
+          </p:cNvPr>
+          <p:cNvSpPr>
+            <a:spLocks xmlns:a="http://schemas.openxmlformats.org/drawingml/2006/main" noGrp="1"/>
+          </p:cNvSpPr>
+          <p:nvPr/>
+        </p:nvSpPr>
+        <p:spPr>
+          <a:xfrm xmlns:a="http://schemas.openxmlformats.org/drawingml/2006/main" flipV="1">
+            <a:off x="1123950" y="2348294"/>
+            <a:ext cx="3200400" cy="1951863"/>
+          </a:xfrm>
+          <a:prstGeom xmlns:a="http://schemas.openxmlformats.org/drawingml/2006/main" prst="line">
+            <a:avLst/>
+          </a:prstGeom>
+          <a:noFill xmlns:a="http://schemas.openxmlformats.org/drawingml/2006/main"/>
+          <a:ln xmlns:a="http://schemas.openxmlformats.org/drawingml/2006/main" w="28575">
+            <a:solidFill>
+              <a:srgbClr val="A8710A"/>
+            </a:solidFill>
+            <a:prstDash val="solid"/>
+          </a:ln>
+        </p:spPr>
+      </p:sp>
+      <p:sp>
+        <p:nvSpPr>
+          <p:cNvPr id="8" name="">
+            <a:extLst xmlns:a="http://schemas.openxmlformats.org/drawingml/2006/main">
+              <a:ext uri="{FF2B5EF4-FFF2-40B4-BE49-F238E27FC236}">
+                <a16:creationId xmlns:a16="http://schemas.microsoft.com/office/drawing/2014/main" id="{86E23750-C7FD-44EB-9B50-B4DF2846C68C}"/>
+              </a:ext>
+            </a:extLst>
+          </p:cNvPr>
+          <p:cNvSpPr>
+            <a:spLocks xmlns:a="http://schemas.openxmlformats.org/drawingml/2006/main" noGrp="1"/>
+          </p:cNvSpPr>
+          <p:nvPr/>
+        </p:nvSpPr>
+        <p:spPr>
+          <a:xfrm xmlns:a="http://schemas.openxmlformats.org/drawingml/2006/main" rot="0">
+            <a:off x="2124075" y="3610547"/>
+            <a:ext cx="133350" cy="133350"/>
+          </a:xfrm>
+          <a:prstGeom xmlns:a="http://schemas.openxmlformats.org/drawingml/2006/main" prst="ellipse">
+            <a:avLst/>
+          </a:prstGeom>
+          <a:solidFill xmlns:a="http://schemas.openxmlformats.org/drawingml/2006/main">
+            <a:srgbClr val="2C6A6C"/>
+          </a:solidFill>
+          <a:ln xmlns:a="http://schemas.openxmlformats.org/drawingml/2006/main" w="19050">
+            <a:solidFill>
+              <a:srgbClr val="FFFFFF"/>
+            </a:solidFill>
+            <a:prstDash val="solid"/>
+          </a:ln>
+        </p:spPr>
+      </p:sp>
+      <p:sp>
+        <p:nvSpPr>
+          <p:cNvPr id="9" name="">
+            <a:extLst xmlns:a="http://schemas.openxmlformats.org/drawingml/2006/main">
+              <a:ext uri="{FF2B5EF4-FFF2-40B4-BE49-F238E27FC236}">
+                <a16:creationId xmlns:a16="http://schemas.microsoft.com/office/drawing/2014/main" id="{4B7B2065-28E4-4EFF-AE00-F637EA85F96E}"/>
+              </a:ext>
+            </a:extLst>
+          </p:cNvPr>
+          <p:cNvSpPr>
+            <a:spLocks xmlns:a="http://schemas.openxmlformats.org/drawingml/2006/main" noGrp="1"/>
+          </p:cNvSpPr>
+          <p:nvPr/>
+        </p:nvSpPr>
+        <p:spPr>
+          <a:xfrm xmlns:a="http://schemas.openxmlformats.org/drawingml/2006/main" rot="0">
+            <a:off x="2657475" y="3368294"/>
+            <a:ext cx="133350" cy="133350"/>
+          </a:xfrm>
+          <a:prstGeom xmlns:a="http://schemas.openxmlformats.org/drawingml/2006/main" prst="ellipse">
+            <a:avLst/>
+          </a:prstGeom>
+          <a:solidFill xmlns:a="http://schemas.openxmlformats.org/drawingml/2006/main">
+            <a:srgbClr val="2C6A6C"/>
+          </a:solidFill>
+          <a:ln xmlns:a="http://schemas.openxmlformats.org/drawingml/2006/main" w="19050">
+            <a:solidFill>
+              <a:srgbClr val="FFFFFF"/>
+            </a:solidFill>
+            <a:prstDash val="solid"/>
+          </a:ln>
+        </p:spPr>
+      </p:sp>
+      <p:sp>
+        <p:nvSpPr>
+          <p:cNvPr id="10" name="">
+            <a:extLst xmlns:a="http://schemas.openxmlformats.org/drawingml/2006/main">
+              <a:ext uri="{FF2B5EF4-FFF2-40B4-BE49-F238E27FC236}">
+                <a16:creationId xmlns:a16="http://schemas.microsoft.com/office/drawing/2014/main" id="{D9832182-9993-4CC5-97EC-CA6FF5C34CAE}"/>
+              </a:ext>
+            </a:extLst>
+          </p:cNvPr>
+          <p:cNvSpPr>
+            <a:spLocks xmlns:a="http://schemas.openxmlformats.org/drawingml/2006/main" noGrp="1"/>
+          </p:cNvSpPr>
+          <p:nvPr/>
+        </p:nvSpPr>
+        <p:spPr>
+          <a:xfrm xmlns:a="http://schemas.openxmlformats.org/drawingml/2006/main" rot="0">
+            <a:off x="1590675" y="3818192"/>
+            <a:ext cx="133350" cy="133350"/>
+          </a:xfrm>
+          <a:prstGeom xmlns:a="http://schemas.openxmlformats.org/drawingml/2006/main" prst="ellipse">
+            <a:avLst/>
+          </a:prstGeom>
+          <a:solidFill xmlns:a="http://schemas.openxmlformats.org/drawingml/2006/main">
+            <a:srgbClr val="2C6A6C"/>
+          </a:solidFill>
+          <a:ln xmlns:a="http://schemas.openxmlformats.org/drawingml/2006/main" w="19050">
+            <a:solidFill>
+              <a:srgbClr val="FFFFFF"/>
+            </a:solidFill>
+            <a:prstDash val="solid"/>
+          </a:ln>
+        </p:spPr>
+      </p:sp>
+      <p:sp>
+        <p:nvSpPr>
+          <p:cNvPr id="11" name="">
+            <a:extLst xmlns:a="http://schemas.openxmlformats.org/drawingml/2006/main">
+              <a:ext uri="{FF2B5EF4-FFF2-40B4-BE49-F238E27FC236}">
+                <a16:creationId xmlns:a16="http://schemas.microsoft.com/office/drawing/2014/main" id="{A9744384-0D23-4BC4-A658-8E60DE9584B7}"/>
+              </a:ext>
+            </a:extLst>
+          </p:cNvPr>
+          <p:cNvSpPr>
+            <a:spLocks xmlns:a="http://schemas.openxmlformats.org/drawingml/2006/main" noGrp="1"/>
+          </p:cNvSpPr>
+          <p:nvPr/>
+        </p:nvSpPr>
+        <p:spPr>
+          <a:xfrm xmlns:a="http://schemas.openxmlformats.org/drawingml/2006/main" rot="0">
+            <a:off x="3724275" y="2503107"/>
+            <a:ext cx="133350" cy="133350"/>
+          </a:xfrm>
+          <a:prstGeom xmlns:a="http://schemas.openxmlformats.org/drawingml/2006/main" prst="ellipse">
+            <a:avLst/>
+          </a:prstGeom>
+          <a:solidFill xmlns:a="http://schemas.openxmlformats.org/drawingml/2006/main">
+            <a:srgbClr val="2C6A6C"/>
+          </a:solidFill>
+          <a:ln xmlns:a="http://schemas.openxmlformats.org/drawingml/2006/main" w="19050">
+            <a:solidFill>
+              <a:srgbClr val="FFFFFF"/>
+            </a:solidFill>
+            <a:prstDash val="solid"/>
+          </a:ln>
+        </p:spPr>
+      </p:sp>
+      <p:sp>
+        <p:nvSpPr>
+          <p:cNvPr id="12" name="">
+            <a:extLst xmlns:a="http://schemas.openxmlformats.org/drawingml/2006/main">
+              <a:ext uri="{FF2B5EF4-FFF2-40B4-BE49-F238E27FC236}">
+                <a16:creationId xmlns:a16="http://schemas.microsoft.com/office/drawing/2014/main" id="{3A147861-6C71-46BC-9C14-64FE682B8B95}"/>
+              </a:ext>
+            </a:extLst>
+          </p:cNvPr>
+          <p:cNvSpPr>
+            <a:spLocks xmlns:a="http://schemas.openxmlformats.org/drawingml/2006/main" noGrp="1"/>
+          </p:cNvSpPr>
+          <p:nvPr/>
+        </p:nvSpPr>
+        <p:spPr>
+          <a:xfrm xmlns:a="http://schemas.openxmlformats.org/drawingml/2006/main" rot="0">
+            <a:off x="3190875" y="2987612"/>
+            <a:ext cx="133350" cy="133350"/>
+          </a:xfrm>
+          <a:prstGeom xmlns:a="http://schemas.openxmlformats.org/drawingml/2006/main" prst="ellipse">
+            <a:avLst/>
+          </a:prstGeom>
+          <a:solidFill xmlns:a="http://schemas.openxmlformats.org/drawingml/2006/main">
+            <a:srgbClr val="2C6A6C"/>
+          </a:solidFill>
+          <a:ln xmlns:a="http://schemas.openxmlformats.org/drawingml/2006/main" w="19050">
+            <a:solidFill>
+              <a:srgbClr val="FFFFFF"/>
+            </a:solidFill>
+            <a:prstDash val="solid"/>
+          </a:ln>
+        </p:spPr>
+      </p:sp>
+      <p:sp>
+        <p:nvSpPr>
+          <p:cNvPr id="13" name="">
+            <a:extLst xmlns:a="http://schemas.openxmlformats.org/drawingml/2006/main">
+              <a:ext uri="{FF2B5EF4-FFF2-40B4-BE49-F238E27FC236}">
+                <a16:creationId xmlns:a16="http://schemas.microsoft.com/office/drawing/2014/main" id="{ED46B744-7A82-4DDE-BC91-A7BE5D11C42D}"/>
+              </a:ext>
+            </a:extLst>
+          </p:cNvPr>
+          <p:cNvSpPr>
+            <a:spLocks xmlns:a="http://schemas.openxmlformats.org/drawingml/2006/main" noGrp="1"/>
+          </p:cNvSpPr>
+          <p:nvPr/>
+        </p:nvSpPr>
+        <p:spPr>
+          <a:xfrm xmlns:a="http://schemas.openxmlformats.org/drawingml/2006/main" rot="0">
+            <a:off x="2638425" y="3238500"/>
+            <a:ext cx="171450" cy="171450"/>
+          </a:xfrm>
+          <a:prstGeom xmlns:a="http://schemas.openxmlformats.org/drawingml/2006/main" prst="ellipse">
+            <a:avLst/>
+          </a:prstGeom>
+          <a:solidFill xmlns:a="http://schemas.openxmlformats.org/drawingml/2006/main">
+            <a:srgbClr val="A8710A"/>
+          </a:solidFill>
+          <a:ln xmlns:a="http://schemas.openxmlformats.org/drawingml/2006/main" w="19050">
+            <a:solidFill>
+              <a:srgbClr val="FFFFFF"/>
+            </a:solidFill>
+            <a:prstDash val="solid"/>
+          </a:ln>
+        </p:spPr>
+      </p:sp>
+      <p:sp>
+        <p:nvSpPr>
+          <p:cNvPr id="14" name="">
+            <a:extLst xmlns:a="http://schemas.openxmlformats.org/drawingml/2006/main">
+              <a:ext uri="{FF2B5EF4-FFF2-40B4-BE49-F238E27FC236}">
+                <a16:creationId xmlns:a16="http://schemas.microsoft.com/office/drawing/2014/main" id="{226C86E4-691A-4EAE-811D-689C14D624A2}"/>
+              </a:ext>
+            </a:extLst>
+          </p:cNvPr>
+          <p:cNvSpPr>
+            <a:spLocks xmlns:a="http://schemas.openxmlformats.org/drawingml/2006/main" noGrp="1"/>
+          </p:cNvSpPr>
+          <p:nvPr/>
+        </p:nvSpPr>
+        <p:spPr>
+          <a:xfrm xmlns:a="http://schemas.openxmlformats.org/drawingml/2006/main" rot="0">
+            <a:off x="1200150" y="2343150"/>
+            <a:ext cx="1066800" cy="228600"/>
+          </a:xfrm>
+          <a:prstGeom xmlns:a="http://schemas.openxmlformats.org/drawingml/2006/main" prst="rect">
+            <a:avLst/>
+          </a:prstGeom>
+          <a:noFill xmlns:a="http://schemas.openxmlformats.org/drawingml/2006/main"/>
+          <a:ln xmlns:a="http://schemas.openxmlformats.org/drawingml/2006/main" w="0">
+            <a:noFill/>
+          </a:ln>
+        </p:spPr>
+        <p:txBody>
+          <a:bodyPr xmlns:a="http://schemas.openxmlformats.org/drawingml/2006/main" wrap="square" lIns="0" tIns="0" rIns="0" bIns="0" anchor="t">
+            <a:noAutofit/>
+          </a:bodyPr>
+          <a:lstStyle xmlns:a="http://schemas.openxmlformats.org/drawingml/2006/main"/>
+          <a:p xmlns:a="http://schemas.openxmlformats.org/drawingml/2006/main">
+            <a:pPr algn="l">
+              <a:lnSpc>
+                <a:spcPct val="105000"/>
+              </a:lnSpc>
+              <a:buNone/>
+              <a:defRPr sz="1200" b="1" i="0">
+                <a:solidFill>
+                  <a:srgbClr val="68717D"/>
+                </a:solidFill>
+                <a:latin typeface="Arial"/>
+                <a:ea typeface="Arial"/>
+                <a:cs typeface="Arial"/>
+              </a:defRPr>
+            </a:pPr>
+            <a:r>
+              <a:rPr sz="1200" b="1" i="0">
+                <a:solidFill>
+                  <a:srgbClr val="68717D"/>
+                </a:solidFill>
+                <a:latin typeface="Arial"/>
+                <a:ea typeface="Arial"/>
+                <a:cs typeface="Arial"/>
+              </a:rPr>
+              <a:t>fuel</a:t>
+            </a:r>
+          </a:p>
+        </p:txBody>
+      </p:sp>
+      <p:sp>
+        <p:nvSpPr>
+          <p:cNvPr id="15" name="">
+            <a:extLst xmlns:a="http://schemas.openxmlformats.org/drawingml/2006/main">
+              <a:ext uri="{FF2B5EF4-FFF2-40B4-BE49-F238E27FC236}">
+                <a16:creationId xmlns:a16="http://schemas.microsoft.com/office/drawing/2014/main" id="{6729E1E1-EF52-4BCC-BE72-80805B73A318}"/>
+              </a:ext>
+            </a:extLst>
+          </p:cNvPr>
+          <p:cNvSpPr>
+            <a:spLocks xmlns:a="http://schemas.openxmlformats.org/drawingml/2006/main" noGrp="1"/>
+          </p:cNvSpPr>
+          <p:nvPr/>
+        </p:nvSpPr>
+        <p:spPr>
+          <a:xfrm xmlns:a="http://schemas.openxmlformats.org/drawingml/2006/main" rot="0">
+            <a:off x="3200400" y="4476750"/>
+            <a:ext cx="1123950" cy="228600"/>
+          </a:xfrm>
+          <a:prstGeom xmlns:a="http://schemas.openxmlformats.org/drawingml/2006/main" prst="rect">
+            <a:avLst/>
+          </a:prstGeom>
+          <a:noFill xmlns:a="http://schemas.openxmlformats.org/drawingml/2006/main"/>
+          <a:ln xmlns:a="http://schemas.openxmlformats.org/drawingml/2006/main" w="0">
+            <a:noFill/>
+          </a:ln>
+        </p:spPr>
+        <p:txBody>
+          <a:bodyPr xmlns:a="http://schemas.openxmlformats.org/drawingml/2006/main" wrap="square" lIns="0" tIns="0" rIns="0" bIns="0" anchor="t">
+            <a:noAutofit/>
+          </a:bodyPr>
+          <a:lstStyle xmlns:a="http://schemas.openxmlformats.org/drawingml/2006/main"/>
+          <a:p xmlns:a="http://schemas.openxmlformats.org/drawingml/2006/main">
+            <a:pPr algn="r">
+              <a:lnSpc>
+                <a:spcPct val="105000"/>
+              </a:lnSpc>
+              <a:buNone/>
+              <a:defRPr sz="1200" b="1" i="0">
+                <a:solidFill>
+                  <a:srgbClr val="68717D"/>
+                </a:solidFill>
+                <a:latin typeface="Arial"/>
+                <a:ea typeface="Arial"/>
+                <a:cs typeface="Arial"/>
+              </a:defRPr>
+            </a:pPr>
+            <a:r>
+              <a:rPr sz="1200" b="1" i="0">
+                <a:solidFill>
+                  <a:srgbClr val="68717D"/>
+                </a:solidFill>
+                <a:latin typeface="Arial"/>
+                <a:ea typeface="Arial"/>
+                <a:cs typeface="Arial"/>
+              </a:rPr>
+              <a:t>weight</a:t>
+            </a:r>
+          </a:p>
+        </p:txBody>
+      </p:sp>
+      <p:sp>
+        <p:nvSpPr>
+          <p:cNvPr id="16" name="">
+            <a:extLst xmlns:a="http://schemas.openxmlformats.org/drawingml/2006/main">
+              <a:ext uri="{FF2B5EF4-FFF2-40B4-BE49-F238E27FC236}">
+                <a16:creationId xmlns:a16="http://schemas.microsoft.com/office/drawing/2014/main" id="{7F8FAFBB-E207-461A-89F9-F913DADA9BB2}"/>
+              </a:ext>
+            </a:extLst>
+          </p:cNvPr>
+          <p:cNvSpPr>
+            <a:spLocks xmlns:a="http://schemas.openxmlformats.org/drawingml/2006/main" noGrp="1"/>
+          </p:cNvSpPr>
+          <p:nvPr/>
+        </p:nvSpPr>
+        <p:spPr>
+          <a:xfrm xmlns:a="http://schemas.openxmlformats.org/drawingml/2006/main" rot="0">
+            <a:off x="2838450" y="3057525"/>
+            <a:ext cx="1466850" cy="228600"/>
+          </a:xfrm>
+          <a:prstGeom xmlns:a="http://schemas.openxmlformats.org/drawingml/2006/main" prst="rect">
+            <a:avLst/>
+          </a:prstGeom>
+          <a:noFill xmlns:a="http://schemas.openxmlformats.org/drawingml/2006/main"/>
+          <a:ln xmlns:a="http://schemas.openxmlformats.org/drawingml/2006/main" w="0">
+            <a:noFill/>
+          </a:ln>
+        </p:spPr>
+        <p:txBody>
+          <a:bodyPr xmlns:a="http://schemas.openxmlformats.org/drawingml/2006/main" wrap="square" lIns="0" tIns="0" rIns="0" bIns="0" anchor="t">
+            <a:noAutofit/>
+          </a:bodyPr>
+          <a:lstStyle xmlns:a="http://schemas.openxmlformats.org/drawingml/2006/main"/>
+          <a:p xmlns:a="http://schemas.openxmlformats.org/drawingml/2006/main">
+            <a:pPr algn="l">
+              <a:lnSpc>
+                <a:spcPct val="105000"/>
+              </a:lnSpc>
+              <a:buNone/>
+              <a:defRPr sz="1200" b="1" i="0">
+                <a:solidFill>
+                  <a:srgbClr val="A8710A"/>
+                </a:solidFill>
+                <a:latin typeface="Arial"/>
+                <a:ea typeface="Arial"/>
+                <a:cs typeface="Arial"/>
+              </a:defRPr>
+            </a:pPr>
+            <a:r>
+              <a:rPr sz="1200" b="1" i="0">
+                <a:solidFill>
+                  <a:srgbClr val="A8710A"/>
+                </a:solidFill>
+                <a:latin typeface="Arial"/>
+                <a:ea typeface="Arial"/>
+                <a:cs typeface="Arial"/>
+              </a:rPr>
+              <a:t>mean (1.4, 7.42)</a:t>
+            </a:r>
+          </a:p>
+        </p:txBody>
+      </p:sp>
+      <p:sp>
+        <p:nvSpPr>
+          <p:cNvPr id="17" name="">
+            <a:extLst xmlns:a="http://schemas.openxmlformats.org/drawingml/2006/main">
+              <a:ext uri="{FF2B5EF4-FFF2-40B4-BE49-F238E27FC236}">
+                <a16:creationId xmlns:a16="http://schemas.microsoft.com/office/drawing/2014/main" id="{6A254E70-A358-4E5D-9EE1-94ADFBD2CAAD}"/>
+              </a:ext>
+            </a:extLst>
+          </p:cNvPr>
+          <p:cNvSpPr>
+            <a:spLocks xmlns:a="http://schemas.openxmlformats.org/drawingml/2006/main" noGrp="1"/>
+          </p:cNvSpPr>
+          <p:nvPr/>
+        </p:nvSpPr>
+        <p:spPr>
+          <a:xfrm xmlns:a="http://schemas.openxmlformats.org/drawingml/2006/main" rot="0">
+            <a:off x="7620000" y="1600200"/>
+            <a:ext cx="3848100" cy="228600"/>
+          </a:xfrm>
+          <a:prstGeom xmlns:a="http://schemas.openxmlformats.org/drawingml/2006/main" prst="rect">
+            <a:avLst/>
+          </a:prstGeom>
+          <a:noFill xmlns:a="http://schemas.openxmlformats.org/drawingml/2006/main"/>
+          <a:ln xmlns:a="http://schemas.openxmlformats.org/drawingml/2006/main" w="0">
+            <a:noFill/>
+          </a:ln>
+        </p:spPr>
+        <p:txBody>
+          <a:bodyPr xmlns:a="http://schemas.openxmlformats.org/drawingml/2006/main" wrap="square" lIns="0" tIns="0" rIns="0" bIns="0" anchor="t">
+            <a:noAutofit/>
+          </a:bodyPr>
+          <a:lstStyle xmlns:a="http://schemas.openxmlformats.org/drawingml/2006/main"/>
+          <a:p xmlns:a="http://schemas.openxmlformats.org/drawingml/2006/main">
+            <a:pPr algn="ctr">
+              <a:lnSpc>
+                <a:spcPct val="105000"/>
+              </a:lnSpc>
+              <a:buNone/>
+              <a:defRPr sz="1125" b="1" i="0">
+                <a:solidFill>
+                  <a:srgbClr val="2C6A6C"/>
+                </a:solidFill>
+                <a:latin typeface="Arial"/>
+                <a:ea typeface="Arial"/>
+                <a:cs typeface="Arial"/>
+              </a:defRPr>
+            </a:pPr>
+            <a:r>
+              <a:rPr sz="1125" b="1" i="0">
+                <a:solidFill>
+                  <a:srgbClr val="2C6A6C"/>
+                </a:solidFill>
+                <a:latin typeface="Arial"/>
+                <a:ea typeface="Arial"/>
+                <a:cs typeface="Arial"/>
+              </a:rPr>
+              <a:t>CENTERED COORDINATES</a:t>
+            </a:r>
+          </a:p>
+        </p:txBody>
+      </p:sp>
+      <p:sp>
+        <p:nvSpPr>
+          <p:cNvPr id="18" name="">
+            <a:extLst xmlns:a="http://schemas.openxmlformats.org/drawingml/2006/main">
+              <a:ext uri="{FF2B5EF4-FFF2-40B4-BE49-F238E27FC236}">
+                <a16:creationId xmlns:a16="http://schemas.microsoft.com/office/drawing/2014/main" id="{5E83A89D-F8A1-42DD-B871-BFCEF5B8839B}"/>
+              </a:ext>
+            </a:extLst>
+          </p:cNvPr>
+          <p:cNvSpPr>
+            <a:spLocks xmlns:a="http://schemas.openxmlformats.org/drawingml/2006/main" noGrp="1"/>
+          </p:cNvSpPr>
+          <p:nvPr/>
+        </p:nvSpPr>
+        <p:spPr>
+          <a:xfrm xmlns:a="http://schemas.openxmlformats.org/drawingml/2006/main" rot="0">
+            <a:off x="7620000" y="1924050"/>
+            <a:ext cx="3848100" cy="2914650"/>
+          </a:xfrm>
+          <a:prstGeom xmlns:a="http://schemas.openxmlformats.org/drawingml/2006/main" prst="roundRect">
+            <a:avLst>
+              <a:gd name="adj" fmla="val 2614"/>
+            </a:avLst>
+          </a:prstGeom>
+          <a:solidFill xmlns:a="http://schemas.openxmlformats.org/drawingml/2006/main">
+            <a:srgbClr val="FFFDF8"/>
+          </a:solidFill>
+          <a:ln xmlns:a="http://schemas.openxmlformats.org/drawingml/2006/main" w="9525">
+            <a:solidFill>
+              <a:srgbClr val="D9D9D3"/>
+            </a:solidFill>
+            <a:prstDash val="solid"/>
+          </a:ln>
+        </p:spPr>
+      </p:sp>
+      <p:sp>
+        <p:nvSpPr>
+          <p:cNvPr id="19" name="">
+            <a:extLst xmlns:a="http://schemas.openxmlformats.org/drawingml/2006/main">
+              <a:ext uri="{FF2B5EF4-FFF2-40B4-BE49-F238E27FC236}">
+                <a16:creationId xmlns:a16="http://schemas.microsoft.com/office/drawing/2014/main" id="{F777F00E-1CB7-409E-BE44-EA0C8F737A34}"/>
+              </a:ext>
+            </a:extLst>
+          </p:cNvPr>
+          <p:cNvSpPr>
+            <a:spLocks xmlns:a="http://schemas.openxmlformats.org/drawingml/2006/main" noGrp="1"/>
+          </p:cNvSpPr>
+          <p:nvPr/>
+        </p:nvSpPr>
+        <p:spPr>
+          <a:xfrm xmlns:a="http://schemas.openxmlformats.org/drawingml/2006/main" rot="0">
+            <a:off x="8020050" y="3324225"/>
+            <a:ext cx="3200400" cy="19050"/>
+          </a:xfrm>
+          <a:prstGeom xmlns:a="http://schemas.openxmlformats.org/drawingml/2006/main" prst="rect">
+            <a:avLst/>
+          </a:prstGeom>
+          <a:solidFill xmlns:a="http://schemas.openxmlformats.org/drawingml/2006/main">
+            <a:srgbClr val="68717D"/>
+          </a:solidFill>
+          <a:ln xmlns:a="http://schemas.openxmlformats.org/drawingml/2006/main" w="0">
+            <a:noFill/>
+          </a:ln>
+        </p:spPr>
+      </p:sp>
+      <p:sp>
+        <p:nvSpPr>
+          <p:cNvPr id="20" name="">
+            <a:extLst xmlns:a="http://schemas.openxmlformats.org/drawingml/2006/main">
+              <a:ext uri="{FF2B5EF4-FFF2-40B4-BE49-F238E27FC236}">
+                <a16:creationId xmlns:a16="http://schemas.microsoft.com/office/drawing/2014/main" id="{B6FA1D45-3B91-4B4A-AD9D-2B8969B1E6FB}"/>
+              </a:ext>
+            </a:extLst>
+          </p:cNvPr>
+          <p:cNvSpPr>
+            <a:spLocks xmlns:a="http://schemas.openxmlformats.org/drawingml/2006/main" noGrp="1"/>
+          </p:cNvSpPr>
+          <p:nvPr/>
+        </p:nvSpPr>
+        <p:spPr>
+          <a:xfrm xmlns:a="http://schemas.openxmlformats.org/drawingml/2006/main" rot="0">
+            <a:off x="9620250" y="2286000"/>
+            <a:ext cx="19050" cy="2076450"/>
+          </a:xfrm>
+          <a:prstGeom xmlns:a="http://schemas.openxmlformats.org/drawingml/2006/main" prst="rect">
+            <a:avLst/>
+          </a:prstGeom>
+          <a:solidFill xmlns:a="http://schemas.openxmlformats.org/drawingml/2006/main">
+            <a:srgbClr val="68717D"/>
+          </a:solidFill>
+          <a:ln xmlns:a="http://schemas.openxmlformats.org/drawingml/2006/main" w="0">
+            <a:noFill/>
+          </a:ln>
+        </p:spPr>
+      </p:sp>
+      <p:sp>
+        <p:nvSpPr>
+          <p:cNvPr id="21" name="">
+            <a:extLst xmlns:a="http://schemas.openxmlformats.org/drawingml/2006/main">
+              <a:ext uri="{FF2B5EF4-FFF2-40B4-BE49-F238E27FC236}">
+                <a16:creationId xmlns:a16="http://schemas.microsoft.com/office/drawing/2014/main" id="{FBDA5F2A-A12C-4586-BDF0-07BBBE9FF4E9}"/>
+              </a:ext>
+            </a:extLst>
+          </p:cNvPr>
+          <p:cNvSpPr>
+            <a:spLocks xmlns:a="http://schemas.openxmlformats.org/drawingml/2006/main" noGrp="1"/>
+          </p:cNvSpPr>
+          <p:nvPr/>
+        </p:nvSpPr>
+        <p:spPr>
+          <a:xfrm xmlns:a="http://schemas.openxmlformats.org/drawingml/2006/main" flipV="1">
+            <a:off x="8020050" y="2348294"/>
+            <a:ext cx="3200400" cy="1951863"/>
+          </a:xfrm>
+          <a:prstGeom xmlns:a="http://schemas.openxmlformats.org/drawingml/2006/main" prst="line">
+            <a:avLst/>
+          </a:prstGeom>
+          <a:noFill xmlns:a="http://schemas.openxmlformats.org/drawingml/2006/main"/>
+          <a:ln xmlns:a="http://schemas.openxmlformats.org/drawingml/2006/main" w="28575">
+            <a:solidFill>
+              <a:srgbClr val="A8710A"/>
+            </a:solidFill>
+            <a:prstDash val="solid"/>
+          </a:ln>
+        </p:spPr>
+      </p:sp>
+      <p:sp>
+        <p:nvSpPr>
+          <p:cNvPr id="22" name="">
+            <a:extLst xmlns:a="http://schemas.openxmlformats.org/drawingml/2006/main">
+              <a:ext uri="{FF2B5EF4-FFF2-40B4-BE49-F238E27FC236}">
+                <a16:creationId xmlns:a16="http://schemas.microsoft.com/office/drawing/2014/main" id="{0C77969C-55BB-4CF9-B636-07430A2FF53E}"/>
+              </a:ext>
+            </a:extLst>
+          </p:cNvPr>
+          <p:cNvSpPr>
+            <a:spLocks xmlns:a="http://schemas.openxmlformats.org/drawingml/2006/main" noGrp="1"/>
+          </p:cNvSpPr>
+          <p:nvPr/>
+        </p:nvSpPr>
+        <p:spPr>
+          <a:xfrm xmlns:a="http://schemas.openxmlformats.org/drawingml/2006/main" rot="0">
+            <a:off x="9020175" y="3610547"/>
+            <a:ext cx="133350" cy="133350"/>
+          </a:xfrm>
+          <a:prstGeom xmlns:a="http://schemas.openxmlformats.org/drawingml/2006/main" prst="ellipse">
+            <a:avLst/>
+          </a:prstGeom>
+          <a:solidFill xmlns:a="http://schemas.openxmlformats.org/drawingml/2006/main">
+            <a:srgbClr val="2C6A6C"/>
+          </a:solidFill>
+          <a:ln xmlns:a="http://schemas.openxmlformats.org/drawingml/2006/main" w="19050">
+            <a:solidFill>
+              <a:srgbClr val="FFFFFF"/>
+            </a:solidFill>
+            <a:prstDash val="solid"/>
+          </a:ln>
+        </p:spPr>
+      </p:sp>
+      <p:sp>
+        <p:nvSpPr>
+          <p:cNvPr id="23" name="">
+            <a:extLst xmlns:a="http://schemas.openxmlformats.org/drawingml/2006/main">
+              <a:ext uri="{FF2B5EF4-FFF2-40B4-BE49-F238E27FC236}">
+                <a16:creationId xmlns:a16="http://schemas.microsoft.com/office/drawing/2014/main" id="{A5E6231C-C248-494F-B68A-D93AF3AF0E16}"/>
+              </a:ext>
+            </a:extLst>
+          </p:cNvPr>
+          <p:cNvSpPr>
+            <a:spLocks xmlns:a="http://schemas.openxmlformats.org/drawingml/2006/main" noGrp="1"/>
+          </p:cNvSpPr>
+          <p:nvPr/>
+        </p:nvSpPr>
+        <p:spPr>
+          <a:xfrm xmlns:a="http://schemas.openxmlformats.org/drawingml/2006/main" rot="0">
+            <a:off x="9553575" y="3368294"/>
+            <a:ext cx="133350" cy="133350"/>
+          </a:xfrm>
+          <a:prstGeom xmlns:a="http://schemas.openxmlformats.org/drawingml/2006/main" prst="ellipse">
+            <a:avLst/>
+          </a:prstGeom>
+          <a:solidFill xmlns:a="http://schemas.openxmlformats.org/drawingml/2006/main">
+            <a:srgbClr val="2C6A6C"/>
+          </a:solidFill>
+          <a:ln xmlns:a="http://schemas.openxmlformats.org/drawingml/2006/main" w="19050">
+            <a:solidFill>
+              <a:srgbClr val="FFFFFF"/>
+            </a:solidFill>
+            <a:prstDash val="solid"/>
+          </a:ln>
+        </p:spPr>
+      </p:sp>
+      <p:sp>
+        <p:nvSpPr>
+          <p:cNvPr id="24" name="">
+            <a:extLst xmlns:a="http://schemas.openxmlformats.org/drawingml/2006/main">
+              <a:ext uri="{FF2B5EF4-FFF2-40B4-BE49-F238E27FC236}">
+                <a16:creationId xmlns:a16="http://schemas.microsoft.com/office/drawing/2014/main" id="{8289D282-6CED-4118-A64D-23217EB5EF71}"/>
+              </a:ext>
+            </a:extLst>
+          </p:cNvPr>
+          <p:cNvSpPr>
+            <a:spLocks xmlns:a="http://schemas.openxmlformats.org/drawingml/2006/main" noGrp="1"/>
+          </p:cNvSpPr>
+          <p:nvPr/>
+        </p:nvSpPr>
+        <p:spPr>
+          <a:xfrm xmlns:a="http://schemas.openxmlformats.org/drawingml/2006/main" rot="0">
+            <a:off x="8486775" y="3818192"/>
+            <a:ext cx="133350" cy="133350"/>
+          </a:xfrm>
+          <a:prstGeom xmlns:a="http://schemas.openxmlformats.org/drawingml/2006/main" prst="ellipse">
+            <a:avLst/>
+          </a:prstGeom>
+          <a:solidFill xmlns:a="http://schemas.openxmlformats.org/drawingml/2006/main">
+            <a:srgbClr val="2C6A6C"/>
+          </a:solidFill>
+          <a:ln xmlns:a="http://schemas.openxmlformats.org/drawingml/2006/main" w="19050">
+            <a:solidFill>
+              <a:srgbClr val="FFFFFF"/>
+            </a:solidFill>
+            <a:prstDash val="solid"/>
+          </a:ln>
+        </p:spPr>
+      </p:sp>
+      <p:sp>
+        <p:nvSpPr>
+          <p:cNvPr id="25" name="">
+            <a:extLst xmlns:a="http://schemas.openxmlformats.org/drawingml/2006/main">
+              <a:ext uri="{FF2B5EF4-FFF2-40B4-BE49-F238E27FC236}">
+                <a16:creationId xmlns:a16="http://schemas.microsoft.com/office/drawing/2014/main" id="{FF4649C8-3F8D-4F2E-B5F6-673811DC6753}"/>
+              </a:ext>
+            </a:extLst>
+          </p:cNvPr>
+          <p:cNvSpPr>
+            <a:spLocks xmlns:a="http://schemas.openxmlformats.org/drawingml/2006/main" noGrp="1"/>
+          </p:cNvSpPr>
+          <p:nvPr/>
+        </p:nvSpPr>
+        <p:spPr>
+          <a:xfrm xmlns:a="http://schemas.openxmlformats.org/drawingml/2006/main" rot="0">
+            <a:off x="10620375" y="2503107"/>
+            <a:ext cx="133350" cy="133350"/>
+          </a:xfrm>
+          <a:prstGeom xmlns:a="http://schemas.openxmlformats.org/drawingml/2006/main" prst="ellipse">
+            <a:avLst/>
+          </a:prstGeom>
+          <a:solidFill xmlns:a="http://schemas.openxmlformats.org/drawingml/2006/main">
+            <a:srgbClr val="2C6A6C"/>
+          </a:solidFill>
+          <a:ln xmlns:a="http://schemas.openxmlformats.org/drawingml/2006/main" w="19050">
+            <a:solidFill>
+              <a:srgbClr val="FFFFFF"/>
+            </a:solidFill>
+            <a:prstDash val="solid"/>
+          </a:ln>
+        </p:spPr>
+      </p:sp>
+      <p:sp>
+        <p:nvSpPr>
+          <p:cNvPr id="26" name="">
+            <a:extLst xmlns:a="http://schemas.openxmlformats.org/drawingml/2006/main">
+              <a:ext uri="{FF2B5EF4-FFF2-40B4-BE49-F238E27FC236}">
+                <a16:creationId xmlns:a16="http://schemas.microsoft.com/office/drawing/2014/main" id="{9894CCBB-8E4A-467E-A578-3BADFE5C9B1A}"/>
+              </a:ext>
+            </a:extLst>
+          </p:cNvPr>
+          <p:cNvSpPr>
+            <a:spLocks xmlns:a="http://schemas.openxmlformats.org/drawingml/2006/main" noGrp="1"/>
+          </p:cNvSpPr>
+          <p:nvPr/>
+        </p:nvSpPr>
+        <p:spPr>
+          <a:xfrm xmlns:a="http://schemas.openxmlformats.org/drawingml/2006/main" rot="0">
+            <a:off x="10086975" y="2987612"/>
+            <a:ext cx="133350" cy="133350"/>
+          </a:xfrm>
+          <a:prstGeom xmlns:a="http://schemas.openxmlformats.org/drawingml/2006/main" prst="ellipse">
+            <a:avLst/>
+          </a:prstGeom>
+          <a:solidFill xmlns:a="http://schemas.openxmlformats.org/drawingml/2006/main">
+            <a:srgbClr val="2C6A6C"/>
+          </a:solidFill>
+          <a:ln xmlns:a="http://schemas.openxmlformats.org/drawingml/2006/main" w="19050">
+            <a:solidFill>
+              <a:srgbClr val="FFFFFF"/>
+            </a:solidFill>
+            <a:prstDash val="solid"/>
+          </a:ln>
+        </p:spPr>
+      </p:sp>
+      <p:sp>
+        <p:nvSpPr>
+          <p:cNvPr id="27" name="">
+            <a:extLst xmlns:a="http://schemas.openxmlformats.org/drawingml/2006/main">
+              <a:ext uri="{FF2B5EF4-FFF2-40B4-BE49-F238E27FC236}">
+                <a16:creationId xmlns:a16="http://schemas.microsoft.com/office/drawing/2014/main" id="{452501E9-1575-471B-ACB7-8017461FB83E}"/>
+              </a:ext>
+            </a:extLst>
+          </p:cNvPr>
+          <p:cNvSpPr>
+            <a:spLocks xmlns:a="http://schemas.openxmlformats.org/drawingml/2006/main" noGrp="1"/>
+          </p:cNvSpPr>
+          <p:nvPr/>
+        </p:nvSpPr>
+        <p:spPr>
+          <a:xfrm xmlns:a="http://schemas.openxmlformats.org/drawingml/2006/main" rot="0">
+            <a:off x="9534525" y="3238500"/>
+            <a:ext cx="171450" cy="171450"/>
+          </a:xfrm>
+          <a:prstGeom xmlns:a="http://schemas.openxmlformats.org/drawingml/2006/main" prst="ellipse">
+            <a:avLst/>
+          </a:prstGeom>
+          <a:solidFill xmlns:a="http://schemas.openxmlformats.org/drawingml/2006/main">
+            <a:srgbClr val="A8710A"/>
+          </a:solidFill>
+          <a:ln xmlns:a="http://schemas.openxmlformats.org/drawingml/2006/main" w="19050">
+            <a:solidFill>
+              <a:srgbClr val="FFFFFF"/>
+            </a:solidFill>
+            <a:prstDash val="solid"/>
+          </a:ln>
+        </p:spPr>
+      </p:sp>
+      <p:sp>
+        <p:nvSpPr>
+          <p:cNvPr id="28" name="">
+            <a:extLst xmlns:a="http://schemas.openxmlformats.org/drawingml/2006/main">
+              <a:ext uri="{FF2B5EF4-FFF2-40B4-BE49-F238E27FC236}">
+                <a16:creationId xmlns:a16="http://schemas.microsoft.com/office/drawing/2014/main" id="{DE9E706F-EE7C-433E-B91A-7D8CA6B97947}"/>
+              </a:ext>
+            </a:extLst>
+          </p:cNvPr>
+          <p:cNvSpPr>
+            <a:spLocks xmlns:a="http://schemas.openxmlformats.org/drawingml/2006/main" noGrp="1"/>
+          </p:cNvSpPr>
+          <p:nvPr/>
+        </p:nvSpPr>
+        <p:spPr>
+          <a:xfrm xmlns:a="http://schemas.openxmlformats.org/drawingml/2006/main" rot="0">
+            <a:off x="8096250" y="2343150"/>
+            <a:ext cx="1066800" cy="228600"/>
+          </a:xfrm>
+          <a:prstGeom xmlns:a="http://schemas.openxmlformats.org/drawingml/2006/main" prst="rect">
+            <a:avLst/>
+          </a:prstGeom>
+          <a:noFill xmlns:a="http://schemas.openxmlformats.org/drawingml/2006/main"/>
+          <a:ln xmlns:a="http://schemas.openxmlformats.org/drawingml/2006/main" w="0">
+            <a:noFill/>
+          </a:ln>
+        </p:spPr>
+        <p:txBody>
+          <a:bodyPr xmlns:a="http://schemas.openxmlformats.org/drawingml/2006/main" wrap="square" lIns="0" tIns="0" rIns="0" bIns="0" anchor="t">
+            <a:noAutofit/>
+          </a:bodyPr>
+          <a:lstStyle xmlns:a="http://schemas.openxmlformats.org/drawingml/2006/main"/>
+          <a:p xmlns:a="http://schemas.openxmlformats.org/drawingml/2006/main">
+            <a:pPr algn="l">
+              <a:lnSpc>
+                <a:spcPct val="105000"/>
+              </a:lnSpc>
+              <a:buNone/>
+              <a:defRPr sz="1200" b="1" i="0">
+                <a:solidFill>
+                  <a:srgbClr val="68717D"/>
+                </a:solidFill>
+                <a:latin typeface="Arial"/>
+                <a:ea typeface="Arial"/>
+                <a:cs typeface="Arial"/>
+              </a:defRPr>
+            </a:pPr>
+            <a:r>
+              <a:rPr sz="1200" b="1" i="0">
+                <a:solidFill>
+                  <a:srgbClr val="68717D"/>
+                </a:solidFill>
+                <a:latin typeface="Arial"/>
+                <a:ea typeface="Arial"/>
+                <a:cs typeface="Arial"/>
+              </a:rPr>
+              <a:t>fuel − 7.42</a:t>
+            </a:r>
+          </a:p>
+        </p:txBody>
+      </p:sp>
+      <p:sp>
+        <p:nvSpPr>
+          <p:cNvPr id="29" name="">
+            <a:extLst xmlns:a="http://schemas.openxmlformats.org/drawingml/2006/main">
+              <a:ext uri="{FF2B5EF4-FFF2-40B4-BE49-F238E27FC236}">
+                <a16:creationId xmlns:a16="http://schemas.microsoft.com/office/drawing/2014/main" id="{1BFD1911-61A0-495F-AE0D-5ED44434718A}"/>
+              </a:ext>
+            </a:extLst>
+          </p:cNvPr>
+          <p:cNvSpPr>
+            <a:spLocks xmlns:a="http://schemas.openxmlformats.org/drawingml/2006/main" noGrp="1"/>
+          </p:cNvSpPr>
+          <p:nvPr/>
+        </p:nvSpPr>
+        <p:spPr>
+          <a:xfrm xmlns:a="http://schemas.openxmlformats.org/drawingml/2006/main" rot="0">
+            <a:off x="10096500" y="4476750"/>
+            <a:ext cx="1123950" cy="228600"/>
+          </a:xfrm>
+          <a:prstGeom xmlns:a="http://schemas.openxmlformats.org/drawingml/2006/main" prst="rect">
+            <a:avLst/>
+          </a:prstGeom>
+          <a:noFill xmlns:a="http://schemas.openxmlformats.org/drawingml/2006/main"/>
+          <a:ln xmlns:a="http://schemas.openxmlformats.org/drawingml/2006/main" w="0">
+            <a:noFill/>
+          </a:ln>
+        </p:spPr>
+        <p:txBody>
+          <a:bodyPr xmlns:a="http://schemas.openxmlformats.org/drawingml/2006/main" wrap="square" lIns="0" tIns="0" rIns="0" bIns="0" anchor="t">
+            <a:noAutofit/>
+          </a:bodyPr>
+          <a:lstStyle xmlns:a="http://schemas.openxmlformats.org/drawingml/2006/main"/>
+          <a:p xmlns:a="http://schemas.openxmlformats.org/drawingml/2006/main">
+            <a:pPr algn="r">
+              <a:lnSpc>
+                <a:spcPct val="105000"/>
+              </a:lnSpc>
+              <a:buNone/>
+              <a:defRPr sz="1200" b="1" i="0">
+                <a:solidFill>
+                  <a:srgbClr val="68717D"/>
+                </a:solidFill>
+                <a:latin typeface="Arial"/>
+                <a:ea typeface="Arial"/>
+                <a:cs typeface="Arial"/>
+              </a:defRPr>
+            </a:pPr>
+            <a:r>
+              <a:rPr sz="1200" b="1" i="0">
+                <a:solidFill>
+                  <a:srgbClr val="68717D"/>
+                </a:solidFill>
+                <a:latin typeface="Arial"/>
+                <a:ea typeface="Arial"/>
+                <a:cs typeface="Arial"/>
+              </a:rPr>
+              <a:t>weight − 1.4</a:t>
+            </a:r>
+          </a:p>
+        </p:txBody>
+      </p:sp>
+      <p:sp>
+        <p:nvSpPr>
+          <p:cNvPr id="30" name="">
+            <a:extLst xmlns:a="http://schemas.openxmlformats.org/drawingml/2006/main">
+              <a:ext uri="{FF2B5EF4-FFF2-40B4-BE49-F238E27FC236}">
+                <a16:creationId xmlns:a16="http://schemas.microsoft.com/office/drawing/2014/main" id="{5508FE07-B0AD-4926-8DFF-680CB5B0D943}"/>
+              </a:ext>
+            </a:extLst>
+          </p:cNvPr>
+          <p:cNvSpPr>
+            <a:spLocks xmlns:a="http://schemas.openxmlformats.org/drawingml/2006/main" noGrp="1"/>
+          </p:cNvSpPr>
+          <p:nvPr/>
+        </p:nvSpPr>
+        <p:spPr>
+          <a:xfrm xmlns:a="http://schemas.openxmlformats.org/drawingml/2006/main" rot="0">
+            <a:off x="9734550" y="3057525"/>
+            <a:ext cx="1466850" cy="228600"/>
+          </a:xfrm>
+          <a:prstGeom xmlns:a="http://schemas.openxmlformats.org/drawingml/2006/main" prst="rect">
+            <a:avLst/>
+          </a:prstGeom>
+          <a:noFill xmlns:a="http://schemas.openxmlformats.org/drawingml/2006/main"/>
+          <a:ln xmlns:a="http://schemas.openxmlformats.org/drawingml/2006/main" w="0">
+            <a:noFill/>
+          </a:ln>
+        </p:spPr>
+        <p:txBody>
+          <a:bodyPr xmlns:a="http://schemas.openxmlformats.org/drawingml/2006/main" wrap="square" lIns="0" tIns="0" rIns="0" bIns="0" anchor="t">
+            <a:noAutofit/>
+          </a:bodyPr>
+          <a:lstStyle xmlns:a="http://schemas.openxmlformats.org/drawingml/2006/main"/>
+          <a:p xmlns:a="http://schemas.openxmlformats.org/drawingml/2006/main">
+            <a:pPr algn="l">
+              <a:lnSpc>
+                <a:spcPct val="105000"/>
+              </a:lnSpc>
+              <a:buNone/>
+              <a:defRPr sz="1200" b="1" i="0">
+                <a:solidFill>
+                  <a:srgbClr val="A8710A"/>
+                </a:solidFill>
+                <a:latin typeface="Arial"/>
+                <a:ea typeface="Arial"/>
+                <a:cs typeface="Arial"/>
+              </a:defRPr>
+            </a:pPr>
+            <a:r>
+              <a:rPr sz="1200" b="1" i="0">
+                <a:solidFill>
+                  <a:srgbClr val="A8710A"/>
+                </a:solidFill>
+                <a:latin typeface="Arial"/>
+                <a:ea typeface="Arial"/>
+                <a:cs typeface="Arial"/>
+              </a:rPr>
+              <a:t>mean (0, 0)</a:t>
+            </a:r>
+          </a:p>
+        </p:txBody>
+      </p:sp>
+      <p:sp>
+        <p:nvSpPr>
+          <p:cNvPr id="31" name="">
+            <a:extLst xmlns:a="http://schemas.openxmlformats.org/drawingml/2006/main">
+              <a:ext uri="{FF2B5EF4-FFF2-40B4-BE49-F238E27FC236}">
+                <a16:creationId xmlns:a16="http://schemas.microsoft.com/office/drawing/2014/main" id="{C1D03AF6-D6B8-4B6A-A9CE-74188656708B}"/>
+              </a:ext>
+            </a:extLst>
+          </p:cNvPr>
+          <p:cNvSpPr>
+            <a:spLocks xmlns:a="http://schemas.openxmlformats.org/drawingml/2006/main" noGrp="1"/>
+          </p:cNvSpPr>
+          <p:nvPr/>
+        </p:nvSpPr>
+        <p:spPr>
+          <a:xfrm xmlns:a="http://schemas.openxmlformats.org/drawingml/2006/main" rot="0">
+            <a:off x="5305425" y="2571750"/>
+            <a:ext cx="1581150" cy="228600"/>
+          </a:xfrm>
+          <a:prstGeom xmlns:a="http://schemas.openxmlformats.org/drawingml/2006/main" prst="rect">
+            <a:avLst/>
+          </a:prstGeom>
+          <a:noFill xmlns:a="http://schemas.openxmlformats.org/drawingml/2006/main"/>
+          <a:ln xmlns:a="http://schemas.openxmlformats.org/drawingml/2006/main" w="0">
+            <a:noFill/>
+          </a:ln>
+        </p:spPr>
+        <p:txBody>
+          <a:bodyPr xmlns:a="http://schemas.openxmlformats.org/drawingml/2006/main" wrap="square" lIns="0" tIns="0" rIns="0" bIns="0" anchor="t">
+            <a:noAutofit/>
+          </a:bodyPr>
+          <a:lstStyle xmlns:a="http://schemas.openxmlformats.org/drawingml/2006/main"/>
+          <a:p xmlns:a="http://schemas.openxmlformats.org/drawingml/2006/main">
+            <a:pPr algn="ctr">
+              <a:lnSpc>
+                <a:spcPct val="105000"/>
+              </a:lnSpc>
+              <a:buNone/>
+              <a:defRPr sz="1125" b="1" i="0">
+                <a:solidFill>
+                  <a:srgbClr val="A8710A"/>
+                </a:solidFill>
+                <a:latin typeface="Arial"/>
+                <a:ea typeface="Arial"/>
+                <a:cs typeface="Arial"/>
+              </a:defRPr>
+            </a:pPr>
+            <a:r>
+              <a:rPr sz="1125" b="1" i="0">
+                <a:solidFill>
+                  <a:srgbClr val="A8710A"/>
+                </a:solidFill>
+                <a:latin typeface="Arial"/>
+                <a:ea typeface="Arial"/>
+                <a:cs typeface="Arial"/>
+              </a:rPr>
+              <a:t>CENTER</a:t>
+            </a:r>
+          </a:p>
+        </p:txBody>
+      </p:sp>
+      <p:sp>
+        <p:nvSpPr>
+          <p:cNvPr id="32" name="">
+            <a:extLst xmlns:a="http://schemas.openxmlformats.org/drawingml/2006/main">
+              <a:ext uri="{FF2B5EF4-FFF2-40B4-BE49-F238E27FC236}">
+                <a16:creationId xmlns:a16="http://schemas.microsoft.com/office/drawing/2014/main" id="{735A835B-858E-41D2-AA25-9C864B2E720F}"/>
+              </a:ext>
+            </a:extLst>
+          </p:cNvPr>
+          <p:cNvSpPr>
+            <a:spLocks xmlns:a="http://schemas.openxmlformats.org/drawingml/2006/main" noGrp="1"/>
+          </p:cNvSpPr>
+          <p:nvPr/>
+        </p:nvSpPr>
+        <p:spPr>
+          <a:xfrm xmlns:a="http://schemas.openxmlformats.org/drawingml/2006/main" rot="0">
+            <a:off x="5143500" y="2952750"/>
+            <a:ext cx="1905000" cy="647700"/>
           </a:xfrm>
           <a:prstGeom xmlns:a="http://schemas.openxmlformats.org/drawingml/2006/main" prst="rect">
             <a:avLst/>
@@ -15084,9 +16281,9 @@
                 <a:spcPct val="105000"/>
               </a:lnSpc>
               <a:buNone/>
-              <a:defRPr sz="3375" b="0" i="0">
-                <a:solidFill>
-                  <a:srgbClr val="252A31"/>
+              <a:defRPr sz="2925" b="0" i="0">
+                <a:solidFill>
+                  <a:srgbClr val="A8710A"/>
                 </a:solidFill>
                 <a:latin typeface="Cambria Math"/>
                 <a:ea typeface="Cambria Math"/>
@@ -15094,37 +16291,37 @@
               </a:defRPr>
             </a:pPr>
             <a:r>
-              <a:rPr sz="3375" b="0" i="0">
-                <a:solidFill>
-                  <a:srgbClr val="252A31"/>
+              <a:rPr sz="2925" b="0" i="0">
+                <a:solidFill>
+                  <a:srgbClr val="A8710A"/>
                 </a:solidFill>
                 <a:latin typeface="Cambria Math"/>
                 <a:ea typeface="Cambria Math"/>
                 <a:cs typeface="Cambria Math"/>
               </a:rPr>
-              <a:t>Y = 1β₀ + Xβ + ε</a:t>
-            </a:r>
-          </a:p>
-        </p:txBody>
-      </p:sp>
-      <p:sp>
-        <p:nvSpPr>
-          <p:cNvPr id="4" name="">
-            <a:extLst xmlns:a="http://schemas.openxmlformats.org/drawingml/2006/main">
-              <a:ext uri="{FF2B5EF4-FFF2-40B4-BE49-F238E27FC236}">
-                <a16:creationId xmlns:a16="http://schemas.microsoft.com/office/drawing/2014/main" id="{E99E920F-BA06-4526-BDE7-5BCCEDD6ECCF}"/>
-              </a:ext>
-            </a:extLst>
-          </p:cNvPr>
-          <p:cNvSpPr>
-            <a:spLocks xmlns:a="http://schemas.openxmlformats.org/drawingml/2006/main" noGrp="1"/>
-          </p:cNvSpPr>
-          <p:nvPr/>
-        </p:nvSpPr>
-        <p:spPr>
-          <a:xfrm xmlns:a="http://schemas.openxmlformats.org/drawingml/2006/main" rot="0">
-            <a:off x="1047750" y="3028950"/>
-            <a:ext cx="10096500" cy="495300"/>
+              <a:t>− (x̄, ȳ)</a:t>
+            </a:r>
+          </a:p>
+        </p:txBody>
+      </p:sp>
+      <p:sp>
+        <p:nvSpPr>
+          <p:cNvPr id="33" name="">
+            <a:extLst xmlns:a="http://schemas.openxmlformats.org/drawingml/2006/main">
+              <a:ext uri="{FF2B5EF4-FFF2-40B4-BE49-F238E27FC236}">
+                <a16:creationId xmlns:a16="http://schemas.microsoft.com/office/drawing/2014/main" id="{797C9483-BAF6-45A8-8DA5-DE7AC1D2F1ED}"/>
+              </a:ext>
+            </a:extLst>
+          </p:cNvPr>
+          <p:cNvSpPr>
+            <a:spLocks xmlns:a="http://schemas.openxmlformats.org/drawingml/2006/main" noGrp="1"/>
+          </p:cNvSpPr>
+          <p:nvPr/>
+        </p:nvSpPr>
+        <p:spPr>
+          <a:xfrm xmlns:a="http://schemas.openxmlformats.org/drawingml/2006/main" rot="0">
+            <a:off x="5143500" y="3676650"/>
+            <a:ext cx="1905000" cy="514350"/>
           </a:xfrm>
           <a:prstGeom xmlns:a="http://schemas.openxmlformats.org/drawingml/2006/main" prst="rect">
             <a:avLst/>
@@ -15145,88 +16342,58 @@
                 <a:spcPct val="105000"/>
               </a:lnSpc>
               <a:buNone/>
-              <a:defRPr sz="2250" b="1" i="0">
-                <a:solidFill>
-                  <a:srgbClr val="252A31"/>
-                </a:solidFill>
-                <a:latin typeface="Arial"/>
-                <a:ea typeface="Arial"/>
-                <a:cs typeface="Arial"/>
-              </a:defRPr>
-            </a:pPr>
-            <a:r>
-              <a:rPr sz="2250" b="1" i="0">
-                <a:solidFill>
-                  <a:srgbClr val="252A31"/>
-                </a:solidFill>
-                <a:latin typeface="Arial"/>
-                <a:ea typeface="Arial"/>
-                <a:cs typeface="Arial"/>
-              </a:rPr>
-              <a:t>Subtract the mean from Y and from every predictor column.</a:t>
-            </a:r>
-          </a:p>
-        </p:txBody>
-      </p:sp>
-      <p:sp>
-        <p:nvSpPr>
-          <p:cNvPr id="5" name="">
-            <a:extLst xmlns:a="http://schemas.openxmlformats.org/drawingml/2006/main">
-              <a:ext uri="{FF2B5EF4-FFF2-40B4-BE49-F238E27FC236}">
-                <a16:creationId xmlns:a16="http://schemas.microsoft.com/office/drawing/2014/main" id="{C9C8003C-46A1-4A74-8D3F-D405562EA4DE}"/>
-              </a:ext>
-            </a:extLst>
-          </p:cNvPr>
-          <p:cNvSpPr>
-            <a:spLocks xmlns:a="http://schemas.openxmlformats.org/drawingml/2006/main" noGrp="1"/>
-          </p:cNvSpPr>
-          <p:nvPr/>
-        </p:nvSpPr>
-        <p:spPr>
-          <a:xfrm xmlns:a="http://schemas.openxmlformats.org/drawingml/2006/main" rot="0">
-            <a:off x="2381250" y="3905250"/>
-            <a:ext cx="7429500" cy="19050"/>
-          </a:xfrm>
-          <a:prstGeom xmlns:a="http://schemas.openxmlformats.org/drawingml/2006/main" prst="rect">
-            <a:avLst/>
-          </a:prstGeom>
-          <a:solidFill xmlns:a="http://schemas.openxmlformats.org/drawingml/2006/main">
-            <a:srgbClr val="A8710A"/>
-          </a:solidFill>
-          <a:ln xmlns:a="http://schemas.openxmlformats.org/drawingml/2006/main" w="0">
-            <a:noFill/>
-          </a:ln>
-        </p:spPr>
-      </p:sp>
-      <p:sp>
-        <p:nvSpPr>
-          <p:cNvPr id="6" name="">
-            <a:extLst xmlns:a="http://schemas.openxmlformats.org/drawingml/2006/main">
-              <a:ext uri="{FF2B5EF4-FFF2-40B4-BE49-F238E27FC236}">
-                <a16:creationId xmlns:a16="http://schemas.microsoft.com/office/drawing/2014/main" id="{41218D26-BB63-4384-AAD1-BA0C9578E237}"/>
-              </a:ext>
-            </a:extLst>
-          </p:cNvPr>
-          <p:cNvSpPr>
-            <a:spLocks xmlns:a="http://schemas.openxmlformats.org/drawingml/2006/main" noGrp="1"/>
-          </p:cNvSpPr>
-          <p:nvPr/>
-        </p:nvSpPr>
-        <p:spPr>
-          <a:xfrm xmlns:a="http://schemas.openxmlformats.org/drawingml/2006/main" rot="0">
-            <a:off x="1676400" y="4248150"/>
-            <a:ext cx="8839200" cy="666750"/>
-          </a:xfrm>
-          <a:prstGeom xmlns:a="http://schemas.openxmlformats.org/drawingml/2006/main" prst="rect">
-            <a:avLst/>
-          </a:prstGeom>
-          <a:noFill xmlns:a="http://schemas.openxmlformats.org/drawingml/2006/main"/>
-          <a:ln xmlns:a="http://schemas.openxmlformats.org/drawingml/2006/main" w="0">
-            <a:noFill/>
-          </a:ln>
-        </p:spPr>
-        <p:txBody>
-          <a:bodyPr xmlns:a="http://schemas.openxmlformats.org/drawingml/2006/main" wrap="square" lIns="0" tIns="0" rIns="0" bIns="0" anchor="t">
+              <a:defRPr sz="1650" b="1" i="0">
+                <a:solidFill>
+                  <a:srgbClr val="68717D"/>
+                </a:solidFill>
+                <a:latin typeface="Arial"/>
+                <a:ea typeface="Arial"/>
+                <a:cs typeface="Arial"/>
+              </a:defRPr>
+            </a:pPr>
+            <a:r>
+              <a:rPr sz="1650" b="1" i="0">
+                <a:solidFill>
+                  <a:srgbClr val="68717D"/>
+                </a:solidFill>
+                <a:latin typeface="Arial"/>
+                <a:ea typeface="Arial"/>
+                <a:cs typeface="Arial"/>
+              </a:rPr>
+              <a:t>from every point</a:t>
+            </a:r>
+          </a:p>
+        </p:txBody>
+      </p:sp>
+      <p:sp>
+        <p:nvSpPr>
+          <p:cNvPr id="34" name="">
+            <a:extLst xmlns:a="http://schemas.openxmlformats.org/drawingml/2006/main">
+              <a:ext uri="{FF2B5EF4-FFF2-40B4-BE49-F238E27FC236}">
+                <a16:creationId xmlns:a16="http://schemas.microsoft.com/office/drawing/2014/main" id="{62933230-E51D-437E-9DE2-3C94A0AEEB55}"/>
+              </a:ext>
+            </a:extLst>
+          </p:cNvPr>
+          <p:cNvSpPr>
+            <a:spLocks xmlns:a="http://schemas.openxmlformats.org/drawingml/2006/main" noGrp="1"/>
+          </p:cNvSpPr>
+          <p:nvPr/>
+        </p:nvSpPr>
+        <p:spPr>
+          <a:xfrm xmlns:a="http://schemas.openxmlformats.org/drawingml/2006/main" rot="0">
+            <a:off x="1714500" y="5095875"/>
+            <a:ext cx="8763000" cy="552450"/>
+          </a:xfrm>
+          <a:prstGeom xmlns:a="http://schemas.openxmlformats.org/drawingml/2006/main" prst="rect">
+            <a:avLst/>
+          </a:prstGeom>
+          <a:noFill xmlns:a="http://schemas.openxmlformats.org/drawingml/2006/main"/>
+          <a:ln xmlns:a="http://schemas.openxmlformats.org/drawingml/2006/main" w="0">
+            <a:noFill/>
+          </a:ln>
+        </p:spPr>
+        <p:txBody>
+          <a:bodyPr xmlns:a="http://schemas.openxmlformats.org/drawingml/2006/main" wrap="square" lIns="114300" tIns="76200" rIns="114300" bIns="76200" anchor="ctr">
             <a:noAutofit/>
           </a:bodyPr>
           <a:lstStyle xmlns:a="http://schemas.openxmlformats.org/drawingml/2006/main"/>
@@ -15236,72 +16403,7 @@
                 <a:spcPct val="105000"/>
               </a:lnSpc>
               <a:buNone/>
-              <a:defRPr sz="2025" b="0" i="0">
-                <a:solidFill>
-                  <a:srgbClr val="68717D"/>
-                </a:solidFill>
-                <a:latin typeface="Arial"/>
-                <a:ea typeface="Arial"/>
-                <a:cs typeface="Arial"/>
-              </a:defRPr>
-            </a:pPr>
-            <a:r>
-              <a:rPr sz="2025" b="0" i="0">
-                <a:solidFill>
-                  <a:srgbClr val="68717D"/>
-                </a:solidFill>
-                <a:latin typeface="Arial"/>
-                <a:ea typeface="Arial"/>
-                <a:cs typeface="Arial"/>
-              </a:rPr>
-              <a:t>In centered coordinates, the fitted intercept is zero. The ridge paper works with the remaining model</a:t>
-            </a:r>
-          </a:p>
-        </p:txBody>
-      </p:sp>
-      <p:sp>
-        <p:nvSpPr>
-          <p:cNvPr id="7" name="">
-            <a:extLst xmlns:a="http://schemas.openxmlformats.org/drawingml/2006/main">
-              <a:ext uri="{FF2B5EF4-FFF2-40B4-BE49-F238E27FC236}">
-                <a16:creationId xmlns:a16="http://schemas.microsoft.com/office/drawing/2014/main" id="{2D26127B-2C3D-4D67-84ED-2D552739A6BD}"/>
-              </a:ext>
-            </a:extLst>
-          </p:cNvPr>
-          <p:cNvSpPr>
-            <a:spLocks xmlns:a="http://schemas.openxmlformats.org/drawingml/2006/main" noGrp="1"/>
-          </p:cNvSpPr>
-          <p:nvPr/>
-        </p:nvSpPr>
-        <p:spPr>
-          <a:xfrm xmlns:a="http://schemas.openxmlformats.org/drawingml/2006/main" rot="0">
-            <a:off x="3619500" y="5095875"/>
-            <a:ext cx="4953000" cy="628650"/>
-          </a:xfrm>
-          <a:prstGeom xmlns:a="http://schemas.openxmlformats.org/drawingml/2006/main" prst="roundRect">
-            <a:avLst>
-              <a:gd name="adj" fmla="val 15152"/>
-            </a:avLst>
-          </a:prstGeom>
-          <a:solidFill xmlns:a="http://schemas.openxmlformats.org/drawingml/2006/main">
-            <a:srgbClr val="FFFDF8"/>
-          </a:solidFill>
-          <a:ln xmlns:a="http://schemas.openxmlformats.org/drawingml/2006/main" w="0">
-            <a:noFill/>
-          </a:ln>
-        </p:spPr>
-        <p:txBody>
-          <a:bodyPr xmlns:a="http://schemas.openxmlformats.org/drawingml/2006/main" wrap="square" lIns="114300" tIns="76200" rIns="114300" bIns="76200" anchor="ctr">
-            <a:noAutofit/>
-          </a:bodyPr>
-          <a:lstStyle xmlns:a="http://schemas.openxmlformats.org/drawingml/2006/main"/>
-          <a:p xmlns:a="http://schemas.openxmlformats.org/drawingml/2006/main">
-            <a:pPr algn="ctr">
-              <a:lnSpc>
-                <a:spcPct val="105000"/>
-              </a:lnSpc>
-              <a:buNone/>
-              <a:defRPr sz="3000" b="0" i="0">
+              <a:defRPr sz="2400" b="0" i="0">
                 <a:solidFill>
                   <a:srgbClr val="252A31"/>
                 </a:solidFill>
@@ -15311,7 +16413,7 @@
               </a:defRPr>
             </a:pPr>
             <a:r>
-              <a:rPr sz="3000" b="0" i="0">
+              <a:rPr sz="2400" b="0" i="0">
                 <a:solidFill>
                   <a:srgbClr val="252A31"/>
                 </a:solidFill>
@@ -15319,7 +16421,129 @@
                 <a:ea typeface="Cambria Math"/>
                 <a:cs typeface="Cambria Math"/>
               </a:rPr>
-              <a:t>Y = Xβ + ε</a:t>
+              <a:t>(xᵢ, yᵢ) becomes (xᵢ − x̄, yᵢ − ȳ)</a:t>
+            </a:r>
+          </a:p>
+        </p:txBody>
+      </p:sp>
+      <p:sp>
+        <p:nvSpPr>
+          <p:cNvPr id="35" name="">
+            <a:extLst xmlns:a="http://schemas.openxmlformats.org/drawingml/2006/main">
+              <a:ext uri="{FF2B5EF4-FFF2-40B4-BE49-F238E27FC236}">
+                <a16:creationId xmlns:a16="http://schemas.microsoft.com/office/drawing/2014/main" id="{E20915F6-BBBA-470D-AE04-97C2AECACEEF}"/>
+              </a:ext>
+            </a:extLst>
+          </p:cNvPr>
+          <p:cNvSpPr>
+            <a:spLocks xmlns:a="http://schemas.openxmlformats.org/drawingml/2006/main" noGrp="1"/>
+          </p:cNvSpPr>
+          <p:nvPr/>
+        </p:nvSpPr>
+        <p:spPr>
+          <a:xfrm xmlns:a="http://schemas.openxmlformats.org/drawingml/2006/main" rot="0">
+            <a:off x="1333500" y="5810250"/>
+            <a:ext cx="9525000" cy="304800"/>
+          </a:xfrm>
+          <a:prstGeom xmlns:a="http://schemas.openxmlformats.org/drawingml/2006/main" prst="rect">
+            <a:avLst/>
+          </a:prstGeom>
+          <a:noFill xmlns:a="http://schemas.openxmlformats.org/drawingml/2006/main"/>
+          <a:ln xmlns:a="http://schemas.openxmlformats.org/drawingml/2006/main" w="0">
+            <a:noFill/>
+          </a:ln>
+        </p:spPr>
+        <p:txBody>
+          <a:bodyPr xmlns:a="http://schemas.openxmlformats.org/drawingml/2006/main" wrap="square" lIns="0" tIns="0" rIns="0" bIns="0" anchor="t">
+            <a:noAutofit/>
+          </a:bodyPr>
+          <a:lstStyle xmlns:a="http://schemas.openxmlformats.org/drawingml/2006/main"/>
+          <a:p xmlns:a="http://schemas.openxmlformats.org/drawingml/2006/main">
+            <a:pPr algn="ctr">
+              <a:lnSpc>
+                <a:spcPct val="105000"/>
+              </a:lnSpc>
+              <a:buNone/>
+              <a:defRPr sz="1725" b="1" i="0">
+                <a:solidFill>
+                  <a:srgbClr val="252A31"/>
+                </a:solidFill>
+                <a:latin typeface="Arial"/>
+                <a:ea typeface="Arial"/>
+                <a:cs typeface="Arial"/>
+              </a:defRPr>
+            </a:pPr>
+            <a:r>
+              <a:rPr sz="1725" b="1" i="0">
+                <a:solidFill>
+                  <a:srgbClr val="252A31"/>
+                </a:solidFill>
+                <a:latin typeface="Arial"/>
+                <a:ea typeface="Arial"/>
+                <a:cs typeface="Arial"/>
+              </a:rPr>
+              <a:t>Every point moves by the same amount. The cloud keeps its shape and slope.</a:t>
+            </a:r>
+          </a:p>
+        </p:txBody>
+      </p:sp>
+      <p:sp>
+        <p:nvSpPr>
+          <p:cNvPr id="36" name="">
+            <a:extLst xmlns:a="http://schemas.openxmlformats.org/drawingml/2006/main">
+              <a:ext uri="{FF2B5EF4-FFF2-40B4-BE49-F238E27FC236}">
+                <a16:creationId xmlns:a16="http://schemas.microsoft.com/office/drawing/2014/main" id="{88DF5C7C-BD4F-4215-91CA-520302F4F7A6}"/>
+              </a:ext>
+            </a:extLst>
+          </p:cNvPr>
+          <p:cNvSpPr>
+            <a:spLocks xmlns:a="http://schemas.openxmlformats.org/drawingml/2006/main" noGrp="1"/>
+          </p:cNvSpPr>
+          <p:nvPr/>
+        </p:nvSpPr>
+        <p:spPr>
+          <a:xfrm xmlns:a="http://schemas.openxmlformats.org/drawingml/2006/main" rot="0">
+            <a:off x="1333500" y="6143625"/>
+            <a:ext cx="9525000" cy="285750"/>
+          </a:xfrm>
+          <a:prstGeom xmlns:a="http://schemas.openxmlformats.org/drawingml/2006/main" prst="rect">
+            <a:avLst/>
+          </a:prstGeom>
+          <a:noFill xmlns:a="http://schemas.openxmlformats.org/drawingml/2006/main"/>
+          <a:ln xmlns:a="http://schemas.openxmlformats.org/drawingml/2006/main" w="0">
+            <a:noFill/>
+          </a:ln>
+        </p:spPr>
+        <p:txBody>
+          <a:bodyPr xmlns:a="http://schemas.openxmlformats.org/drawingml/2006/main" wrap="square" lIns="0" tIns="0" rIns="0" bIns="0" anchor="t">
+            <a:noAutofit/>
+          </a:bodyPr>
+          <a:lstStyle xmlns:a="http://schemas.openxmlformats.org/drawingml/2006/main"/>
+          <a:p xmlns:a="http://schemas.openxmlformats.org/drawingml/2006/main">
+            <a:pPr algn="ctr">
+              <a:lnSpc>
+                <a:spcPct val="105000"/>
+              </a:lnSpc>
+              <a:buNone/>
+              <a:defRPr sz="1575" b="0" i="0">
+                <a:solidFill>
+                  <a:srgbClr val="68717D"/>
+                </a:solidFill>
+                <a:latin typeface="Arial"/>
+                <a:ea typeface="Arial"/>
+                <a:cs typeface="Arial"/>
+              </a:defRPr>
+            </a:pPr>
+            <a:r>
+              <a:rPr sz="1575" b="0" i="0">
+                <a:solidFill>
+                  <a:srgbClr val="68717D"/>
+                </a:solidFill>
+                <a:latin typeface="Arial"/>
+                <a:ea typeface="Arial"/>
+                <a:cs typeface="Arial"/>
+              </a:rPr>
+              <a:t>The mean becomes (0, 0), so the fitted intercept is zero in centered coordinates.</a:t>
             </a:r>
           </a:p>
         </p:txBody>
@@ -15327,7 +16551,7 @@
     </p:spTree>
     <p:extLst>
       <p:ext uri="{BB962C8B-B14F-4D97-AF65-F5344CB8AC3E}">
-        <p14:creationId xmlns:p14="http://schemas.microsoft.com/office/powerpoint/2010/main" val="1225266766"/>
+        <p14:creationId xmlns:p14="http://schemas.microsoft.com/office/powerpoint/2010/main" val="1369568911"/>
       </p:ext>
     </p:extLst>
   </p:cSld>
@@ -15358,7 +16582,7 @@
           <p:cNvPr id="10" name="">
             <a:extLst xmlns:a="http://schemas.openxmlformats.org/drawingml/2006/main">
               <a:ext uri="{FF2B5EF4-FFF2-40B4-BE49-F238E27FC236}">
-                <a16:creationId xmlns:a16="http://schemas.microsoft.com/office/drawing/2014/main" id="{3BDA2197-A7C7-4410-AFDA-34FED154C666}"/>
+                <a16:creationId xmlns:a16="http://schemas.microsoft.com/office/drawing/2014/main" id="{FD4B3771-ECC4-4D9F-A2D3-4E0391D168C1}"/>
               </a:ext>
             </a:extLst>
           </p:cNvPr>
@@ -15419,7 +16643,7 @@
           <p:cNvPr id="2" name="">
             <a:extLst xmlns:a="http://schemas.openxmlformats.org/drawingml/2006/main">
               <a:ext uri="{FF2B5EF4-FFF2-40B4-BE49-F238E27FC236}">
-                <a16:creationId xmlns:a16="http://schemas.microsoft.com/office/drawing/2014/main" id="{CBA23C75-8C96-480B-BBF0-C1CBEF36969F}"/>
+                <a16:creationId xmlns:a16="http://schemas.microsoft.com/office/drawing/2014/main" id="{2D91CF90-4127-45E7-A8DA-29391DF5C4E1}"/>
               </a:ext>
             </a:extLst>
           </p:cNvPr>
@@ -15480,7 +16704,7 @@
           <p:cNvPr id="3" name="">
             <a:extLst xmlns:a="http://schemas.openxmlformats.org/drawingml/2006/main">
               <a:ext uri="{FF2B5EF4-FFF2-40B4-BE49-F238E27FC236}">
-                <a16:creationId xmlns:a16="http://schemas.microsoft.com/office/drawing/2014/main" id="{E8396204-C959-4350-9E16-56B7D6AFE41A}"/>
+                <a16:creationId xmlns:a16="http://schemas.microsoft.com/office/drawing/2014/main" id="{767740A3-0AEA-4205-9147-BD402237B982}"/>
               </a:ext>
             </a:extLst>
           </p:cNvPr>
@@ -15541,7 +16765,7 @@
           <p:cNvPr id="4" name="">
             <a:extLst xmlns:a="http://schemas.openxmlformats.org/drawingml/2006/main">
               <a:ext uri="{FF2B5EF4-FFF2-40B4-BE49-F238E27FC236}">
-                <a16:creationId xmlns:a16="http://schemas.microsoft.com/office/drawing/2014/main" id="{D389B594-1532-497C-B3F7-1EF9968A11CD}"/>
+                <a16:creationId xmlns:a16="http://schemas.microsoft.com/office/drawing/2014/main" id="{D62138BF-59E7-485A-9DDA-398DA7F78C84}"/>
               </a:ext>
             </a:extLst>
           </p:cNvPr>
@@ -15602,7 +16826,7 @@
           <p:cNvPr id="5" name="">
             <a:extLst xmlns:a="http://schemas.openxmlformats.org/drawingml/2006/main">
               <a:ext uri="{FF2B5EF4-FFF2-40B4-BE49-F238E27FC236}">
-                <a16:creationId xmlns:a16="http://schemas.microsoft.com/office/drawing/2014/main" id="{FB81F519-F914-49B3-ACC8-AF0CB982ED73}"/>
+                <a16:creationId xmlns:a16="http://schemas.microsoft.com/office/drawing/2014/main" id="{A631B438-BA5A-423B-8505-095619C84005}"/>
               </a:ext>
             </a:extLst>
           </p:cNvPr>
@@ -15663,7 +16887,7 @@
           <p:cNvPr id="6" name="">
             <a:extLst xmlns:a="http://schemas.openxmlformats.org/drawingml/2006/main">
               <a:ext uri="{FF2B5EF4-FFF2-40B4-BE49-F238E27FC236}">
-                <a16:creationId xmlns:a16="http://schemas.microsoft.com/office/drawing/2014/main" id="{4506AE74-A02B-437A-9F7A-A94F8291C6B6}"/>
+                <a16:creationId xmlns:a16="http://schemas.microsoft.com/office/drawing/2014/main" id="{9EADA7D7-CF9C-42E9-B283-6012B82D5F87}"/>
               </a:ext>
             </a:extLst>
           </p:cNvPr>
@@ -15728,7 +16952,7 @@
           <p:cNvPr id="7" name="">
             <a:extLst xmlns:a="http://schemas.openxmlformats.org/drawingml/2006/main">
               <a:ext uri="{FF2B5EF4-FFF2-40B4-BE49-F238E27FC236}">
-                <a16:creationId xmlns:a16="http://schemas.microsoft.com/office/drawing/2014/main" id="{6530152F-2ED1-46A9-9E65-143AEDBDDCCA}"/>
+                <a16:creationId xmlns:a16="http://schemas.microsoft.com/office/drawing/2014/main" id="{83F08F70-E63A-4241-AD85-91866B931AC7}"/>
               </a:ext>
             </a:extLst>
           </p:cNvPr>
@@ -15758,7 +16982,7 @@
           <p:cNvPr id="8" name="">
             <a:extLst xmlns:a="http://schemas.openxmlformats.org/drawingml/2006/main">
               <a:ext uri="{FF2B5EF4-FFF2-40B4-BE49-F238E27FC236}">
-                <a16:creationId xmlns:a16="http://schemas.microsoft.com/office/drawing/2014/main" id="{0D6B56E0-8401-4B5E-BCB5-19716903A46E}"/>
+                <a16:creationId xmlns:a16="http://schemas.microsoft.com/office/drawing/2014/main" id="{4CB30543-D8FF-408B-95AF-4B975FC99924}"/>
               </a:ext>
             </a:extLst>
           </p:cNvPr>
@@ -15819,7 +17043,7 @@
           <p:cNvPr id="9" name="">
             <a:extLst xmlns:a="http://schemas.openxmlformats.org/drawingml/2006/main">
               <a:ext uri="{FF2B5EF4-FFF2-40B4-BE49-F238E27FC236}">
-                <a16:creationId xmlns:a16="http://schemas.microsoft.com/office/drawing/2014/main" id="{16D45D7F-3E77-4CCF-A25A-DBA726F08AD8}"/>
+                <a16:creationId xmlns:a16="http://schemas.microsoft.com/office/drawing/2014/main" id="{234F1771-559B-486D-88DC-8EA3E32FE5C1}"/>
               </a:ext>
             </a:extLst>
           </p:cNvPr>
@@ -15878,7 +17102,7 @@
     </p:spTree>
     <p:extLst>
       <p:ext uri="{BB962C8B-B14F-4D97-AF65-F5344CB8AC3E}">
-        <p14:creationId xmlns:p14="http://schemas.microsoft.com/office/powerpoint/2010/main" val="38202634"/>
+        <p14:creationId xmlns:p14="http://schemas.microsoft.com/office/powerpoint/2010/main" val="1177941706"/>
       </p:ext>
     </p:extLst>
   </p:cSld>
@@ -15909,7 +17133,7 @@
           <p:cNvPr id="10" name="">
             <a:extLst xmlns:a="http://schemas.openxmlformats.org/drawingml/2006/main">
               <a:ext uri="{FF2B5EF4-FFF2-40B4-BE49-F238E27FC236}">
-                <a16:creationId xmlns:a16="http://schemas.microsoft.com/office/drawing/2014/main" id="{7539DA40-5625-426D-9883-0D5A18E075B5}"/>
+                <a16:creationId xmlns:a16="http://schemas.microsoft.com/office/drawing/2014/main" id="{81B20FCB-8705-4266-913D-88E1DEB3618A}"/>
               </a:ext>
             </a:extLst>
           </p:cNvPr>
@@ -15970,7 +17194,7 @@
           <p:cNvPr id="2" name="">
             <a:extLst xmlns:a="http://schemas.openxmlformats.org/drawingml/2006/main">
               <a:ext uri="{FF2B5EF4-FFF2-40B4-BE49-F238E27FC236}">
-                <a16:creationId xmlns:a16="http://schemas.microsoft.com/office/drawing/2014/main" id="{F1ADFA1A-3F4E-4290-9F82-34A4B54D5A79}"/>
+                <a16:creationId xmlns:a16="http://schemas.microsoft.com/office/drawing/2014/main" id="{CACB8591-F63E-43AC-86B1-3BBA5E21D346}"/>
               </a:ext>
             </a:extLst>
           </p:cNvPr>
@@ -16031,7 +17255,7 @@
           <p:cNvPr id="3" name="">
             <a:extLst xmlns:a="http://schemas.openxmlformats.org/drawingml/2006/main">
               <a:ext uri="{FF2B5EF4-FFF2-40B4-BE49-F238E27FC236}">
-                <a16:creationId xmlns:a16="http://schemas.microsoft.com/office/drawing/2014/main" id="{F1E054D1-CBEA-4528-A234-63CF7267943F}"/>
+                <a16:creationId xmlns:a16="http://schemas.microsoft.com/office/drawing/2014/main" id="{D4B1D42A-46C0-4704-8880-AF8E4D753928}"/>
               </a:ext>
             </a:extLst>
           </p:cNvPr>
@@ -16092,7 +17316,7 @@
           <p:cNvPr id="4" name="">
             <a:extLst xmlns:a="http://schemas.openxmlformats.org/drawingml/2006/main">
               <a:ext uri="{FF2B5EF4-FFF2-40B4-BE49-F238E27FC236}">
-                <a16:creationId xmlns:a16="http://schemas.microsoft.com/office/drawing/2014/main" id="{708802C2-24DB-4058-8F89-76DBA45360F5}"/>
+                <a16:creationId xmlns:a16="http://schemas.microsoft.com/office/drawing/2014/main" id="{4B828FC4-0BC3-4B24-A6DD-FAE4A299DFD3}"/>
               </a:ext>
             </a:extLst>
           </p:cNvPr>
@@ -16153,7 +17377,7 @@
           <p:cNvPr id="5" name="">
             <a:extLst xmlns:a="http://schemas.openxmlformats.org/drawingml/2006/main">
               <a:ext uri="{FF2B5EF4-FFF2-40B4-BE49-F238E27FC236}">
-                <a16:creationId xmlns:a16="http://schemas.microsoft.com/office/drawing/2014/main" id="{7A77E504-983C-4B7D-AD99-9344B9023B01}"/>
+                <a16:creationId xmlns:a16="http://schemas.microsoft.com/office/drawing/2014/main" id="{83F9C36D-673C-4260-B307-B0D230F99962}"/>
               </a:ext>
             </a:extLst>
           </p:cNvPr>
@@ -16218,7 +17442,7 @@
           <p:cNvPr id="6" name="">
             <a:extLst xmlns:a="http://schemas.openxmlformats.org/drawingml/2006/main">
               <a:ext uri="{FF2B5EF4-FFF2-40B4-BE49-F238E27FC236}">
-                <a16:creationId xmlns:a16="http://schemas.microsoft.com/office/drawing/2014/main" id="{DC1E4148-C953-4A09-91D0-1E7B11D3F358}"/>
+                <a16:creationId xmlns:a16="http://schemas.microsoft.com/office/drawing/2014/main" id="{634126CE-A9F0-473A-B1AB-BE3403067203}"/>
               </a:ext>
             </a:extLst>
           </p:cNvPr>
@@ -16279,7 +17503,7 @@
           <p:cNvPr id="7" name="">
             <a:extLst xmlns:a="http://schemas.openxmlformats.org/drawingml/2006/main">
               <a:ext uri="{FF2B5EF4-FFF2-40B4-BE49-F238E27FC236}">
-                <a16:creationId xmlns:a16="http://schemas.microsoft.com/office/drawing/2014/main" id="{13408B76-74BB-4AEB-8E93-7E19BDD3CA64}"/>
+                <a16:creationId xmlns:a16="http://schemas.microsoft.com/office/drawing/2014/main" id="{1A359C08-9A6F-4307-9DFF-26C2C1167A56}"/>
               </a:ext>
             </a:extLst>
           </p:cNvPr>
@@ -16340,7 +17564,7 @@
           <p:cNvPr id="8" name="">
             <a:extLst xmlns:a="http://schemas.openxmlformats.org/drawingml/2006/main">
               <a:ext uri="{FF2B5EF4-FFF2-40B4-BE49-F238E27FC236}">
-                <a16:creationId xmlns:a16="http://schemas.microsoft.com/office/drawing/2014/main" id="{EA353278-38B1-4E2E-B866-9A1FF6283C2B}"/>
+                <a16:creationId xmlns:a16="http://schemas.microsoft.com/office/drawing/2014/main" id="{AEF49B4B-B757-4646-ABEB-0956334C4A5A}"/>
               </a:ext>
             </a:extLst>
           </p:cNvPr>
@@ -16401,7 +17625,7 @@
           <p:cNvPr id="9" name="">
             <a:extLst xmlns:a="http://schemas.openxmlformats.org/drawingml/2006/main">
               <a:ext uri="{FF2B5EF4-FFF2-40B4-BE49-F238E27FC236}">
-                <a16:creationId xmlns:a16="http://schemas.microsoft.com/office/drawing/2014/main" id="{7FF8645A-F9B1-48C1-8E26-4BDE94430E82}"/>
+                <a16:creationId xmlns:a16="http://schemas.microsoft.com/office/drawing/2014/main" id="{71E5253E-52F5-4D7B-873B-5910BE73C40F}"/>
               </a:ext>
             </a:extLst>
           </p:cNvPr>
@@ -16464,7 +17688,7 @@
     </p:spTree>
     <p:extLst>
       <p:ext uri="{BB962C8B-B14F-4D97-AF65-F5344CB8AC3E}">
-        <p14:creationId xmlns:p14="http://schemas.microsoft.com/office/powerpoint/2010/main" val="1877732680"/>
+        <p14:creationId xmlns:p14="http://schemas.microsoft.com/office/powerpoint/2010/main" val="471678742"/>
       </p:ext>
     </p:extLst>
   </p:cSld>
@@ -16495,7 +17719,7 @@
           <p:cNvPr id="13" name="">
             <a:extLst xmlns:a="http://schemas.openxmlformats.org/drawingml/2006/main">
               <a:ext uri="{FF2B5EF4-FFF2-40B4-BE49-F238E27FC236}">
-                <a16:creationId xmlns:a16="http://schemas.microsoft.com/office/drawing/2014/main" id="{953FA4F2-0A67-4B5F-B468-DD24A1B6EF1F}"/>
+                <a16:creationId xmlns:a16="http://schemas.microsoft.com/office/drawing/2014/main" id="{85DFD7A5-9477-446A-A76E-704521762039}"/>
               </a:ext>
             </a:extLst>
           </p:cNvPr>
@@ -16556,7 +17780,7 @@
           <p:cNvPr id="2" name="">
             <a:extLst xmlns:a="http://schemas.openxmlformats.org/drawingml/2006/main">
               <a:ext uri="{FF2B5EF4-FFF2-40B4-BE49-F238E27FC236}">
-                <a16:creationId xmlns:a16="http://schemas.microsoft.com/office/drawing/2014/main" id="{A00ED2BF-1C6C-44C1-A138-4A1E5C686949}"/>
+                <a16:creationId xmlns:a16="http://schemas.microsoft.com/office/drawing/2014/main" id="{06404020-1325-4513-AF7D-2DFC13C63B87}"/>
               </a:ext>
             </a:extLst>
           </p:cNvPr>
@@ -16617,7 +17841,7 @@
           <p:cNvPr id="3" name="">
             <a:extLst xmlns:a="http://schemas.openxmlformats.org/drawingml/2006/main">
               <a:ext uri="{FF2B5EF4-FFF2-40B4-BE49-F238E27FC236}">
-                <a16:creationId xmlns:a16="http://schemas.microsoft.com/office/drawing/2014/main" id="{6D43DB46-F4C3-4478-B577-D8BABE5D59AA}"/>
+                <a16:creationId xmlns:a16="http://schemas.microsoft.com/office/drawing/2014/main" id="{54CCA8AF-90E9-474D-BB6F-E90E4C58F874}"/>
               </a:ext>
             </a:extLst>
           </p:cNvPr>
@@ -16682,7 +17906,7 @@
           <p:cNvPr id="4" name="">
             <a:extLst xmlns:a="http://schemas.openxmlformats.org/drawingml/2006/main">
               <a:ext uri="{FF2B5EF4-FFF2-40B4-BE49-F238E27FC236}">
-                <a16:creationId xmlns:a16="http://schemas.microsoft.com/office/drawing/2014/main" id="{17E4485A-C675-408A-9228-F43EC40CBC47}"/>
+                <a16:creationId xmlns:a16="http://schemas.microsoft.com/office/drawing/2014/main" id="{DE98921E-8CD9-44D1-A0C1-90D717402545}"/>
               </a:ext>
             </a:extLst>
           </p:cNvPr>
@@ -16743,7 +17967,7 @@
           <p:cNvPr id="5" name="">
             <a:extLst xmlns:a="http://schemas.openxmlformats.org/drawingml/2006/main">
               <a:ext uri="{FF2B5EF4-FFF2-40B4-BE49-F238E27FC236}">
-                <a16:creationId xmlns:a16="http://schemas.microsoft.com/office/drawing/2014/main" id="{01931481-D60C-43E0-BF0C-831EF0911E57}"/>
+                <a16:creationId xmlns:a16="http://schemas.microsoft.com/office/drawing/2014/main" id="{C3C1B2C7-E578-4949-BD15-C5B3B038AB26}"/>
               </a:ext>
             </a:extLst>
           </p:cNvPr>
@@ -16773,7 +17997,7 @@
           <p:cNvPr id="6" name="">
             <a:extLst xmlns:a="http://schemas.openxmlformats.org/drawingml/2006/main">
               <a:ext uri="{FF2B5EF4-FFF2-40B4-BE49-F238E27FC236}">
-                <a16:creationId xmlns:a16="http://schemas.microsoft.com/office/drawing/2014/main" id="{8E323172-EB2B-4435-BACC-CACFC7CEC4F1}"/>
+                <a16:creationId xmlns:a16="http://schemas.microsoft.com/office/drawing/2014/main" id="{49EF5240-0A7A-433F-991F-A4D97B9147A1}"/>
               </a:ext>
             </a:extLst>
           </p:cNvPr>
@@ -16803,7 +18027,7 @@
           <p:cNvPr id="7" name="">
             <a:extLst xmlns:a="http://schemas.openxmlformats.org/drawingml/2006/main">
               <a:ext uri="{FF2B5EF4-FFF2-40B4-BE49-F238E27FC236}">
-                <a16:creationId xmlns:a16="http://schemas.microsoft.com/office/drawing/2014/main" id="{310CB187-7BB2-439C-AF4E-BDF552DA0A1A}"/>
+                <a16:creationId xmlns:a16="http://schemas.microsoft.com/office/drawing/2014/main" id="{DC1DF94A-12B8-45C5-A712-28C8DBC41A89}"/>
               </a:ext>
             </a:extLst>
           </p:cNvPr>
@@ -16864,7 +18088,7 @@
           <p:cNvPr id="8" name="">
             <a:extLst xmlns:a="http://schemas.openxmlformats.org/drawingml/2006/main">
               <a:ext uri="{FF2B5EF4-FFF2-40B4-BE49-F238E27FC236}">
-                <a16:creationId xmlns:a16="http://schemas.microsoft.com/office/drawing/2014/main" id="{288FA9BD-E2EA-4E70-BD16-3DC480F08284}"/>
+                <a16:creationId xmlns:a16="http://schemas.microsoft.com/office/drawing/2014/main" id="{97C71F53-E8B4-4236-AAAB-061C1D5A2D74}"/>
               </a:ext>
             </a:extLst>
           </p:cNvPr>
@@ -16925,7 +18149,7 @@
           <p:cNvPr id="9" name="">
             <a:extLst xmlns:a="http://schemas.openxmlformats.org/drawingml/2006/main">
               <a:ext uri="{FF2B5EF4-FFF2-40B4-BE49-F238E27FC236}">
-                <a16:creationId xmlns:a16="http://schemas.microsoft.com/office/drawing/2014/main" id="{DD7A4D9E-9422-4B06-A1ED-B71FBD5F0166}"/>
+                <a16:creationId xmlns:a16="http://schemas.microsoft.com/office/drawing/2014/main" id="{1469E4B9-A446-4146-9BAD-8CDE9B46F53E}"/>
               </a:ext>
             </a:extLst>
           </p:cNvPr>
@@ -16986,7 +18210,7 @@
           <p:cNvPr id="10" name="">
             <a:extLst xmlns:a="http://schemas.openxmlformats.org/drawingml/2006/main">
               <a:ext uri="{FF2B5EF4-FFF2-40B4-BE49-F238E27FC236}">
-                <a16:creationId xmlns:a16="http://schemas.microsoft.com/office/drawing/2014/main" id="{D0883C7E-7DC9-4235-A718-4649F00CF380}"/>
+                <a16:creationId xmlns:a16="http://schemas.microsoft.com/office/drawing/2014/main" id="{83DF69B8-8B3A-40C1-B09A-5D655FAD78A4}"/>
               </a:ext>
             </a:extLst>
           </p:cNvPr>
@@ -17047,7 +18271,7 @@
           <p:cNvPr id="11" name="">
             <a:extLst xmlns:a="http://schemas.openxmlformats.org/drawingml/2006/main">
               <a:ext uri="{FF2B5EF4-FFF2-40B4-BE49-F238E27FC236}">
-                <a16:creationId xmlns:a16="http://schemas.microsoft.com/office/drawing/2014/main" id="{B7CCD140-94B3-4D41-9EF6-78E9DDF9AE4F}"/>
+                <a16:creationId xmlns:a16="http://schemas.microsoft.com/office/drawing/2014/main" id="{50F3BA47-E979-4FA7-B251-3622C453E74B}"/>
               </a:ext>
             </a:extLst>
           </p:cNvPr>
@@ -17108,7 +18332,7 @@
           <p:cNvPr id="12" name="">
             <a:extLst xmlns:a="http://schemas.openxmlformats.org/drawingml/2006/main">
               <a:ext uri="{FF2B5EF4-FFF2-40B4-BE49-F238E27FC236}">
-                <a16:creationId xmlns:a16="http://schemas.microsoft.com/office/drawing/2014/main" id="{8811D035-3A32-4F72-BBD2-F2E0C22DCB17}"/>
+                <a16:creationId xmlns:a16="http://schemas.microsoft.com/office/drawing/2014/main" id="{848ACBF2-1CAC-4CF8-B2ED-01888055EA70}"/>
               </a:ext>
             </a:extLst>
           </p:cNvPr>
@@ -17167,7 +18391,7 @@
     </p:spTree>
     <p:extLst>
       <p:ext uri="{BB962C8B-B14F-4D97-AF65-F5344CB8AC3E}">
-        <p14:creationId xmlns:p14="http://schemas.microsoft.com/office/powerpoint/2010/main" val="1084364121"/>
+        <p14:creationId xmlns:p14="http://schemas.microsoft.com/office/powerpoint/2010/main" val="614003709"/>
       </p:ext>
     </p:extLst>
   </p:cSld>

</xml_diff>

<commit_message>
Improve centering graph in Session 0 slides
</commit_message>
<xml_diff>
--- a/public/slides/session-0-least-squares-foundations.pptx
+++ b/public/slides/session-0-least-squares-foundations.pptx
@@ -2,34 +2,34 @@
 <file path=ppt/presentation.xml><?xml version="1.0" encoding="utf-8"?>
 <p:presentation xmlns:p="http://schemas.openxmlformats.org/presentationml/2006/main">
   <p:sldMasterIdLst>
-    <p:sldMasterId xmlns:r="http://schemas.openxmlformats.org/officeDocument/2006/relationships" id="2147483648" r:id="R91e92c5e0a5344cf"/>
+    <p:sldMasterId xmlns:r="http://schemas.openxmlformats.org/officeDocument/2006/relationships" id="2147483648" r:id="R352e95f75c2c44e4"/>
   </p:sldMasterIdLst>
   <p:notesMasterIdLst>
-    <p:notesMasterId xmlns:r="http://schemas.openxmlformats.org/officeDocument/2006/relationships" r:id="R4dd794b02e2f4ecc"/>
+    <p:notesMasterId xmlns:r="http://schemas.openxmlformats.org/officeDocument/2006/relationships" r:id="Rc9d21c8467d747e7"/>
   </p:notesMasterIdLst>
   <p:sldIdLst>
-    <p:sldId xmlns:r="http://schemas.openxmlformats.org/officeDocument/2006/relationships" id="256" r:id="R36c12c358b0e4aa4"/>
-    <p:sldId xmlns:r="http://schemas.openxmlformats.org/officeDocument/2006/relationships" id="257" r:id="R708a0f45c4e34d7f"/>
-    <p:sldId xmlns:r="http://schemas.openxmlformats.org/officeDocument/2006/relationships" id="258" r:id="R4ae0fca77ff44ff8"/>
-    <p:sldId xmlns:r="http://schemas.openxmlformats.org/officeDocument/2006/relationships" id="259" r:id="Rba55b5a7a4854399"/>
-    <p:sldId xmlns:r="http://schemas.openxmlformats.org/officeDocument/2006/relationships" id="260" r:id="Rac84379d10bb4990"/>
-    <p:sldId xmlns:r="http://schemas.openxmlformats.org/officeDocument/2006/relationships" id="261" r:id="Rb233c63ca79f4c0d"/>
-    <p:sldId xmlns:r="http://schemas.openxmlformats.org/officeDocument/2006/relationships" id="262" r:id="R0862d112b2e14ebd"/>
-    <p:sldId xmlns:r="http://schemas.openxmlformats.org/officeDocument/2006/relationships" id="263" r:id="Rdadfbfea5d884487"/>
-    <p:sldId xmlns:r="http://schemas.openxmlformats.org/officeDocument/2006/relationships" id="264" r:id="Rfd8f50393de94ac5"/>
-    <p:sldId xmlns:r="http://schemas.openxmlformats.org/officeDocument/2006/relationships" id="265" r:id="R52977c99eb87408a"/>
-    <p:sldId xmlns:r="http://schemas.openxmlformats.org/officeDocument/2006/relationships" id="266" r:id="R300ddfd956594625"/>
-    <p:sldId xmlns:r="http://schemas.openxmlformats.org/officeDocument/2006/relationships" id="267" r:id="Re1b3e6139b444efc"/>
-    <p:sldId xmlns:r="http://schemas.openxmlformats.org/officeDocument/2006/relationships" id="268" r:id="Rd6fad451582a4062"/>
-    <p:sldId xmlns:r="http://schemas.openxmlformats.org/officeDocument/2006/relationships" id="269" r:id="Rf5c57e24f9aa4821"/>
-    <p:sldId xmlns:r="http://schemas.openxmlformats.org/officeDocument/2006/relationships" id="270" r:id="R36c5b1480ffe4089"/>
-    <p:sldId xmlns:r="http://schemas.openxmlformats.org/officeDocument/2006/relationships" id="271" r:id="Rd742602c8b5e4198"/>
-    <p:sldId xmlns:r="http://schemas.openxmlformats.org/officeDocument/2006/relationships" id="272" r:id="R35f648de3dae478c"/>
-    <p:sldId xmlns:r="http://schemas.openxmlformats.org/officeDocument/2006/relationships" id="273" r:id="Reed87f435f754214"/>
-    <p:sldId xmlns:r="http://schemas.openxmlformats.org/officeDocument/2006/relationships" id="274" r:id="Rbbaa36f1bb614957"/>
-    <p:sldId xmlns:r="http://schemas.openxmlformats.org/officeDocument/2006/relationships" id="275" r:id="Rfa4ee5ab2b324133"/>
-    <p:sldId xmlns:r="http://schemas.openxmlformats.org/officeDocument/2006/relationships" id="276" r:id="R9a4bd208f21d4d43"/>
-    <p:sldId xmlns:r="http://schemas.openxmlformats.org/officeDocument/2006/relationships" id="277" r:id="R38c11bbb23e740f8"/>
+    <p:sldId xmlns:r="http://schemas.openxmlformats.org/officeDocument/2006/relationships" id="256" r:id="R2a2f326eb37c4d76"/>
+    <p:sldId xmlns:r="http://schemas.openxmlformats.org/officeDocument/2006/relationships" id="257" r:id="Rccc2bdd4da5f48c8"/>
+    <p:sldId xmlns:r="http://schemas.openxmlformats.org/officeDocument/2006/relationships" id="258" r:id="R6c47b54322214695"/>
+    <p:sldId xmlns:r="http://schemas.openxmlformats.org/officeDocument/2006/relationships" id="259" r:id="R8ea8eac8c49d4b53"/>
+    <p:sldId xmlns:r="http://schemas.openxmlformats.org/officeDocument/2006/relationships" id="260" r:id="R9bfb96f1b6064294"/>
+    <p:sldId xmlns:r="http://schemas.openxmlformats.org/officeDocument/2006/relationships" id="261" r:id="R461a4e2c8a8e472f"/>
+    <p:sldId xmlns:r="http://schemas.openxmlformats.org/officeDocument/2006/relationships" id="262" r:id="Ra362e589736f40de"/>
+    <p:sldId xmlns:r="http://schemas.openxmlformats.org/officeDocument/2006/relationships" id="263" r:id="R3c61b632c75f45f5"/>
+    <p:sldId xmlns:r="http://schemas.openxmlformats.org/officeDocument/2006/relationships" id="264" r:id="R5ccd2cdfca624c00"/>
+    <p:sldId xmlns:r="http://schemas.openxmlformats.org/officeDocument/2006/relationships" id="265" r:id="Reb76a1e250be4af7"/>
+    <p:sldId xmlns:r="http://schemas.openxmlformats.org/officeDocument/2006/relationships" id="266" r:id="Reafbb718e72f4aa3"/>
+    <p:sldId xmlns:r="http://schemas.openxmlformats.org/officeDocument/2006/relationships" id="267" r:id="Rb2dfae76f2724d56"/>
+    <p:sldId xmlns:r="http://schemas.openxmlformats.org/officeDocument/2006/relationships" id="268" r:id="R18379bda5bbe424a"/>
+    <p:sldId xmlns:r="http://schemas.openxmlformats.org/officeDocument/2006/relationships" id="269" r:id="Rd9f94236e8c248d2"/>
+    <p:sldId xmlns:r="http://schemas.openxmlformats.org/officeDocument/2006/relationships" id="270" r:id="Rb60c486cb972420e"/>
+    <p:sldId xmlns:r="http://schemas.openxmlformats.org/officeDocument/2006/relationships" id="271" r:id="R6ca89ef1a4b84cf9"/>
+    <p:sldId xmlns:r="http://schemas.openxmlformats.org/officeDocument/2006/relationships" id="272" r:id="R402f063183d54cb1"/>
+    <p:sldId xmlns:r="http://schemas.openxmlformats.org/officeDocument/2006/relationships" id="273" r:id="Rbd985f557fd74a41"/>
+    <p:sldId xmlns:r="http://schemas.openxmlformats.org/officeDocument/2006/relationships" id="274" r:id="Rbb81f1aded174c1f"/>
+    <p:sldId xmlns:r="http://schemas.openxmlformats.org/officeDocument/2006/relationships" id="275" r:id="R620d0dedc9714e64"/>
+    <p:sldId xmlns:r="http://schemas.openxmlformats.org/officeDocument/2006/relationships" id="276" r:id="R0dcfbd5c658b4ba4"/>
+    <p:sldId xmlns:r="http://schemas.openxmlformats.org/officeDocument/2006/relationships" id="277" r:id="Rbc86e49cf6014f13"/>
   </p:sldIdLst>
   <p:sldSz cx="12192000" cy="6858000"/>
   <p:notesSz cx="6858000" cy="9144000"/>
@@ -1653,7 +1653,7 @@
           <a:lstStyle xmlns:a="http://schemas.openxmlformats.org/drawingml/2006/main"/>
           <a:p xmlns:a="http://schemas.openxmlformats.org/drawingml/2006/main">
             <a:r>
-              <a:t>[5 min] Use weight and fuel consumption as a two dimensional example. The gold dot is the sample mean. Subtract the same mean vector from every observation. Ask students to compare the two clouds: pairwise distances, relative positions, and the fitted slope stay unchanged. Only the origin changes. The centered fitted line passes through (0, 0), so its intercept is zero. Stress that both X and Y must be centered. Recover the original intercept with beta zero hat equals y bar minus x bar transpose beta hat.</a:t>
+              <a:t>[5 min] This is an illustrative two dimensional example, separate from the car values. Both clouds use the same axes. The teal cloud has mean (6, 4.5). Subtracting that mean from every point moves the gold cloud to mean (0, 0). The dashed line tracks the mean itself. Ask students what changes: location. Ask what stays fixed: pairwise distances, relative positions, and slope. Stress that both X and Y must be centered. Recover the original intercept with beta zero hat equals y bar minus x bar transpose beta hat.</a:t>
             </a:r>
           </a:p>
         </p:txBody>
@@ -2001,7 +2001,7 @@
   </p:cSld>
   <p:clrMap bg1="lt1" tx1="dk1" bg2="lt2" tx2="dk2" accent1="accent1" accent2="accent2" accent3="accent3" accent4="accent4" accent5="accent5" accent6="accent6" hlink="hlink" folHlink="folHlink"/>
   <p:sldLayoutIdLst>
-    <p:sldLayoutId xmlns:r="http://schemas.openxmlformats.org/officeDocument/2006/relationships" id="2147483649" r:id="R754ed44275cb49ca"/>
+    <p:sldLayoutId xmlns:r="http://schemas.openxmlformats.org/officeDocument/2006/relationships" id="2147483649" r:id="R77097ba2688e4791"/>
   </p:sldLayoutIdLst>
   <p:txStyles>
     <p:titleStyle>
@@ -2528,6 +2528,469 @@
 </a:theme>
 </file>
 
+<file path=ppt/slides/charts/chart1.xml><?xml version="1.0" encoding="utf-8"?>
+<c:chartSpace xmlns:c="http://schemas.openxmlformats.org/drawingml/2006/chart" xmlns:r="http://schemas.openxmlformats.org/officeDocument/2006/relationships">
+  <c:lang val="en-US"/>
+  <c:chart>
+    <c:plotArea>
+      <c:scatterChart>
+        <c:scatterStyle val="lineMarker"/>
+        <c:ser>
+          <c:idx val="0"/>
+          <c:order val="0"/>
+          <c:tx>
+            <c:v>Original cloud</c:v>
+          </c:tx>
+          <c:spPr>
+            <a:solidFill xmlns:a="http://schemas.openxmlformats.org/drawingml/2006/main">
+              <a:srgbClr val="2C6A6C"/>
+            </a:solidFill>
+            <a:ln xmlns:a="http://schemas.openxmlformats.org/drawingml/2006/main" w="0">
+              <a:noFill/>
+            </a:ln>
+          </c:spPr>
+          <c:marker>
+            <c:symbol val="circle"/>
+            <c:size val="10"/>
+            <c:spPr>
+              <a:noFill xmlns:a="http://schemas.openxmlformats.org/drawingml/2006/main"/>
+            </c:spPr>
+          </c:marker>
+          <c:xVal>
+            <c:numRef>
+              <c:f>'Chart Data'!$A$2:$A$7</c:f>
+              <c:numCache>
+                <c:formatCode>General</c:formatCode>
+                <c:ptCount val="6"/>
+                <c:pt idx="0">
+                  <c:v>4</c:v>
+                </c:pt>
+                <c:pt idx="1">
+                  <c:v>4.8</c:v>
+                </c:pt>
+                <c:pt idx="2">
+                  <c:v>5.6</c:v>
+                </c:pt>
+                <c:pt idx="3">
+                  <c:v>6.6</c:v>
+                </c:pt>
+                <c:pt idx="4">
+                  <c:v>7.1</c:v>
+                </c:pt>
+                <c:pt idx="5">
+                  <c:v>7.9</c:v>
+                </c:pt>
+              </c:numCache>
+            </c:numRef>
+          </c:xVal>
+          <c:yVal>
+            <c:numRef>
+              <c:f>'Chart Data'!$B$2:$B$7</c:f>
+              <c:numCache>
+                <c:formatCode>0.0</c:formatCode>
+                <c:ptCount val="6"/>
+                <c:pt idx="0">
+                  <c:v>3</c:v>
+                </c:pt>
+                <c:pt idx="1">
+                  <c:v>4.2</c:v>
+                </c:pt>
+                <c:pt idx="2">
+                  <c:v>3.7</c:v>
+                </c:pt>
+                <c:pt idx="3">
+                  <c:v>5.2</c:v>
+                </c:pt>
+                <c:pt idx="4">
+                  <c:v>5</c:v>
+                </c:pt>
+                <c:pt idx="5">
+                  <c:v>5.9</c:v>
+                </c:pt>
+              </c:numCache>
+            </c:numRef>
+          </c:yVal>
+        </c:ser>
+        <c:ser>
+          <c:idx val="1"/>
+          <c:order val="1"/>
+          <c:tx>
+            <c:v>Centered cloud</c:v>
+          </c:tx>
+          <c:spPr>
+            <a:solidFill xmlns:a="http://schemas.openxmlformats.org/drawingml/2006/main">
+              <a:srgbClr val="A8710A"/>
+            </a:solidFill>
+            <a:ln xmlns:a="http://schemas.openxmlformats.org/drawingml/2006/main" w="0">
+              <a:noFill/>
+            </a:ln>
+          </c:spPr>
+          <c:marker>
+            <c:symbol val="circle"/>
+            <c:size val="10"/>
+            <c:spPr>
+              <a:noFill xmlns:a="http://schemas.openxmlformats.org/drawingml/2006/main"/>
+            </c:spPr>
+          </c:marker>
+          <c:xVal>
+            <c:numRef>
+              <c:f>'Chart Data'!$C$2:$C$7</c:f>
+              <c:numCache>
+                <c:formatCode>General</c:formatCode>
+                <c:ptCount val="6"/>
+                <c:pt idx="0">
+                  <c:v>-2</c:v>
+                </c:pt>
+                <c:pt idx="1">
+                  <c:v>-1.2</c:v>
+                </c:pt>
+                <c:pt idx="2">
+                  <c:v>-0.4</c:v>
+                </c:pt>
+                <c:pt idx="3">
+                  <c:v>0.6</c:v>
+                </c:pt>
+                <c:pt idx="4">
+                  <c:v>1.1</c:v>
+                </c:pt>
+                <c:pt idx="5">
+                  <c:v>1.9</c:v>
+                </c:pt>
+              </c:numCache>
+            </c:numRef>
+          </c:xVal>
+          <c:yVal>
+            <c:numRef>
+              <c:f>'Chart Data'!$D$2:$D$7</c:f>
+              <c:numCache>
+                <c:formatCode>0.0</c:formatCode>
+                <c:ptCount val="6"/>
+                <c:pt idx="0">
+                  <c:v>-1.5</c:v>
+                </c:pt>
+                <c:pt idx="1">
+                  <c:v>-0.3</c:v>
+                </c:pt>
+                <c:pt idx="2">
+                  <c:v>-0.8</c:v>
+                </c:pt>
+                <c:pt idx="3">
+                  <c:v>0.7</c:v>
+                </c:pt>
+                <c:pt idx="4">
+                  <c:v>0.5</c:v>
+                </c:pt>
+                <c:pt idx="5">
+                  <c:v>1.4</c:v>
+                </c:pt>
+              </c:numCache>
+            </c:numRef>
+          </c:yVal>
+        </c:ser>
+        <c:ser>
+          <c:idx val="2"/>
+          <c:order val="2"/>
+          <c:tx>
+            <c:v>Mean translation</c:v>
+          </c:tx>
+          <c:spPr>
+            <a:solidFill xmlns:a="http://schemas.openxmlformats.org/drawingml/2006/main">
+              <a:srgbClr val="A64B3C"/>
+            </a:solidFill>
+            <a:ln xmlns:a="http://schemas.openxmlformats.org/drawingml/2006/main" w="28575">
+              <a:solidFill>
+                <a:srgbClr val="A64B3C"/>
+              </a:solidFill>
+              <a:prstDash val="dash"/>
+            </a:ln>
+          </c:spPr>
+          <c:marker>
+            <c:symbol val="diamond"/>
+            <c:size val="12"/>
+            <c:spPr>
+              <a:solidFill xmlns:a="http://schemas.openxmlformats.org/drawingml/2006/main">
+                <a:srgbClr val="A64B3C"/>
+              </a:solidFill>
+            </c:spPr>
+          </c:marker>
+          <c:xVal>
+            <c:numRef>
+              <c:f>'Chart Data'!$E$2:$E$3</c:f>
+              <c:numCache>
+                <c:formatCode>General</c:formatCode>
+                <c:ptCount val="2"/>
+                <c:pt idx="0">
+                  <c:v>6</c:v>
+                </c:pt>
+                <c:pt idx="1">
+                  <c:v>0</c:v>
+                </c:pt>
+              </c:numCache>
+            </c:numRef>
+          </c:xVal>
+          <c:yVal>
+            <c:numRef>
+              <c:f>'Chart Data'!$F$2:$F$3</c:f>
+              <c:numCache>
+                <c:formatCode>0.0</c:formatCode>
+                <c:ptCount val="2"/>
+                <c:pt idx="0">
+                  <c:v>4.5</c:v>
+                </c:pt>
+                <c:pt idx="1">
+                  <c:v>0</c:v>
+                </c:pt>
+              </c:numCache>
+            </c:numRef>
+          </c:yVal>
+        </c:ser>
+        <c:dLbls>
+          <c:txPr>
+            <a:bodyPr xmlns:a="http://schemas.openxmlformats.org/drawingml/2006/main" anchorCtr="1"/>
+            <a:lstStyle xmlns:a="http://schemas.openxmlformats.org/drawingml/2006/main"/>
+            <a:p xmlns:a="http://schemas.openxmlformats.org/drawingml/2006/main">
+              <a:pPr>
+                <a:defRPr>
+                  <a:latin typeface="Arial"/>
+                  <a:ea typeface="Arial"/>
+                  <a:cs typeface="Arial"/>
+                </a:defRPr>
+              </a:pPr>
+            </a:p>
+          </c:txPr>
+          <c:showLegendKey val="0"/>
+          <c:showVal val="0"/>
+          <c:showCatName val="0"/>
+          <c:showSerName val="0"/>
+          <c:showPercent val="0"/>
+          <c:showBubbleSize val="0"/>
+          <c:showLeaderLines val="0"/>
+        </c:dLbls>
+        <c:axId val="48650112"/>
+        <c:axId val="48672768"/>
+      </c:scatterChart>
+      <c:valAx>
+        <c:axId val="48672768"/>
+        <c:scaling>
+          <c:orientation val="minMax"/>
+          <c:max val="7"/>
+          <c:min val="-2"/>
+        </c:scaling>
+        <c:delete val="0"/>
+        <c:axPos val="l"/>
+        <c:majorGridlines>
+          <c:spPr>
+            <a:ln xmlns:a="http://schemas.openxmlformats.org/drawingml/2006/main" w="9525">
+              <a:solidFill>
+                <a:srgbClr val="D9D9D3"/>
+              </a:solidFill>
+              <a:prstDash val="solid"/>
+            </a:ln>
+          </c:spPr>
+        </c:majorGridlines>
+        <c:title>
+          <c:tx>
+            <c:rich>
+              <a:bodyPr xmlns:a="http://schemas.openxmlformats.org/drawingml/2006/main"/>
+              <a:lstStyle xmlns:a="http://schemas.openxmlformats.org/drawingml/2006/main"/>
+              <a:p xmlns:a="http://schemas.openxmlformats.org/drawingml/2006/main">
+                <a:r>
+                  <a:rPr sz="1125" b="1">
+                    <a:solidFill>
+                      <a:srgbClr val="68717D"/>
+                    </a:solidFill>
+                    <a:latin typeface="Arial"/>
+                    <a:ea typeface="Arial"/>
+                    <a:cs typeface="Arial"/>
+                  </a:rPr>
+                  <a:t>response y</a:t>
+                </a:r>
+              </a:p>
+            </c:rich>
+          </c:tx>
+          <c:overlay val="0"/>
+          <c:txPr>
+            <a:bodyPr xmlns:a="http://schemas.openxmlformats.org/drawingml/2006/main" anchorCtr="1"/>
+            <a:lstStyle xmlns:a="http://schemas.openxmlformats.org/drawingml/2006/main"/>
+            <a:p xmlns:a="http://schemas.openxmlformats.org/drawingml/2006/main">
+              <a:pPr>
+                <a:defRPr sz="1125" b="1">
+                  <a:solidFill>
+                    <a:srgbClr val="68717D"/>
+                  </a:solidFill>
+                  <a:latin typeface="Arial"/>
+                  <a:ea typeface="Arial"/>
+                  <a:cs typeface="Arial"/>
+                </a:defRPr>
+              </a:pPr>
+            </a:p>
+          </c:txPr>
+        </c:title>
+        <c:numFmt formatCode="0.0"/>
+        <c:majorTickMark val="none"/>
+        <c:minorTickMark val="none"/>
+        <c:spPr>
+          <a:ln xmlns:a="http://schemas.openxmlformats.org/drawingml/2006/main" w="9525">
+            <a:solidFill>
+              <a:srgbClr val="68717D"/>
+            </a:solidFill>
+            <a:prstDash val="solid"/>
+          </a:ln>
+        </c:spPr>
+        <c:txPr>
+          <a:bodyPr xmlns:a="http://schemas.openxmlformats.org/drawingml/2006/main" anchorCtr="1"/>
+          <a:lstStyle xmlns:a="http://schemas.openxmlformats.org/drawingml/2006/main"/>
+          <a:p xmlns:a="http://schemas.openxmlformats.org/drawingml/2006/main">
+            <a:pPr>
+              <a:defRPr sz="1050">
+                <a:solidFill>
+                  <a:srgbClr val="68717D"/>
+                </a:solidFill>
+                <a:latin typeface="Arial"/>
+                <a:ea typeface="Arial"/>
+                <a:cs typeface="Arial"/>
+              </a:defRPr>
+            </a:pPr>
+          </a:p>
+        </c:txPr>
+        <c:crossAx val="48650112"/>
+        <c:majorUnit val="1"/>
+      </c:valAx>
+      <c:valAx>
+        <c:axId val="48650112"/>
+        <c:scaling>
+          <c:orientation val="minMax"/>
+          <c:max val="9"/>
+          <c:min val="-3"/>
+        </c:scaling>
+        <c:delete val="0"/>
+        <c:axPos val="b"/>
+        <c:majorGridlines>
+          <c:spPr>
+            <a:ln xmlns:a="http://schemas.openxmlformats.org/drawingml/2006/main" w="9525">
+              <a:solidFill>
+                <a:srgbClr val="D9D9D3"/>
+              </a:solidFill>
+              <a:prstDash val="solid"/>
+            </a:ln>
+          </c:spPr>
+        </c:majorGridlines>
+        <c:title>
+          <c:tx>
+            <c:rich>
+              <a:bodyPr xmlns:a="http://schemas.openxmlformats.org/drawingml/2006/main"/>
+              <a:lstStyle xmlns:a="http://schemas.openxmlformats.org/drawingml/2006/main"/>
+              <a:p xmlns:a="http://schemas.openxmlformats.org/drawingml/2006/main">
+                <a:r>
+                  <a:rPr sz="1125" b="1">
+                    <a:solidFill>
+                      <a:srgbClr val="68717D"/>
+                    </a:solidFill>
+                    <a:latin typeface="Arial"/>
+                    <a:ea typeface="Arial"/>
+                    <a:cs typeface="Arial"/>
+                  </a:rPr>
+                  <a:t>predictor x</a:t>
+                </a:r>
+              </a:p>
+            </c:rich>
+          </c:tx>
+          <c:overlay val="0"/>
+          <c:txPr>
+            <a:bodyPr xmlns:a="http://schemas.openxmlformats.org/drawingml/2006/main" anchorCtr="1"/>
+            <a:lstStyle xmlns:a="http://schemas.openxmlformats.org/drawingml/2006/main"/>
+            <a:p xmlns:a="http://schemas.openxmlformats.org/drawingml/2006/main">
+              <a:pPr>
+                <a:defRPr sz="1125" b="1">
+                  <a:solidFill>
+                    <a:srgbClr val="68717D"/>
+                  </a:solidFill>
+                  <a:latin typeface="Arial"/>
+                  <a:ea typeface="Arial"/>
+                  <a:cs typeface="Arial"/>
+                </a:defRPr>
+              </a:pPr>
+            </a:p>
+          </c:txPr>
+        </c:title>
+        <c:numFmt formatCode="0"/>
+        <c:majorTickMark val="none"/>
+        <c:minorTickMark val="none"/>
+        <c:spPr>
+          <a:ln xmlns:a="http://schemas.openxmlformats.org/drawingml/2006/main" w="9525">
+            <a:solidFill>
+              <a:srgbClr val="68717D"/>
+            </a:solidFill>
+            <a:prstDash val="solid"/>
+          </a:ln>
+        </c:spPr>
+        <c:txPr>
+          <a:bodyPr xmlns:a="http://schemas.openxmlformats.org/drawingml/2006/main" anchorCtr="1"/>
+          <a:lstStyle xmlns:a="http://schemas.openxmlformats.org/drawingml/2006/main"/>
+          <a:p xmlns:a="http://schemas.openxmlformats.org/drawingml/2006/main">
+            <a:pPr>
+              <a:defRPr sz="1050">
+                <a:solidFill>
+                  <a:srgbClr val="68717D"/>
+                </a:solidFill>
+                <a:latin typeface="Arial"/>
+                <a:ea typeface="Arial"/>
+                <a:cs typeface="Arial"/>
+              </a:defRPr>
+            </a:pPr>
+          </a:p>
+        </c:txPr>
+        <c:crossAx val="48672768"/>
+        <c:majorUnit val="2"/>
+      </c:valAx>
+      <c:spPr>
+        <a:solidFill xmlns:a="http://schemas.openxmlformats.org/drawingml/2006/main">
+          <a:srgbClr val="FFFDF8"/>
+        </a:solidFill>
+        <a:ln xmlns:a="http://schemas.openxmlformats.org/drawingml/2006/main" w="9525">
+          <a:solidFill>
+            <a:srgbClr val="D9D9D3"/>
+          </a:solidFill>
+          <a:prstDash val="solid"/>
+        </a:ln>
+      </c:spPr>
+    </c:plotArea>
+    <c:legend>
+      <c:legendPos val="t"/>
+      <c:overlay val="0"/>
+      <c:txPr>
+        <a:bodyPr xmlns:a="http://schemas.openxmlformats.org/drawingml/2006/main" anchorCtr="1"/>
+        <a:lstStyle xmlns:a="http://schemas.openxmlformats.org/drawingml/2006/main"/>
+        <a:p xmlns:a="http://schemas.openxmlformats.org/drawingml/2006/main">
+          <a:pPr>
+            <a:defRPr sz="1125">
+              <a:solidFill>
+                <a:srgbClr val="252A31"/>
+              </a:solidFill>
+              <a:latin typeface="Arial"/>
+              <a:ea typeface="Arial"/>
+              <a:cs typeface="Arial"/>
+            </a:defRPr>
+          </a:pPr>
+        </a:p>
+      </c:txPr>
+    </c:legend>
+    <c:plotVisOnly val="1"/>
+  </c:chart>
+  <c:spPr>
+    <a:solidFill xmlns:a="http://schemas.openxmlformats.org/drawingml/2006/main">
+      <a:srgbClr val="F7F7F5"/>
+    </a:solidFill>
+    <a:ln xmlns:a="http://schemas.openxmlformats.org/drawingml/2006/main" w="0">
+      <a:noFill/>
+    </a:ln>
+  </c:spPr>
+  <c:externalData r:id="rIdChartSnapshot1">
+    <c:autoUpdate val="0"/>
+  </c:externalData>
+</c:chartSpace>
+</file>
+
 <file path=ppt/slides/slide1.xml><?xml version="1.0" encoding="utf-8"?>
 <p:sld xmlns:p="http://schemas.openxmlformats.org/presentationml/2006/main">
   <p:cSld>
@@ -2552,7 +3015,7 @@
           <p:cNvPr id="8" name="">
             <a:extLst xmlns:a="http://schemas.openxmlformats.org/drawingml/2006/main">
               <a:ext uri="{FF2B5EF4-FFF2-40B4-BE49-F238E27FC236}">
-                <a16:creationId xmlns:a16="http://schemas.microsoft.com/office/drawing/2014/main" id="{A2901212-4861-41C4-B532-122D99FF69A1}"/>
+                <a16:creationId xmlns:a16="http://schemas.microsoft.com/office/drawing/2014/main" id="{5D2F3C8E-344F-4CCC-AC74-BBC88C928C62}"/>
               </a:ext>
             </a:extLst>
           </p:cNvPr>
@@ -2582,7 +3045,7 @@
           <p:cNvPr id="2" name="">
             <a:extLst xmlns:a="http://schemas.openxmlformats.org/drawingml/2006/main">
               <a:ext uri="{FF2B5EF4-FFF2-40B4-BE49-F238E27FC236}">
-                <a16:creationId xmlns:a16="http://schemas.microsoft.com/office/drawing/2014/main" id="{0219F1C0-6147-4173-926A-10500832EA87}"/>
+                <a16:creationId xmlns:a16="http://schemas.microsoft.com/office/drawing/2014/main" id="{0D880E96-3C6F-46DC-A0D3-7B5957609853}"/>
               </a:ext>
             </a:extLst>
           </p:cNvPr>
@@ -2643,7 +3106,7 @@
           <p:cNvPr id="3" name="">
             <a:extLst xmlns:a="http://schemas.openxmlformats.org/drawingml/2006/main">
               <a:ext uri="{FF2B5EF4-FFF2-40B4-BE49-F238E27FC236}">
-                <a16:creationId xmlns:a16="http://schemas.microsoft.com/office/drawing/2014/main" id="{49816AC7-79D0-4462-93D0-38CAB8585CF0}"/>
+                <a16:creationId xmlns:a16="http://schemas.microsoft.com/office/drawing/2014/main" id="{B2FEB48F-FAC6-4D8A-8259-31CA9DF16FB6}"/>
               </a:ext>
             </a:extLst>
           </p:cNvPr>
@@ -2731,7 +3194,7 @@
           <p:cNvPr id="4" name="">
             <a:extLst xmlns:a="http://schemas.openxmlformats.org/drawingml/2006/main">
               <a:ext uri="{FF2B5EF4-FFF2-40B4-BE49-F238E27FC236}">
-                <a16:creationId xmlns:a16="http://schemas.microsoft.com/office/drawing/2014/main" id="{640CC865-6B74-4AC6-9D92-FEA109EF60D8}"/>
+                <a16:creationId xmlns:a16="http://schemas.microsoft.com/office/drawing/2014/main" id="{ED2A7001-F9B0-439D-9F7C-B88A1485FB11}"/>
               </a:ext>
             </a:extLst>
           </p:cNvPr>
@@ -2792,7 +3255,7 @@
           <p:cNvPr id="5" name="">
             <a:extLst xmlns:a="http://schemas.openxmlformats.org/drawingml/2006/main">
               <a:ext uri="{FF2B5EF4-FFF2-40B4-BE49-F238E27FC236}">
-                <a16:creationId xmlns:a16="http://schemas.microsoft.com/office/drawing/2014/main" id="{3D9973E5-F6E4-4587-8D29-18A100A510C0}"/>
+                <a16:creationId xmlns:a16="http://schemas.microsoft.com/office/drawing/2014/main" id="{F1ADCC27-F976-46CE-89CF-2F1D1CE0DCCD}"/>
               </a:ext>
             </a:extLst>
           </p:cNvPr>
@@ -2853,7 +3316,7 @@
           <p:cNvPr id="6" name="">
             <a:extLst xmlns:a="http://schemas.openxmlformats.org/drawingml/2006/main">
               <a:ext uri="{FF2B5EF4-FFF2-40B4-BE49-F238E27FC236}">
-                <a16:creationId xmlns:a16="http://schemas.microsoft.com/office/drawing/2014/main" id="{C299201C-D4B1-4037-8B03-CE7FF0B5AE65}"/>
+                <a16:creationId xmlns:a16="http://schemas.microsoft.com/office/drawing/2014/main" id="{EC154192-7F6A-4F4D-9B30-23745F62319D}"/>
               </a:ext>
             </a:extLst>
           </p:cNvPr>
@@ -2914,7 +3377,7 @@
           <p:cNvPr id="7" name="">
             <a:extLst xmlns:a="http://schemas.openxmlformats.org/drawingml/2006/main">
               <a:ext uri="{FF2B5EF4-FFF2-40B4-BE49-F238E27FC236}">
-                <a16:creationId xmlns:a16="http://schemas.microsoft.com/office/drawing/2014/main" id="{85C26381-2E1A-45CD-974B-72D227F458B6}"/>
+                <a16:creationId xmlns:a16="http://schemas.microsoft.com/office/drawing/2014/main" id="{F0C9E8BF-5603-4F3A-959E-61DFC775A314}"/>
               </a:ext>
             </a:extLst>
           </p:cNvPr>
@@ -2973,7 +3436,7 @@
     </p:spTree>
     <p:extLst>
       <p:ext uri="{BB962C8B-B14F-4D97-AF65-F5344CB8AC3E}">
-        <p14:creationId xmlns:p14="http://schemas.microsoft.com/office/powerpoint/2010/main" val="1391394373"/>
+        <p14:creationId xmlns:p14="http://schemas.microsoft.com/office/powerpoint/2010/main" val="550787013"/>
       </p:ext>
     </p:extLst>
   </p:cSld>
@@ -3004,7 +3467,7 @@
           <p:cNvPr id="10" name="">
             <a:extLst xmlns:a="http://schemas.openxmlformats.org/drawingml/2006/main">
               <a:ext uri="{FF2B5EF4-FFF2-40B4-BE49-F238E27FC236}">
-                <a16:creationId xmlns:a16="http://schemas.microsoft.com/office/drawing/2014/main" id="{AB9BD2A0-918B-499B-8082-0CEF7E5E4A58}"/>
+                <a16:creationId xmlns:a16="http://schemas.microsoft.com/office/drawing/2014/main" id="{F194327A-99CC-433D-A61D-C71E50637DAD}"/>
               </a:ext>
             </a:extLst>
           </p:cNvPr>
@@ -3065,7 +3528,7 @@
           <p:cNvPr id="2" name="">
             <a:extLst xmlns:a="http://schemas.openxmlformats.org/drawingml/2006/main">
               <a:ext uri="{FF2B5EF4-FFF2-40B4-BE49-F238E27FC236}">
-                <a16:creationId xmlns:a16="http://schemas.microsoft.com/office/drawing/2014/main" id="{3EB50738-E14D-4CF0-91E1-0AD3A840E3D6}"/>
+                <a16:creationId xmlns:a16="http://schemas.microsoft.com/office/drawing/2014/main" id="{766C1946-13DC-462F-B596-B28528BDFBE6}"/>
               </a:ext>
             </a:extLst>
           </p:cNvPr>
@@ -3126,7 +3589,7 @@
           <p:cNvPr id="3" name="">
             <a:extLst xmlns:a="http://schemas.openxmlformats.org/drawingml/2006/main">
               <a:ext uri="{FF2B5EF4-FFF2-40B4-BE49-F238E27FC236}">
-                <a16:creationId xmlns:a16="http://schemas.microsoft.com/office/drawing/2014/main" id="{4017D79B-121B-47C3-80AB-F378B3AD8403}"/>
+                <a16:creationId xmlns:a16="http://schemas.microsoft.com/office/drawing/2014/main" id="{9CE85007-A718-44B7-BE46-C7AB34D553DD}"/>
               </a:ext>
             </a:extLst>
           </p:cNvPr>
@@ -3187,7 +3650,7 @@
           <p:cNvPr id="4" name="">
             <a:extLst xmlns:a="http://schemas.openxmlformats.org/drawingml/2006/main">
               <a:ext uri="{FF2B5EF4-FFF2-40B4-BE49-F238E27FC236}">
-                <a16:creationId xmlns:a16="http://schemas.microsoft.com/office/drawing/2014/main" id="{D16738DA-7540-48D7-8F4E-66BBCE28CECE}"/>
+                <a16:creationId xmlns:a16="http://schemas.microsoft.com/office/drawing/2014/main" id="{DDA7EC9C-8EC2-4632-9E7B-406009A90CB4}"/>
               </a:ext>
             </a:extLst>
           </p:cNvPr>
@@ -3255,7 +3718,7 @@
           <p:cNvPr id="5" name="">
             <a:extLst xmlns:a="http://schemas.openxmlformats.org/drawingml/2006/main">
               <a:ext uri="{FF2B5EF4-FFF2-40B4-BE49-F238E27FC236}">
-                <a16:creationId xmlns:a16="http://schemas.microsoft.com/office/drawing/2014/main" id="{C4A8B640-2052-40EE-A7B2-F65320011D1B}"/>
+                <a16:creationId xmlns:a16="http://schemas.microsoft.com/office/drawing/2014/main" id="{99655F68-0DB1-403E-AE57-BD7CE113A714}"/>
               </a:ext>
             </a:extLst>
           </p:cNvPr>
@@ -3316,7 +3779,7 @@
           <p:cNvPr id="6" name="">
             <a:extLst xmlns:a="http://schemas.openxmlformats.org/drawingml/2006/main">
               <a:ext uri="{FF2B5EF4-FFF2-40B4-BE49-F238E27FC236}">
-                <a16:creationId xmlns:a16="http://schemas.microsoft.com/office/drawing/2014/main" id="{7D41620B-9659-4EAC-A5F7-6A8E40B8049F}"/>
+                <a16:creationId xmlns:a16="http://schemas.microsoft.com/office/drawing/2014/main" id="{7E5F3EB0-3B32-4762-B2C4-ACDCC4A58E61}"/>
               </a:ext>
             </a:extLst>
           </p:cNvPr>
@@ -3384,7 +3847,7 @@
           <p:cNvPr id="7" name="">
             <a:extLst xmlns:a="http://schemas.openxmlformats.org/drawingml/2006/main">
               <a:ext uri="{FF2B5EF4-FFF2-40B4-BE49-F238E27FC236}">
-                <a16:creationId xmlns:a16="http://schemas.microsoft.com/office/drawing/2014/main" id="{79D02588-2EC2-49C9-BB9C-959ECA3F522D}"/>
+                <a16:creationId xmlns:a16="http://schemas.microsoft.com/office/drawing/2014/main" id="{E6AC69D5-A7BE-49EA-B508-800FA62EF25D}"/>
               </a:ext>
             </a:extLst>
           </p:cNvPr>
@@ -3445,7 +3908,7 @@
           <p:cNvPr id="8" name="">
             <a:extLst xmlns:a="http://schemas.openxmlformats.org/drawingml/2006/main">
               <a:ext uri="{FF2B5EF4-FFF2-40B4-BE49-F238E27FC236}">
-                <a16:creationId xmlns:a16="http://schemas.microsoft.com/office/drawing/2014/main" id="{C1220F2D-A143-42C1-8B03-3535C40FA6D8}"/>
+                <a16:creationId xmlns:a16="http://schemas.microsoft.com/office/drawing/2014/main" id="{DF55DB76-C822-4FA3-814B-9B6C56472E49}"/>
               </a:ext>
             </a:extLst>
           </p:cNvPr>
@@ -3475,7 +3938,7 @@
           <p:cNvPr id="9" name="">
             <a:extLst xmlns:a="http://schemas.openxmlformats.org/drawingml/2006/main">
               <a:ext uri="{FF2B5EF4-FFF2-40B4-BE49-F238E27FC236}">
-                <a16:creationId xmlns:a16="http://schemas.microsoft.com/office/drawing/2014/main" id="{7A27970B-7325-46DC-855C-CA1C83D89684}"/>
+                <a16:creationId xmlns:a16="http://schemas.microsoft.com/office/drawing/2014/main" id="{EBDDE365-8346-489B-9D3C-5E480858C01D}"/>
               </a:ext>
             </a:extLst>
           </p:cNvPr>
@@ -3534,7 +3997,7 @@
     </p:spTree>
     <p:extLst>
       <p:ext uri="{BB962C8B-B14F-4D97-AF65-F5344CB8AC3E}">
-        <p14:creationId xmlns:p14="http://schemas.microsoft.com/office/powerpoint/2010/main" val="2058282734"/>
+        <p14:creationId xmlns:p14="http://schemas.microsoft.com/office/powerpoint/2010/main" val="470467172"/>
       </p:ext>
     </p:extLst>
   </p:cSld>
@@ -3565,7 +4028,7 @@
           <p:cNvPr id="11" name="">
             <a:extLst xmlns:a="http://schemas.openxmlformats.org/drawingml/2006/main">
               <a:ext uri="{FF2B5EF4-FFF2-40B4-BE49-F238E27FC236}">
-                <a16:creationId xmlns:a16="http://schemas.microsoft.com/office/drawing/2014/main" id="{24DD8B59-8CA1-4E00-BF9E-F11B5317BAB0}"/>
+                <a16:creationId xmlns:a16="http://schemas.microsoft.com/office/drawing/2014/main" id="{3965F6DE-508F-48B4-B9A8-638A24A6D488}"/>
               </a:ext>
             </a:extLst>
           </p:cNvPr>
@@ -3626,7 +4089,7 @@
           <p:cNvPr id="2" name="">
             <a:extLst xmlns:a="http://schemas.openxmlformats.org/drawingml/2006/main">
               <a:ext uri="{FF2B5EF4-FFF2-40B4-BE49-F238E27FC236}">
-                <a16:creationId xmlns:a16="http://schemas.microsoft.com/office/drawing/2014/main" id="{317BD8B5-0824-4E2C-91A8-BCF43F83D080}"/>
+                <a16:creationId xmlns:a16="http://schemas.microsoft.com/office/drawing/2014/main" id="{9C3FD971-5E8E-4BFE-A1BF-B9E28B99E628}"/>
               </a:ext>
             </a:extLst>
           </p:cNvPr>
@@ -3687,7 +4150,7 @@
           <p:cNvPr id="3" name="">
             <a:extLst xmlns:a="http://schemas.openxmlformats.org/drawingml/2006/main">
               <a:ext uri="{FF2B5EF4-FFF2-40B4-BE49-F238E27FC236}">
-                <a16:creationId xmlns:a16="http://schemas.microsoft.com/office/drawing/2014/main" id="{E360D002-B08B-4C27-B462-7A2A901B0F4B}"/>
+                <a16:creationId xmlns:a16="http://schemas.microsoft.com/office/drawing/2014/main" id="{0BA7032A-9CB0-4343-BE7B-790B9ADC6294}"/>
               </a:ext>
             </a:extLst>
           </p:cNvPr>
@@ -3748,7 +4211,7 @@
           <p:cNvPr id="4" name="">
             <a:extLst xmlns:a="http://schemas.openxmlformats.org/drawingml/2006/main">
               <a:ext uri="{FF2B5EF4-FFF2-40B4-BE49-F238E27FC236}">
-                <a16:creationId xmlns:a16="http://schemas.microsoft.com/office/drawing/2014/main" id="{28F73AF3-A374-489D-BCF1-D0C10FF79775}"/>
+                <a16:creationId xmlns:a16="http://schemas.microsoft.com/office/drawing/2014/main" id="{BABE0A82-4DE8-4DB1-A0C1-698B218A5ED1}"/>
               </a:ext>
             </a:extLst>
           </p:cNvPr>
@@ -3809,7 +4272,7 @@
           <p:cNvPr id="5" name="">
             <a:extLst xmlns:a="http://schemas.openxmlformats.org/drawingml/2006/main">
               <a:ext uri="{FF2B5EF4-FFF2-40B4-BE49-F238E27FC236}">
-                <a16:creationId xmlns:a16="http://schemas.microsoft.com/office/drawing/2014/main" id="{82779ECD-5A40-4DF3-8B4C-C934A86448A1}"/>
+                <a16:creationId xmlns:a16="http://schemas.microsoft.com/office/drawing/2014/main" id="{82806C36-D61D-44FA-86A0-91C8F64FF203}"/>
               </a:ext>
             </a:extLst>
           </p:cNvPr>
@@ -3870,7 +4333,7 @@
           <p:cNvPr id="6" name="">
             <a:extLst xmlns:a="http://schemas.openxmlformats.org/drawingml/2006/main">
               <a:ext uri="{FF2B5EF4-FFF2-40B4-BE49-F238E27FC236}">
-                <a16:creationId xmlns:a16="http://schemas.microsoft.com/office/drawing/2014/main" id="{69A0C57D-8452-4EB2-9B52-B8E8DFF6FFCA}"/>
+                <a16:creationId xmlns:a16="http://schemas.microsoft.com/office/drawing/2014/main" id="{8184AF1C-91C4-4652-92BB-6FC481BD9D8A}"/>
               </a:ext>
             </a:extLst>
           </p:cNvPr>
@@ -3931,7 +4394,7 @@
           <p:cNvPr id="7" name="">
             <a:extLst xmlns:a="http://schemas.openxmlformats.org/drawingml/2006/main">
               <a:ext uri="{FF2B5EF4-FFF2-40B4-BE49-F238E27FC236}">
-                <a16:creationId xmlns:a16="http://schemas.microsoft.com/office/drawing/2014/main" id="{7380ABC9-267A-4022-83AF-5479E1DA8534}"/>
+                <a16:creationId xmlns:a16="http://schemas.microsoft.com/office/drawing/2014/main" id="{25D5A563-7DA9-4D93-9AFA-1C72C51E2E33}"/>
               </a:ext>
             </a:extLst>
           </p:cNvPr>
@@ -3996,7 +4459,7 @@
           <p:cNvPr id="8" name="">
             <a:extLst xmlns:a="http://schemas.openxmlformats.org/drawingml/2006/main">
               <a:ext uri="{FF2B5EF4-FFF2-40B4-BE49-F238E27FC236}">
-                <a16:creationId xmlns:a16="http://schemas.microsoft.com/office/drawing/2014/main" id="{00C1C9DC-FD5E-437A-BF88-E811D0224C74}"/>
+                <a16:creationId xmlns:a16="http://schemas.microsoft.com/office/drawing/2014/main" id="{EBC44778-276D-442E-BF69-91DD0426BE35}"/>
               </a:ext>
             </a:extLst>
           </p:cNvPr>
@@ -4026,7 +4489,7 @@
           <p:cNvPr id="9" name="">
             <a:extLst xmlns:a="http://schemas.openxmlformats.org/drawingml/2006/main">
               <a:ext uri="{FF2B5EF4-FFF2-40B4-BE49-F238E27FC236}">
-                <a16:creationId xmlns:a16="http://schemas.microsoft.com/office/drawing/2014/main" id="{99D48892-2D39-44F7-A06A-61BB39F2940C}"/>
+                <a16:creationId xmlns:a16="http://schemas.microsoft.com/office/drawing/2014/main" id="{F46CE691-02E7-4123-8DFD-6C9D28EF6912}"/>
               </a:ext>
             </a:extLst>
           </p:cNvPr>
@@ -4087,7 +4550,7 @@
           <p:cNvPr id="10" name="">
             <a:extLst xmlns:a="http://schemas.openxmlformats.org/drawingml/2006/main">
               <a:ext uri="{FF2B5EF4-FFF2-40B4-BE49-F238E27FC236}">
-                <a16:creationId xmlns:a16="http://schemas.microsoft.com/office/drawing/2014/main" id="{8C938F71-C7F9-40C7-B817-B5F8806C9307}"/>
+                <a16:creationId xmlns:a16="http://schemas.microsoft.com/office/drawing/2014/main" id="{15870573-D1FC-4692-99FB-664B2E4833EB}"/>
               </a:ext>
             </a:extLst>
           </p:cNvPr>
@@ -4146,7 +4609,7 @@
     </p:spTree>
     <p:extLst>
       <p:ext uri="{BB962C8B-B14F-4D97-AF65-F5344CB8AC3E}">
-        <p14:creationId xmlns:p14="http://schemas.microsoft.com/office/powerpoint/2010/main" val="1093655986"/>
+        <p14:creationId xmlns:p14="http://schemas.microsoft.com/office/powerpoint/2010/main" val="587721283"/>
       </p:ext>
     </p:extLst>
   </p:cSld>
@@ -4177,7 +4640,7 @@
           <p:cNvPr id="11" name="">
             <a:extLst xmlns:a="http://schemas.openxmlformats.org/drawingml/2006/main">
               <a:ext uri="{FF2B5EF4-FFF2-40B4-BE49-F238E27FC236}">
-                <a16:creationId xmlns:a16="http://schemas.microsoft.com/office/drawing/2014/main" id="{9DB3DF72-4B0D-4D72-A488-4241793958CA}"/>
+                <a16:creationId xmlns:a16="http://schemas.microsoft.com/office/drawing/2014/main" id="{121C36BD-D72D-400D-9A30-2D1050B5F9DA}"/>
               </a:ext>
             </a:extLst>
           </p:cNvPr>
@@ -4238,7 +4701,7 @@
           <p:cNvPr id="2" name="">
             <a:extLst xmlns:a="http://schemas.openxmlformats.org/drawingml/2006/main">
               <a:ext uri="{FF2B5EF4-FFF2-40B4-BE49-F238E27FC236}">
-                <a16:creationId xmlns:a16="http://schemas.microsoft.com/office/drawing/2014/main" id="{DB9A3DE6-855C-4C2A-A2DF-B4FC1AF71792}"/>
+                <a16:creationId xmlns:a16="http://schemas.microsoft.com/office/drawing/2014/main" id="{6C420014-5ADE-4820-92F9-2FA32691C6B5}"/>
               </a:ext>
             </a:extLst>
           </p:cNvPr>
@@ -4299,7 +4762,7 @@
           <p:cNvPr id="3" name="">
             <a:extLst xmlns:a="http://schemas.openxmlformats.org/drawingml/2006/main">
               <a:ext uri="{FF2B5EF4-FFF2-40B4-BE49-F238E27FC236}">
-                <a16:creationId xmlns:a16="http://schemas.microsoft.com/office/drawing/2014/main" id="{AD5BBC91-CDBD-4160-9DE8-ED69A57B4ED6}"/>
+                <a16:creationId xmlns:a16="http://schemas.microsoft.com/office/drawing/2014/main" id="{AE9B3C2E-FE36-4386-B98E-9270E36C5209}"/>
               </a:ext>
             </a:extLst>
           </p:cNvPr>
@@ -4360,7 +4823,7 @@
           <p:cNvPr id="4" name="">
             <a:extLst xmlns:a="http://schemas.openxmlformats.org/drawingml/2006/main">
               <a:ext uri="{FF2B5EF4-FFF2-40B4-BE49-F238E27FC236}">
-                <a16:creationId xmlns:a16="http://schemas.microsoft.com/office/drawing/2014/main" id="{86946285-2446-4F6E-A260-53A8CF3FF722}"/>
+                <a16:creationId xmlns:a16="http://schemas.microsoft.com/office/drawing/2014/main" id="{08D4554E-08B2-45DD-B0ED-A57AA1E6CD6C}"/>
               </a:ext>
             </a:extLst>
           </p:cNvPr>
@@ -4421,7 +4884,7 @@
           <p:cNvPr id="5" name="">
             <a:extLst xmlns:a="http://schemas.openxmlformats.org/drawingml/2006/main">
               <a:ext uri="{FF2B5EF4-FFF2-40B4-BE49-F238E27FC236}">
-                <a16:creationId xmlns:a16="http://schemas.microsoft.com/office/drawing/2014/main" id="{E71F12B1-4C95-40B4-9969-E9850A669D75}"/>
+                <a16:creationId xmlns:a16="http://schemas.microsoft.com/office/drawing/2014/main" id="{1F2324DD-CF58-4AFD-9F4F-082BF7093F12}"/>
               </a:ext>
             </a:extLst>
           </p:cNvPr>
@@ -4482,7 +4945,7 @@
           <p:cNvPr id="6" name="">
             <a:extLst xmlns:a="http://schemas.openxmlformats.org/drawingml/2006/main">
               <a:ext uri="{FF2B5EF4-FFF2-40B4-BE49-F238E27FC236}">
-                <a16:creationId xmlns:a16="http://schemas.microsoft.com/office/drawing/2014/main" id="{44EDBB60-6500-4239-8A26-D92B5713861F}"/>
+                <a16:creationId xmlns:a16="http://schemas.microsoft.com/office/drawing/2014/main" id="{86B71476-500C-4EDE-B50B-17B01C174426}"/>
               </a:ext>
             </a:extLst>
           </p:cNvPr>
@@ -4547,7 +5010,7 @@
           <p:cNvPr id="7" name="">
             <a:extLst xmlns:a="http://schemas.openxmlformats.org/drawingml/2006/main">
               <a:ext uri="{FF2B5EF4-FFF2-40B4-BE49-F238E27FC236}">
-                <a16:creationId xmlns:a16="http://schemas.microsoft.com/office/drawing/2014/main" id="{432A97C7-B063-4FBF-B89C-CE8D2F327609}"/>
+                <a16:creationId xmlns:a16="http://schemas.microsoft.com/office/drawing/2014/main" id="{869E6BFC-7A23-4696-8690-E51EEF634448}"/>
               </a:ext>
             </a:extLst>
           </p:cNvPr>
@@ -4608,7 +5071,7 @@
           <p:cNvPr id="8" name="">
             <a:extLst xmlns:a="http://schemas.openxmlformats.org/drawingml/2006/main">
               <a:ext uri="{FF2B5EF4-FFF2-40B4-BE49-F238E27FC236}">
-                <a16:creationId xmlns:a16="http://schemas.microsoft.com/office/drawing/2014/main" id="{31CF0FF3-08F7-4505-8B9B-9B51E5DFEDA5}"/>
+                <a16:creationId xmlns:a16="http://schemas.microsoft.com/office/drawing/2014/main" id="{EFCBDA5B-E0AC-40B1-BD0C-0BC8E81CA75E}"/>
               </a:ext>
             </a:extLst>
           </p:cNvPr>
@@ -4669,7 +5132,7 @@
           <p:cNvPr id="9" name="">
             <a:extLst xmlns:a="http://schemas.openxmlformats.org/drawingml/2006/main">
               <a:ext uri="{FF2B5EF4-FFF2-40B4-BE49-F238E27FC236}">
-                <a16:creationId xmlns:a16="http://schemas.microsoft.com/office/drawing/2014/main" id="{509F553C-7B2F-4975-8518-1ED7527B3BD8}"/>
+                <a16:creationId xmlns:a16="http://schemas.microsoft.com/office/drawing/2014/main" id="{6C52BCD3-C7FC-43CA-84DC-5FDC3379DF13}"/>
               </a:ext>
             </a:extLst>
           </p:cNvPr>
@@ -4730,7 +5193,7 @@
           <p:cNvPr id="10" name="">
             <a:extLst xmlns:a="http://schemas.openxmlformats.org/drawingml/2006/main">
               <a:ext uri="{FF2B5EF4-FFF2-40B4-BE49-F238E27FC236}">
-                <a16:creationId xmlns:a16="http://schemas.microsoft.com/office/drawing/2014/main" id="{5DEB03A1-D41B-46FD-B397-D13421C43FA8}"/>
+                <a16:creationId xmlns:a16="http://schemas.microsoft.com/office/drawing/2014/main" id="{F25AD734-1FE1-410A-BE05-2789688ACD27}"/>
               </a:ext>
             </a:extLst>
           </p:cNvPr>
@@ -4793,7 +5256,7 @@
     </p:spTree>
     <p:extLst>
       <p:ext uri="{BB962C8B-B14F-4D97-AF65-F5344CB8AC3E}">
-        <p14:creationId xmlns:p14="http://schemas.microsoft.com/office/powerpoint/2010/main" val="1286862829"/>
+        <p14:creationId xmlns:p14="http://schemas.microsoft.com/office/powerpoint/2010/main" val="717791019"/>
       </p:ext>
     </p:extLst>
   </p:cSld>
@@ -4824,7 +5287,7 @@
           <p:cNvPr id="14" name="">
             <a:extLst xmlns:a="http://schemas.openxmlformats.org/drawingml/2006/main">
               <a:ext uri="{FF2B5EF4-FFF2-40B4-BE49-F238E27FC236}">
-                <a16:creationId xmlns:a16="http://schemas.microsoft.com/office/drawing/2014/main" id="{E3A3C9D0-4A6E-4F59-9ED5-55775B37E6B0}"/>
+                <a16:creationId xmlns:a16="http://schemas.microsoft.com/office/drawing/2014/main" id="{E9D88CD8-CDA0-4F52-A5AB-EE520AE12651}"/>
               </a:ext>
             </a:extLst>
           </p:cNvPr>
@@ -4885,7 +5348,7 @@
           <p:cNvPr id="2" name="">
             <a:extLst xmlns:a="http://schemas.openxmlformats.org/drawingml/2006/main">
               <a:ext uri="{FF2B5EF4-FFF2-40B4-BE49-F238E27FC236}">
-                <a16:creationId xmlns:a16="http://schemas.microsoft.com/office/drawing/2014/main" id="{C213F3FB-61BC-4307-8D04-AF4F590817B5}"/>
+                <a16:creationId xmlns:a16="http://schemas.microsoft.com/office/drawing/2014/main" id="{BA1D0886-94A0-48EE-9028-543A87441E5E}"/>
               </a:ext>
             </a:extLst>
           </p:cNvPr>
@@ -4946,7 +5409,7 @@
           <p:cNvPr id="3" name="">
             <a:extLst xmlns:a="http://schemas.openxmlformats.org/drawingml/2006/main">
               <a:ext uri="{FF2B5EF4-FFF2-40B4-BE49-F238E27FC236}">
-                <a16:creationId xmlns:a16="http://schemas.microsoft.com/office/drawing/2014/main" id="{B591386D-FC84-4827-8EB5-84D3D32F7754}"/>
+                <a16:creationId xmlns:a16="http://schemas.microsoft.com/office/drawing/2014/main" id="{31CE5778-EC9B-4C9E-9027-387F0F834A2C}"/>
               </a:ext>
             </a:extLst>
           </p:cNvPr>
@@ -5007,7 +5470,7 @@
           <p:cNvPr id="4" name="">
             <a:extLst xmlns:a="http://schemas.openxmlformats.org/drawingml/2006/main">
               <a:ext uri="{FF2B5EF4-FFF2-40B4-BE49-F238E27FC236}">
-                <a16:creationId xmlns:a16="http://schemas.microsoft.com/office/drawing/2014/main" id="{9C12469F-B560-40D8-91B5-917052A75815}"/>
+                <a16:creationId xmlns:a16="http://schemas.microsoft.com/office/drawing/2014/main" id="{7E69044E-CEBC-4903-8E8B-208155BC90E1}"/>
               </a:ext>
             </a:extLst>
           </p:cNvPr>
@@ -5072,7 +5535,7 @@
           <p:cNvPr id="5" name="">
             <a:extLst xmlns:a="http://schemas.openxmlformats.org/drawingml/2006/main">
               <a:ext uri="{FF2B5EF4-FFF2-40B4-BE49-F238E27FC236}">
-                <a16:creationId xmlns:a16="http://schemas.microsoft.com/office/drawing/2014/main" id="{54058173-A162-47CB-8063-ADE656F02342}"/>
+                <a16:creationId xmlns:a16="http://schemas.microsoft.com/office/drawing/2014/main" id="{0877004C-ACD7-4CB1-A4A0-30982C870EE0}"/>
               </a:ext>
             </a:extLst>
           </p:cNvPr>
@@ -5133,7 +5596,7 @@
           <p:cNvPr id="6" name="">
             <a:extLst xmlns:a="http://schemas.openxmlformats.org/drawingml/2006/main">
               <a:ext uri="{FF2B5EF4-FFF2-40B4-BE49-F238E27FC236}">
-                <a16:creationId xmlns:a16="http://schemas.microsoft.com/office/drawing/2014/main" id="{DFB287DE-62D3-49A8-ABD2-97E00A8ECA61}"/>
+                <a16:creationId xmlns:a16="http://schemas.microsoft.com/office/drawing/2014/main" id="{E8E9204B-6BE5-463C-A7AE-2BA68BD2704B}"/>
               </a:ext>
             </a:extLst>
           </p:cNvPr>
@@ -5163,7 +5626,7 @@
           <p:cNvPr id="7" name="">
             <a:extLst xmlns:a="http://schemas.openxmlformats.org/drawingml/2006/main">
               <a:ext uri="{FF2B5EF4-FFF2-40B4-BE49-F238E27FC236}">
-                <a16:creationId xmlns:a16="http://schemas.microsoft.com/office/drawing/2014/main" id="{90183A7E-1A83-43E8-8E55-EA0F8E2C75DF}"/>
+                <a16:creationId xmlns:a16="http://schemas.microsoft.com/office/drawing/2014/main" id="{A3A10E35-6C2B-493C-92E2-2FE8E902B0AF}"/>
               </a:ext>
             </a:extLst>
           </p:cNvPr>
@@ -5193,7 +5656,7 @@
           <p:cNvPr id="8" name="">
             <a:extLst xmlns:a="http://schemas.openxmlformats.org/drawingml/2006/main">
               <a:ext uri="{FF2B5EF4-FFF2-40B4-BE49-F238E27FC236}">
-                <a16:creationId xmlns:a16="http://schemas.microsoft.com/office/drawing/2014/main" id="{F1F6B43F-E261-4B6F-AFFC-E558A8B194CE}"/>
+                <a16:creationId xmlns:a16="http://schemas.microsoft.com/office/drawing/2014/main" id="{8519B133-B664-4B0D-A590-7F554CB87246}"/>
               </a:ext>
             </a:extLst>
           </p:cNvPr>
@@ -5254,7 +5717,7 @@
           <p:cNvPr id="9" name="">
             <a:extLst xmlns:a="http://schemas.openxmlformats.org/drawingml/2006/main">
               <a:ext uri="{FF2B5EF4-FFF2-40B4-BE49-F238E27FC236}">
-                <a16:creationId xmlns:a16="http://schemas.microsoft.com/office/drawing/2014/main" id="{9B7D456D-E9C8-4E19-A9C9-246527B9850C}"/>
+                <a16:creationId xmlns:a16="http://schemas.microsoft.com/office/drawing/2014/main" id="{6DCD0663-0297-4F89-BEC3-DE7DF636E1CB}"/>
               </a:ext>
             </a:extLst>
           </p:cNvPr>
@@ -5315,7 +5778,7 @@
           <p:cNvPr id="10" name="">
             <a:extLst xmlns:a="http://schemas.openxmlformats.org/drawingml/2006/main">
               <a:ext uri="{FF2B5EF4-FFF2-40B4-BE49-F238E27FC236}">
-                <a16:creationId xmlns:a16="http://schemas.microsoft.com/office/drawing/2014/main" id="{232CDF54-1A5C-41D4-A25C-5974AD34B891}"/>
+                <a16:creationId xmlns:a16="http://schemas.microsoft.com/office/drawing/2014/main" id="{7F0C277A-E404-4967-99D1-D766F7B257B2}"/>
               </a:ext>
             </a:extLst>
           </p:cNvPr>
@@ -5376,7 +5839,7 @@
           <p:cNvPr id="11" name="">
             <a:extLst xmlns:a="http://schemas.openxmlformats.org/drawingml/2006/main">
               <a:ext uri="{FF2B5EF4-FFF2-40B4-BE49-F238E27FC236}">
-                <a16:creationId xmlns:a16="http://schemas.microsoft.com/office/drawing/2014/main" id="{C2E0DF8B-4C88-444C-B4BD-7CB28DFACB7C}"/>
+                <a16:creationId xmlns:a16="http://schemas.microsoft.com/office/drawing/2014/main" id="{731F7C5D-D928-4441-8C92-75CF3C090FEB}"/>
               </a:ext>
             </a:extLst>
           </p:cNvPr>
@@ -5437,7 +5900,7 @@
           <p:cNvPr id="12" name="">
             <a:extLst xmlns:a="http://schemas.openxmlformats.org/drawingml/2006/main">
               <a:ext uri="{FF2B5EF4-FFF2-40B4-BE49-F238E27FC236}">
-                <a16:creationId xmlns:a16="http://schemas.microsoft.com/office/drawing/2014/main" id="{D76BDB4A-C7EB-4B70-B601-C1DE7EA8E05D}"/>
+                <a16:creationId xmlns:a16="http://schemas.microsoft.com/office/drawing/2014/main" id="{8937F1E1-D6D1-46BC-8387-C82B0E80BABA}"/>
               </a:ext>
             </a:extLst>
           </p:cNvPr>
@@ -5498,7 +5961,7 @@
           <p:cNvPr id="13" name="">
             <a:extLst xmlns:a="http://schemas.openxmlformats.org/drawingml/2006/main">
               <a:ext uri="{FF2B5EF4-FFF2-40B4-BE49-F238E27FC236}">
-                <a16:creationId xmlns:a16="http://schemas.microsoft.com/office/drawing/2014/main" id="{5F8CC9A3-35CF-4043-A4A0-32A4E22E18A4}"/>
+                <a16:creationId xmlns:a16="http://schemas.microsoft.com/office/drawing/2014/main" id="{374132B5-8A2A-4EB4-9843-CC429FC4A616}"/>
               </a:ext>
             </a:extLst>
           </p:cNvPr>
@@ -5557,7 +6020,7 @@
     </p:spTree>
     <p:extLst>
       <p:ext uri="{BB962C8B-B14F-4D97-AF65-F5344CB8AC3E}">
-        <p14:creationId xmlns:p14="http://schemas.microsoft.com/office/powerpoint/2010/main" val="1552069025"/>
+        <p14:creationId xmlns:p14="http://schemas.microsoft.com/office/powerpoint/2010/main" val="2039989471"/>
       </p:ext>
     </p:extLst>
   </p:cSld>
@@ -5588,7 +6051,7 @@
           <p:cNvPr id="10" name="">
             <a:extLst xmlns:a="http://schemas.openxmlformats.org/drawingml/2006/main">
               <a:ext uri="{FF2B5EF4-FFF2-40B4-BE49-F238E27FC236}">
-                <a16:creationId xmlns:a16="http://schemas.microsoft.com/office/drawing/2014/main" id="{F0C62AC0-49C5-4D1D-9FFC-2CABFE308FF9}"/>
+                <a16:creationId xmlns:a16="http://schemas.microsoft.com/office/drawing/2014/main" id="{84DFE75B-1480-4364-A8A9-D5323B969A0A}"/>
               </a:ext>
             </a:extLst>
           </p:cNvPr>
@@ -5649,7 +6112,7 @@
           <p:cNvPr id="2" name="">
             <a:extLst xmlns:a="http://schemas.openxmlformats.org/drawingml/2006/main">
               <a:ext uri="{FF2B5EF4-FFF2-40B4-BE49-F238E27FC236}">
-                <a16:creationId xmlns:a16="http://schemas.microsoft.com/office/drawing/2014/main" id="{9A09C793-C530-45CD-93E0-D3D8E97B5963}"/>
+                <a16:creationId xmlns:a16="http://schemas.microsoft.com/office/drawing/2014/main" id="{E68CB2F0-D7B9-4BFF-9AB2-089D1B44E0AB}"/>
               </a:ext>
             </a:extLst>
           </p:cNvPr>
@@ -5710,7 +6173,7 @@
           <p:cNvPr id="3" name="">
             <a:extLst xmlns:a="http://schemas.openxmlformats.org/drawingml/2006/main">
               <a:ext uri="{FF2B5EF4-FFF2-40B4-BE49-F238E27FC236}">
-                <a16:creationId xmlns:a16="http://schemas.microsoft.com/office/drawing/2014/main" id="{C345557F-93B5-48B8-97A5-E02F6769182A}"/>
+                <a16:creationId xmlns:a16="http://schemas.microsoft.com/office/drawing/2014/main" id="{A3EA0556-BE3E-437E-845F-89B743534DEC}"/>
               </a:ext>
             </a:extLst>
           </p:cNvPr>
@@ -5771,7 +6234,7 @@
           <p:cNvPr id="4" name="">
             <a:extLst xmlns:a="http://schemas.openxmlformats.org/drawingml/2006/main">
               <a:ext uri="{FF2B5EF4-FFF2-40B4-BE49-F238E27FC236}">
-                <a16:creationId xmlns:a16="http://schemas.microsoft.com/office/drawing/2014/main" id="{21C1F268-3E85-416C-8236-B244B3112192}"/>
+                <a16:creationId xmlns:a16="http://schemas.microsoft.com/office/drawing/2014/main" id="{72B678D6-DFC8-45A5-A7D4-5C63A1100F26}"/>
               </a:ext>
             </a:extLst>
           </p:cNvPr>
@@ -5832,7 +6295,7 @@
           <p:cNvPr id="5" name="">
             <a:extLst xmlns:a="http://schemas.openxmlformats.org/drawingml/2006/main">
               <a:ext uri="{FF2B5EF4-FFF2-40B4-BE49-F238E27FC236}">
-                <a16:creationId xmlns:a16="http://schemas.microsoft.com/office/drawing/2014/main" id="{B73DB8D1-C24A-49FA-8D6E-448AC08EFFE0}"/>
+                <a16:creationId xmlns:a16="http://schemas.microsoft.com/office/drawing/2014/main" id="{0B15D637-8F7E-4AEA-B657-EEFB8F0A2A7F}"/>
               </a:ext>
             </a:extLst>
           </p:cNvPr>
@@ -5897,7 +6360,7 @@
           <p:cNvPr id="6" name="">
             <a:extLst xmlns:a="http://schemas.openxmlformats.org/drawingml/2006/main">
               <a:ext uri="{FF2B5EF4-FFF2-40B4-BE49-F238E27FC236}">
-                <a16:creationId xmlns:a16="http://schemas.microsoft.com/office/drawing/2014/main" id="{92053A3D-E174-43C5-97ED-E5081B1DED7B}"/>
+                <a16:creationId xmlns:a16="http://schemas.microsoft.com/office/drawing/2014/main" id="{27353B13-B7D1-40F3-A78B-B3D3EC104B57}"/>
               </a:ext>
             </a:extLst>
           </p:cNvPr>
@@ -5958,7 +6421,7 @@
           <p:cNvPr id="7" name="">
             <a:extLst xmlns:a="http://schemas.openxmlformats.org/drawingml/2006/main">
               <a:ext uri="{FF2B5EF4-FFF2-40B4-BE49-F238E27FC236}">
-                <a16:creationId xmlns:a16="http://schemas.microsoft.com/office/drawing/2014/main" id="{986214AF-5861-4011-B943-962FB5F2C899}"/>
+                <a16:creationId xmlns:a16="http://schemas.microsoft.com/office/drawing/2014/main" id="{AD40D5E4-2938-4100-A6CA-E389E5DB7E98}"/>
               </a:ext>
             </a:extLst>
           </p:cNvPr>
@@ -6019,7 +6482,7 @@
           <p:cNvPr id="8" name="">
             <a:extLst xmlns:a="http://schemas.openxmlformats.org/drawingml/2006/main">
               <a:ext uri="{FF2B5EF4-FFF2-40B4-BE49-F238E27FC236}">
-                <a16:creationId xmlns:a16="http://schemas.microsoft.com/office/drawing/2014/main" id="{E5AF597A-0A9D-453C-8AAC-C5FA87AC1288}"/>
+                <a16:creationId xmlns:a16="http://schemas.microsoft.com/office/drawing/2014/main" id="{43C9EB80-F4E8-41D0-AC00-8F0000207135}"/>
               </a:ext>
             </a:extLst>
           </p:cNvPr>
@@ -6080,7 +6543,7 @@
           <p:cNvPr id="9" name="">
             <a:extLst xmlns:a="http://schemas.openxmlformats.org/drawingml/2006/main">
               <a:ext uri="{FF2B5EF4-FFF2-40B4-BE49-F238E27FC236}">
-                <a16:creationId xmlns:a16="http://schemas.microsoft.com/office/drawing/2014/main" id="{0328D412-7F53-4692-8341-730AD35195FA}"/>
+                <a16:creationId xmlns:a16="http://schemas.microsoft.com/office/drawing/2014/main" id="{3F6E7C54-6D90-4A03-BB59-8DCAE5F7E260}"/>
               </a:ext>
             </a:extLst>
           </p:cNvPr>
@@ -6139,7 +6602,7 @@
     </p:spTree>
     <p:extLst>
       <p:ext uri="{BB962C8B-B14F-4D97-AF65-F5344CB8AC3E}">
-        <p14:creationId xmlns:p14="http://schemas.microsoft.com/office/powerpoint/2010/main" val="1885447359"/>
+        <p14:creationId xmlns:p14="http://schemas.microsoft.com/office/powerpoint/2010/main" val="256174520"/>
       </p:ext>
     </p:extLst>
   </p:cSld>
@@ -6170,7 +6633,7 @@
           <p:cNvPr id="14" name="">
             <a:extLst xmlns:a="http://schemas.openxmlformats.org/drawingml/2006/main">
               <a:ext uri="{FF2B5EF4-FFF2-40B4-BE49-F238E27FC236}">
-                <a16:creationId xmlns:a16="http://schemas.microsoft.com/office/drawing/2014/main" id="{EDDCDCDB-DC81-4202-8CCB-5D7550B23D3A}"/>
+                <a16:creationId xmlns:a16="http://schemas.microsoft.com/office/drawing/2014/main" id="{557EAF83-3D05-4E34-88B2-30C140636F82}"/>
               </a:ext>
             </a:extLst>
           </p:cNvPr>
@@ -6231,7 +6694,7 @@
           <p:cNvPr id="2" name="">
             <a:extLst xmlns:a="http://schemas.openxmlformats.org/drawingml/2006/main">
               <a:ext uri="{FF2B5EF4-FFF2-40B4-BE49-F238E27FC236}">
-                <a16:creationId xmlns:a16="http://schemas.microsoft.com/office/drawing/2014/main" id="{5D925BDB-EFD6-4472-9272-204A0507E5B0}"/>
+                <a16:creationId xmlns:a16="http://schemas.microsoft.com/office/drawing/2014/main" id="{98594839-1377-4A42-AFEB-968982155085}"/>
               </a:ext>
             </a:extLst>
           </p:cNvPr>
@@ -6292,7 +6755,7 @@
           <p:cNvPr id="3" name="">
             <a:extLst xmlns:a="http://schemas.openxmlformats.org/drawingml/2006/main">
               <a:ext uri="{FF2B5EF4-FFF2-40B4-BE49-F238E27FC236}">
-                <a16:creationId xmlns:a16="http://schemas.microsoft.com/office/drawing/2014/main" id="{24A14B81-81CA-49B3-A301-0C45074460B1}"/>
+                <a16:creationId xmlns:a16="http://schemas.microsoft.com/office/drawing/2014/main" id="{9955B354-61D4-4630-AFF4-9261ACA28164}"/>
               </a:ext>
             </a:extLst>
           </p:cNvPr>
@@ -6353,7 +6816,7 @@
           <p:cNvPr id="4" name="">
             <a:extLst xmlns:a="http://schemas.openxmlformats.org/drawingml/2006/main">
               <a:ext uri="{FF2B5EF4-FFF2-40B4-BE49-F238E27FC236}">
-                <a16:creationId xmlns:a16="http://schemas.microsoft.com/office/drawing/2014/main" id="{867DEA78-51C4-4636-96E4-51F4741FB265}"/>
+                <a16:creationId xmlns:a16="http://schemas.microsoft.com/office/drawing/2014/main" id="{B2E35510-743D-417C-BB9F-D2D74A0DE5EB}"/>
               </a:ext>
             </a:extLst>
           </p:cNvPr>
@@ -6414,7 +6877,7 @@
           <p:cNvPr id="5" name="">
             <a:extLst xmlns:a="http://schemas.openxmlformats.org/drawingml/2006/main">
               <a:ext uri="{FF2B5EF4-FFF2-40B4-BE49-F238E27FC236}">
-                <a16:creationId xmlns:a16="http://schemas.microsoft.com/office/drawing/2014/main" id="{612C9BED-8D8B-4152-A9DF-563B4FF8D7B8}"/>
+                <a16:creationId xmlns:a16="http://schemas.microsoft.com/office/drawing/2014/main" id="{B69E7C0D-B86D-4665-ACD7-155C949A87D8}"/>
               </a:ext>
             </a:extLst>
           </p:cNvPr>
@@ -6479,7 +6942,7 @@
           <p:cNvPr id="6" name="">
             <a:extLst xmlns:a="http://schemas.openxmlformats.org/drawingml/2006/main">
               <a:ext uri="{FF2B5EF4-FFF2-40B4-BE49-F238E27FC236}">
-                <a16:creationId xmlns:a16="http://schemas.microsoft.com/office/drawing/2014/main" id="{7E8D9CB7-20BE-408D-8F14-6441DA229D39}"/>
+                <a16:creationId xmlns:a16="http://schemas.microsoft.com/office/drawing/2014/main" id="{401E4F2C-A3AE-46CE-B416-42827C0FAFD7}"/>
               </a:ext>
             </a:extLst>
           </p:cNvPr>
@@ -6540,7 +7003,7 @@
           <p:cNvPr id="7" name="">
             <a:extLst xmlns:a="http://schemas.openxmlformats.org/drawingml/2006/main">
               <a:ext uri="{FF2B5EF4-FFF2-40B4-BE49-F238E27FC236}">
-                <a16:creationId xmlns:a16="http://schemas.microsoft.com/office/drawing/2014/main" id="{CA3A8C90-5872-4781-8DDE-F4400C9C4DA1}"/>
+                <a16:creationId xmlns:a16="http://schemas.microsoft.com/office/drawing/2014/main" id="{CE5E5B95-F237-4CD8-B8B9-34AAD08F3276}"/>
               </a:ext>
             </a:extLst>
           </p:cNvPr>
@@ -6601,7 +7064,7 @@
           <p:cNvPr id="8" name="">
             <a:extLst xmlns:a="http://schemas.openxmlformats.org/drawingml/2006/main">
               <a:ext uri="{FF2B5EF4-FFF2-40B4-BE49-F238E27FC236}">
-                <a16:creationId xmlns:a16="http://schemas.microsoft.com/office/drawing/2014/main" id="{F0E7ABC4-2397-4C1F-B15E-607A5FAE4D1F}"/>
+                <a16:creationId xmlns:a16="http://schemas.microsoft.com/office/drawing/2014/main" id="{687200DA-ABAA-4783-BD72-7BA2D170CF35}"/>
               </a:ext>
             </a:extLst>
           </p:cNvPr>
@@ -6666,7 +7129,7 @@
           <p:cNvPr id="9" name="">
             <a:extLst xmlns:a="http://schemas.openxmlformats.org/drawingml/2006/main">
               <a:ext uri="{FF2B5EF4-FFF2-40B4-BE49-F238E27FC236}">
-                <a16:creationId xmlns:a16="http://schemas.microsoft.com/office/drawing/2014/main" id="{A328687B-3CC0-493A-9F9E-BB3A7A001A2A}"/>
+                <a16:creationId xmlns:a16="http://schemas.microsoft.com/office/drawing/2014/main" id="{0C6D1DAF-EC03-4F95-BA08-97169A646389}"/>
               </a:ext>
             </a:extLst>
           </p:cNvPr>
@@ -6727,7 +7190,7 @@
           <p:cNvPr id="10" name="">
             <a:extLst xmlns:a="http://schemas.openxmlformats.org/drawingml/2006/main">
               <a:ext uri="{FF2B5EF4-FFF2-40B4-BE49-F238E27FC236}">
-                <a16:creationId xmlns:a16="http://schemas.microsoft.com/office/drawing/2014/main" id="{466C158D-0E20-4AE7-A71D-6B4FC20D0C83}"/>
+                <a16:creationId xmlns:a16="http://schemas.microsoft.com/office/drawing/2014/main" id="{06EACB17-B7A7-474B-9C7E-8D8E48EB9130}"/>
               </a:ext>
             </a:extLst>
           </p:cNvPr>
@@ -6757,7 +7220,7 @@
           <p:cNvPr id="11" name="">
             <a:extLst xmlns:a="http://schemas.openxmlformats.org/drawingml/2006/main">
               <a:ext uri="{FF2B5EF4-FFF2-40B4-BE49-F238E27FC236}">
-                <a16:creationId xmlns:a16="http://schemas.microsoft.com/office/drawing/2014/main" id="{52F591D0-C6BD-4AD8-B9DF-4B0FCFDCAFFF}"/>
+                <a16:creationId xmlns:a16="http://schemas.microsoft.com/office/drawing/2014/main" id="{1F28DADE-4890-47F2-8F26-45C3D01DC15F}"/>
               </a:ext>
             </a:extLst>
           </p:cNvPr>
@@ -6818,7 +7281,7 @@
           <p:cNvPr id="12" name="">
             <a:extLst xmlns:a="http://schemas.openxmlformats.org/drawingml/2006/main">
               <a:ext uri="{FF2B5EF4-FFF2-40B4-BE49-F238E27FC236}">
-                <a16:creationId xmlns:a16="http://schemas.microsoft.com/office/drawing/2014/main" id="{D71F5CF3-D344-4DB8-8235-696391813980}"/>
+                <a16:creationId xmlns:a16="http://schemas.microsoft.com/office/drawing/2014/main" id="{2167C46D-1FB9-4C6E-9FBD-11FA4504C518}"/>
               </a:ext>
             </a:extLst>
           </p:cNvPr>
@@ -6883,7 +7346,7 @@
           <p:cNvPr id="13" name="">
             <a:extLst xmlns:a="http://schemas.openxmlformats.org/drawingml/2006/main">
               <a:ext uri="{FF2B5EF4-FFF2-40B4-BE49-F238E27FC236}">
-                <a16:creationId xmlns:a16="http://schemas.microsoft.com/office/drawing/2014/main" id="{F7DE1648-962E-479F-95D3-122148A993AC}"/>
+                <a16:creationId xmlns:a16="http://schemas.microsoft.com/office/drawing/2014/main" id="{E3638237-D988-4F64-B4AF-03F68DD4EF9F}"/>
               </a:ext>
             </a:extLst>
           </p:cNvPr>
@@ -6942,7 +7405,7 @@
     </p:spTree>
     <p:extLst>
       <p:ext uri="{BB962C8B-B14F-4D97-AF65-F5344CB8AC3E}">
-        <p14:creationId xmlns:p14="http://schemas.microsoft.com/office/powerpoint/2010/main" val="1471546357"/>
+        <p14:creationId xmlns:p14="http://schemas.microsoft.com/office/powerpoint/2010/main" val="2081892628"/>
       </p:ext>
     </p:extLst>
   </p:cSld>
@@ -6973,7 +7436,7 @@
           <p:cNvPr id="10" name="">
             <a:extLst xmlns:a="http://schemas.openxmlformats.org/drawingml/2006/main">
               <a:ext uri="{FF2B5EF4-FFF2-40B4-BE49-F238E27FC236}">
-                <a16:creationId xmlns:a16="http://schemas.microsoft.com/office/drawing/2014/main" id="{3716843B-02C2-4B45-8201-E11D0F52486C}"/>
+                <a16:creationId xmlns:a16="http://schemas.microsoft.com/office/drawing/2014/main" id="{EFF735A3-EF14-4656-85CA-932B1D3B1520}"/>
               </a:ext>
             </a:extLst>
           </p:cNvPr>
@@ -7034,7 +7497,7 @@
           <p:cNvPr id="2" name="">
             <a:extLst xmlns:a="http://schemas.openxmlformats.org/drawingml/2006/main">
               <a:ext uri="{FF2B5EF4-FFF2-40B4-BE49-F238E27FC236}">
-                <a16:creationId xmlns:a16="http://schemas.microsoft.com/office/drawing/2014/main" id="{8B43272B-C259-4147-A71F-FDEAD7ED6761}"/>
+                <a16:creationId xmlns:a16="http://schemas.microsoft.com/office/drawing/2014/main" id="{96ED52FE-76EE-4F16-AA98-A3ABB6F12D8C}"/>
               </a:ext>
             </a:extLst>
           </p:cNvPr>
@@ -7095,7 +7558,7 @@
           <p:cNvPr id="3" name="">
             <a:extLst xmlns:a="http://schemas.openxmlformats.org/drawingml/2006/main">
               <a:ext uri="{FF2B5EF4-FFF2-40B4-BE49-F238E27FC236}">
-                <a16:creationId xmlns:a16="http://schemas.microsoft.com/office/drawing/2014/main" id="{698F3731-8206-4BEB-9B34-2D956800D471}"/>
+                <a16:creationId xmlns:a16="http://schemas.microsoft.com/office/drawing/2014/main" id="{C6DAC329-A890-4ECC-AF6F-FEE25AEB2D5D}"/>
               </a:ext>
             </a:extLst>
           </p:cNvPr>
@@ -7156,7 +7619,7 @@
           <p:cNvPr id="4" name="">
             <a:extLst xmlns:a="http://schemas.openxmlformats.org/drawingml/2006/main">
               <a:ext uri="{FF2B5EF4-FFF2-40B4-BE49-F238E27FC236}">
-                <a16:creationId xmlns:a16="http://schemas.microsoft.com/office/drawing/2014/main" id="{69061611-7803-43FB-8219-DC0A8E5A3BE4}"/>
+                <a16:creationId xmlns:a16="http://schemas.microsoft.com/office/drawing/2014/main" id="{1CAAAF0E-6875-4F87-8652-D97FCFF8B275}"/>
               </a:ext>
             </a:extLst>
           </p:cNvPr>
@@ -7217,7 +7680,7 @@
           <p:cNvPr id="5" name="">
             <a:extLst xmlns:a="http://schemas.openxmlformats.org/drawingml/2006/main">
               <a:ext uri="{FF2B5EF4-FFF2-40B4-BE49-F238E27FC236}">
-                <a16:creationId xmlns:a16="http://schemas.microsoft.com/office/drawing/2014/main" id="{7F37581C-5275-417F-999C-B97C3B796397}"/>
+                <a16:creationId xmlns:a16="http://schemas.microsoft.com/office/drawing/2014/main" id="{F5469DE0-BDEA-409E-85BD-BEDA48D26861}"/>
               </a:ext>
             </a:extLst>
           </p:cNvPr>
@@ -7278,7 +7741,7 @@
           <p:cNvPr id="6" name="">
             <a:extLst xmlns:a="http://schemas.openxmlformats.org/drawingml/2006/main">
               <a:ext uri="{FF2B5EF4-FFF2-40B4-BE49-F238E27FC236}">
-                <a16:creationId xmlns:a16="http://schemas.microsoft.com/office/drawing/2014/main" id="{BA424DA0-04CD-4590-92C1-4DF370B7A902}"/>
+                <a16:creationId xmlns:a16="http://schemas.microsoft.com/office/drawing/2014/main" id="{2EA22C1A-6B20-4DDF-85F8-C63AB4364031}"/>
               </a:ext>
             </a:extLst>
           </p:cNvPr>
@@ -7339,7 +7802,7 @@
           <p:cNvPr id="7" name="">
             <a:extLst xmlns:a="http://schemas.openxmlformats.org/drawingml/2006/main">
               <a:ext uri="{FF2B5EF4-FFF2-40B4-BE49-F238E27FC236}">
-                <a16:creationId xmlns:a16="http://schemas.microsoft.com/office/drawing/2014/main" id="{79D511D8-5CF1-4CE1-A612-7A5C33C69E30}"/>
+                <a16:creationId xmlns:a16="http://schemas.microsoft.com/office/drawing/2014/main" id="{264720A3-F853-4195-9F4F-0F861813E938}"/>
               </a:ext>
             </a:extLst>
           </p:cNvPr>
@@ -7404,7 +7867,7 @@
           <p:cNvPr id="8" name="">
             <a:extLst xmlns:a="http://schemas.openxmlformats.org/drawingml/2006/main">
               <a:ext uri="{FF2B5EF4-FFF2-40B4-BE49-F238E27FC236}">
-                <a16:creationId xmlns:a16="http://schemas.microsoft.com/office/drawing/2014/main" id="{94A366AD-6110-4141-8C99-F3F8234276E7}"/>
+                <a16:creationId xmlns:a16="http://schemas.microsoft.com/office/drawing/2014/main" id="{7A713729-6EE0-41AE-981B-0F9E6C967292}"/>
               </a:ext>
             </a:extLst>
           </p:cNvPr>
@@ -7465,7 +7928,7 @@
           <p:cNvPr id="9" name="">
             <a:extLst xmlns:a="http://schemas.openxmlformats.org/drawingml/2006/main">
               <a:ext uri="{FF2B5EF4-FFF2-40B4-BE49-F238E27FC236}">
-                <a16:creationId xmlns:a16="http://schemas.microsoft.com/office/drawing/2014/main" id="{D81A472B-CE32-4FE3-AF13-DBFA4B613579}"/>
+                <a16:creationId xmlns:a16="http://schemas.microsoft.com/office/drawing/2014/main" id="{2A7F55FC-5A58-4E9A-9444-0906C4E8FC28}"/>
               </a:ext>
             </a:extLst>
           </p:cNvPr>
@@ -7524,7 +7987,7 @@
     </p:spTree>
     <p:extLst>
       <p:ext uri="{BB962C8B-B14F-4D97-AF65-F5344CB8AC3E}">
-        <p14:creationId xmlns:p14="http://schemas.microsoft.com/office/powerpoint/2010/main" val="1561017861"/>
+        <p14:creationId xmlns:p14="http://schemas.microsoft.com/office/powerpoint/2010/main" val="648054443"/>
       </p:ext>
     </p:extLst>
   </p:cSld>
@@ -7555,7 +8018,7 @@
           <p:cNvPr id="11" name="">
             <a:extLst xmlns:a="http://schemas.openxmlformats.org/drawingml/2006/main">
               <a:ext uri="{FF2B5EF4-FFF2-40B4-BE49-F238E27FC236}">
-                <a16:creationId xmlns:a16="http://schemas.microsoft.com/office/drawing/2014/main" id="{02849EB3-FF82-4342-8B3A-4BDC3BB95F4D}"/>
+                <a16:creationId xmlns:a16="http://schemas.microsoft.com/office/drawing/2014/main" id="{4A98B37A-452A-4837-9E2C-F03CF0E3B047}"/>
               </a:ext>
             </a:extLst>
           </p:cNvPr>
@@ -7616,7 +8079,7 @@
           <p:cNvPr id="2" name="">
             <a:extLst xmlns:a="http://schemas.openxmlformats.org/drawingml/2006/main">
               <a:ext uri="{FF2B5EF4-FFF2-40B4-BE49-F238E27FC236}">
-                <a16:creationId xmlns:a16="http://schemas.microsoft.com/office/drawing/2014/main" id="{297778ED-EBA7-44F2-A428-CC54709A2EE4}"/>
+                <a16:creationId xmlns:a16="http://schemas.microsoft.com/office/drawing/2014/main" id="{9B253292-3585-4150-BF7D-179B11AA857A}"/>
               </a:ext>
             </a:extLst>
           </p:cNvPr>
@@ -7677,7 +8140,7 @@
           <p:cNvPr id="3" name="">
             <a:extLst xmlns:a="http://schemas.openxmlformats.org/drawingml/2006/main">
               <a:ext uri="{FF2B5EF4-FFF2-40B4-BE49-F238E27FC236}">
-                <a16:creationId xmlns:a16="http://schemas.microsoft.com/office/drawing/2014/main" id="{AC468276-5DE1-4667-AF7C-E3DCB013E60B}"/>
+                <a16:creationId xmlns:a16="http://schemas.microsoft.com/office/drawing/2014/main" id="{7CD664DB-2143-4BB2-89F6-F3E7A3D2C0C2}"/>
               </a:ext>
             </a:extLst>
           </p:cNvPr>
@@ -7738,7 +8201,7 @@
           <p:cNvPr id="4" name="">
             <a:extLst xmlns:a="http://schemas.openxmlformats.org/drawingml/2006/main">
               <a:ext uri="{FF2B5EF4-FFF2-40B4-BE49-F238E27FC236}">
-                <a16:creationId xmlns:a16="http://schemas.microsoft.com/office/drawing/2014/main" id="{1D47BDDA-1986-4CCC-B61B-40A4E54CF905}"/>
+                <a16:creationId xmlns:a16="http://schemas.microsoft.com/office/drawing/2014/main" id="{F5F97858-51E7-4596-AA3C-D09E0E3AAA5D}"/>
               </a:ext>
             </a:extLst>
           </p:cNvPr>
@@ -7799,7 +8262,7 @@
           <p:cNvPr id="5" name="">
             <a:extLst xmlns:a="http://schemas.openxmlformats.org/drawingml/2006/main">
               <a:ext uri="{FF2B5EF4-FFF2-40B4-BE49-F238E27FC236}">
-                <a16:creationId xmlns:a16="http://schemas.microsoft.com/office/drawing/2014/main" id="{AC6C83C0-9CFD-4999-982B-021B72B790A4}"/>
+                <a16:creationId xmlns:a16="http://schemas.microsoft.com/office/drawing/2014/main" id="{796BC8F5-D03E-4281-BD91-87DC45E4616C}"/>
               </a:ext>
             </a:extLst>
           </p:cNvPr>
@@ -7860,7 +8323,7 @@
           <p:cNvPr id="6" name="">
             <a:extLst xmlns:a="http://schemas.openxmlformats.org/drawingml/2006/main">
               <a:ext uri="{FF2B5EF4-FFF2-40B4-BE49-F238E27FC236}">
-                <a16:creationId xmlns:a16="http://schemas.microsoft.com/office/drawing/2014/main" id="{6DA650B8-B613-4520-AA00-48AA232CD6BD}"/>
+                <a16:creationId xmlns:a16="http://schemas.microsoft.com/office/drawing/2014/main" id="{9037B294-6195-46D6-996E-431BF111C3ED}"/>
               </a:ext>
             </a:extLst>
           </p:cNvPr>
@@ -7890,7 +8353,7 @@
           <p:cNvPr id="7" name="">
             <a:extLst xmlns:a="http://schemas.openxmlformats.org/drawingml/2006/main">
               <a:ext uri="{FF2B5EF4-FFF2-40B4-BE49-F238E27FC236}">
-                <a16:creationId xmlns:a16="http://schemas.microsoft.com/office/drawing/2014/main" id="{C3171E62-9318-4965-8E33-C95D2E4CED7F}"/>
+                <a16:creationId xmlns:a16="http://schemas.microsoft.com/office/drawing/2014/main" id="{87B018FD-8EE0-4B88-BD5D-0E2D2D5ACACC}"/>
               </a:ext>
             </a:extLst>
           </p:cNvPr>
@@ -7951,7 +8414,7 @@
           <p:cNvPr id="8" name="">
             <a:extLst xmlns:a="http://schemas.openxmlformats.org/drawingml/2006/main">
               <a:ext uri="{FF2B5EF4-FFF2-40B4-BE49-F238E27FC236}">
-                <a16:creationId xmlns:a16="http://schemas.microsoft.com/office/drawing/2014/main" id="{CB5BD878-105B-4949-B303-A74153B83368}"/>
+                <a16:creationId xmlns:a16="http://schemas.microsoft.com/office/drawing/2014/main" id="{265C4300-818F-4D53-B7E4-C0D37AAA1EE8}"/>
               </a:ext>
             </a:extLst>
           </p:cNvPr>
@@ -8012,7 +8475,7 @@
           <p:cNvPr id="9" name="">
             <a:extLst xmlns:a="http://schemas.openxmlformats.org/drawingml/2006/main">
               <a:ext uri="{FF2B5EF4-FFF2-40B4-BE49-F238E27FC236}">
-                <a16:creationId xmlns:a16="http://schemas.microsoft.com/office/drawing/2014/main" id="{1B12A9C1-6BDC-4832-8D61-B7801D4C7BB2}"/>
+                <a16:creationId xmlns:a16="http://schemas.microsoft.com/office/drawing/2014/main" id="{7E20CA68-F78B-4827-B782-A714F74D2A3B}"/>
               </a:ext>
             </a:extLst>
           </p:cNvPr>
@@ -8077,7 +8540,7 @@
           <p:cNvPr id="10" name="">
             <a:extLst xmlns:a="http://schemas.openxmlformats.org/drawingml/2006/main">
               <a:ext uri="{FF2B5EF4-FFF2-40B4-BE49-F238E27FC236}">
-                <a16:creationId xmlns:a16="http://schemas.microsoft.com/office/drawing/2014/main" id="{653A5745-6C40-4219-BC4D-7756146814B9}"/>
+                <a16:creationId xmlns:a16="http://schemas.microsoft.com/office/drawing/2014/main" id="{8868A897-8D53-4293-AFF2-60CBD8A07E9A}"/>
               </a:ext>
             </a:extLst>
           </p:cNvPr>
@@ -8136,7 +8599,7 @@
     </p:spTree>
     <p:extLst>
       <p:ext uri="{BB962C8B-B14F-4D97-AF65-F5344CB8AC3E}">
-        <p14:creationId xmlns:p14="http://schemas.microsoft.com/office/powerpoint/2010/main" val="1034125256"/>
+        <p14:creationId xmlns:p14="http://schemas.microsoft.com/office/powerpoint/2010/main" val="627019133"/>
       </p:ext>
     </p:extLst>
   </p:cSld>
@@ -8167,7 +8630,7 @@
           <p:cNvPr id="12" name="">
             <a:extLst xmlns:a="http://schemas.openxmlformats.org/drawingml/2006/main">
               <a:ext uri="{FF2B5EF4-FFF2-40B4-BE49-F238E27FC236}">
-                <a16:creationId xmlns:a16="http://schemas.microsoft.com/office/drawing/2014/main" id="{F1DD034D-37E2-4663-82E3-7E8111A76573}"/>
+                <a16:creationId xmlns:a16="http://schemas.microsoft.com/office/drawing/2014/main" id="{9B941A3E-E934-46CB-975C-AC1C959B5D34}"/>
               </a:ext>
             </a:extLst>
           </p:cNvPr>
@@ -8228,7 +8691,7 @@
           <p:cNvPr id="2" name="">
             <a:extLst xmlns:a="http://schemas.openxmlformats.org/drawingml/2006/main">
               <a:ext uri="{FF2B5EF4-FFF2-40B4-BE49-F238E27FC236}">
-                <a16:creationId xmlns:a16="http://schemas.microsoft.com/office/drawing/2014/main" id="{C07926FF-C7FF-4CC6-A93F-294C9632F3E2}"/>
+                <a16:creationId xmlns:a16="http://schemas.microsoft.com/office/drawing/2014/main" id="{E288CF9F-8C32-4ECD-A171-435994856587}"/>
               </a:ext>
             </a:extLst>
           </p:cNvPr>
@@ -8289,7 +8752,7 @@
           <p:cNvPr id="3" name="">
             <a:extLst xmlns:a="http://schemas.openxmlformats.org/drawingml/2006/main">
               <a:ext uri="{FF2B5EF4-FFF2-40B4-BE49-F238E27FC236}">
-                <a16:creationId xmlns:a16="http://schemas.microsoft.com/office/drawing/2014/main" id="{DD4A31CD-0814-49EB-A5BA-7B9952CD0E00}"/>
+                <a16:creationId xmlns:a16="http://schemas.microsoft.com/office/drawing/2014/main" id="{151CF8B3-8561-4896-A655-8E65DE95DAC1}"/>
               </a:ext>
             </a:extLst>
           </p:cNvPr>
@@ -8350,7 +8813,7 @@
           <p:cNvPr id="4" name="">
             <a:extLst xmlns:a="http://schemas.openxmlformats.org/drawingml/2006/main">
               <a:ext uri="{FF2B5EF4-FFF2-40B4-BE49-F238E27FC236}">
-                <a16:creationId xmlns:a16="http://schemas.microsoft.com/office/drawing/2014/main" id="{773EDF02-AE32-4111-AED7-A7081570864C}"/>
+                <a16:creationId xmlns:a16="http://schemas.microsoft.com/office/drawing/2014/main" id="{A74D58F0-1042-4A4B-9DCB-ACD0B7C247C5}"/>
               </a:ext>
             </a:extLst>
           </p:cNvPr>
@@ -8411,7 +8874,7 @@
           <p:cNvPr id="5" name="">
             <a:extLst xmlns:a="http://schemas.openxmlformats.org/drawingml/2006/main">
               <a:ext uri="{FF2B5EF4-FFF2-40B4-BE49-F238E27FC236}">
-                <a16:creationId xmlns:a16="http://schemas.microsoft.com/office/drawing/2014/main" id="{8168622A-FB60-49BD-8550-6C2301D67EE5}"/>
+                <a16:creationId xmlns:a16="http://schemas.microsoft.com/office/drawing/2014/main" id="{3249C604-6F5D-4DCA-8ADE-73EB32724ADE}"/>
               </a:ext>
             </a:extLst>
           </p:cNvPr>
@@ -8472,7 +8935,7 @@
           <p:cNvPr id="6" name="">
             <a:extLst xmlns:a="http://schemas.openxmlformats.org/drawingml/2006/main">
               <a:ext uri="{FF2B5EF4-FFF2-40B4-BE49-F238E27FC236}">
-                <a16:creationId xmlns:a16="http://schemas.microsoft.com/office/drawing/2014/main" id="{2921A9AF-8F5D-4036-B820-9F507E18F2A0}"/>
+                <a16:creationId xmlns:a16="http://schemas.microsoft.com/office/drawing/2014/main" id="{1CE7A723-12B8-4A6E-B36F-8924C05C1D75}"/>
               </a:ext>
             </a:extLst>
           </p:cNvPr>
@@ -8533,7 +8996,7 @@
           <p:cNvPr id="7" name="">
             <a:extLst xmlns:a="http://schemas.openxmlformats.org/drawingml/2006/main">
               <a:ext uri="{FF2B5EF4-FFF2-40B4-BE49-F238E27FC236}">
-                <a16:creationId xmlns:a16="http://schemas.microsoft.com/office/drawing/2014/main" id="{E275AF48-ECA5-42D5-8226-1D13F91CA967}"/>
+                <a16:creationId xmlns:a16="http://schemas.microsoft.com/office/drawing/2014/main" id="{E62E64D6-FB55-4E79-A8E8-DB44F5AF2BC9}"/>
               </a:ext>
             </a:extLst>
           </p:cNvPr>
@@ -8594,7 +9057,7 @@
           <p:cNvPr id="8" name="">
             <a:extLst xmlns:a="http://schemas.openxmlformats.org/drawingml/2006/main">
               <a:ext uri="{FF2B5EF4-FFF2-40B4-BE49-F238E27FC236}">
-                <a16:creationId xmlns:a16="http://schemas.microsoft.com/office/drawing/2014/main" id="{D4E72CAB-1BFD-4C23-9EE2-CBE0801B72DB}"/>
+                <a16:creationId xmlns:a16="http://schemas.microsoft.com/office/drawing/2014/main" id="{A5445EBD-8150-4E26-B9D3-0E1473A65885}"/>
               </a:ext>
             </a:extLst>
           </p:cNvPr>
@@ -8655,7 +9118,7 @@
           <p:cNvPr id="9" name="">
             <a:extLst xmlns:a="http://schemas.openxmlformats.org/drawingml/2006/main">
               <a:ext uri="{FF2B5EF4-FFF2-40B4-BE49-F238E27FC236}">
-                <a16:creationId xmlns:a16="http://schemas.microsoft.com/office/drawing/2014/main" id="{F5F68F05-EB12-49DB-91F6-04584DDE3F75}"/>
+                <a16:creationId xmlns:a16="http://schemas.microsoft.com/office/drawing/2014/main" id="{D84AB648-FA14-473F-A62D-857C4D6A8AE8}"/>
               </a:ext>
             </a:extLst>
           </p:cNvPr>
@@ -8720,7 +9183,7 @@
           <p:cNvPr id="10" name="">
             <a:extLst xmlns:a="http://schemas.openxmlformats.org/drawingml/2006/main">
               <a:ext uri="{FF2B5EF4-FFF2-40B4-BE49-F238E27FC236}">
-                <a16:creationId xmlns:a16="http://schemas.microsoft.com/office/drawing/2014/main" id="{1BF84014-CF6D-4831-BFE2-F9605D64CAAF}"/>
+                <a16:creationId xmlns:a16="http://schemas.microsoft.com/office/drawing/2014/main" id="{6D77A9CE-FA8E-4840-A391-18C8E21F2CB9}"/>
               </a:ext>
             </a:extLst>
           </p:cNvPr>
@@ -8750,7 +9213,7 @@
           <p:cNvPr id="11" name="">
             <a:extLst xmlns:a="http://schemas.openxmlformats.org/drawingml/2006/main">
               <a:ext uri="{FF2B5EF4-FFF2-40B4-BE49-F238E27FC236}">
-                <a16:creationId xmlns:a16="http://schemas.microsoft.com/office/drawing/2014/main" id="{9F2BD3CB-E52C-4D3E-A7F2-45EE9439826F}"/>
+                <a16:creationId xmlns:a16="http://schemas.microsoft.com/office/drawing/2014/main" id="{433A0FCD-A0FF-490D-8AB8-FB42C858EE77}"/>
               </a:ext>
             </a:extLst>
           </p:cNvPr>
@@ -8809,7 +9272,7 @@
     </p:spTree>
     <p:extLst>
       <p:ext uri="{BB962C8B-B14F-4D97-AF65-F5344CB8AC3E}">
-        <p14:creationId xmlns:p14="http://schemas.microsoft.com/office/powerpoint/2010/main" val="973125556"/>
+        <p14:creationId xmlns:p14="http://schemas.microsoft.com/office/powerpoint/2010/main" val="1703257804"/>
       </p:ext>
     </p:extLst>
   </p:cSld>
@@ -8840,7 +9303,7 @@
           <p:cNvPr id="12" name="">
             <a:extLst xmlns:a="http://schemas.openxmlformats.org/drawingml/2006/main">
               <a:ext uri="{FF2B5EF4-FFF2-40B4-BE49-F238E27FC236}">
-                <a16:creationId xmlns:a16="http://schemas.microsoft.com/office/drawing/2014/main" id="{431808E6-6135-4C85-B5E7-74847F096335}"/>
+                <a16:creationId xmlns:a16="http://schemas.microsoft.com/office/drawing/2014/main" id="{16D69D6D-8391-432B-9E19-BFC070C4B23E}"/>
               </a:ext>
             </a:extLst>
           </p:cNvPr>
@@ -8901,7 +9364,7 @@
           <p:cNvPr id="2" name="">
             <a:extLst xmlns:a="http://schemas.openxmlformats.org/drawingml/2006/main">
               <a:ext uri="{FF2B5EF4-FFF2-40B4-BE49-F238E27FC236}">
-                <a16:creationId xmlns:a16="http://schemas.microsoft.com/office/drawing/2014/main" id="{A4A08BD7-2DDC-45C2-85AC-A6FEA4E5BF6B}"/>
+                <a16:creationId xmlns:a16="http://schemas.microsoft.com/office/drawing/2014/main" id="{38235F76-01FE-4512-BA0B-B57922138AC2}"/>
               </a:ext>
             </a:extLst>
           </p:cNvPr>
@@ -8962,7 +9425,7 @@
           <p:cNvPr id="3" name="">
             <a:extLst xmlns:a="http://schemas.openxmlformats.org/drawingml/2006/main">
               <a:ext uri="{FF2B5EF4-FFF2-40B4-BE49-F238E27FC236}">
-                <a16:creationId xmlns:a16="http://schemas.microsoft.com/office/drawing/2014/main" id="{6F661C63-F627-41AE-A9A1-B313457B69BC}"/>
+                <a16:creationId xmlns:a16="http://schemas.microsoft.com/office/drawing/2014/main" id="{D03793A6-C6AE-400A-A7C5-3280A699AC99}"/>
               </a:ext>
             </a:extLst>
           </p:cNvPr>
@@ -9023,7 +9486,7 @@
           <p:cNvPr id="4" name="">
             <a:extLst xmlns:a="http://schemas.openxmlformats.org/drawingml/2006/main">
               <a:ext uri="{FF2B5EF4-FFF2-40B4-BE49-F238E27FC236}">
-                <a16:creationId xmlns:a16="http://schemas.microsoft.com/office/drawing/2014/main" id="{B5B11A1C-8B13-4BC3-923A-DAD9BA4D1705}"/>
+                <a16:creationId xmlns:a16="http://schemas.microsoft.com/office/drawing/2014/main" id="{53FDB1C9-D49E-42F7-9C94-99D4711D5B05}"/>
               </a:ext>
             </a:extLst>
           </p:cNvPr>
@@ -9084,7 +9547,7 @@
           <p:cNvPr id="5" name="">
             <a:extLst xmlns:a="http://schemas.openxmlformats.org/drawingml/2006/main">
               <a:ext uri="{FF2B5EF4-FFF2-40B4-BE49-F238E27FC236}">
-                <a16:creationId xmlns:a16="http://schemas.microsoft.com/office/drawing/2014/main" id="{9BE572FC-C1FA-4549-9E43-34E5C8679ED5}"/>
+                <a16:creationId xmlns:a16="http://schemas.microsoft.com/office/drawing/2014/main" id="{0EAF2A10-ACF1-4169-A3D7-BA39859260A4}"/>
               </a:ext>
             </a:extLst>
           </p:cNvPr>
@@ -9149,7 +9612,7 @@
           <p:cNvPr id="6" name="">
             <a:extLst xmlns:a="http://schemas.openxmlformats.org/drawingml/2006/main">
               <a:ext uri="{FF2B5EF4-FFF2-40B4-BE49-F238E27FC236}">
-                <a16:creationId xmlns:a16="http://schemas.microsoft.com/office/drawing/2014/main" id="{02E88802-BF6A-4DE4-8EDB-91C649F41B73}"/>
+                <a16:creationId xmlns:a16="http://schemas.microsoft.com/office/drawing/2014/main" id="{18BF9A43-CF60-438D-9C10-9A8F654C1CC2}"/>
               </a:ext>
             </a:extLst>
           </p:cNvPr>
@@ -9210,7 +9673,7 @@
           <p:cNvPr id="7" name="">
             <a:extLst xmlns:a="http://schemas.openxmlformats.org/drawingml/2006/main">
               <a:ext uri="{FF2B5EF4-FFF2-40B4-BE49-F238E27FC236}">
-                <a16:creationId xmlns:a16="http://schemas.microsoft.com/office/drawing/2014/main" id="{43EC9BBE-0CAB-4EA0-BDC5-1B9344E24F52}"/>
+                <a16:creationId xmlns:a16="http://schemas.microsoft.com/office/drawing/2014/main" id="{39D3EB3D-BB22-4735-B5A2-4D42A391B5BC}"/>
               </a:ext>
             </a:extLst>
           </p:cNvPr>
@@ -9275,7 +9738,7 @@
           <p:cNvPr id="8" name="">
             <a:extLst xmlns:a="http://schemas.openxmlformats.org/drawingml/2006/main">
               <a:ext uri="{FF2B5EF4-FFF2-40B4-BE49-F238E27FC236}">
-                <a16:creationId xmlns:a16="http://schemas.microsoft.com/office/drawing/2014/main" id="{BE585F9D-A4BB-44E6-8786-10C761C594CB}"/>
+                <a16:creationId xmlns:a16="http://schemas.microsoft.com/office/drawing/2014/main" id="{CC15CF68-739E-4851-8E78-B60805A6060D}"/>
               </a:ext>
             </a:extLst>
           </p:cNvPr>
@@ -9305,7 +9768,7 @@
           <p:cNvPr id="9" name="">
             <a:extLst xmlns:a="http://schemas.openxmlformats.org/drawingml/2006/main">
               <a:ext uri="{FF2B5EF4-FFF2-40B4-BE49-F238E27FC236}">
-                <a16:creationId xmlns:a16="http://schemas.microsoft.com/office/drawing/2014/main" id="{EEDFDEB7-3552-4C5E-972E-CDF44776BF14}"/>
+                <a16:creationId xmlns:a16="http://schemas.microsoft.com/office/drawing/2014/main" id="{6884AE8F-0257-4972-B40C-C66F7901F76B}"/>
               </a:ext>
             </a:extLst>
           </p:cNvPr>
@@ -9366,7 +9829,7 @@
           <p:cNvPr id="10" name="">
             <a:extLst xmlns:a="http://schemas.openxmlformats.org/drawingml/2006/main">
               <a:ext uri="{FF2B5EF4-FFF2-40B4-BE49-F238E27FC236}">
-                <a16:creationId xmlns:a16="http://schemas.microsoft.com/office/drawing/2014/main" id="{51A7EAE1-2ED0-4298-9D32-FA6622E7AC4A}"/>
+                <a16:creationId xmlns:a16="http://schemas.microsoft.com/office/drawing/2014/main" id="{E8EAA79C-5210-4B78-A782-9F82D573452C}"/>
               </a:ext>
             </a:extLst>
           </p:cNvPr>
@@ -9427,7 +9890,7 @@
           <p:cNvPr id="11" name="">
             <a:extLst xmlns:a="http://schemas.openxmlformats.org/drawingml/2006/main">
               <a:ext uri="{FF2B5EF4-FFF2-40B4-BE49-F238E27FC236}">
-                <a16:creationId xmlns:a16="http://schemas.microsoft.com/office/drawing/2014/main" id="{ABB6E98D-56FB-473C-9C66-43546BA10C12}"/>
+                <a16:creationId xmlns:a16="http://schemas.microsoft.com/office/drawing/2014/main" id="{A45F6505-397F-4C89-B09C-A2CAA63398CE}"/>
               </a:ext>
             </a:extLst>
           </p:cNvPr>
@@ -9486,7 +9949,7 @@
     </p:spTree>
     <p:extLst>
       <p:ext uri="{BB962C8B-B14F-4D97-AF65-F5344CB8AC3E}">
-        <p14:creationId xmlns:p14="http://schemas.microsoft.com/office/powerpoint/2010/main" val="407738431"/>
+        <p14:creationId xmlns:p14="http://schemas.microsoft.com/office/powerpoint/2010/main" val="461300919"/>
       </p:ext>
     </p:extLst>
   </p:cSld>
@@ -9517,7 +9980,7 @@
           <p:cNvPr id="14" name="">
             <a:extLst xmlns:a="http://schemas.openxmlformats.org/drawingml/2006/main">
               <a:ext uri="{FF2B5EF4-FFF2-40B4-BE49-F238E27FC236}">
-                <a16:creationId xmlns:a16="http://schemas.microsoft.com/office/drawing/2014/main" id="{1486E3C8-B0BE-4C79-AA0A-2403BDA16140}"/>
+                <a16:creationId xmlns:a16="http://schemas.microsoft.com/office/drawing/2014/main" id="{F863B636-6621-451A-BDBF-715F996B8056}"/>
               </a:ext>
             </a:extLst>
           </p:cNvPr>
@@ -9578,7 +10041,7 @@
           <p:cNvPr id="2" name="">
             <a:extLst xmlns:a="http://schemas.openxmlformats.org/drawingml/2006/main">
               <a:ext uri="{FF2B5EF4-FFF2-40B4-BE49-F238E27FC236}">
-                <a16:creationId xmlns:a16="http://schemas.microsoft.com/office/drawing/2014/main" id="{BA1B4711-69C0-469C-AA13-33C316B994EB}"/>
+                <a16:creationId xmlns:a16="http://schemas.microsoft.com/office/drawing/2014/main" id="{46388097-5415-49DC-8949-0CD662C282F1}"/>
               </a:ext>
             </a:extLst>
           </p:cNvPr>
@@ -9639,7 +10102,7 @@
           <p:cNvPr id="3" name="">
             <a:extLst xmlns:a="http://schemas.openxmlformats.org/drawingml/2006/main">
               <a:ext uri="{FF2B5EF4-FFF2-40B4-BE49-F238E27FC236}">
-                <a16:creationId xmlns:a16="http://schemas.microsoft.com/office/drawing/2014/main" id="{AF00F091-E3B5-47BF-8709-C6A72CD0EBEE}"/>
+                <a16:creationId xmlns:a16="http://schemas.microsoft.com/office/drawing/2014/main" id="{D0050C86-FC65-4D2E-B675-3974CFEFC0D4}"/>
               </a:ext>
             </a:extLst>
           </p:cNvPr>
@@ -9700,7 +10163,7 @@
           <p:cNvPr id="4" name="">
             <a:extLst xmlns:a="http://schemas.openxmlformats.org/drawingml/2006/main">
               <a:ext uri="{FF2B5EF4-FFF2-40B4-BE49-F238E27FC236}">
-                <a16:creationId xmlns:a16="http://schemas.microsoft.com/office/drawing/2014/main" id="{1A2E2455-5F56-4B78-B93F-3302F5C51618}"/>
+                <a16:creationId xmlns:a16="http://schemas.microsoft.com/office/drawing/2014/main" id="{0B1EAB40-8745-4F0C-9333-209011C65DBA}"/>
               </a:ext>
             </a:extLst>
           </p:cNvPr>
@@ -9761,7 +10224,7 @@
           <p:cNvPr id="5" name="">
             <a:extLst xmlns:a="http://schemas.openxmlformats.org/drawingml/2006/main">
               <a:ext uri="{FF2B5EF4-FFF2-40B4-BE49-F238E27FC236}">
-                <a16:creationId xmlns:a16="http://schemas.microsoft.com/office/drawing/2014/main" id="{821DA0D4-BB06-402E-87F4-D83210963181}"/>
+                <a16:creationId xmlns:a16="http://schemas.microsoft.com/office/drawing/2014/main" id="{DF664B1E-80F9-4438-8749-715B13836C7F}"/>
               </a:ext>
             </a:extLst>
           </p:cNvPr>
@@ -9849,7 +10312,7 @@
           <p:cNvPr id="6" name="">
             <a:extLst xmlns:a="http://schemas.openxmlformats.org/drawingml/2006/main">
               <a:ext uri="{FF2B5EF4-FFF2-40B4-BE49-F238E27FC236}">
-                <a16:creationId xmlns:a16="http://schemas.microsoft.com/office/drawing/2014/main" id="{8B202411-0CF9-435D-9140-412211FDF612}"/>
+                <a16:creationId xmlns:a16="http://schemas.microsoft.com/office/drawing/2014/main" id="{4E2069FF-B853-4C2B-86D1-8F405FDDFD72}"/>
               </a:ext>
             </a:extLst>
           </p:cNvPr>
@@ -9910,7 +10373,7 @@
           <p:cNvPr id="7" name="">
             <a:extLst xmlns:a="http://schemas.openxmlformats.org/drawingml/2006/main">
               <a:ext uri="{FF2B5EF4-FFF2-40B4-BE49-F238E27FC236}">
-                <a16:creationId xmlns:a16="http://schemas.microsoft.com/office/drawing/2014/main" id="{15209762-92F6-47AC-8D0F-D30B563AC665}"/>
+                <a16:creationId xmlns:a16="http://schemas.microsoft.com/office/drawing/2014/main" id="{0E8BD415-1923-4884-BC4B-84861BF2AA8F}"/>
               </a:ext>
             </a:extLst>
           </p:cNvPr>
@@ -10079,7 +10542,7 @@
           <p:cNvPr id="8" name="">
             <a:extLst xmlns:a="http://schemas.openxmlformats.org/drawingml/2006/main">
               <a:ext uri="{FF2B5EF4-FFF2-40B4-BE49-F238E27FC236}">
-                <a16:creationId xmlns:a16="http://schemas.microsoft.com/office/drawing/2014/main" id="{9EF8A6E9-96FC-4BD7-A81E-91593DA8B443}"/>
+                <a16:creationId xmlns:a16="http://schemas.microsoft.com/office/drawing/2014/main" id="{7BA9E7AE-16FD-4598-95FE-82EF841FBB0B}"/>
               </a:ext>
             </a:extLst>
           </p:cNvPr>
@@ -10109,7 +10572,7 @@
           <p:cNvPr id="9" name="">
             <a:extLst xmlns:a="http://schemas.openxmlformats.org/drawingml/2006/main">
               <a:ext uri="{FF2B5EF4-FFF2-40B4-BE49-F238E27FC236}">
-                <a16:creationId xmlns:a16="http://schemas.microsoft.com/office/drawing/2014/main" id="{F7195C5A-0970-4EF0-B617-F3DAA3C63C7B}"/>
+                <a16:creationId xmlns:a16="http://schemas.microsoft.com/office/drawing/2014/main" id="{8E593910-D7BD-43BD-A111-B725DAA1A882}"/>
               </a:ext>
             </a:extLst>
           </p:cNvPr>
@@ -10170,7 +10633,7 @@
           <p:cNvPr id="10" name="">
             <a:extLst xmlns:a="http://schemas.openxmlformats.org/drawingml/2006/main">
               <a:ext uri="{FF2B5EF4-FFF2-40B4-BE49-F238E27FC236}">
-                <a16:creationId xmlns:a16="http://schemas.microsoft.com/office/drawing/2014/main" id="{E4E8A837-769F-46C1-AF3D-9EB76CE02910}"/>
+                <a16:creationId xmlns:a16="http://schemas.microsoft.com/office/drawing/2014/main" id="{F1540F72-298A-46A2-8E7B-BDAF8BCC6CA2}"/>
               </a:ext>
             </a:extLst>
           </p:cNvPr>
@@ -10339,7 +10802,7 @@
           <p:cNvPr id="11" name="">
             <a:extLst xmlns:a="http://schemas.openxmlformats.org/drawingml/2006/main">
               <a:ext uri="{FF2B5EF4-FFF2-40B4-BE49-F238E27FC236}">
-                <a16:creationId xmlns:a16="http://schemas.microsoft.com/office/drawing/2014/main" id="{10511A95-8425-49A4-A31A-8AAEF11D109C}"/>
+                <a16:creationId xmlns:a16="http://schemas.microsoft.com/office/drawing/2014/main" id="{6592DF72-D0F2-4FA1-9AEF-BE671C3DD8EB}"/>
               </a:ext>
             </a:extLst>
           </p:cNvPr>
@@ -10400,7 +10863,7 @@
           <p:cNvPr id="12" name="">
             <a:extLst xmlns:a="http://schemas.openxmlformats.org/drawingml/2006/main">
               <a:ext uri="{FF2B5EF4-FFF2-40B4-BE49-F238E27FC236}">
-                <a16:creationId xmlns:a16="http://schemas.microsoft.com/office/drawing/2014/main" id="{EC3BECE1-D7A9-4343-97C6-63506D503862}"/>
+                <a16:creationId xmlns:a16="http://schemas.microsoft.com/office/drawing/2014/main" id="{E85EBCDE-441F-4FA4-B811-2A4F4C588A72}"/>
               </a:ext>
             </a:extLst>
           </p:cNvPr>
@@ -10488,7 +10951,7 @@
           <p:cNvPr id="13" name="">
             <a:extLst xmlns:a="http://schemas.openxmlformats.org/drawingml/2006/main">
               <a:ext uri="{FF2B5EF4-FFF2-40B4-BE49-F238E27FC236}">
-                <a16:creationId xmlns:a16="http://schemas.microsoft.com/office/drawing/2014/main" id="{1B1E81E8-48DD-4220-8D0F-C134C31824DD}"/>
+                <a16:creationId xmlns:a16="http://schemas.microsoft.com/office/drawing/2014/main" id="{36271B97-2437-495E-9140-964EB979F067}"/>
               </a:ext>
             </a:extLst>
           </p:cNvPr>
@@ -10547,7 +11010,7 @@
     </p:spTree>
     <p:extLst>
       <p:ext uri="{BB962C8B-B14F-4D97-AF65-F5344CB8AC3E}">
-        <p14:creationId xmlns:p14="http://schemas.microsoft.com/office/powerpoint/2010/main" val="1369584277"/>
+        <p14:creationId xmlns:p14="http://schemas.microsoft.com/office/powerpoint/2010/main" val="2094706006"/>
       </p:ext>
     </p:extLst>
   </p:cSld>
@@ -10578,7 +11041,7 @@
           <p:cNvPr id="14" name="">
             <a:extLst xmlns:a="http://schemas.openxmlformats.org/drawingml/2006/main">
               <a:ext uri="{FF2B5EF4-FFF2-40B4-BE49-F238E27FC236}">
-                <a16:creationId xmlns:a16="http://schemas.microsoft.com/office/drawing/2014/main" id="{D9A63302-932D-466F-8451-BAD8C9CDF7BD}"/>
+                <a16:creationId xmlns:a16="http://schemas.microsoft.com/office/drawing/2014/main" id="{FF5D6DC7-7DFD-4BD5-886C-B138D202D08B}"/>
               </a:ext>
             </a:extLst>
           </p:cNvPr>
@@ -10639,7 +11102,7 @@
           <p:cNvPr id="2" name="">
             <a:extLst xmlns:a="http://schemas.openxmlformats.org/drawingml/2006/main">
               <a:ext uri="{FF2B5EF4-FFF2-40B4-BE49-F238E27FC236}">
-                <a16:creationId xmlns:a16="http://schemas.microsoft.com/office/drawing/2014/main" id="{4FCFCB02-B15D-4E12-80AF-2BEBC29CEBF5}"/>
+                <a16:creationId xmlns:a16="http://schemas.microsoft.com/office/drawing/2014/main" id="{B9A97255-A6DA-45A3-AB75-92B9044DC83D}"/>
               </a:ext>
             </a:extLst>
           </p:cNvPr>
@@ -10700,7 +11163,7 @@
           <p:cNvPr id="3" name="">
             <a:extLst xmlns:a="http://schemas.openxmlformats.org/drawingml/2006/main">
               <a:ext uri="{FF2B5EF4-FFF2-40B4-BE49-F238E27FC236}">
-                <a16:creationId xmlns:a16="http://schemas.microsoft.com/office/drawing/2014/main" id="{EF33792E-62C6-4208-81AF-BB0E6404358E}"/>
+                <a16:creationId xmlns:a16="http://schemas.microsoft.com/office/drawing/2014/main" id="{29E98132-66FC-471B-9BB4-362C6504ACF6}"/>
               </a:ext>
             </a:extLst>
           </p:cNvPr>
@@ -10761,7 +11224,7 @@
           <p:cNvPr id="4" name="">
             <a:extLst xmlns:a="http://schemas.openxmlformats.org/drawingml/2006/main">
               <a:ext uri="{FF2B5EF4-FFF2-40B4-BE49-F238E27FC236}">
-                <a16:creationId xmlns:a16="http://schemas.microsoft.com/office/drawing/2014/main" id="{A1D56540-A626-4690-AE6E-8A5B2150655D}"/>
+                <a16:creationId xmlns:a16="http://schemas.microsoft.com/office/drawing/2014/main" id="{28AC6276-0A62-4166-A233-B00D3C76B971}"/>
               </a:ext>
             </a:extLst>
           </p:cNvPr>
@@ -10822,7 +11285,7 @@
           <p:cNvPr id="5" name="">
             <a:extLst xmlns:a="http://schemas.openxmlformats.org/drawingml/2006/main">
               <a:ext uri="{FF2B5EF4-FFF2-40B4-BE49-F238E27FC236}">
-                <a16:creationId xmlns:a16="http://schemas.microsoft.com/office/drawing/2014/main" id="{B5935492-5DAC-4A41-9CFB-5A0D7EF4A95A}"/>
+                <a16:creationId xmlns:a16="http://schemas.microsoft.com/office/drawing/2014/main" id="{5BD67A86-D7FD-4006-88D1-89150E578EE2}"/>
               </a:ext>
             </a:extLst>
           </p:cNvPr>
@@ -10883,7 +11346,7 @@
           <p:cNvPr id="6" name="">
             <a:extLst xmlns:a="http://schemas.openxmlformats.org/drawingml/2006/main">
               <a:ext uri="{FF2B5EF4-FFF2-40B4-BE49-F238E27FC236}">
-                <a16:creationId xmlns:a16="http://schemas.microsoft.com/office/drawing/2014/main" id="{64DFAB13-C57A-4E23-A4EE-633DFAE854FD}"/>
+                <a16:creationId xmlns:a16="http://schemas.microsoft.com/office/drawing/2014/main" id="{B29375FE-ACEC-4364-9C3A-59D1FCD40E04}"/>
               </a:ext>
             </a:extLst>
           </p:cNvPr>
@@ -10944,7 +11407,7 @@
           <p:cNvPr id="7" name="">
             <a:extLst xmlns:a="http://schemas.openxmlformats.org/drawingml/2006/main">
               <a:ext uri="{FF2B5EF4-FFF2-40B4-BE49-F238E27FC236}">
-                <a16:creationId xmlns:a16="http://schemas.microsoft.com/office/drawing/2014/main" id="{6BAC22DC-436C-4737-A013-35D5B42CB78F}"/>
+                <a16:creationId xmlns:a16="http://schemas.microsoft.com/office/drawing/2014/main" id="{B1C6D6BA-EAFE-4D98-9C1D-B2054D636F4B}"/>
               </a:ext>
             </a:extLst>
           </p:cNvPr>
@@ -11005,7 +11468,7 @@
           <p:cNvPr id="8" name="">
             <a:extLst xmlns:a="http://schemas.openxmlformats.org/drawingml/2006/main">
               <a:ext uri="{FF2B5EF4-FFF2-40B4-BE49-F238E27FC236}">
-                <a16:creationId xmlns:a16="http://schemas.microsoft.com/office/drawing/2014/main" id="{D546F91D-A92C-49E3-8A62-2CD49D4FBF00}"/>
+                <a16:creationId xmlns:a16="http://schemas.microsoft.com/office/drawing/2014/main" id="{47AB9C82-CEF6-4BE6-A849-954BC4499E07}"/>
               </a:ext>
             </a:extLst>
           </p:cNvPr>
@@ -11066,7 +11529,7 @@
           <p:cNvPr id="9" name="">
             <a:extLst xmlns:a="http://schemas.openxmlformats.org/drawingml/2006/main">
               <a:ext uri="{FF2B5EF4-FFF2-40B4-BE49-F238E27FC236}">
-                <a16:creationId xmlns:a16="http://schemas.microsoft.com/office/drawing/2014/main" id="{4A294DF3-4297-43F6-9947-2470EE46FFCD}"/>
+                <a16:creationId xmlns:a16="http://schemas.microsoft.com/office/drawing/2014/main" id="{DDC054F5-9A29-44FD-B9AB-ED309D84AF06}"/>
               </a:ext>
             </a:extLst>
           </p:cNvPr>
@@ -11127,7 +11590,7 @@
           <p:cNvPr id="10" name="">
             <a:extLst xmlns:a="http://schemas.openxmlformats.org/drawingml/2006/main">
               <a:ext uri="{FF2B5EF4-FFF2-40B4-BE49-F238E27FC236}">
-                <a16:creationId xmlns:a16="http://schemas.microsoft.com/office/drawing/2014/main" id="{B3593567-DA87-4C2A-89A0-CBC40F8881FC}"/>
+                <a16:creationId xmlns:a16="http://schemas.microsoft.com/office/drawing/2014/main" id="{895460E6-3791-468B-BFD8-E86C8608D488}"/>
               </a:ext>
             </a:extLst>
           </p:cNvPr>
@@ -11188,7 +11651,7 @@
           <p:cNvPr id="11" name="">
             <a:extLst xmlns:a="http://schemas.openxmlformats.org/drawingml/2006/main">
               <a:ext uri="{FF2B5EF4-FFF2-40B4-BE49-F238E27FC236}">
-                <a16:creationId xmlns:a16="http://schemas.microsoft.com/office/drawing/2014/main" id="{5F4A6190-93C5-4CCE-A2E1-2DECE06B3282}"/>
+                <a16:creationId xmlns:a16="http://schemas.microsoft.com/office/drawing/2014/main" id="{FE839F0A-7CD6-464E-B4BE-426D9AD1BC93}"/>
               </a:ext>
             </a:extLst>
           </p:cNvPr>
@@ -11249,7 +11712,7 @@
           <p:cNvPr id="12" name="">
             <a:extLst xmlns:a="http://schemas.openxmlformats.org/drawingml/2006/main">
               <a:ext uri="{FF2B5EF4-FFF2-40B4-BE49-F238E27FC236}">
-                <a16:creationId xmlns:a16="http://schemas.microsoft.com/office/drawing/2014/main" id="{26FB943F-C909-47DE-91B0-B08053FF3441}"/>
+                <a16:creationId xmlns:a16="http://schemas.microsoft.com/office/drawing/2014/main" id="{27C0BABB-27F3-4125-9FB9-1A017B9523C4}"/>
               </a:ext>
             </a:extLst>
           </p:cNvPr>
@@ -11279,7 +11742,7 @@
           <p:cNvPr id="13" name="">
             <a:extLst xmlns:a="http://schemas.openxmlformats.org/drawingml/2006/main">
               <a:ext uri="{FF2B5EF4-FFF2-40B4-BE49-F238E27FC236}">
-                <a16:creationId xmlns:a16="http://schemas.microsoft.com/office/drawing/2014/main" id="{4FD92661-1B97-415C-A614-8FABD3A71BD6}"/>
+                <a16:creationId xmlns:a16="http://schemas.microsoft.com/office/drawing/2014/main" id="{1DB1BAEE-C100-4AB9-94AB-A14D4C9EC685}"/>
               </a:ext>
             </a:extLst>
           </p:cNvPr>
@@ -11338,7 +11801,7 @@
     </p:spTree>
     <p:extLst>
       <p:ext uri="{BB962C8B-B14F-4D97-AF65-F5344CB8AC3E}">
-        <p14:creationId xmlns:p14="http://schemas.microsoft.com/office/powerpoint/2010/main" val="1780667024"/>
+        <p14:creationId xmlns:p14="http://schemas.microsoft.com/office/powerpoint/2010/main" val="1635000894"/>
       </p:ext>
     </p:extLst>
   </p:cSld>
@@ -11369,7 +11832,7 @@
           <p:cNvPr id="14" name="">
             <a:extLst xmlns:a="http://schemas.openxmlformats.org/drawingml/2006/main">
               <a:ext uri="{FF2B5EF4-FFF2-40B4-BE49-F238E27FC236}">
-                <a16:creationId xmlns:a16="http://schemas.microsoft.com/office/drawing/2014/main" id="{45183595-735F-4CB1-983D-6F25B00358A6}"/>
+                <a16:creationId xmlns:a16="http://schemas.microsoft.com/office/drawing/2014/main" id="{FB98BA86-E5B2-4ED9-8CD6-E97B4B070642}"/>
               </a:ext>
             </a:extLst>
           </p:cNvPr>
@@ -11430,7 +11893,7 @@
           <p:cNvPr id="2" name="">
             <a:extLst xmlns:a="http://schemas.openxmlformats.org/drawingml/2006/main">
               <a:ext uri="{FF2B5EF4-FFF2-40B4-BE49-F238E27FC236}">
-                <a16:creationId xmlns:a16="http://schemas.microsoft.com/office/drawing/2014/main" id="{E2B4750C-DD21-4D19-9702-6A5CE4C01D05}"/>
+                <a16:creationId xmlns:a16="http://schemas.microsoft.com/office/drawing/2014/main" id="{E344DA1C-4AD2-4894-B8F0-0FE28AAB8D96}"/>
               </a:ext>
             </a:extLst>
           </p:cNvPr>
@@ -11491,7 +11954,7 @@
           <p:cNvPr id="3" name="">
             <a:extLst xmlns:a="http://schemas.openxmlformats.org/drawingml/2006/main">
               <a:ext uri="{FF2B5EF4-FFF2-40B4-BE49-F238E27FC236}">
-                <a16:creationId xmlns:a16="http://schemas.microsoft.com/office/drawing/2014/main" id="{F35895AD-A8D1-4991-85D2-AC8614C54421}"/>
+                <a16:creationId xmlns:a16="http://schemas.microsoft.com/office/drawing/2014/main" id="{9BA83DE6-4DD0-4E73-B80B-BEB232AF8927}"/>
               </a:ext>
             </a:extLst>
           </p:cNvPr>
@@ -11552,7 +12015,7 @@
           <p:cNvPr id="4" name="">
             <a:extLst xmlns:a="http://schemas.openxmlformats.org/drawingml/2006/main">
               <a:ext uri="{FF2B5EF4-FFF2-40B4-BE49-F238E27FC236}">
-                <a16:creationId xmlns:a16="http://schemas.microsoft.com/office/drawing/2014/main" id="{BA7FDEE4-D1A4-475B-85F7-0C577DAF4AB9}"/>
+                <a16:creationId xmlns:a16="http://schemas.microsoft.com/office/drawing/2014/main" id="{47F36C8F-C8EC-40A4-AE3F-C3A26F3E91D0}"/>
               </a:ext>
             </a:extLst>
           </p:cNvPr>
@@ -11613,7 +12076,7 @@
           <p:cNvPr id="5" name="">
             <a:extLst xmlns:a="http://schemas.openxmlformats.org/drawingml/2006/main">
               <a:ext uri="{FF2B5EF4-FFF2-40B4-BE49-F238E27FC236}">
-                <a16:creationId xmlns:a16="http://schemas.microsoft.com/office/drawing/2014/main" id="{F7F4221B-BE79-4B12-9B52-713A2D731F17}"/>
+                <a16:creationId xmlns:a16="http://schemas.microsoft.com/office/drawing/2014/main" id="{B90BDE2B-1CCC-4382-BC25-72EEC8FEA059}"/>
               </a:ext>
             </a:extLst>
           </p:cNvPr>
@@ -11674,7 +12137,7 @@
           <p:cNvPr id="6" name="">
             <a:extLst xmlns:a="http://schemas.openxmlformats.org/drawingml/2006/main">
               <a:ext uri="{FF2B5EF4-FFF2-40B4-BE49-F238E27FC236}">
-                <a16:creationId xmlns:a16="http://schemas.microsoft.com/office/drawing/2014/main" id="{13370605-2994-461B-A311-63DA810CD3A8}"/>
+                <a16:creationId xmlns:a16="http://schemas.microsoft.com/office/drawing/2014/main" id="{CE726F08-4BD1-48ED-B8F0-BDEB41751612}"/>
               </a:ext>
             </a:extLst>
           </p:cNvPr>
@@ -11735,7 +12198,7 @@
           <p:cNvPr id="7" name="">
             <a:extLst xmlns:a="http://schemas.openxmlformats.org/drawingml/2006/main">
               <a:ext uri="{FF2B5EF4-FFF2-40B4-BE49-F238E27FC236}">
-                <a16:creationId xmlns:a16="http://schemas.microsoft.com/office/drawing/2014/main" id="{08E0E63F-A79D-4F38-B8B3-ACE8A0F6B33F}"/>
+                <a16:creationId xmlns:a16="http://schemas.microsoft.com/office/drawing/2014/main" id="{18666D05-7157-4CAD-89CF-27D71509A536}"/>
               </a:ext>
             </a:extLst>
           </p:cNvPr>
@@ -11796,7 +12259,7 @@
           <p:cNvPr id="8" name="">
             <a:extLst xmlns:a="http://schemas.openxmlformats.org/drawingml/2006/main">
               <a:ext uri="{FF2B5EF4-FFF2-40B4-BE49-F238E27FC236}">
-                <a16:creationId xmlns:a16="http://schemas.microsoft.com/office/drawing/2014/main" id="{2337D901-511D-4BB6-86DF-983A40A1759D}"/>
+                <a16:creationId xmlns:a16="http://schemas.microsoft.com/office/drawing/2014/main" id="{B0094ECE-2FB7-44B5-A45D-F65E7AA97D7E}"/>
               </a:ext>
             </a:extLst>
           </p:cNvPr>
@@ -11857,7 +12320,7 @@
           <p:cNvPr id="9" name="">
             <a:extLst xmlns:a="http://schemas.openxmlformats.org/drawingml/2006/main">
               <a:ext uri="{FF2B5EF4-FFF2-40B4-BE49-F238E27FC236}">
-                <a16:creationId xmlns:a16="http://schemas.microsoft.com/office/drawing/2014/main" id="{F5971C35-8255-4599-9D6A-3DCDB50A7C57}"/>
+                <a16:creationId xmlns:a16="http://schemas.microsoft.com/office/drawing/2014/main" id="{9FC6E341-6C49-498D-88F0-C8BFC4B065D8}"/>
               </a:ext>
             </a:extLst>
           </p:cNvPr>
@@ -11918,7 +12381,7 @@
           <p:cNvPr id="10" name="">
             <a:extLst xmlns:a="http://schemas.openxmlformats.org/drawingml/2006/main">
               <a:ext uri="{FF2B5EF4-FFF2-40B4-BE49-F238E27FC236}">
-                <a16:creationId xmlns:a16="http://schemas.microsoft.com/office/drawing/2014/main" id="{E1DAFED1-870B-4686-B53A-50C74368A59A}"/>
+                <a16:creationId xmlns:a16="http://schemas.microsoft.com/office/drawing/2014/main" id="{A0869468-1B81-4FED-A74B-0BC464615285}"/>
               </a:ext>
             </a:extLst>
           </p:cNvPr>
@@ -11979,7 +12442,7 @@
           <p:cNvPr id="11" name="">
             <a:extLst xmlns:a="http://schemas.openxmlformats.org/drawingml/2006/main">
               <a:ext uri="{FF2B5EF4-FFF2-40B4-BE49-F238E27FC236}">
-                <a16:creationId xmlns:a16="http://schemas.microsoft.com/office/drawing/2014/main" id="{2BBED6B2-0ADA-473B-86AB-B3876F778EF5}"/>
+                <a16:creationId xmlns:a16="http://schemas.microsoft.com/office/drawing/2014/main" id="{CAAA469F-4A8C-483B-91CB-EEB016C2BF54}"/>
               </a:ext>
             </a:extLst>
           </p:cNvPr>
@@ -12040,7 +12503,7 @@
           <p:cNvPr id="12" name="">
             <a:extLst xmlns:a="http://schemas.openxmlformats.org/drawingml/2006/main">
               <a:ext uri="{FF2B5EF4-FFF2-40B4-BE49-F238E27FC236}">
-                <a16:creationId xmlns:a16="http://schemas.microsoft.com/office/drawing/2014/main" id="{DD938EAA-F22A-4370-8D52-130E8B70F7EC}"/>
+                <a16:creationId xmlns:a16="http://schemas.microsoft.com/office/drawing/2014/main" id="{06C14CAC-BECA-4D29-97DF-3DAFAAF53A0E}"/>
               </a:ext>
             </a:extLst>
           </p:cNvPr>
@@ -12070,7 +12533,7 @@
           <p:cNvPr id="13" name="">
             <a:extLst xmlns:a="http://schemas.openxmlformats.org/drawingml/2006/main">
               <a:ext uri="{FF2B5EF4-FFF2-40B4-BE49-F238E27FC236}">
-                <a16:creationId xmlns:a16="http://schemas.microsoft.com/office/drawing/2014/main" id="{35609276-AA7E-4AF4-8D17-AA3BE43AA022}"/>
+                <a16:creationId xmlns:a16="http://schemas.microsoft.com/office/drawing/2014/main" id="{85742FFE-6E3E-4CE0-9503-FF2D97C5B03F}"/>
               </a:ext>
             </a:extLst>
           </p:cNvPr>
@@ -12129,7 +12592,7 @@
     </p:spTree>
     <p:extLst>
       <p:ext uri="{BB962C8B-B14F-4D97-AF65-F5344CB8AC3E}">
-        <p14:creationId xmlns:p14="http://schemas.microsoft.com/office/powerpoint/2010/main" val="266729210"/>
+        <p14:creationId xmlns:p14="http://schemas.microsoft.com/office/powerpoint/2010/main" val="447244993"/>
       </p:ext>
     </p:extLst>
   </p:cSld>
@@ -12160,7 +12623,7 @@
           <p:cNvPr id="23" name="">
             <a:extLst xmlns:a="http://schemas.openxmlformats.org/drawingml/2006/main">
               <a:ext uri="{FF2B5EF4-FFF2-40B4-BE49-F238E27FC236}">
-                <a16:creationId xmlns:a16="http://schemas.microsoft.com/office/drawing/2014/main" id="{C58DA707-AB33-4CDB-9563-D6BE983822D7}"/>
+                <a16:creationId xmlns:a16="http://schemas.microsoft.com/office/drawing/2014/main" id="{FCF4FD3D-606E-4A67-A420-A7603DCC32F5}"/>
               </a:ext>
             </a:extLst>
           </p:cNvPr>
@@ -12221,7 +12684,7 @@
           <p:cNvPr id="2" name="">
             <a:extLst xmlns:a="http://schemas.openxmlformats.org/drawingml/2006/main">
               <a:ext uri="{FF2B5EF4-FFF2-40B4-BE49-F238E27FC236}">
-                <a16:creationId xmlns:a16="http://schemas.microsoft.com/office/drawing/2014/main" id="{B546BFB3-2484-418A-9F63-D68209ADDE5F}"/>
+                <a16:creationId xmlns:a16="http://schemas.microsoft.com/office/drawing/2014/main" id="{CEB3ED57-5A11-443E-A34F-9E283AC0714F}"/>
               </a:ext>
             </a:extLst>
           </p:cNvPr>
@@ -12282,7 +12745,7 @@
           <p:cNvPr id="3" name="">
             <a:extLst xmlns:a="http://schemas.openxmlformats.org/drawingml/2006/main">
               <a:ext uri="{FF2B5EF4-FFF2-40B4-BE49-F238E27FC236}">
-                <a16:creationId xmlns:a16="http://schemas.microsoft.com/office/drawing/2014/main" id="{AD0AD599-E7DA-439D-938E-012F1E89B4EC}"/>
+                <a16:creationId xmlns:a16="http://schemas.microsoft.com/office/drawing/2014/main" id="{F59496C1-5B40-4A4C-A0F3-1A6A227D1167}"/>
               </a:ext>
             </a:extLst>
           </p:cNvPr>
@@ -12343,7 +12806,7 @@
           <p:cNvPr id="4" name="">
             <a:extLst xmlns:a="http://schemas.openxmlformats.org/drawingml/2006/main">
               <a:ext uri="{FF2B5EF4-FFF2-40B4-BE49-F238E27FC236}">
-                <a16:creationId xmlns:a16="http://schemas.microsoft.com/office/drawing/2014/main" id="{1C0C5FFB-B3BC-4365-AE71-F640E5326264}"/>
+                <a16:creationId xmlns:a16="http://schemas.microsoft.com/office/drawing/2014/main" id="{56B084A9-564B-403D-9126-8C93F20EF5E4}"/>
               </a:ext>
             </a:extLst>
           </p:cNvPr>
@@ -12404,7 +12867,7 @@
           <p:cNvPr id="5" name="">
             <a:extLst xmlns:a="http://schemas.openxmlformats.org/drawingml/2006/main">
               <a:ext uri="{FF2B5EF4-FFF2-40B4-BE49-F238E27FC236}">
-                <a16:creationId xmlns:a16="http://schemas.microsoft.com/office/drawing/2014/main" id="{A2A690C0-95C3-4B8D-8A0B-BDC2D379CDE4}"/>
+                <a16:creationId xmlns:a16="http://schemas.microsoft.com/office/drawing/2014/main" id="{A0437904-AC00-433D-A199-76ABB5C34AB2}"/>
               </a:ext>
             </a:extLst>
           </p:cNvPr>
@@ -12465,7 +12928,7 @@
           <p:cNvPr id="6" name="">
             <a:extLst xmlns:a="http://schemas.openxmlformats.org/drawingml/2006/main">
               <a:ext uri="{FF2B5EF4-FFF2-40B4-BE49-F238E27FC236}">
-                <a16:creationId xmlns:a16="http://schemas.microsoft.com/office/drawing/2014/main" id="{1D4C03EA-2FB2-4C18-B5B5-C1FC0ACDED08}"/>
+                <a16:creationId xmlns:a16="http://schemas.microsoft.com/office/drawing/2014/main" id="{0AB8CB35-35D7-4003-9837-7E3EA05FC510}"/>
               </a:ext>
             </a:extLst>
           </p:cNvPr>
@@ -12526,7 +12989,7 @@
           <p:cNvPr id="7" name="">
             <a:extLst xmlns:a="http://schemas.openxmlformats.org/drawingml/2006/main">
               <a:ext uri="{FF2B5EF4-FFF2-40B4-BE49-F238E27FC236}">
-                <a16:creationId xmlns:a16="http://schemas.microsoft.com/office/drawing/2014/main" id="{22FB49C4-3B7E-49E7-A17D-787C9B20977C}"/>
+                <a16:creationId xmlns:a16="http://schemas.microsoft.com/office/drawing/2014/main" id="{7AC3731F-7515-4AA5-929D-401F01A0C91A}"/>
               </a:ext>
             </a:extLst>
           </p:cNvPr>
@@ -12587,7 +13050,7 @@
           <p:cNvPr id="8" name="">
             <a:extLst xmlns:a="http://schemas.openxmlformats.org/drawingml/2006/main">
               <a:ext uri="{FF2B5EF4-FFF2-40B4-BE49-F238E27FC236}">
-                <a16:creationId xmlns:a16="http://schemas.microsoft.com/office/drawing/2014/main" id="{8E6ACB5A-5F45-48D6-9F16-1431F3D9335F}"/>
+                <a16:creationId xmlns:a16="http://schemas.microsoft.com/office/drawing/2014/main" id="{E6AE3C46-7933-4673-A27D-884765F07A1A}"/>
               </a:ext>
             </a:extLst>
           </p:cNvPr>
@@ -12648,7 +13111,7 @@
           <p:cNvPr id="9" name="">
             <a:extLst xmlns:a="http://schemas.openxmlformats.org/drawingml/2006/main">
               <a:ext uri="{FF2B5EF4-FFF2-40B4-BE49-F238E27FC236}">
-                <a16:creationId xmlns:a16="http://schemas.microsoft.com/office/drawing/2014/main" id="{CD75CB86-1344-46EA-BE36-EB90CDDAE107}"/>
+                <a16:creationId xmlns:a16="http://schemas.microsoft.com/office/drawing/2014/main" id="{9DD606ED-BBAA-4F0F-BE4E-DE6FD0E3E63B}"/>
               </a:ext>
             </a:extLst>
           </p:cNvPr>
@@ -12709,7 +13172,7 @@
           <p:cNvPr id="10" name="">
             <a:extLst xmlns:a="http://schemas.openxmlformats.org/drawingml/2006/main">
               <a:ext uri="{FF2B5EF4-FFF2-40B4-BE49-F238E27FC236}">
-                <a16:creationId xmlns:a16="http://schemas.microsoft.com/office/drawing/2014/main" id="{72754488-B315-460F-9591-0B6FD06ECDD2}"/>
+                <a16:creationId xmlns:a16="http://schemas.microsoft.com/office/drawing/2014/main" id="{DBCF8AE1-0876-4FFA-9E38-EF69DB36BAB7}"/>
               </a:ext>
             </a:extLst>
           </p:cNvPr>
@@ -12770,7 +13233,7 @@
           <p:cNvPr id="11" name="">
             <a:extLst xmlns:a="http://schemas.openxmlformats.org/drawingml/2006/main">
               <a:ext uri="{FF2B5EF4-FFF2-40B4-BE49-F238E27FC236}">
-                <a16:creationId xmlns:a16="http://schemas.microsoft.com/office/drawing/2014/main" id="{3300B526-A1D2-438E-957C-A541F99C0BC4}"/>
+                <a16:creationId xmlns:a16="http://schemas.microsoft.com/office/drawing/2014/main" id="{1F34484A-2791-4991-BF73-DE043B10286B}"/>
               </a:ext>
             </a:extLst>
           </p:cNvPr>
@@ -12831,7 +13294,7 @@
           <p:cNvPr id="12" name="">
             <a:extLst xmlns:a="http://schemas.openxmlformats.org/drawingml/2006/main">
               <a:ext uri="{FF2B5EF4-FFF2-40B4-BE49-F238E27FC236}">
-                <a16:creationId xmlns:a16="http://schemas.microsoft.com/office/drawing/2014/main" id="{18947146-E7C7-4B0F-8C91-B8AA950202D1}"/>
+                <a16:creationId xmlns:a16="http://schemas.microsoft.com/office/drawing/2014/main" id="{522D9179-069D-49E9-8206-187D9F1F0ECB}"/>
               </a:ext>
             </a:extLst>
           </p:cNvPr>
@@ -12892,7 +13355,7 @@
           <p:cNvPr id="13" name="">
             <a:extLst xmlns:a="http://schemas.openxmlformats.org/drawingml/2006/main">
               <a:ext uri="{FF2B5EF4-FFF2-40B4-BE49-F238E27FC236}">
-                <a16:creationId xmlns:a16="http://schemas.microsoft.com/office/drawing/2014/main" id="{38C3C9A6-494F-48AF-968B-62903AB8B891}"/>
+                <a16:creationId xmlns:a16="http://schemas.microsoft.com/office/drawing/2014/main" id="{B63ED4AC-300D-46D2-9E8D-1AE51A8A103B}"/>
               </a:ext>
             </a:extLst>
           </p:cNvPr>
@@ -12953,7 +13416,7 @@
           <p:cNvPr id="14" name="">
             <a:extLst xmlns:a="http://schemas.openxmlformats.org/drawingml/2006/main">
               <a:ext uri="{FF2B5EF4-FFF2-40B4-BE49-F238E27FC236}">
-                <a16:creationId xmlns:a16="http://schemas.microsoft.com/office/drawing/2014/main" id="{585692DD-A751-4001-B083-78AD2464C3A4}"/>
+                <a16:creationId xmlns:a16="http://schemas.microsoft.com/office/drawing/2014/main" id="{03F14AF0-8553-47FE-9F8B-97BBA5E8D150}"/>
               </a:ext>
             </a:extLst>
           </p:cNvPr>
@@ -13014,7 +13477,7 @@
           <p:cNvPr id="15" name="">
             <a:extLst xmlns:a="http://schemas.openxmlformats.org/drawingml/2006/main">
               <a:ext uri="{FF2B5EF4-FFF2-40B4-BE49-F238E27FC236}">
-                <a16:creationId xmlns:a16="http://schemas.microsoft.com/office/drawing/2014/main" id="{7024FA06-13EC-4C61-970A-59762BA0A914}"/>
+                <a16:creationId xmlns:a16="http://schemas.microsoft.com/office/drawing/2014/main" id="{D8B12921-B0A4-4277-A69B-B3065E02525F}"/>
               </a:ext>
             </a:extLst>
           </p:cNvPr>
@@ -13075,7 +13538,7 @@
           <p:cNvPr id="16" name="">
             <a:extLst xmlns:a="http://schemas.openxmlformats.org/drawingml/2006/main">
               <a:ext uri="{FF2B5EF4-FFF2-40B4-BE49-F238E27FC236}">
-                <a16:creationId xmlns:a16="http://schemas.microsoft.com/office/drawing/2014/main" id="{83913F70-8BFE-4BDA-BBC7-75511FEF1A8E}"/>
+                <a16:creationId xmlns:a16="http://schemas.microsoft.com/office/drawing/2014/main" id="{45331F30-8574-4EAB-97E0-73864D407219}"/>
               </a:ext>
             </a:extLst>
           </p:cNvPr>
@@ -13136,7 +13599,7 @@
           <p:cNvPr id="17" name="">
             <a:extLst xmlns:a="http://schemas.openxmlformats.org/drawingml/2006/main">
               <a:ext uri="{FF2B5EF4-FFF2-40B4-BE49-F238E27FC236}">
-                <a16:creationId xmlns:a16="http://schemas.microsoft.com/office/drawing/2014/main" id="{3534E6BD-4AC2-4300-BBC8-E86EBADE33DF}"/>
+                <a16:creationId xmlns:a16="http://schemas.microsoft.com/office/drawing/2014/main" id="{D516EF42-FB16-4D16-A900-76009A8788CC}"/>
               </a:ext>
             </a:extLst>
           </p:cNvPr>
@@ -13197,7 +13660,7 @@
           <p:cNvPr id="18" name="">
             <a:extLst xmlns:a="http://schemas.openxmlformats.org/drawingml/2006/main">
               <a:ext uri="{FF2B5EF4-FFF2-40B4-BE49-F238E27FC236}">
-                <a16:creationId xmlns:a16="http://schemas.microsoft.com/office/drawing/2014/main" id="{2DC8B4E3-0C56-40BC-B229-4ACEA4D607CC}"/>
+                <a16:creationId xmlns:a16="http://schemas.microsoft.com/office/drawing/2014/main" id="{3C21CB70-00C9-4AF3-B954-6CC0B6536034}"/>
               </a:ext>
             </a:extLst>
           </p:cNvPr>
@@ -13258,7 +13721,7 @@
           <p:cNvPr id="19" name="">
             <a:extLst xmlns:a="http://schemas.openxmlformats.org/drawingml/2006/main">
               <a:ext uri="{FF2B5EF4-FFF2-40B4-BE49-F238E27FC236}">
-                <a16:creationId xmlns:a16="http://schemas.microsoft.com/office/drawing/2014/main" id="{2C0FE076-7288-4D03-A0BC-AE70B8433CCF}"/>
+                <a16:creationId xmlns:a16="http://schemas.microsoft.com/office/drawing/2014/main" id="{1FC859EC-ECD9-4D39-A505-808291F9E279}"/>
               </a:ext>
             </a:extLst>
           </p:cNvPr>
@@ -13319,7 +13782,7 @@
           <p:cNvPr id="20" name="">
             <a:extLst xmlns:a="http://schemas.openxmlformats.org/drawingml/2006/main">
               <a:ext uri="{FF2B5EF4-FFF2-40B4-BE49-F238E27FC236}">
-                <a16:creationId xmlns:a16="http://schemas.microsoft.com/office/drawing/2014/main" id="{5A51F7B1-0B40-4190-B190-62F2FDFF8FA3}"/>
+                <a16:creationId xmlns:a16="http://schemas.microsoft.com/office/drawing/2014/main" id="{2C1A45C4-8FD3-47CD-BB96-85C36CF21C81}"/>
               </a:ext>
             </a:extLst>
           </p:cNvPr>
@@ -13349,7 +13812,7 @@
           <p:cNvPr id="21" name="">
             <a:extLst xmlns:a="http://schemas.openxmlformats.org/drawingml/2006/main">
               <a:ext uri="{FF2B5EF4-FFF2-40B4-BE49-F238E27FC236}">
-                <a16:creationId xmlns:a16="http://schemas.microsoft.com/office/drawing/2014/main" id="{81092A79-275F-4FE6-94B2-3756C018E345}"/>
+                <a16:creationId xmlns:a16="http://schemas.microsoft.com/office/drawing/2014/main" id="{09FBF07F-063A-4561-9451-68805C589A52}"/>
               </a:ext>
             </a:extLst>
           </p:cNvPr>
@@ -13410,7 +13873,7 @@
           <p:cNvPr id="22" name="">
             <a:extLst xmlns:a="http://schemas.openxmlformats.org/drawingml/2006/main">
               <a:ext uri="{FF2B5EF4-FFF2-40B4-BE49-F238E27FC236}">
-                <a16:creationId xmlns:a16="http://schemas.microsoft.com/office/drawing/2014/main" id="{D43EA06D-51C9-4D07-9910-9465B21BEA4F}"/>
+                <a16:creationId xmlns:a16="http://schemas.microsoft.com/office/drawing/2014/main" id="{8D889A48-2802-4D5A-AB3D-318877C04849}"/>
               </a:ext>
             </a:extLst>
           </p:cNvPr>
@@ -13469,7 +13932,7 @@
     </p:spTree>
     <p:extLst>
       <p:ext uri="{BB962C8B-B14F-4D97-AF65-F5344CB8AC3E}">
-        <p14:creationId xmlns:p14="http://schemas.microsoft.com/office/powerpoint/2010/main" val="424379384"/>
+        <p14:creationId xmlns:p14="http://schemas.microsoft.com/office/powerpoint/2010/main" val="808768407"/>
       </p:ext>
     </p:extLst>
   </p:cSld>
@@ -13500,7 +13963,7 @@
           <p:cNvPr id="6" name="">
             <a:extLst xmlns:a="http://schemas.openxmlformats.org/drawingml/2006/main">
               <a:ext uri="{FF2B5EF4-FFF2-40B4-BE49-F238E27FC236}">
-                <a16:creationId xmlns:a16="http://schemas.microsoft.com/office/drawing/2014/main" id="{ED8C53B1-4B7C-4FD5-A10C-E56B8EFFCE3D}"/>
+                <a16:creationId xmlns:a16="http://schemas.microsoft.com/office/drawing/2014/main" id="{9B15A18B-8FDE-41C4-9D4E-56E81CDA0512}"/>
               </a:ext>
             </a:extLst>
           </p:cNvPr>
@@ -13561,7 +14024,7 @@
           <p:cNvPr id="2" name="">
             <a:extLst xmlns:a="http://schemas.openxmlformats.org/drawingml/2006/main">
               <a:ext uri="{FF2B5EF4-FFF2-40B4-BE49-F238E27FC236}">
-                <a16:creationId xmlns:a16="http://schemas.microsoft.com/office/drawing/2014/main" id="{5F861D95-1D30-4826-928D-75E9E78D2A76}"/>
+                <a16:creationId xmlns:a16="http://schemas.microsoft.com/office/drawing/2014/main" id="{BAD4F920-F675-4F30-BE7E-6A9938042477}"/>
               </a:ext>
             </a:extLst>
           </p:cNvPr>
@@ -13622,7 +14085,7 @@
           <p:cNvPr id="3" name="">
             <a:extLst xmlns:a="http://schemas.openxmlformats.org/drawingml/2006/main">
               <a:ext uri="{FF2B5EF4-FFF2-40B4-BE49-F238E27FC236}">
-                <a16:creationId xmlns:a16="http://schemas.microsoft.com/office/drawing/2014/main" id="{8C1160BA-B7CF-45F7-9B59-9AD696E90932}"/>
+                <a16:creationId xmlns:a16="http://schemas.microsoft.com/office/drawing/2014/main" id="{10CA46E2-F37B-4434-BA83-0982ADE2EAB4}"/>
               </a:ext>
             </a:extLst>
           </p:cNvPr>
@@ -14319,7 +14782,7 @@
           <p:cNvPr id="5" name="">
             <a:extLst xmlns:a="http://schemas.openxmlformats.org/drawingml/2006/main">
               <a:ext uri="{FF2B5EF4-FFF2-40B4-BE49-F238E27FC236}">
-                <a16:creationId xmlns:a16="http://schemas.microsoft.com/office/drawing/2014/main" id="{3B69D7BD-EF9B-45BF-9AB2-5818290C61CB}"/>
+                <a16:creationId xmlns:a16="http://schemas.microsoft.com/office/drawing/2014/main" id="{46FC2F7F-1A59-4019-9809-A2EFBB317623}"/>
               </a:ext>
             </a:extLst>
           </p:cNvPr>
@@ -14411,7 +14874,7 @@
     </p:spTree>
     <p:extLst>
       <p:ext uri="{BB962C8B-B14F-4D97-AF65-F5344CB8AC3E}">
-        <p14:creationId xmlns:p14="http://schemas.microsoft.com/office/powerpoint/2010/main" val="1376125857"/>
+        <p14:creationId xmlns:p14="http://schemas.microsoft.com/office/powerpoint/2010/main" val="45514429"/>
       </p:ext>
     </p:extLst>
   </p:cSld>
@@ -14442,7 +14905,7 @@
           <p:cNvPr id="12" name="">
             <a:extLst xmlns:a="http://schemas.openxmlformats.org/drawingml/2006/main">
               <a:ext uri="{FF2B5EF4-FFF2-40B4-BE49-F238E27FC236}">
-                <a16:creationId xmlns:a16="http://schemas.microsoft.com/office/drawing/2014/main" id="{0B466B1D-213E-4EFD-A2BB-F1AA75EA5A3D}"/>
+                <a16:creationId xmlns:a16="http://schemas.microsoft.com/office/drawing/2014/main" id="{0BE4219C-B956-44E8-865E-A3EC60213A15}"/>
               </a:ext>
             </a:extLst>
           </p:cNvPr>
@@ -14503,7 +14966,7 @@
           <p:cNvPr id="2" name="">
             <a:extLst xmlns:a="http://schemas.openxmlformats.org/drawingml/2006/main">
               <a:ext uri="{FF2B5EF4-FFF2-40B4-BE49-F238E27FC236}">
-                <a16:creationId xmlns:a16="http://schemas.microsoft.com/office/drawing/2014/main" id="{764AE225-9651-4716-A4C7-47D1134ED9CF}"/>
+                <a16:creationId xmlns:a16="http://schemas.microsoft.com/office/drawing/2014/main" id="{CC32560C-0DDF-46A5-ADFC-5E413ACEDB84}"/>
               </a:ext>
             </a:extLst>
           </p:cNvPr>
@@ -14564,7 +15027,7 @@
           <p:cNvPr id="3" name="">
             <a:extLst xmlns:a="http://schemas.openxmlformats.org/drawingml/2006/main">
               <a:ext uri="{FF2B5EF4-FFF2-40B4-BE49-F238E27FC236}">
-                <a16:creationId xmlns:a16="http://schemas.microsoft.com/office/drawing/2014/main" id="{7F7F8A60-86A9-4E48-A8FB-28181450D24E}"/>
+                <a16:creationId xmlns:a16="http://schemas.microsoft.com/office/drawing/2014/main" id="{498DE0F8-635E-4F6B-AAB9-54BE3114037C}"/>
               </a:ext>
             </a:extLst>
           </p:cNvPr>
@@ -14625,7 +15088,7 @@
           <p:cNvPr id="4" name="">
             <a:extLst xmlns:a="http://schemas.openxmlformats.org/drawingml/2006/main">
               <a:ext uri="{FF2B5EF4-FFF2-40B4-BE49-F238E27FC236}">
-                <a16:creationId xmlns:a16="http://schemas.microsoft.com/office/drawing/2014/main" id="{D2832033-1E3E-433E-9D61-91CA2D7C5C86}"/>
+                <a16:creationId xmlns:a16="http://schemas.microsoft.com/office/drawing/2014/main" id="{517FCC82-94D9-4955-8C22-73CDB1F62834}"/>
               </a:ext>
             </a:extLst>
           </p:cNvPr>
@@ -14693,7 +15156,7 @@
           <p:cNvPr id="5" name="">
             <a:extLst xmlns:a="http://schemas.openxmlformats.org/drawingml/2006/main">
               <a:ext uri="{FF2B5EF4-FFF2-40B4-BE49-F238E27FC236}">
-                <a16:creationId xmlns:a16="http://schemas.microsoft.com/office/drawing/2014/main" id="{30F452D6-E546-400A-8076-4F201E5F9C00}"/>
+                <a16:creationId xmlns:a16="http://schemas.microsoft.com/office/drawing/2014/main" id="{25E653DA-8AED-403A-8BB4-1A94F089A5C2}"/>
               </a:ext>
             </a:extLst>
           </p:cNvPr>
@@ -14754,7 +15217,7 @@
           <p:cNvPr id="6" name="">
             <a:extLst xmlns:a="http://schemas.openxmlformats.org/drawingml/2006/main">
               <a:ext uri="{FF2B5EF4-FFF2-40B4-BE49-F238E27FC236}">
-                <a16:creationId xmlns:a16="http://schemas.microsoft.com/office/drawing/2014/main" id="{0432262C-BDF7-4D22-ADD6-96625EEDD889}"/>
+                <a16:creationId xmlns:a16="http://schemas.microsoft.com/office/drawing/2014/main" id="{45C4FF5B-E91B-4010-9E7B-FA57ABE8128F}"/>
               </a:ext>
             </a:extLst>
           </p:cNvPr>
@@ -14815,7 +15278,7 @@
           <p:cNvPr id="7" name="">
             <a:extLst xmlns:a="http://schemas.openxmlformats.org/drawingml/2006/main">
               <a:ext uri="{FF2B5EF4-FFF2-40B4-BE49-F238E27FC236}">
-                <a16:creationId xmlns:a16="http://schemas.microsoft.com/office/drawing/2014/main" id="{947D5A78-278B-493B-BA29-CD672533ED25}"/>
+                <a16:creationId xmlns:a16="http://schemas.microsoft.com/office/drawing/2014/main" id="{4E60E17D-FBDD-43AA-B108-ADB65B34D9D9}"/>
               </a:ext>
             </a:extLst>
           </p:cNvPr>
@@ -14876,7 +15339,7 @@
           <p:cNvPr id="8" name="">
             <a:extLst xmlns:a="http://schemas.openxmlformats.org/drawingml/2006/main">
               <a:ext uri="{FF2B5EF4-FFF2-40B4-BE49-F238E27FC236}">
-                <a16:creationId xmlns:a16="http://schemas.microsoft.com/office/drawing/2014/main" id="{181F3E6E-D073-4272-B080-513747DA7025}"/>
+                <a16:creationId xmlns:a16="http://schemas.microsoft.com/office/drawing/2014/main" id="{ECA15725-0981-4922-A8A3-E68CC653DA99}"/>
               </a:ext>
             </a:extLst>
           </p:cNvPr>
@@ -14937,7 +15400,7 @@
           <p:cNvPr id="9" name="">
             <a:extLst xmlns:a="http://schemas.openxmlformats.org/drawingml/2006/main">
               <a:ext uri="{FF2B5EF4-FFF2-40B4-BE49-F238E27FC236}">
-                <a16:creationId xmlns:a16="http://schemas.microsoft.com/office/drawing/2014/main" id="{2301343F-AD08-49F5-8656-5883B95BDF7E}"/>
+                <a16:creationId xmlns:a16="http://schemas.microsoft.com/office/drawing/2014/main" id="{701A7484-1598-45E2-832C-2A969D683FEC}"/>
               </a:ext>
             </a:extLst>
           </p:cNvPr>
@@ -14998,7 +15461,7 @@
           <p:cNvPr id="10" name="">
             <a:extLst xmlns:a="http://schemas.openxmlformats.org/drawingml/2006/main">
               <a:ext uri="{FF2B5EF4-FFF2-40B4-BE49-F238E27FC236}">
-                <a16:creationId xmlns:a16="http://schemas.microsoft.com/office/drawing/2014/main" id="{21C9AB8E-0744-4793-A1BC-446FAAB7729D}"/>
+                <a16:creationId xmlns:a16="http://schemas.microsoft.com/office/drawing/2014/main" id="{941BBDDE-6E76-4F70-BF6A-2C57B4A0E7BC}"/>
               </a:ext>
             </a:extLst>
           </p:cNvPr>
@@ -15059,7 +15522,7 @@
           <p:cNvPr id="11" name="">
             <a:extLst xmlns:a="http://schemas.openxmlformats.org/drawingml/2006/main">
               <a:ext uri="{FF2B5EF4-FFF2-40B4-BE49-F238E27FC236}">
-                <a16:creationId xmlns:a16="http://schemas.microsoft.com/office/drawing/2014/main" id="{2A2D44C9-946F-4E38-8188-AAD56C5AEDDE}"/>
+                <a16:creationId xmlns:a16="http://schemas.microsoft.com/office/drawing/2014/main" id="{1A1B7C05-DCB0-4057-8B2E-865FAF366604}"/>
               </a:ext>
             </a:extLst>
           </p:cNvPr>
@@ -15118,7 +15581,7 @@
     </p:spTree>
     <p:extLst>
       <p:ext uri="{BB962C8B-B14F-4D97-AF65-F5344CB8AC3E}">
-        <p14:creationId xmlns:p14="http://schemas.microsoft.com/office/powerpoint/2010/main" val="765547611"/>
+        <p14:creationId xmlns:p14="http://schemas.microsoft.com/office/powerpoint/2010/main" val="1256612456"/>
       </p:ext>
     </p:extLst>
   </p:cSld>
@@ -15146,10 +15609,10 @@
       </p:grpSpPr>
       <p:sp>
         <p:nvSpPr>
-          <p:cNvPr id="38" name="">
-            <a:extLst xmlns:a="http://schemas.openxmlformats.org/drawingml/2006/main">
-              <a:ext uri="{FF2B5EF4-FFF2-40B4-BE49-F238E27FC236}">
-                <a16:creationId xmlns:a16="http://schemas.microsoft.com/office/drawing/2014/main" id="{CEB76F7A-F9F5-4F01-A268-37DB99BD0741}"/>
+          <p:cNvPr id="11" name="">
+            <a:extLst xmlns:a="http://schemas.openxmlformats.org/drawingml/2006/main">
+              <a:ext uri="{FF2B5EF4-FFF2-40B4-BE49-F238E27FC236}">
+                <a16:creationId xmlns:a16="http://schemas.microsoft.com/office/drawing/2014/main" id="{7160F846-A9CF-4E1F-A646-08EFACDBF433}"/>
               </a:ext>
             </a:extLst>
           </p:cNvPr>
@@ -15210,7 +15673,7 @@
           <p:cNvPr id="2" name="">
             <a:extLst xmlns:a="http://schemas.openxmlformats.org/drawingml/2006/main">
               <a:ext uri="{FF2B5EF4-FFF2-40B4-BE49-F238E27FC236}">
-                <a16:creationId xmlns:a16="http://schemas.microsoft.com/office/drawing/2014/main" id="{D94ADD39-D251-490F-813B-42D80FAA4090}"/>
+                <a16:creationId xmlns:a16="http://schemas.microsoft.com/office/drawing/2014/main" id="{35F777FC-1D87-4840-A2BC-0DE8283EE736}"/>
               </a:ext>
             </a:extLst>
           </p:cNvPr>
@@ -15271,7 +15734,7 @@
           <p:cNvPr id="3" name="">
             <a:extLst xmlns:a="http://schemas.openxmlformats.org/drawingml/2006/main">
               <a:ext uri="{FF2B5EF4-FFF2-40B4-BE49-F238E27FC236}">
-                <a16:creationId xmlns:a16="http://schemas.microsoft.com/office/drawing/2014/main" id="{45D548CC-181E-4F2D-A90D-B02A4654EA97}"/>
+                <a16:creationId xmlns:a16="http://schemas.microsoft.com/office/drawing/2014/main" id="{D6C74BE2-C38D-4A14-BB13-6B1291DFECBF}"/>
               </a:ext>
             </a:extLst>
           </p:cNvPr>
@@ -15332,19 +15795,19 @@
           <p:cNvPr id="4" name="">
             <a:extLst xmlns:a="http://schemas.openxmlformats.org/drawingml/2006/main">
               <a:ext uri="{FF2B5EF4-FFF2-40B4-BE49-F238E27FC236}">
-                <a16:creationId xmlns:a16="http://schemas.microsoft.com/office/drawing/2014/main" id="{FB70B231-94E5-4523-A81A-AE36088CFFD7}"/>
-              </a:ext>
-            </a:extLst>
-          </p:cNvPr>
-          <p:cNvSpPr>
-            <a:spLocks xmlns:a="http://schemas.openxmlformats.org/drawingml/2006/main" noGrp="1"/>
-          </p:cNvSpPr>
-          <p:nvPr/>
-        </p:nvSpPr>
-        <p:spPr>
-          <a:xfrm xmlns:a="http://schemas.openxmlformats.org/drawingml/2006/main" rot="0">
-            <a:off x="723900" y="1600200"/>
-            <a:ext cx="3848100" cy="228600"/>
+                <a16:creationId xmlns:a16="http://schemas.microsoft.com/office/drawing/2014/main" id="{3F88488B-9944-4C19-B2A7-97FAB0D8FAD6}"/>
+              </a:ext>
+            </a:extLst>
+          </p:cNvPr>
+          <p:cNvSpPr>
+            <a:spLocks xmlns:a="http://schemas.openxmlformats.org/drawingml/2006/main" noGrp="1"/>
+          </p:cNvSpPr>
+          <p:nvPr/>
+        </p:nvSpPr>
+        <p:spPr>
+          <a:xfrm xmlns:a="http://schemas.openxmlformats.org/drawingml/2006/main" rot="0">
+            <a:off x="876300" y="1428750"/>
+            <a:ext cx="10439400" cy="285750"/>
           </a:xfrm>
           <a:prstGeom xmlns:a="http://schemas.openxmlformats.org/drawingml/2006/main" prst="rect">
             <a:avLst/>
@@ -15365,1183 +15828,252 @@
                 <a:spcPct val="105000"/>
               </a:lnSpc>
               <a:buNone/>
-              <a:defRPr sz="1125" b="1" i="0">
-                <a:solidFill>
-                  <a:srgbClr val="A8710A"/>
-                </a:solidFill>
-                <a:latin typeface="Arial"/>
-                <a:ea typeface="Arial"/>
-                <a:cs typeface="Arial"/>
-              </a:defRPr>
-            </a:pPr>
-            <a:r>
-              <a:rPr sz="1125" b="1" i="0">
-                <a:solidFill>
-                  <a:srgbClr val="A8710A"/>
-                </a:solidFill>
-                <a:latin typeface="Arial"/>
-                <a:ea typeface="Arial"/>
-                <a:cs typeface="Arial"/>
-              </a:rPr>
-              <a:t>ORIGINAL MEASUREMENTS</a:t>
-            </a:r>
-          </a:p>
-        </p:txBody>
-      </p:sp>
-      <p:sp>
-        <p:nvSpPr>
-          <p:cNvPr id="5" name="">
-            <a:extLst xmlns:a="http://schemas.openxmlformats.org/drawingml/2006/main">
-              <a:ext uri="{FF2B5EF4-FFF2-40B4-BE49-F238E27FC236}">
-                <a16:creationId xmlns:a16="http://schemas.microsoft.com/office/drawing/2014/main" id="{ADB5049E-C5B7-422C-A371-B7E836B0353A}"/>
-              </a:ext>
-            </a:extLst>
-          </p:cNvPr>
-          <p:cNvSpPr>
-            <a:spLocks xmlns:a="http://schemas.openxmlformats.org/drawingml/2006/main" noGrp="1"/>
-          </p:cNvSpPr>
-          <p:nvPr/>
-        </p:nvSpPr>
-        <p:spPr>
-          <a:xfrm xmlns:a="http://schemas.openxmlformats.org/drawingml/2006/main" rot="0">
-            <a:off x="723900" y="1924050"/>
-            <a:ext cx="3848100" cy="2914650"/>
-          </a:xfrm>
-          <a:prstGeom xmlns:a="http://schemas.openxmlformats.org/drawingml/2006/main" prst="roundRect">
-            <a:avLst>
-              <a:gd name="adj" fmla="val 2614"/>
-            </a:avLst>
+              <a:defRPr sz="1575" b="0" i="0">
+                <a:solidFill>
+                  <a:srgbClr val="68717D"/>
+                </a:solidFill>
+                <a:latin typeface="Arial"/>
+                <a:ea typeface="Arial"/>
+                <a:cs typeface="Arial"/>
+              </a:defRPr>
+            </a:pPr>
+            <a:r>
+              <a:rPr sz="1575" b="0" i="0">
+                <a:solidFill>
+                  <a:srgbClr val="68717D"/>
+                </a:solidFill>
+                <a:latin typeface="Arial"/>
+                <a:ea typeface="Arial"/>
+                <a:cs typeface="Arial"/>
+              </a:rPr>
+              <a:t>One shared coordinate plane makes the translation visible.</a:t>
+            </a:r>
+          </a:p>
+        </p:txBody>
+      </p:sp>
+      <p:graphicFrame>
+        <p:nvGraphicFramePr>
+          <p:cNvPr id="15" name="Chart"/>
+          <p:cNvGraphicFramePr/>
+          <p:nvPr/>
+        </p:nvGraphicFramePr>
+        <p:xfrm>
+          <a:off xmlns:a="http://schemas.openxmlformats.org/drawingml/2006/main" x="1200150" y="1771650"/>
+          <a:ext xmlns:a="http://schemas.openxmlformats.org/drawingml/2006/main" cx="9791700" cy="3638550"/>
+        </p:xfrm>
+        <a:graphic xmlns:a="http://schemas.openxmlformats.org/drawingml/2006/main">
+          <a:graphicData uri="http://schemas.openxmlformats.org/drawingml/2006/chart">
+            <c:chart xmlns:r="http://schemas.openxmlformats.org/officeDocument/2006/relationships" xmlns:c="http://schemas.openxmlformats.org/drawingml/2006/chart" r:id="Reee8dc81549f4a80"/>
+          </a:graphicData>
+        </a:graphic>
+      </p:graphicFrame>
+      <p:sp>
+        <p:nvSpPr>
+          <p:cNvPr id="6" name="">
+            <a:extLst xmlns:a="http://schemas.openxmlformats.org/drawingml/2006/main">
+              <a:ext uri="{FF2B5EF4-FFF2-40B4-BE49-F238E27FC236}">
+                <a16:creationId xmlns:a16="http://schemas.microsoft.com/office/drawing/2014/main" id="{D46B75CB-F24D-4C48-A51B-1A34D067C72D}"/>
+              </a:ext>
+            </a:extLst>
+          </p:cNvPr>
+          <p:cNvSpPr>
+            <a:spLocks xmlns:a="http://schemas.openxmlformats.org/drawingml/2006/main" noGrp="1"/>
+          </p:cNvSpPr>
+          <p:nvPr/>
+        </p:nvSpPr>
+        <p:spPr>
+          <a:xfrm xmlns:a="http://schemas.openxmlformats.org/drawingml/2006/main" rot="0">
+            <a:off x="8343900" y="2428875"/>
+            <a:ext cx="1809750" cy="247650"/>
+          </a:xfrm>
+          <a:prstGeom xmlns:a="http://schemas.openxmlformats.org/drawingml/2006/main" prst="rect">
+            <a:avLst/>
           </a:prstGeom>
           <a:solidFill xmlns:a="http://schemas.openxmlformats.org/drawingml/2006/main">
             <a:srgbClr val="FFFDF8"/>
           </a:solidFill>
-          <a:ln xmlns:a="http://schemas.openxmlformats.org/drawingml/2006/main" w="9525">
-            <a:solidFill>
-              <a:srgbClr val="D9D9D3"/>
-            </a:solidFill>
-            <a:prstDash val="solid"/>
-          </a:ln>
-        </p:spPr>
-      </p:sp>
-      <p:sp>
-        <p:nvSpPr>
-          <p:cNvPr id="6" name="">
-            <a:extLst xmlns:a="http://schemas.openxmlformats.org/drawingml/2006/main">
-              <a:ext uri="{FF2B5EF4-FFF2-40B4-BE49-F238E27FC236}">
-                <a16:creationId xmlns:a16="http://schemas.microsoft.com/office/drawing/2014/main" id="{8A58C1FA-2D22-4A23-B117-5A2B12C45D3D}"/>
-              </a:ext>
-            </a:extLst>
-          </p:cNvPr>
-          <p:cNvSpPr>
-            <a:spLocks xmlns:a="http://schemas.openxmlformats.org/drawingml/2006/main" noGrp="1"/>
-          </p:cNvSpPr>
-          <p:nvPr/>
-        </p:nvSpPr>
-        <p:spPr>
-          <a:xfrm xmlns:a="http://schemas.openxmlformats.org/drawingml/2006/main" rot="0">
-            <a:off x="1123950" y="4362450"/>
-            <a:ext cx="3200400" cy="19050"/>
-          </a:xfrm>
-          <a:prstGeom xmlns:a="http://schemas.openxmlformats.org/drawingml/2006/main" prst="rect">
-            <a:avLst/>
-          </a:prstGeom>
-          <a:solidFill xmlns:a="http://schemas.openxmlformats.org/drawingml/2006/main">
-            <a:srgbClr val="68717D"/>
-          </a:solidFill>
-          <a:ln xmlns:a="http://schemas.openxmlformats.org/drawingml/2006/main" w="0">
-            <a:noFill/>
-          </a:ln>
-        </p:spPr>
+          <a:ln xmlns:a="http://schemas.openxmlformats.org/drawingml/2006/main" w="0">
+            <a:noFill/>
+          </a:ln>
+        </p:spPr>
+        <p:txBody>
+          <a:bodyPr xmlns:a="http://schemas.openxmlformats.org/drawingml/2006/main" wrap="square" lIns="0" tIns="0" rIns="0" bIns="0" anchor="t">
+            <a:noAutofit/>
+          </a:bodyPr>
+          <a:lstStyle xmlns:a="http://schemas.openxmlformats.org/drawingml/2006/main"/>
+          <a:p xmlns:a="http://schemas.openxmlformats.org/drawingml/2006/main">
+            <a:pPr algn="ctr">
+              <a:lnSpc>
+                <a:spcPct val="105000"/>
+              </a:lnSpc>
+              <a:buNone/>
+              <a:defRPr sz="1200" b="1" i="0">
+                <a:solidFill>
+                  <a:srgbClr val="A64B3C"/>
+                </a:solidFill>
+                <a:latin typeface="Arial"/>
+                <a:ea typeface="Arial"/>
+                <a:cs typeface="Arial"/>
+              </a:defRPr>
+            </a:pPr>
+            <a:r>
+              <a:rPr sz="1200" b="1" i="0">
+                <a:solidFill>
+                  <a:srgbClr val="A64B3C"/>
+                </a:solidFill>
+                <a:latin typeface="Arial"/>
+                <a:ea typeface="Arial"/>
+                <a:cs typeface="Arial"/>
+              </a:rPr>
+              <a:t>mean (6, 4.5)</a:t>
+            </a:r>
+          </a:p>
+        </p:txBody>
       </p:sp>
       <p:sp>
         <p:nvSpPr>
           <p:cNvPr id="7" name="">
             <a:extLst xmlns:a="http://schemas.openxmlformats.org/drawingml/2006/main">
               <a:ext uri="{FF2B5EF4-FFF2-40B4-BE49-F238E27FC236}">
-                <a16:creationId xmlns:a16="http://schemas.microsoft.com/office/drawing/2014/main" id="{1CF3CAC5-837D-4428-B6A0-27D28DEB3F5B}"/>
-              </a:ext>
-            </a:extLst>
-          </p:cNvPr>
-          <p:cNvSpPr>
-            <a:spLocks xmlns:a="http://schemas.openxmlformats.org/drawingml/2006/main" noGrp="1"/>
-          </p:cNvSpPr>
-          <p:nvPr/>
-        </p:nvSpPr>
-        <p:spPr>
-          <a:xfrm xmlns:a="http://schemas.openxmlformats.org/drawingml/2006/main" rot="0">
-            <a:off x="1123950" y="2286000"/>
-            <a:ext cx="19050" cy="2076450"/>
-          </a:xfrm>
-          <a:prstGeom xmlns:a="http://schemas.openxmlformats.org/drawingml/2006/main" prst="rect">
-            <a:avLst/>
-          </a:prstGeom>
-          <a:solidFill xmlns:a="http://schemas.openxmlformats.org/drawingml/2006/main">
-            <a:srgbClr val="68717D"/>
-          </a:solidFill>
-          <a:ln xmlns:a="http://schemas.openxmlformats.org/drawingml/2006/main" w="0">
-            <a:noFill/>
-          </a:ln>
-        </p:spPr>
-      </p:sp>
-      <p:sp>
-        <p:nvSpPr>
-          <p:cNvPr id="8" name="">
-            <a:extLst xmlns:a="http://schemas.openxmlformats.org/drawingml/2006/main">
-              <a:ext uri="{FF2B5EF4-FFF2-40B4-BE49-F238E27FC236}">
-                <a16:creationId xmlns:a16="http://schemas.microsoft.com/office/drawing/2014/main" id="{83A0406B-6302-4042-A9F2-1D2162F6E42A}"/>
-              </a:ext>
-            </a:extLst>
-          </p:cNvPr>
-          <p:cNvSpPr>
-            <a:spLocks xmlns:a="http://schemas.openxmlformats.org/drawingml/2006/main" noGrp="1"/>
-          </p:cNvSpPr>
-          <p:nvPr/>
-        </p:nvSpPr>
-        <p:spPr>
-          <a:xfrm xmlns:a="http://schemas.openxmlformats.org/drawingml/2006/main" flipV="1">
-            <a:off x="1123950" y="2348294"/>
-            <a:ext cx="3200400" cy="1951863"/>
-          </a:xfrm>
-          <a:prstGeom xmlns:a="http://schemas.openxmlformats.org/drawingml/2006/main" prst="line">
-            <a:avLst/>
-          </a:prstGeom>
-          <a:noFill xmlns:a="http://schemas.openxmlformats.org/drawingml/2006/main"/>
-          <a:ln xmlns:a="http://schemas.openxmlformats.org/drawingml/2006/main" w="28575">
-            <a:solidFill>
-              <a:srgbClr val="A8710A"/>
-            </a:solidFill>
-            <a:prstDash val="solid"/>
-          </a:ln>
-        </p:spPr>
-      </p:sp>
-      <p:sp>
-        <p:nvSpPr>
-          <p:cNvPr id="9" name="">
-            <a:extLst xmlns:a="http://schemas.openxmlformats.org/drawingml/2006/main">
-              <a:ext uri="{FF2B5EF4-FFF2-40B4-BE49-F238E27FC236}">
-                <a16:creationId xmlns:a16="http://schemas.microsoft.com/office/drawing/2014/main" id="{23E847AC-DF83-4813-833C-637AB5171944}"/>
-              </a:ext>
-            </a:extLst>
-          </p:cNvPr>
-          <p:cNvSpPr>
-            <a:spLocks xmlns:a="http://schemas.openxmlformats.org/drawingml/2006/main" noGrp="1"/>
-          </p:cNvSpPr>
-          <p:nvPr/>
-        </p:nvSpPr>
-        <p:spPr>
-          <a:xfrm xmlns:a="http://schemas.openxmlformats.org/drawingml/2006/main" rot="0">
-            <a:off x="2124075" y="3610547"/>
-            <a:ext cx="133350" cy="133350"/>
-          </a:xfrm>
-          <a:prstGeom xmlns:a="http://schemas.openxmlformats.org/drawingml/2006/main" prst="ellipse">
-            <a:avLst/>
-          </a:prstGeom>
-          <a:solidFill xmlns:a="http://schemas.openxmlformats.org/drawingml/2006/main">
-            <a:srgbClr val="2C6A6C"/>
-          </a:solidFill>
-          <a:ln xmlns:a="http://schemas.openxmlformats.org/drawingml/2006/main" w="19050">
-            <a:solidFill>
-              <a:srgbClr val="FFFFFF"/>
-            </a:solidFill>
-            <a:prstDash val="solid"/>
-          </a:ln>
-        </p:spPr>
-      </p:sp>
-      <p:sp>
-        <p:nvSpPr>
-          <p:cNvPr id="10" name="">
-            <a:extLst xmlns:a="http://schemas.openxmlformats.org/drawingml/2006/main">
-              <a:ext uri="{FF2B5EF4-FFF2-40B4-BE49-F238E27FC236}">
-                <a16:creationId xmlns:a16="http://schemas.microsoft.com/office/drawing/2014/main" id="{12050B4C-1ACA-4EBD-9311-88CC4C158D0C}"/>
-              </a:ext>
-            </a:extLst>
-          </p:cNvPr>
-          <p:cNvSpPr>
-            <a:spLocks xmlns:a="http://schemas.openxmlformats.org/drawingml/2006/main" noGrp="1"/>
-          </p:cNvSpPr>
-          <p:nvPr/>
-        </p:nvSpPr>
-        <p:spPr>
-          <a:xfrm xmlns:a="http://schemas.openxmlformats.org/drawingml/2006/main" rot="0">
-            <a:off x="2657475" y="3368294"/>
-            <a:ext cx="133350" cy="133350"/>
-          </a:xfrm>
-          <a:prstGeom xmlns:a="http://schemas.openxmlformats.org/drawingml/2006/main" prst="ellipse">
-            <a:avLst/>
-          </a:prstGeom>
-          <a:solidFill xmlns:a="http://schemas.openxmlformats.org/drawingml/2006/main">
-            <a:srgbClr val="2C6A6C"/>
-          </a:solidFill>
-          <a:ln xmlns:a="http://schemas.openxmlformats.org/drawingml/2006/main" w="19050">
-            <a:solidFill>
-              <a:srgbClr val="FFFFFF"/>
-            </a:solidFill>
-            <a:prstDash val="solid"/>
-          </a:ln>
-        </p:spPr>
-      </p:sp>
-      <p:sp>
-        <p:nvSpPr>
-          <p:cNvPr id="11" name="">
-            <a:extLst xmlns:a="http://schemas.openxmlformats.org/drawingml/2006/main">
-              <a:ext uri="{FF2B5EF4-FFF2-40B4-BE49-F238E27FC236}">
-                <a16:creationId xmlns:a16="http://schemas.microsoft.com/office/drawing/2014/main" id="{E21AFE97-CD1A-4538-A40F-CE7A10FB4794}"/>
-              </a:ext>
-            </a:extLst>
-          </p:cNvPr>
-          <p:cNvSpPr>
-            <a:spLocks xmlns:a="http://schemas.openxmlformats.org/drawingml/2006/main" noGrp="1"/>
-          </p:cNvSpPr>
-          <p:nvPr/>
-        </p:nvSpPr>
-        <p:spPr>
-          <a:xfrm xmlns:a="http://schemas.openxmlformats.org/drawingml/2006/main" rot="0">
-            <a:off x="1590675" y="3818192"/>
-            <a:ext cx="133350" cy="133350"/>
-          </a:xfrm>
-          <a:prstGeom xmlns:a="http://schemas.openxmlformats.org/drawingml/2006/main" prst="ellipse">
-            <a:avLst/>
-          </a:prstGeom>
-          <a:solidFill xmlns:a="http://schemas.openxmlformats.org/drawingml/2006/main">
-            <a:srgbClr val="2C6A6C"/>
-          </a:solidFill>
-          <a:ln xmlns:a="http://schemas.openxmlformats.org/drawingml/2006/main" w="19050">
-            <a:solidFill>
-              <a:srgbClr val="FFFFFF"/>
-            </a:solidFill>
-            <a:prstDash val="solid"/>
-          </a:ln>
-        </p:spPr>
-      </p:sp>
-      <p:sp>
-        <p:nvSpPr>
-          <p:cNvPr id="12" name="">
-            <a:extLst xmlns:a="http://schemas.openxmlformats.org/drawingml/2006/main">
-              <a:ext uri="{FF2B5EF4-FFF2-40B4-BE49-F238E27FC236}">
-                <a16:creationId xmlns:a16="http://schemas.microsoft.com/office/drawing/2014/main" id="{6DC42E48-822F-44E3-BAA3-BFB92CFD4F04}"/>
-              </a:ext>
-            </a:extLst>
-          </p:cNvPr>
-          <p:cNvSpPr>
-            <a:spLocks xmlns:a="http://schemas.openxmlformats.org/drawingml/2006/main" noGrp="1"/>
-          </p:cNvSpPr>
-          <p:nvPr/>
-        </p:nvSpPr>
-        <p:spPr>
-          <a:xfrm xmlns:a="http://schemas.openxmlformats.org/drawingml/2006/main" rot="0">
-            <a:off x="3724275" y="2503107"/>
-            <a:ext cx="133350" cy="133350"/>
-          </a:xfrm>
-          <a:prstGeom xmlns:a="http://schemas.openxmlformats.org/drawingml/2006/main" prst="ellipse">
-            <a:avLst/>
-          </a:prstGeom>
-          <a:solidFill xmlns:a="http://schemas.openxmlformats.org/drawingml/2006/main">
-            <a:srgbClr val="2C6A6C"/>
-          </a:solidFill>
-          <a:ln xmlns:a="http://schemas.openxmlformats.org/drawingml/2006/main" w="19050">
-            <a:solidFill>
-              <a:srgbClr val="FFFFFF"/>
-            </a:solidFill>
-            <a:prstDash val="solid"/>
-          </a:ln>
-        </p:spPr>
-      </p:sp>
-      <p:sp>
-        <p:nvSpPr>
-          <p:cNvPr id="13" name="">
-            <a:extLst xmlns:a="http://schemas.openxmlformats.org/drawingml/2006/main">
-              <a:ext uri="{FF2B5EF4-FFF2-40B4-BE49-F238E27FC236}">
-                <a16:creationId xmlns:a16="http://schemas.microsoft.com/office/drawing/2014/main" id="{D4B99AE2-806B-4777-9728-C4835D085AB4}"/>
-              </a:ext>
-            </a:extLst>
-          </p:cNvPr>
-          <p:cNvSpPr>
-            <a:spLocks xmlns:a="http://schemas.openxmlformats.org/drawingml/2006/main" noGrp="1"/>
-          </p:cNvSpPr>
-          <p:nvPr/>
-        </p:nvSpPr>
-        <p:spPr>
-          <a:xfrm xmlns:a="http://schemas.openxmlformats.org/drawingml/2006/main" rot="0">
-            <a:off x="3190875" y="2987612"/>
-            <a:ext cx="133350" cy="133350"/>
-          </a:xfrm>
-          <a:prstGeom xmlns:a="http://schemas.openxmlformats.org/drawingml/2006/main" prst="ellipse">
-            <a:avLst/>
-          </a:prstGeom>
-          <a:solidFill xmlns:a="http://schemas.openxmlformats.org/drawingml/2006/main">
-            <a:srgbClr val="2C6A6C"/>
-          </a:solidFill>
-          <a:ln xmlns:a="http://schemas.openxmlformats.org/drawingml/2006/main" w="19050">
-            <a:solidFill>
-              <a:srgbClr val="FFFFFF"/>
-            </a:solidFill>
-            <a:prstDash val="solid"/>
-          </a:ln>
-        </p:spPr>
-      </p:sp>
-      <p:sp>
-        <p:nvSpPr>
-          <p:cNvPr id="14" name="">
-            <a:extLst xmlns:a="http://schemas.openxmlformats.org/drawingml/2006/main">
-              <a:ext uri="{FF2B5EF4-FFF2-40B4-BE49-F238E27FC236}">
-                <a16:creationId xmlns:a16="http://schemas.microsoft.com/office/drawing/2014/main" id="{3F720E68-E195-4B6D-8CE3-03ABBA8D9D8A}"/>
-              </a:ext>
-            </a:extLst>
-          </p:cNvPr>
-          <p:cNvSpPr>
-            <a:spLocks xmlns:a="http://schemas.openxmlformats.org/drawingml/2006/main" noGrp="1"/>
-          </p:cNvSpPr>
-          <p:nvPr/>
-        </p:nvSpPr>
-        <p:spPr>
-          <a:xfrm xmlns:a="http://schemas.openxmlformats.org/drawingml/2006/main" rot="0">
-            <a:off x="2638425" y="3238500"/>
-            <a:ext cx="171450" cy="171450"/>
-          </a:xfrm>
-          <a:prstGeom xmlns:a="http://schemas.openxmlformats.org/drawingml/2006/main" prst="ellipse">
-            <a:avLst/>
-          </a:prstGeom>
-          <a:solidFill xmlns:a="http://schemas.openxmlformats.org/drawingml/2006/main">
-            <a:srgbClr val="A8710A"/>
-          </a:solidFill>
-          <a:ln xmlns:a="http://schemas.openxmlformats.org/drawingml/2006/main" w="19050">
-            <a:solidFill>
-              <a:srgbClr val="FFFFFF"/>
-            </a:solidFill>
-            <a:prstDash val="solid"/>
-          </a:ln>
-        </p:spPr>
-      </p:sp>
-      <p:sp>
-        <p:nvSpPr>
-          <p:cNvPr id="15" name="">
-            <a:extLst xmlns:a="http://schemas.openxmlformats.org/drawingml/2006/main">
-              <a:ext uri="{FF2B5EF4-FFF2-40B4-BE49-F238E27FC236}">
-                <a16:creationId xmlns:a16="http://schemas.microsoft.com/office/drawing/2014/main" id="{D1554D5C-46B4-48B0-8949-8ED75330D7C5}"/>
-              </a:ext>
-            </a:extLst>
-          </p:cNvPr>
-          <p:cNvSpPr>
-            <a:spLocks xmlns:a="http://schemas.openxmlformats.org/drawingml/2006/main" noGrp="1"/>
-          </p:cNvSpPr>
-          <p:nvPr/>
-        </p:nvSpPr>
-        <p:spPr>
-          <a:xfrm xmlns:a="http://schemas.openxmlformats.org/drawingml/2006/main" rot="0">
-            <a:off x="1200150" y="2343150"/>
-            <a:ext cx="1066800" cy="228600"/>
-          </a:xfrm>
-          <a:prstGeom xmlns:a="http://schemas.openxmlformats.org/drawingml/2006/main" prst="rect">
-            <a:avLst/>
-          </a:prstGeom>
-          <a:noFill xmlns:a="http://schemas.openxmlformats.org/drawingml/2006/main"/>
-          <a:ln xmlns:a="http://schemas.openxmlformats.org/drawingml/2006/main" w="0">
-            <a:noFill/>
-          </a:ln>
-        </p:spPr>
-        <p:txBody>
-          <a:bodyPr xmlns:a="http://schemas.openxmlformats.org/drawingml/2006/main" wrap="square" lIns="0" tIns="0" rIns="0" bIns="0" anchor="t">
-            <a:noAutofit/>
-          </a:bodyPr>
-          <a:lstStyle xmlns:a="http://schemas.openxmlformats.org/drawingml/2006/main"/>
-          <a:p xmlns:a="http://schemas.openxmlformats.org/drawingml/2006/main">
-            <a:pPr algn="l">
-              <a:lnSpc>
-                <a:spcPct val="105000"/>
-              </a:lnSpc>
-              <a:buNone/>
-              <a:defRPr sz="1200" b="1" i="0">
-                <a:solidFill>
-                  <a:srgbClr val="68717D"/>
-                </a:solidFill>
-                <a:latin typeface="Arial"/>
-                <a:ea typeface="Arial"/>
-                <a:cs typeface="Arial"/>
-              </a:defRPr>
-            </a:pPr>
-            <a:r>
-              <a:rPr sz="1200" b="1" i="0">
-                <a:solidFill>
-                  <a:srgbClr val="68717D"/>
-                </a:solidFill>
-                <a:latin typeface="Arial"/>
-                <a:ea typeface="Arial"/>
-                <a:cs typeface="Arial"/>
-              </a:rPr>
-              <a:t>fuel</a:t>
-            </a:r>
-          </a:p>
-        </p:txBody>
-      </p:sp>
-      <p:sp>
-        <p:nvSpPr>
-          <p:cNvPr id="16" name="">
-            <a:extLst xmlns:a="http://schemas.openxmlformats.org/drawingml/2006/main">
-              <a:ext uri="{FF2B5EF4-FFF2-40B4-BE49-F238E27FC236}">
-                <a16:creationId xmlns:a16="http://schemas.microsoft.com/office/drawing/2014/main" id="{11409EE2-3D27-46DE-8D7E-71BBC381E8BD}"/>
-              </a:ext>
-            </a:extLst>
-          </p:cNvPr>
-          <p:cNvSpPr>
-            <a:spLocks xmlns:a="http://schemas.openxmlformats.org/drawingml/2006/main" noGrp="1"/>
-          </p:cNvSpPr>
-          <p:nvPr/>
-        </p:nvSpPr>
-        <p:spPr>
-          <a:xfrm xmlns:a="http://schemas.openxmlformats.org/drawingml/2006/main" rot="0">
-            <a:off x="3200400" y="4476750"/>
-            <a:ext cx="1123950" cy="228600"/>
-          </a:xfrm>
-          <a:prstGeom xmlns:a="http://schemas.openxmlformats.org/drawingml/2006/main" prst="rect">
-            <a:avLst/>
-          </a:prstGeom>
-          <a:noFill xmlns:a="http://schemas.openxmlformats.org/drawingml/2006/main"/>
-          <a:ln xmlns:a="http://schemas.openxmlformats.org/drawingml/2006/main" w="0">
-            <a:noFill/>
-          </a:ln>
-        </p:spPr>
-        <p:txBody>
-          <a:bodyPr xmlns:a="http://schemas.openxmlformats.org/drawingml/2006/main" wrap="square" lIns="0" tIns="0" rIns="0" bIns="0" anchor="t">
-            <a:noAutofit/>
-          </a:bodyPr>
-          <a:lstStyle xmlns:a="http://schemas.openxmlformats.org/drawingml/2006/main"/>
-          <a:p xmlns:a="http://schemas.openxmlformats.org/drawingml/2006/main">
-            <a:pPr algn="r">
-              <a:lnSpc>
-                <a:spcPct val="105000"/>
-              </a:lnSpc>
-              <a:buNone/>
-              <a:defRPr sz="1200" b="1" i="0">
-                <a:solidFill>
-                  <a:srgbClr val="68717D"/>
-                </a:solidFill>
-                <a:latin typeface="Arial"/>
-                <a:ea typeface="Arial"/>
-                <a:cs typeface="Arial"/>
-              </a:defRPr>
-            </a:pPr>
-            <a:r>
-              <a:rPr sz="1200" b="1" i="0">
-                <a:solidFill>
-                  <a:srgbClr val="68717D"/>
-                </a:solidFill>
-                <a:latin typeface="Arial"/>
-                <a:ea typeface="Arial"/>
-                <a:cs typeface="Arial"/>
-              </a:rPr>
-              <a:t>weight</a:t>
-            </a:r>
-          </a:p>
-        </p:txBody>
-      </p:sp>
-      <p:sp>
-        <p:nvSpPr>
-          <p:cNvPr id="17" name="">
-            <a:extLst xmlns:a="http://schemas.openxmlformats.org/drawingml/2006/main">
-              <a:ext uri="{FF2B5EF4-FFF2-40B4-BE49-F238E27FC236}">
-                <a16:creationId xmlns:a16="http://schemas.microsoft.com/office/drawing/2014/main" id="{402CE50A-C176-4883-BB1E-EDF5AA4B9E90}"/>
-              </a:ext>
-            </a:extLst>
-          </p:cNvPr>
-          <p:cNvSpPr>
-            <a:spLocks xmlns:a="http://schemas.openxmlformats.org/drawingml/2006/main" noGrp="1"/>
-          </p:cNvSpPr>
-          <p:nvPr/>
-        </p:nvSpPr>
-        <p:spPr>
-          <a:xfrm xmlns:a="http://schemas.openxmlformats.org/drawingml/2006/main" rot="0">
-            <a:off x="2838450" y="3057525"/>
-            <a:ext cx="1466850" cy="228600"/>
-          </a:xfrm>
-          <a:prstGeom xmlns:a="http://schemas.openxmlformats.org/drawingml/2006/main" prst="rect">
-            <a:avLst/>
-          </a:prstGeom>
-          <a:noFill xmlns:a="http://schemas.openxmlformats.org/drawingml/2006/main"/>
-          <a:ln xmlns:a="http://schemas.openxmlformats.org/drawingml/2006/main" w="0">
-            <a:noFill/>
-          </a:ln>
-        </p:spPr>
-        <p:txBody>
-          <a:bodyPr xmlns:a="http://schemas.openxmlformats.org/drawingml/2006/main" wrap="square" lIns="0" tIns="0" rIns="0" bIns="0" anchor="t">
-            <a:noAutofit/>
-          </a:bodyPr>
-          <a:lstStyle xmlns:a="http://schemas.openxmlformats.org/drawingml/2006/main"/>
-          <a:p xmlns:a="http://schemas.openxmlformats.org/drawingml/2006/main">
-            <a:pPr algn="l">
-              <a:lnSpc>
-                <a:spcPct val="105000"/>
-              </a:lnSpc>
-              <a:buNone/>
-              <a:defRPr sz="1200" b="1" i="0">
-                <a:solidFill>
-                  <a:srgbClr val="A8710A"/>
-                </a:solidFill>
-                <a:latin typeface="Arial"/>
-                <a:ea typeface="Arial"/>
-                <a:cs typeface="Arial"/>
-              </a:defRPr>
-            </a:pPr>
-            <a:r>
-              <a:rPr sz="1200" b="1" i="0">
-                <a:solidFill>
-                  <a:srgbClr val="A8710A"/>
-                </a:solidFill>
-                <a:latin typeface="Arial"/>
-                <a:ea typeface="Arial"/>
-                <a:cs typeface="Arial"/>
-              </a:rPr>
-              <a:t>mean (1.4, 7.42)</a:t>
-            </a:r>
-          </a:p>
-        </p:txBody>
-      </p:sp>
-      <p:sp>
-        <p:nvSpPr>
-          <p:cNvPr id="18" name="">
-            <a:extLst xmlns:a="http://schemas.openxmlformats.org/drawingml/2006/main">
-              <a:ext uri="{FF2B5EF4-FFF2-40B4-BE49-F238E27FC236}">
-                <a16:creationId xmlns:a16="http://schemas.microsoft.com/office/drawing/2014/main" id="{CA392856-3E24-47AC-A27C-7D78139B9187}"/>
-              </a:ext>
-            </a:extLst>
-          </p:cNvPr>
-          <p:cNvSpPr>
-            <a:spLocks xmlns:a="http://schemas.openxmlformats.org/drawingml/2006/main" noGrp="1"/>
-          </p:cNvSpPr>
-          <p:nvPr/>
-        </p:nvSpPr>
-        <p:spPr>
-          <a:xfrm xmlns:a="http://schemas.openxmlformats.org/drawingml/2006/main" rot="0">
-            <a:off x="7620000" y="1600200"/>
-            <a:ext cx="3848100" cy="228600"/>
-          </a:xfrm>
-          <a:prstGeom xmlns:a="http://schemas.openxmlformats.org/drawingml/2006/main" prst="rect">
-            <a:avLst/>
-          </a:prstGeom>
-          <a:noFill xmlns:a="http://schemas.openxmlformats.org/drawingml/2006/main"/>
-          <a:ln xmlns:a="http://schemas.openxmlformats.org/drawingml/2006/main" w="0">
-            <a:noFill/>
-          </a:ln>
-        </p:spPr>
-        <p:txBody>
-          <a:bodyPr xmlns:a="http://schemas.openxmlformats.org/drawingml/2006/main" wrap="square" lIns="0" tIns="0" rIns="0" bIns="0" anchor="t">
-            <a:noAutofit/>
-          </a:bodyPr>
-          <a:lstStyle xmlns:a="http://schemas.openxmlformats.org/drawingml/2006/main"/>
-          <a:p xmlns:a="http://schemas.openxmlformats.org/drawingml/2006/main">
-            <a:pPr algn="ctr">
-              <a:lnSpc>
-                <a:spcPct val="105000"/>
-              </a:lnSpc>
-              <a:buNone/>
-              <a:defRPr sz="1125" b="1" i="0">
-                <a:solidFill>
-                  <a:srgbClr val="2C6A6C"/>
-                </a:solidFill>
-                <a:latin typeface="Arial"/>
-                <a:ea typeface="Arial"/>
-                <a:cs typeface="Arial"/>
-              </a:defRPr>
-            </a:pPr>
-            <a:r>
-              <a:rPr sz="1125" b="1" i="0">
-                <a:solidFill>
-                  <a:srgbClr val="2C6A6C"/>
-                </a:solidFill>
-                <a:latin typeface="Arial"/>
-                <a:ea typeface="Arial"/>
-                <a:cs typeface="Arial"/>
-              </a:rPr>
-              <a:t>CENTERED COORDINATES</a:t>
-            </a:r>
-          </a:p>
-        </p:txBody>
-      </p:sp>
-      <p:sp>
-        <p:nvSpPr>
-          <p:cNvPr id="19" name="">
-            <a:extLst xmlns:a="http://schemas.openxmlformats.org/drawingml/2006/main">
-              <a:ext uri="{FF2B5EF4-FFF2-40B4-BE49-F238E27FC236}">
-                <a16:creationId xmlns:a16="http://schemas.microsoft.com/office/drawing/2014/main" id="{2E8A0B1D-51F6-4FF1-899F-42D94B3714ED}"/>
-              </a:ext>
-            </a:extLst>
-          </p:cNvPr>
-          <p:cNvSpPr>
-            <a:spLocks xmlns:a="http://schemas.openxmlformats.org/drawingml/2006/main" noGrp="1"/>
-          </p:cNvSpPr>
-          <p:nvPr/>
-        </p:nvSpPr>
-        <p:spPr>
-          <a:xfrm xmlns:a="http://schemas.openxmlformats.org/drawingml/2006/main" rot="0">
-            <a:off x="7620000" y="1924050"/>
-            <a:ext cx="3848100" cy="2914650"/>
-          </a:xfrm>
-          <a:prstGeom xmlns:a="http://schemas.openxmlformats.org/drawingml/2006/main" prst="roundRect">
-            <a:avLst>
-              <a:gd name="adj" fmla="val 2614"/>
-            </a:avLst>
+                <a16:creationId xmlns:a16="http://schemas.microsoft.com/office/drawing/2014/main" id="{57AE9606-A185-48AF-921E-306086831FD6}"/>
+              </a:ext>
+            </a:extLst>
+          </p:cNvPr>
+          <p:cNvSpPr>
+            <a:spLocks xmlns:a="http://schemas.openxmlformats.org/drawingml/2006/main" noGrp="1"/>
+          </p:cNvSpPr>
+          <p:nvPr/>
+        </p:nvSpPr>
+        <p:spPr>
+          <a:xfrm xmlns:a="http://schemas.openxmlformats.org/drawingml/2006/main" rot="0">
+            <a:off x="2800350" y="4495800"/>
+            <a:ext cx="1905000" cy="247650"/>
+          </a:xfrm>
+          <a:prstGeom xmlns:a="http://schemas.openxmlformats.org/drawingml/2006/main" prst="rect">
+            <a:avLst/>
           </a:prstGeom>
           <a:solidFill xmlns:a="http://schemas.openxmlformats.org/drawingml/2006/main">
             <a:srgbClr val="FFFDF8"/>
           </a:solidFill>
-          <a:ln xmlns:a="http://schemas.openxmlformats.org/drawingml/2006/main" w="9525">
-            <a:solidFill>
-              <a:srgbClr val="D9D9D3"/>
-            </a:solidFill>
-            <a:prstDash val="solid"/>
-          </a:ln>
-        </p:spPr>
-      </p:sp>
-      <p:sp>
-        <p:nvSpPr>
-          <p:cNvPr id="20" name="">
-            <a:extLst xmlns:a="http://schemas.openxmlformats.org/drawingml/2006/main">
-              <a:ext uri="{FF2B5EF4-FFF2-40B4-BE49-F238E27FC236}">
-                <a16:creationId xmlns:a16="http://schemas.microsoft.com/office/drawing/2014/main" id="{90904555-44EF-4721-88D9-83B8AA948BAB}"/>
-              </a:ext>
-            </a:extLst>
-          </p:cNvPr>
-          <p:cNvSpPr>
-            <a:spLocks xmlns:a="http://schemas.openxmlformats.org/drawingml/2006/main" noGrp="1"/>
-          </p:cNvSpPr>
-          <p:nvPr/>
-        </p:nvSpPr>
-        <p:spPr>
-          <a:xfrm xmlns:a="http://schemas.openxmlformats.org/drawingml/2006/main" rot="0">
-            <a:off x="8020050" y="3324225"/>
-            <a:ext cx="3200400" cy="19050"/>
+          <a:ln xmlns:a="http://schemas.openxmlformats.org/drawingml/2006/main" w="0">
+            <a:noFill/>
+          </a:ln>
+        </p:spPr>
+        <p:txBody>
+          <a:bodyPr xmlns:a="http://schemas.openxmlformats.org/drawingml/2006/main" wrap="square" lIns="0" tIns="0" rIns="0" bIns="0" anchor="t">
+            <a:noAutofit/>
+          </a:bodyPr>
+          <a:lstStyle xmlns:a="http://schemas.openxmlformats.org/drawingml/2006/main"/>
+          <a:p xmlns:a="http://schemas.openxmlformats.org/drawingml/2006/main">
+            <a:pPr algn="ctr">
+              <a:lnSpc>
+                <a:spcPct val="105000"/>
+              </a:lnSpc>
+              <a:buNone/>
+              <a:defRPr sz="1200" b="1" i="0">
+                <a:solidFill>
+                  <a:srgbClr val="A64B3C"/>
+                </a:solidFill>
+                <a:latin typeface="Arial"/>
+                <a:ea typeface="Arial"/>
+                <a:cs typeface="Arial"/>
+              </a:defRPr>
+            </a:pPr>
+            <a:r>
+              <a:rPr sz="1200" b="1" i="0">
+                <a:solidFill>
+                  <a:srgbClr val="A64B3C"/>
+                </a:solidFill>
+                <a:latin typeface="Arial"/>
+                <a:ea typeface="Arial"/>
+                <a:cs typeface="Arial"/>
+              </a:rPr>
+              <a:t>new mean (0, 0)</a:t>
+            </a:r>
+          </a:p>
+        </p:txBody>
+      </p:sp>
+      <p:sp>
+        <p:nvSpPr>
+          <p:cNvPr id="8" name="">
+            <a:extLst xmlns:a="http://schemas.openxmlformats.org/drawingml/2006/main">
+              <a:ext uri="{FF2B5EF4-FFF2-40B4-BE49-F238E27FC236}">
+                <a16:creationId xmlns:a16="http://schemas.microsoft.com/office/drawing/2014/main" id="{1EB16123-CEEB-424A-AE84-F126F211F80F}"/>
+              </a:ext>
+            </a:extLst>
+          </p:cNvPr>
+          <p:cNvSpPr>
+            <a:spLocks xmlns:a="http://schemas.openxmlformats.org/drawingml/2006/main" noGrp="1"/>
+          </p:cNvSpPr>
+          <p:nvPr/>
+        </p:nvSpPr>
+        <p:spPr>
+          <a:xfrm xmlns:a="http://schemas.openxmlformats.org/drawingml/2006/main" rot="0">
+            <a:off x="5143500" y="3333750"/>
+            <a:ext cx="2095500" cy="266700"/>
           </a:xfrm>
           <a:prstGeom xmlns:a="http://schemas.openxmlformats.org/drawingml/2006/main" prst="rect">
             <a:avLst/>
           </a:prstGeom>
           <a:solidFill xmlns:a="http://schemas.openxmlformats.org/drawingml/2006/main">
-            <a:srgbClr val="68717D"/>
+            <a:srgbClr val="FFFDF8"/>
           </a:solidFill>
           <a:ln xmlns:a="http://schemas.openxmlformats.org/drawingml/2006/main" w="0">
             <a:noFill/>
           </a:ln>
         </p:spPr>
-      </p:sp>
-      <p:sp>
-        <p:nvSpPr>
-          <p:cNvPr id="21" name="">
-            <a:extLst xmlns:a="http://schemas.openxmlformats.org/drawingml/2006/main">
-              <a:ext uri="{FF2B5EF4-FFF2-40B4-BE49-F238E27FC236}">
-                <a16:creationId xmlns:a16="http://schemas.microsoft.com/office/drawing/2014/main" id="{503B33E3-53E9-42F3-8E32-10A3E9E44EEE}"/>
-              </a:ext>
-            </a:extLst>
-          </p:cNvPr>
-          <p:cNvSpPr>
-            <a:spLocks xmlns:a="http://schemas.openxmlformats.org/drawingml/2006/main" noGrp="1"/>
-          </p:cNvSpPr>
-          <p:nvPr/>
-        </p:nvSpPr>
-        <p:spPr>
-          <a:xfrm xmlns:a="http://schemas.openxmlformats.org/drawingml/2006/main" rot="0">
-            <a:off x="9620250" y="2286000"/>
-            <a:ext cx="19050" cy="2076450"/>
-          </a:xfrm>
-          <a:prstGeom xmlns:a="http://schemas.openxmlformats.org/drawingml/2006/main" prst="rect">
-            <a:avLst/>
-          </a:prstGeom>
-          <a:solidFill xmlns:a="http://schemas.openxmlformats.org/drawingml/2006/main">
-            <a:srgbClr val="68717D"/>
-          </a:solidFill>
-          <a:ln xmlns:a="http://schemas.openxmlformats.org/drawingml/2006/main" w="0">
-            <a:noFill/>
-          </a:ln>
-        </p:spPr>
-      </p:sp>
-      <p:sp>
-        <p:nvSpPr>
-          <p:cNvPr id="22" name="">
-            <a:extLst xmlns:a="http://schemas.openxmlformats.org/drawingml/2006/main">
-              <a:ext uri="{FF2B5EF4-FFF2-40B4-BE49-F238E27FC236}">
-                <a16:creationId xmlns:a16="http://schemas.microsoft.com/office/drawing/2014/main" id="{0A1B54F3-2019-4871-BD71-8A00F6DDAF18}"/>
-              </a:ext>
-            </a:extLst>
-          </p:cNvPr>
-          <p:cNvSpPr>
-            <a:spLocks xmlns:a="http://schemas.openxmlformats.org/drawingml/2006/main" noGrp="1"/>
-          </p:cNvSpPr>
-          <p:nvPr/>
-        </p:nvSpPr>
-        <p:spPr>
-          <a:xfrm xmlns:a="http://schemas.openxmlformats.org/drawingml/2006/main" flipV="1">
-            <a:off x="8020050" y="2348294"/>
-            <a:ext cx="3200400" cy="1951863"/>
-          </a:xfrm>
-          <a:prstGeom xmlns:a="http://schemas.openxmlformats.org/drawingml/2006/main" prst="line">
-            <a:avLst/>
-          </a:prstGeom>
-          <a:noFill xmlns:a="http://schemas.openxmlformats.org/drawingml/2006/main"/>
-          <a:ln xmlns:a="http://schemas.openxmlformats.org/drawingml/2006/main" w="28575">
-            <a:solidFill>
-              <a:srgbClr val="A8710A"/>
-            </a:solidFill>
-            <a:prstDash val="solid"/>
-          </a:ln>
-        </p:spPr>
-      </p:sp>
-      <p:sp>
-        <p:nvSpPr>
-          <p:cNvPr id="23" name="">
-            <a:extLst xmlns:a="http://schemas.openxmlformats.org/drawingml/2006/main">
-              <a:ext uri="{FF2B5EF4-FFF2-40B4-BE49-F238E27FC236}">
-                <a16:creationId xmlns:a16="http://schemas.microsoft.com/office/drawing/2014/main" id="{5AD06C82-BECC-4905-B8CB-712316ECD747}"/>
-              </a:ext>
-            </a:extLst>
-          </p:cNvPr>
-          <p:cNvSpPr>
-            <a:spLocks xmlns:a="http://schemas.openxmlformats.org/drawingml/2006/main" noGrp="1"/>
-          </p:cNvSpPr>
-          <p:nvPr/>
-        </p:nvSpPr>
-        <p:spPr>
-          <a:xfrm xmlns:a="http://schemas.openxmlformats.org/drawingml/2006/main" rot="0">
-            <a:off x="9020175" y="3610547"/>
-            <a:ext cx="133350" cy="133350"/>
-          </a:xfrm>
-          <a:prstGeom xmlns:a="http://schemas.openxmlformats.org/drawingml/2006/main" prst="ellipse">
-            <a:avLst/>
-          </a:prstGeom>
-          <a:solidFill xmlns:a="http://schemas.openxmlformats.org/drawingml/2006/main">
-            <a:srgbClr val="2C6A6C"/>
-          </a:solidFill>
-          <a:ln xmlns:a="http://schemas.openxmlformats.org/drawingml/2006/main" w="19050">
-            <a:solidFill>
-              <a:srgbClr val="FFFFFF"/>
-            </a:solidFill>
-            <a:prstDash val="solid"/>
-          </a:ln>
-        </p:spPr>
-      </p:sp>
-      <p:sp>
-        <p:nvSpPr>
-          <p:cNvPr id="24" name="">
-            <a:extLst xmlns:a="http://schemas.openxmlformats.org/drawingml/2006/main">
-              <a:ext uri="{FF2B5EF4-FFF2-40B4-BE49-F238E27FC236}">
-                <a16:creationId xmlns:a16="http://schemas.microsoft.com/office/drawing/2014/main" id="{A608BC95-96E6-4128-ACE2-5E93519A56BE}"/>
-              </a:ext>
-            </a:extLst>
-          </p:cNvPr>
-          <p:cNvSpPr>
-            <a:spLocks xmlns:a="http://schemas.openxmlformats.org/drawingml/2006/main" noGrp="1"/>
-          </p:cNvSpPr>
-          <p:nvPr/>
-        </p:nvSpPr>
-        <p:spPr>
-          <a:xfrm xmlns:a="http://schemas.openxmlformats.org/drawingml/2006/main" rot="0">
-            <a:off x="9553575" y="3368294"/>
-            <a:ext cx="133350" cy="133350"/>
-          </a:xfrm>
-          <a:prstGeom xmlns:a="http://schemas.openxmlformats.org/drawingml/2006/main" prst="ellipse">
-            <a:avLst/>
-          </a:prstGeom>
-          <a:solidFill xmlns:a="http://schemas.openxmlformats.org/drawingml/2006/main">
-            <a:srgbClr val="2C6A6C"/>
-          </a:solidFill>
-          <a:ln xmlns:a="http://schemas.openxmlformats.org/drawingml/2006/main" w="19050">
-            <a:solidFill>
-              <a:srgbClr val="FFFFFF"/>
-            </a:solidFill>
-            <a:prstDash val="solid"/>
-          </a:ln>
-        </p:spPr>
-      </p:sp>
-      <p:sp>
-        <p:nvSpPr>
-          <p:cNvPr id="25" name="">
-            <a:extLst xmlns:a="http://schemas.openxmlformats.org/drawingml/2006/main">
-              <a:ext uri="{FF2B5EF4-FFF2-40B4-BE49-F238E27FC236}">
-                <a16:creationId xmlns:a16="http://schemas.microsoft.com/office/drawing/2014/main" id="{FD2C981E-9460-4DAD-ABC1-F0D3DF8F7D61}"/>
-              </a:ext>
-            </a:extLst>
-          </p:cNvPr>
-          <p:cNvSpPr>
-            <a:spLocks xmlns:a="http://schemas.openxmlformats.org/drawingml/2006/main" noGrp="1"/>
-          </p:cNvSpPr>
-          <p:nvPr/>
-        </p:nvSpPr>
-        <p:spPr>
-          <a:xfrm xmlns:a="http://schemas.openxmlformats.org/drawingml/2006/main" rot="0">
-            <a:off x="8486775" y="3818192"/>
-            <a:ext cx="133350" cy="133350"/>
-          </a:xfrm>
-          <a:prstGeom xmlns:a="http://schemas.openxmlformats.org/drawingml/2006/main" prst="ellipse">
-            <a:avLst/>
-          </a:prstGeom>
-          <a:solidFill xmlns:a="http://schemas.openxmlformats.org/drawingml/2006/main">
-            <a:srgbClr val="2C6A6C"/>
-          </a:solidFill>
-          <a:ln xmlns:a="http://schemas.openxmlformats.org/drawingml/2006/main" w="19050">
-            <a:solidFill>
-              <a:srgbClr val="FFFFFF"/>
-            </a:solidFill>
-            <a:prstDash val="solid"/>
-          </a:ln>
-        </p:spPr>
-      </p:sp>
-      <p:sp>
-        <p:nvSpPr>
-          <p:cNvPr id="26" name="">
-            <a:extLst xmlns:a="http://schemas.openxmlformats.org/drawingml/2006/main">
-              <a:ext uri="{FF2B5EF4-FFF2-40B4-BE49-F238E27FC236}">
-                <a16:creationId xmlns:a16="http://schemas.microsoft.com/office/drawing/2014/main" id="{C14F78B5-E9FF-4091-BF47-6F22947E32A3}"/>
-              </a:ext>
-            </a:extLst>
-          </p:cNvPr>
-          <p:cNvSpPr>
-            <a:spLocks xmlns:a="http://schemas.openxmlformats.org/drawingml/2006/main" noGrp="1"/>
-          </p:cNvSpPr>
-          <p:nvPr/>
-        </p:nvSpPr>
-        <p:spPr>
-          <a:xfrm xmlns:a="http://schemas.openxmlformats.org/drawingml/2006/main" rot="0">
-            <a:off x="10620375" y="2503107"/>
-            <a:ext cx="133350" cy="133350"/>
-          </a:xfrm>
-          <a:prstGeom xmlns:a="http://schemas.openxmlformats.org/drawingml/2006/main" prst="ellipse">
-            <a:avLst/>
-          </a:prstGeom>
-          <a:solidFill xmlns:a="http://schemas.openxmlformats.org/drawingml/2006/main">
-            <a:srgbClr val="2C6A6C"/>
-          </a:solidFill>
-          <a:ln xmlns:a="http://schemas.openxmlformats.org/drawingml/2006/main" w="19050">
-            <a:solidFill>
-              <a:srgbClr val="FFFFFF"/>
-            </a:solidFill>
-            <a:prstDash val="solid"/>
-          </a:ln>
-        </p:spPr>
-      </p:sp>
-      <p:sp>
-        <p:nvSpPr>
-          <p:cNvPr id="27" name="">
-            <a:extLst xmlns:a="http://schemas.openxmlformats.org/drawingml/2006/main">
-              <a:ext uri="{FF2B5EF4-FFF2-40B4-BE49-F238E27FC236}">
-                <a16:creationId xmlns:a16="http://schemas.microsoft.com/office/drawing/2014/main" id="{DF0B617B-6AA6-45A5-8FC0-2D092018F4FA}"/>
-              </a:ext>
-            </a:extLst>
-          </p:cNvPr>
-          <p:cNvSpPr>
-            <a:spLocks xmlns:a="http://schemas.openxmlformats.org/drawingml/2006/main" noGrp="1"/>
-          </p:cNvSpPr>
-          <p:nvPr/>
-        </p:nvSpPr>
-        <p:spPr>
-          <a:xfrm xmlns:a="http://schemas.openxmlformats.org/drawingml/2006/main" rot="0">
-            <a:off x="10086975" y="2987612"/>
-            <a:ext cx="133350" cy="133350"/>
-          </a:xfrm>
-          <a:prstGeom xmlns:a="http://schemas.openxmlformats.org/drawingml/2006/main" prst="ellipse">
-            <a:avLst/>
-          </a:prstGeom>
-          <a:solidFill xmlns:a="http://schemas.openxmlformats.org/drawingml/2006/main">
-            <a:srgbClr val="2C6A6C"/>
-          </a:solidFill>
-          <a:ln xmlns:a="http://schemas.openxmlformats.org/drawingml/2006/main" w="19050">
-            <a:solidFill>
-              <a:srgbClr val="FFFFFF"/>
-            </a:solidFill>
-            <a:prstDash val="solid"/>
-          </a:ln>
-        </p:spPr>
-      </p:sp>
-      <p:sp>
-        <p:nvSpPr>
-          <p:cNvPr id="28" name="">
-            <a:extLst xmlns:a="http://schemas.openxmlformats.org/drawingml/2006/main">
-              <a:ext uri="{FF2B5EF4-FFF2-40B4-BE49-F238E27FC236}">
-                <a16:creationId xmlns:a16="http://schemas.microsoft.com/office/drawing/2014/main" id="{3F0DA026-55AD-4EF5-B943-8705C65B9A01}"/>
-              </a:ext>
-            </a:extLst>
-          </p:cNvPr>
-          <p:cNvSpPr>
-            <a:spLocks xmlns:a="http://schemas.openxmlformats.org/drawingml/2006/main" noGrp="1"/>
-          </p:cNvSpPr>
-          <p:nvPr/>
-        </p:nvSpPr>
-        <p:spPr>
-          <a:xfrm xmlns:a="http://schemas.openxmlformats.org/drawingml/2006/main" rot="0">
-            <a:off x="9534525" y="3238500"/>
-            <a:ext cx="171450" cy="171450"/>
-          </a:xfrm>
-          <a:prstGeom xmlns:a="http://schemas.openxmlformats.org/drawingml/2006/main" prst="ellipse">
-            <a:avLst/>
-          </a:prstGeom>
-          <a:solidFill xmlns:a="http://schemas.openxmlformats.org/drawingml/2006/main">
-            <a:srgbClr val="A8710A"/>
-          </a:solidFill>
-          <a:ln xmlns:a="http://schemas.openxmlformats.org/drawingml/2006/main" w="19050">
-            <a:solidFill>
-              <a:srgbClr val="FFFFFF"/>
-            </a:solidFill>
-            <a:prstDash val="solid"/>
-          </a:ln>
-        </p:spPr>
-      </p:sp>
-      <p:sp>
-        <p:nvSpPr>
-          <p:cNvPr id="29" name="">
-            <a:extLst xmlns:a="http://schemas.openxmlformats.org/drawingml/2006/main">
-              <a:ext uri="{FF2B5EF4-FFF2-40B4-BE49-F238E27FC236}">
-                <a16:creationId xmlns:a16="http://schemas.microsoft.com/office/drawing/2014/main" id="{C3CDD67F-756B-4823-91A6-8A18D2781797}"/>
-              </a:ext>
-            </a:extLst>
-          </p:cNvPr>
-          <p:cNvSpPr>
-            <a:spLocks xmlns:a="http://schemas.openxmlformats.org/drawingml/2006/main" noGrp="1"/>
-          </p:cNvSpPr>
-          <p:nvPr/>
-        </p:nvSpPr>
-        <p:spPr>
-          <a:xfrm xmlns:a="http://schemas.openxmlformats.org/drawingml/2006/main" rot="0">
-            <a:off x="8096250" y="2343150"/>
-            <a:ext cx="1066800" cy="228600"/>
-          </a:xfrm>
-          <a:prstGeom xmlns:a="http://schemas.openxmlformats.org/drawingml/2006/main" prst="rect">
-            <a:avLst/>
-          </a:prstGeom>
-          <a:noFill xmlns:a="http://schemas.openxmlformats.org/drawingml/2006/main"/>
-          <a:ln xmlns:a="http://schemas.openxmlformats.org/drawingml/2006/main" w="0">
-            <a:noFill/>
-          </a:ln>
-        </p:spPr>
         <p:txBody>
           <a:bodyPr xmlns:a="http://schemas.openxmlformats.org/drawingml/2006/main" wrap="square" lIns="0" tIns="0" rIns="0" bIns="0" anchor="t">
             <a:noAutofit/>
           </a:bodyPr>
           <a:lstStyle xmlns:a="http://schemas.openxmlformats.org/drawingml/2006/main"/>
           <a:p xmlns:a="http://schemas.openxmlformats.org/drawingml/2006/main">
-            <a:pPr algn="l">
-              <a:lnSpc>
-                <a:spcPct val="105000"/>
-              </a:lnSpc>
-              <a:buNone/>
-              <a:defRPr sz="1200" b="1" i="0">
-                <a:solidFill>
-                  <a:srgbClr val="68717D"/>
-                </a:solidFill>
-                <a:latin typeface="Arial"/>
-                <a:ea typeface="Arial"/>
-                <a:cs typeface="Arial"/>
-              </a:defRPr>
-            </a:pPr>
-            <a:r>
-              <a:rPr sz="1200" b="1" i="0">
-                <a:solidFill>
-                  <a:srgbClr val="68717D"/>
-                </a:solidFill>
-                <a:latin typeface="Arial"/>
-                <a:ea typeface="Arial"/>
-                <a:cs typeface="Arial"/>
-              </a:rPr>
-              <a:t>fuel − 7.42</a:t>
-            </a:r>
-          </a:p>
-        </p:txBody>
-      </p:sp>
-      <p:sp>
-        <p:nvSpPr>
-          <p:cNvPr id="30" name="">
-            <a:extLst xmlns:a="http://schemas.openxmlformats.org/drawingml/2006/main">
-              <a:ext uri="{FF2B5EF4-FFF2-40B4-BE49-F238E27FC236}">
-                <a16:creationId xmlns:a16="http://schemas.microsoft.com/office/drawing/2014/main" id="{A3EDEC71-E84A-42B0-815D-6A437477D7A4}"/>
-              </a:ext>
-            </a:extLst>
-          </p:cNvPr>
-          <p:cNvSpPr>
-            <a:spLocks xmlns:a="http://schemas.openxmlformats.org/drawingml/2006/main" noGrp="1"/>
-          </p:cNvSpPr>
-          <p:nvPr/>
-        </p:nvSpPr>
-        <p:spPr>
-          <a:xfrm xmlns:a="http://schemas.openxmlformats.org/drawingml/2006/main" rot="0">
-            <a:off x="10096500" y="4476750"/>
-            <a:ext cx="1123950" cy="228600"/>
-          </a:xfrm>
-          <a:prstGeom xmlns:a="http://schemas.openxmlformats.org/drawingml/2006/main" prst="rect">
-            <a:avLst/>
-          </a:prstGeom>
-          <a:noFill xmlns:a="http://schemas.openxmlformats.org/drawingml/2006/main"/>
-          <a:ln xmlns:a="http://schemas.openxmlformats.org/drawingml/2006/main" w="0">
-            <a:noFill/>
-          </a:ln>
-        </p:spPr>
-        <p:txBody>
-          <a:bodyPr xmlns:a="http://schemas.openxmlformats.org/drawingml/2006/main" wrap="square" lIns="0" tIns="0" rIns="0" bIns="0" anchor="t">
-            <a:noAutofit/>
-          </a:bodyPr>
-          <a:lstStyle xmlns:a="http://schemas.openxmlformats.org/drawingml/2006/main"/>
-          <a:p xmlns:a="http://schemas.openxmlformats.org/drawingml/2006/main">
-            <a:pPr algn="r">
-              <a:lnSpc>
-                <a:spcPct val="105000"/>
-              </a:lnSpc>
-              <a:buNone/>
-              <a:defRPr sz="1200" b="1" i="0">
-                <a:solidFill>
-                  <a:srgbClr val="68717D"/>
-                </a:solidFill>
-                <a:latin typeface="Arial"/>
-                <a:ea typeface="Arial"/>
-                <a:cs typeface="Arial"/>
-              </a:defRPr>
-            </a:pPr>
-            <a:r>
-              <a:rPr sz="1200" b="1" i="0">
-                <a:solidFill>
-                  <a:srgbClr val="68717D"/>
-                </a:solidFill>
-                <a:latin typeface="Arial"/>
-                <a:ea typeface="Arial"/>
-                <a:cs typeface="Arial"/>
-              </a:rPr>
-              <a:t>weight − 1.4</a:t>
-            </a:r>
-          </a:p>
-        </p:txBody>
-      </p:sp>
-      <p:sp>
-        <p:nvSpPr>
-          <p:cNvPr id="31" name="">
-            <a:extLst xmlns:a="http://schemas.openxmlformats.org/drawingml/2006/main">
-              <a:ext uri="{FF2B5EF4-FFF2-40B4-BE49-F238E27FC236}">
-                <a16:creationId xmlns:a16="http://schemas.microsoft.com/office/drawing/2014/main" id="{BB472F85-3EC8-4317-9867-BDC1933C6620}"/>
-              </a:ext>
-            </a:extLst>
-          </p:cNvPr>
-          <p:cNvSpPr>
-            <a:spLocks xmlns:a="http://schemas.openxmlformats.org/drawingml/2006/main" noGrp="1"/>
-          </p:cNvSpPr>
-          <p:nvPr/>
-        </p:nvSpPr>
-        <p:spPr>
-          <a:xfrm xmlns:a="http://schemas.openxmlformats.org/drawingml/2006/main" rot="0">
-            <a:off x="9734550" y="3057525"/>
-            <a:ext cx="1466850" cy="228600"/>
-          </a:xfrm>
-          <a:prstGeom xmlns:a="http://schemas.openxmlformats.org/drawingml/2006/main" prst="rect">
-            <a:avLst/>
-          </a:prstGeom>
-          <a:noFill xmlns:a="http://schemas.openxmlformats.org/drawingml/2006/main"/>
-          <a:ln xmlns:a="http://schemas.openxmlformats.org/drawingml/2006/main" w="0">
-            <a:noFill/>
-          </a:ln>
-        </p:spPr>
-        <p:txBody>
-          <a:bodyPr xmlns:a="http://schemas.openxmlformats.org/drawingml/2006/main" wrap="square" lIns="0" tIns="0" rIns="0" bIns="0" anchor="t">
-            <a:noAutofit/>
-          </a:bodyPr>
-          <a:lstStyle xmlns:a="http://schemas.openxmlformats.org/drawingml/2006/main"/>
-          <a:p xmlns:a="http://schemas.openxmlformats.org/drawingml/2006/main">
-            <a:pPr algn="l">
-              <a:lnSpc>
-                <a:spcPct val="105000"/>
-              </a:lnSpc>
-              <a:buNone/>
-              <a:defRPr sz="1200" b="1" i="0">
-                <a:solidFill>
-                  <a:srgbClr val="A8710A"/>
-                </a:solidFill>
-                <a:latin typeface="Arial"/>
-                <a:ea typeface="Arial"/>
-                <a:cs typeface="Arial"/>
-              </a:defRPr>
-            </a:pPr>
-            <a:r>
-              <a:rPr sz="1200" b="1" i="0">
-                <a:solidFill>
-                  <a:srgbClr val="A8710A"/>
-                </a:solidFill>
-                <a:latin typeface="Arial"/>
-                <a:ea typeface="Arial"/>
-                <a:cs typeface="Arial"/>
-              </a:rPr>
-              <a:t>mean (0, 0)</a:t>
-            </a:r>
-          </a:p>
-        </p:txBody>
-      </p:sp>
-      <p:sp>
-        <p:nvSpPr>
-          <p:cNvPr id="32" name="">
-            <a:extLst xmlns:a="http://schemas.openxmlformats.org/drawingml/2006/main">
-              <a:ext uri="{FF2B5EF4-FFF2-40B4-BE49-F238E27FC236}">
-                <a16:creationId xmlns:a16="http://schemas.microsoft.com/office/drawing/2014/main" id="{51CCCF6F-40D9-4B51-84E2-812090120790}"/>
-              </a:ext>
-            </a:extLst>
-          </p:cNvPr>
-          <p:cNvSpPr>
-            <a:spLocks xmlns:a="http://schemas.openxmlformats.org/drawingml/2006/main" noGrp="1"/>
-          </p:cNvSpPr>
-          <p:nvPr/>
-        </p:nvSpPr>
-        <p:spPr>
-          <a:xfrm xmlns:a="http://schemas.openxmlformats.org/drawingml/2006/main" rot="0">
-            <a:off x="5305425" y="2571750"/>
-            <a:ext cx="1581150" cy="228600"/>
-          </a:xfrm>
-          <a:prstGeom xmlns:a="http://schemas.openxmlformats.org/drawingml/2006/main" prst="rect">
-            <a:avLst/>
-          </a:prstGeom>
-          <a:noFill xmlns:a="http://schemas.openxmlformats.org/drawingml/2006/main"/>
-          <a:ln xmlns:a="http://schemas.openxmlformats.org/drawingml/2006/main" w="0">
-            <a:noFill/>
-          </a:ln>
-        </p:spPr>
-        <p:txBody>
-          <a:bodyPr xmlns:a="http://schemas.openxmlformats.org/drawingml/2006/main" wrap="square" lIns="0" tIns="0" rIns="0" bIns="0" anchor="t">
-            <a:noAutofit/>
-          </a:bodyPr>
-          <a:lstStyle xmlns:a="http://schemas.openxmlformats.org/drawingml/2006/main"/>
-          <a:p xmlns:a="http://schemas.openxmlformats.org/drawingml/2006/main">
             <a:pPr algn="ctr">
               <a:lnSpc>
                 <a:spcPct val="105000"/>
               </a:lnSpc>
               <a:buNone/>
-              <a:defRPr sz="1125" b="1" i="0">
-                <a:solidFill>
-                  <a:srgbClr val="A8710A"/>
-                </a:solidFill>
-                <a:latin typeface="Arial"/>
-                <a:ea typeface="Arial"/>
-                <a:cs typeface="Arial"/>
-              </a:defRPr>
-            </a:pPr>
-            <a:r>
-              <a:rPr sz="1125" b="1" i="0">
-                <a:solidFill>
-                  <a:srgbClr val="A8710A"/>
-                </a:solidFill>
-                <a:latin typeface="Arial"/>
-                <a:ea typeface="Arial"/>
-                <a:cs typeface="Arial"/>
-              </a:rPr>
-              <a:t>CENTER</a:t>
-            </a:r>
-          </a:p>
-        </p:txBody>
-      </p:sp>
-      <p:sp>
-        <p:nvSpPr>
-          <p:cNvPr id="33" name="">
-            <a:extLst xmlns:a="http://schemas.openxmlformats.org/drawingml/2006/main">
-              <a:ext uri="{FF2B5EF4-FFF2-40B4-BE49-F238E27FC236}">
-                <a16:creationId xmlns:a16="http://schemas.microsoft.com/office/drawing/2014/main" id="{F2735601-97A5-4E45-AD08-AF488CA4B289}"/>
-              </a:ext>
-            </a:extLst>
-          </p:cNvPr>
-          <p:cNvSpPr>
-            <a:spLocks xmlns:a="http://schemas.openxmlformats.org/drawingml/2006/main" noGrp="1"/>
-          </p:cNvSpPr>
-          <p:nvPr/>
-        </p:nvSpPr>
-        <p:spPr>
-          <a:xfrm xmlns:a="http://schemas.openxmlformats.org/drawingml/2006/main" rot="0">
-            <a:off x="5143500" y="2952750"/>
-            <a:ext cx="1905000" cy="647700"/>
+              <a:defRPr sz="1275" b="1" i="0">
+                <a:solidFill>
+                  <a:srgbClr val="A64B3C"/>
+                </a:solidFill>
+                <a:latin typeface="Arial"/>
+                <a:ea typeface="Arial"/>
+                <a:cs typeface="Arial"/>
+              </a:defRPr>
+            </a:pPr>
+            <a:r>
+              <a:rPr sz="1275" b="1" i="0">
+                <a:solidFill>
+                  <a:srgbClr val="A64B3C"/>
+                </a:solidFill>
+                <a:latin typeface="Arial"/>
+                <a:ea typeface="Arial"/>
+                <a:cs typeface="Arial"/>
+              </a:rPr>
+              <a:t>subtract (6, 4.5)</a:t>
+            </a:r>
+          </a:p>
+        </p:txBody>
+      </p:sp>
+      <p:sp>
+        <p:nvSpPr>
+          <p:cNvPr id="9" name="">
+            <a:extLst xmlns:a="http://schemas.openxmlformats.org/drawingml/2006/main">
+              <a:ext uri="{FF2B5EF4-FFF2-40B4-BE49-F238E27FC236}">
+                <a16:creationId xmlns:a16="http://schemas.microsoft.com/office/drawing/2014/main" id="{03110934-5A52-4701-8972-F7F632F9C4E8}"/>
+              </a:ext>
+            </a:extLst>
+          </p:cNvPr>
+          <p:cNvSpPr>
+            <a:spLocks xmlns:a="http://schemas.openxmlformats.org/drawingml/2006/main" noGrp="1"/>
+          </p:cNvSpPr>
+          <p:nvPr/>
+        </p:nvSpPr>
+        <p:spPr>
+          <a:xfrm xmlns:a="http://schemas.openxmlformats.org/drawingml/2006/main" rot="0">
+            <a:off x="1657350" y="5553075"/>
+            <a:ext cx="8877300" cy="514350"/>
           </a:xfrm>
           <a:prstGeom xmlns:a="http://schemas.openxmlformats.org/drawingml/2006/main" prst="rect">
             <a:avLst/>
@@ -16562,7 +16094,7 @@
                 <a:spcPct val="105000"/>
               </a:lnSpc>
               <a:buNone/>
-              <a:defRPr sz="2925" b="0" i="0">
+              <a:defRPr sz="2250" b="0" i="0">
                 <a:solidFill>
                   <a:srgbClr val="A8710A"/>
                 </a:solidFill>
@@ -16572,7 +16104,7 @@
               </a:defRPr>
             </a:pPr>
             <a:r>
-              <a:rPr sz="2925" b="0" i="0">
+              <a:rPr sz="2250" b="0" i="0">
                 <a:solidFill>
                   <a:srgbClr val="A8710A"/>
                 </a:solidFill>
@@ -16580,29 +16112,29 @@
                 <a:ea typeface="Cambria Math"/>
                 <a:cs typeface="Cambria Math"/>
               </a:rPr>
-              <a:t>− (x̄, ȳ)</a:t>
-            </a:r>
-          </a:p>
-        </p:txBody>
-      </p:sp>
-      <p:sp>
-        <p:nvSpPr>
-          <p:cNvPr id="34" name="">
-            <a:extLst xmlns:a="http://schemas.openxmlformats.org/drawingml/2006/main">
-              <a:ext uri="{FF2B5EF4-FFF2-40B4-BE49-F238E27FC236}">
-                <a16:creationId xmlns:a16="http://schemas.microsoft.com/office/drawing/2014/main" id="{1D6E560F-931C-4F30-8B67-8E35674D9A7A}"/>
-              </a:ext>
-            </a:extLst>
-          </p:cNvPr>
-          <p:cNvSpPr>
-            <a:spLocks xmlns:a="http://schemas.openxmlformats.org/drawingml/2006/main" noGrp="1"/>
-          </p:cNvSpPr>
-          <p:nvPr/>
-        </p:nvSpPr>
-        <p:spPr>
-          <a:xfrm xmlns:a="http://schemas.openxmlformats.org/drawingml/2006/main" rot="0">
-            <a:off x="5143500" y="3676650"/>
-            <a:ext cx="1905000" cy="514350"/>
+              <a:t>center every point:  (xᵢ, yᵢ) ↦ (xᵢ − 6, yᵢ − 4.5)</a:t>
+            </a:r>
+          </a:p>
+        </p:txBody>
+      </p:sp>
+      <p:sp>
+        <p:nvSpPr>
+          <p:cNvPr id="10" name="">
+            <a:extLst xmlns:a="http://schemas.openxmlformats.org/drawingml/2006/main">
+              <a:ext uri="{FF2B5EF4-FFF2-40B4-BE49-F238E27FC236}">
+                <a16:creationId xmlns:a16="http://schemas.microsoft.com/office/drawing/2014/main" id="{819797C5-3817-4AF6-AD66-A3798468ABBC}"/>
+              </a:ext>
+            </a:extLst>
+          </p:cNvPr>
+          <p:cNvSpPr>
+            <a:spLocks xmlns:a="http://schemas.openxmlformats.org/drawingml/2006/main" noGrp="1"/>
+          </p:cNvSpPr>
+          <p:nvPr/>
+        </p:nvSpPr>
+        <p:spPr>
+          <a:xfrm xmlns:a="http://schemas.openxmlformats.org/drawingml/2006/main" rot="0">
+            <a:off x="1333500" y="6115050"/>
+            <a:ext cx="9525000" cy="266700"/>
           </a:xfrm>
           <a:prstGeom xmlns:a="http://schemas.openxmlformats.org/drawingml/2006/main" prst="rect">
             <a:avLst/>
@@ -16625,7 +16157,7 @@
               <a:buNone/>
               <a:defRPr sz="1650" b="1" i="0">
                 <a:solidFill>
-                  <a:srgbClr val="68717D"/>
+                  <a:srgbClr val="252A31"/>
                 </a:solidFill>
                 <a:latin typeface="Arial"/>
                 <a:ea typeface="Arial"/>
@@ -16635,196 +16167,13 @@
             <a:r>
               <a:rPr sz="1650" b="1" i="0">
                 <a:solidFill>
-                  <a:srgbClr val="68717D"/>
-                </a:solidFill>
-                <a:latin typeface="Arial"/>
-                <a:ea typeface="Arial"/>
-                <a:cs typeface="Arial"/>
-              </a:rPr>
-              <a:t>from every point</a:t>
-            </a:r>
-          </a:p>
-        </p:txBody>
-      </p:sp>
-      <p:sp>
-        <p:nvSpPr>
-          <p:cNvPr id="35" name="">
-            <a:extLst xmlns:a="http://schemas.openxmlformats.org/drawingml/2006/main">
-              <a:ext uri="{FF2B5EF4-FFF2-40B4-BE49-F238E27FC236}">
-                <a16:creationId xmlns:a16="http://schemas.microsoft.com/office/drawing/2014/main" id="{FDDC2BD2-ED9D-4D3E-83EA-699E31EC16CF}"/>
-              </a:ext>
-            </a:extLst>
-          </p:cNvPr>
-          <p:cNvSpPr>
-            <a:spLocks xmlns:a="http://schemas.openxmlformats.org/drawingml/2006/main" noGrp="1"/>
-          </p:cNvSpPr>
-          <p:nvPr/>
-        </p:nvSpPr>
-        <p:spPr>
-          <a:xfrm xmlns:a="http://schemas.openxmlformats.org/drawingml/2006/main" rot="0">
-            <a:off x="1714500" y="5095875"/>
-            <a:ext cx="8763000" cy="552450"/>
-          </a:xfrm>
-          <a:prstGeom xmlns:a="http://schemas.openxmlformats.org/drawingml/2006/main" prst="rect">
-            <a:avLst/>
-          </a:prstGeom>
-          <a:noFill xmlns:a="http://schemas.openxmlformats.org/drawingml/2006/main"/>
-          <a:ln xmlns:a="http://schemas.openxmlformats.org/drawingml/2006/main" w="0">
-            <a:noFill/>
-          </a:ln>
-        </p:spPr>
-        <p:txBody>
-          <a:bodyPr xmlns:a="http://schemas.openxmlformats.org/drawingml/2006/main" wrap="square" lIns="114300" tIns="76200" rIns="114300" bIns="76200" anchor="ctr">
-            <a:noAutofit/>
-          </a:bodyPr>
-          <a:lstStyle xmlns:a="http://schemas.openxmlformats.org/drawingml/2006/main"/>
-          <a:p xmlns:a="http://schemas.openxmlformats.org/drawingml/2006/main">
-            <a:pPr algn="ctr">
-              <a:lnSpc>
-                <a:spcPct val="105000"/>
-              </a:lnSpc>
-              <a:buNone/>
-              <a:defRPr sz="2400" b="0" i="0">
-                <a:solidFill>
-                  <a:srgbClr val="252A31"/>
-                </a:solidFill>
-                <a:latin typeface="Cambria Math"/>
-                <a:ea typeface="Cambria Math"/>
-                <a:cs typeface="Cambria Math"/>
-              </a:defRPr>
-            </a:pPr>
-            <a:r>
-              <a:rPr sz="2400" b="0" i="0">
-                <a:solidFill>
-                  <a:srgbClr val="252A31"/>
-                </a:solidFill>
-                <a:latin typeface="Cambria Math"/>
-                <a:ea typeface="Cambria Math"/>
-                <a:cs typeface="Cambria Math"/>
-              </a:rPr>
-              <a:t>(xᵢ, yᵢ) becomes (xᵢ − x̄, yᵢ − ȳ)</a:t>
-            </a:r>
-          </a:p>
-        </p:txBody>
-      </p:sp>
-      <p:sp>
-        <p:nvSpPr>
-          <p:cNvPr id="36" name="">
-            <a:extLst xmlns:a="http://schemas.openxmlformats.org/drawingml/2006/main">
-              <a:ext uri="{FF2B5EF4-FFF2-40B4-BE49-F238E27FC236}">
-                <a16:creationId xmlns:a16="http://schemas.microsoft.com/office/drawing/2014/main" id="{8A42BE65-D1E1-4CDD-A68B-2F39C936A753}"/>
-              </a:ext>
-            </a:extLst>
-          </p:cNvPr>
-          <p:cNvSpPr>
-            <a:spLocks xmlns:a="http://schemas.openxmlformats.org/drawingml/2006/main" noGrp="1"/>
-          </p:cNvSpPr>
-          <p:nvPr/>
-        </p:nvSpPr>
-        <p:spPr>
-          <a:xfrm xmlns:a="http://schemas.openxmlformats.org/drawingml/2006/main" rot="0">
-            <a:off x="1333500" y="5810250"/>
-            <a:ext cx="9525000" cy="304800"/>
-          </a:xfrm>
-          <a:prstGeom xmlns:a="http://schemas.openxmlformats.org/drawingml/2006/main" prst="rect">
-            <a:avLst/>
-          </a:prstGeom>
-          <a:noFill xmlns:a="http://schemas.openxmlformats.org/drawingml/2006/main"/>
-          <a:ln xmlns:a="http://schemas.openxmlformats.org/drawingml/2006/main" w="0">
-            <a:noFill/>
-          </a:ln>
-        </p:spPr>
-        <p:txBody>
-          <a:bodyPr xmlns:a="http://schemas.openxmlformats.org/drawingml/2006/main" wrap="square" lIns="0" tIns="0" rIns="0" bIns="0" anchor="t">
-            <a:noAutofit/>
-          </a:bodyPr>
-          <a:lstStyle xmlns:a="http://schemas.openxmlformats.org/drawingml/2006/main"/>
-          <a:p xmlns:a="http://schemas.openxmlformats.org/drawingml/2006/main">
-            <a:pPr algn="ctr">
-              <a:lnSpc>
-                <a:spcPct val="105000"/>
-              </a:lnSpc>
-              <a:buNone/>
-              <a:defRPr sz="1725" b="1" i="0">
-                <a:solidFill>
-                  <a:srgbClr val="252A31"/>
-                </a:solidFill>
-                <a:latin typeface="Arial"/>
-                <a:ea typeface="Arial"/>
-                <a:cs typeface="Arial"/>
-              </a:defRPr>
-            </a:pPr>
-            <a:r>
-              <a:rPr sz="1725" b="1" i="0">
-                <a:solidFill>
-                  <a:srgbClr val="252A31"/>
-                </a:solidFill>
-                <a:latin typeface="Arial"/>
-                <a:ea typeface="Arial"/>
-                <a:cs typeface="Arial"/>
-              </a:rPr>
-              <a:t>Every point moves by the same amount. The cloud keeps its shape and slope.</a:t>
-            </a:r>
-          </a:p>
-        </p:txBody>
-      </p:sp>
-      <p:sp>
-        <p:nvSpPr>
-          <p:cNvPr id="37" name="">
-            <a:extLst xmlns:a="http://schemas.openxmlformats.org/drawingml/2006/main">
-              <a:ext uri="{FF2B5EF4-FFF2-40B4-BE49-F238E27FC236}">
-                <a16:creationId xmlns:a16="http://schemas.microsoft.com/office/drawing/2014/main" id="{53F79925-C664-4480-9922-5759481ADA2C}"/>
-              </a:ext>
-            </a:extLst>
-          </p:cNvPr>
-          <p:cNvSpPr>
-            <a:spLocks xmlns:a="http://schemas.openxmlformats.org/drawingml/2006/main" noGrp="1"/>
-          </p:cNvSpPr>
-          <p:nvPr/>
-        </p:nvSpPr>
-        <p:spPr>
-          <a:xfrm xmlns:a="http://schemas.openxmlformats.org/drawingml/2006/main" rot="0">
-            <a:off x="1333500" y="6143625"/>
-            <a:ext cx="9525000" cy="285750"/>
-          </a:xfrm>
-          <a:prstGeom xmlns:a="http://schemas.openxmlformats.org/drawingml/2006/main" prst="rect">
-            <a:avLst/>
-          </a:prstGeom>
-          <a:noFill xmlns:a="http://schemas.openxmlformats.org/drawingml/2006/main"/>
-          <a:ln xmlns:a="http://schemas.openxmlformats.org/drawingml/2006/main" w="0">
-            <a:noFill/>
-          </a:ln>
-        </p:spPr>
-        <p:txBody>
-          <a:bodyPr xmlns:a="http://schemas.openxmlformats.org/drawingml/2006/main" wrap="square" lIns="0" tIns="0" rIns="0" bIns="0" anchor="t">
-            <a:noAutofit/>
-          </a:bodyPr>
-          <a:lstStyle xmlns:a="http://schemas.openxmlformats.org/drawingml/2006/main"/>
-          <a:p xmlns:a="http://schemas.openxmlformats.org/drawingml/2006/main">
-            <a:pPr algn="ctr">
-              <a:lnSpc>
-                <a:spcPct val="105000"/>
-              </a:lnSpc>
-              <a:buNone/>
-              <a:defRPr sz="1575" b="0" i="0">
-                <a:solidFill>
-                  <a:srgbClr val="68717D"/>
-                </a:solidFill>
-                <a:latin typeface="Arial"/>
-                <a:ea typeface="Arial"/>
-                <a:cs typeface="Arial"/>
-              </a:defRPr>
-            </a:pPr>
-            <a:r>
-              <a:rPr sz="1575" b="0" i="0">
-                <a:solidFill>
-                  <a:srgbClr val="68717D"/>
-                </a:solidFill>
-                <a:latin typeface="Arial"/>
-                <a:ea typeface="Arial"/>
-                <a:cs typeface="Arial"/>
-              </a:rPr>
-              <a:t>The mean becomes (0, 0), so the fitted intercept is zero in centered coordinates.</a:t>
+                  <a:srgbClr val="252A31"/>
+                </a:solidFill>
+                <a:latin typeface="Arial"/>
+                <a:ea typeface="Arial"/>
+                <a:cs typeface="Arial"/>
+              </a:rPr>
+              <a:t>The cloud moves to the origin. Its shape and slope do not change.</a:t>
             </a:r>
           </a:p>
         </p:txBody>
@@ -16832,7 +16181,7 @@
     </p:spTree>
     <p:extLst>
       <p:ext uri="{BB962C8B-B14F-4D97-AF65-F5344CB8AC3E}">
-        <p14:creationId xmlns:p14="http://schemas.microsoft.com/office/powerpoint/2010/main" val="1471488335"/>
+        <p14:creationId xmlns:p14="http://schemas.microsoft.com/office/powerpoint/2010/main" val="22383506"/>
       </p:ext>
     </p:extLst>
   </p:cSld>
@@ -16863,7 +16212,7 @@
           <p:cNvPr id="28" name="">
             <a:extLst xmlns:a="http://schemas.openxmlformats.org/drawingml/2006/main">
               <a:ext uri="{FF2B5EF4-FFF2-40B4-BE49-F238E27FC236}">
-                <a16:creationId xmlns:a16="http://schemas.microsoft.com/office/drawing/2014/main" id="{801CE8DF-1BEF-4130-879A-43A6A6DFFC8A}"/>
+                <a16:creationId xmlns:a16="http://schemas.microsoft.com/office/drawing/2014/main" id="{91CBF218-3CFC-4AA2-9DE4-4CA44C81CF75}"/>
               </a:ext>
             </a:extLst>
           </p:cNvPr>
@@ -16924,7 +16273,7 @@
           <p:cNvPr id="2" name="">
             <a:extLst xmlns:a="http://schemas.openxmlformats.org/drawingml/2006/main">
               <a:ext uri="{FF2B5EF4-FFF2-40B4-BE49-F238E27FC236}">
-                <a16:creationId xmlns:a16="http://schemas.microsoft.com/office/drawing/2014/main" id="{A549A86D-6B17-41F1-9C83-B8BA8148DBF4}"/>
+                <a16:creationId xmlns:a16="http://schemas.microsoft.com/office/drawing/2014/main" id="{29EA9C36-6C1A-490F-B4A3-528D1FF3F921}"/>
               </a:ext>
             </a:extLst>
           </p:cNvPr>
@@ -16985,7 +16334,7 @@
           <p:cNvPr id="3" name="">
             <a:extLst xmlns:a="http://schemas.openxmlformats.org/drawingml/2006/main">
               <a:ext uri="{FF2B5EF4-FFF2-40B4-BE49-F238E27FC236}">
-                <a16:creationId xmlns:a16="http://schemas.microsoft.com/office/drawing/2014/main" id="{EE8E290F-A36C-476B-9530-8753FA43363B}"/>
+                <a16:creationId xmlns:a16="http://schemas.microsoft.com/office/drawing/2014/main" id="{46B6AD91-7F12-444D-A7C5-2069C648C046}"/>
               </a:ext>
             </a:extLst>
           </p:cNvPr>
@@ -17046,7 +16395,7 @@
           <p:cNvPr id="4" name="">
             <a:extLst xmlns:a="http://schemas.openxmlformats.org/drawingml/2006/main">
               <a:ext uri="{FF2B5EF4-FFF2-40B4-BE49-F238E27FC236}">
-                <a16:creationId xmlns:a16="http://schemas.microsoft.com/office/drawing/2014/main" id="{A989F5DF-FB1D-4052-9DA2-22062C6E60E2}"/>
+                <a16:creationId xmlns:a16="http://schemas.microsoft.com/office/drawing/2014/main" id="{478E9C1D-9ED3-466B-947A-BF710E8AE515}"/>
               </a:ext>
             </a:extLst>
           </p:cNvPr>
@@ -17107,7 +16456,7 @@
           <p:cNvPr id="5" name="">
             <a:extLst xmlns:a="http://schemas.openxmlformats.org/drawingml/2006/main">
               <a:ext uri="{FF2B5EF4-FFF2-40B4-BE49-F238E27FC236}">
-                <a16:creationId xmlns:a16="http://schemas.microsoft.com/office/drawing/2014/main" id="{FEF04F1F-C19A-4DDB-A35D-2B10A7F83043}"/>
+                <a16:creationId xmlns:a16="http://schemas.microsoft.com/office/drawing/2014/main" id="{64A65920-3C98-4F8F-AA5B-AFDBF8685E4A}"/>
               </a:ext>
             </a:extLst>
           </p:cNvPr>
@@ -17142,7 +16491,7 @@
           <p:cNvPr id="6" name="">
             <a:extLst xmlns:a="http://schemas.openxmlformats.org/drawingml/2006/main">
               <a:ext uri="{FF2B5EF4-FFF2-40B4-BE49-F238E27FC236}">
-                <a16:creationId xmlns:a16="http://schemas.microsoft.com/office/drawing/2014/main" id="{98ECFD0F-9596-46F7-A9A9-60F2CC79CD4F}"/>
+                <a16:creationId xmlns:a16="http://schemas.microsoft.com/office/drawing/2014/main" id="{EDF631AB-B12F-485E-B11E-860EA746A8EA}"/>
               </a:ext>
             </a:extLst>
           </p:cNvPr>
@@ -17177,7 +16526,7 @@
           <p:cNvPr id="7" name="">
             <a:extLst xmlns:a="http://schemas.openxmlformats.org/drawingml/2006/main">
               <a:ext uri="{FF2B5EF4-FFF2-40B4-BE49-F238E27FC236}">
-                <a16:creationId xmlns:a16="http://schemas.microsoft.com/office/drawing/2014/main" id="{4D2E386F-EBD1-42CE-90B9-4605A173AFDE}"/>
+                <a16:creationId xmlns:a16="http://schemas.microsoft.com/office/drawing/2014/main" id="{2715674E-2503-4678-8A9D-B2D4FE82C44F}"/>
               </a:ext>
             </a:extLst>
           </p:cNvPr>
@@ -17238,7 +16587,7 @@
           <p:cNvPr id="8" name="">
             <a:extLst xmlns:a="http://schemas.openxmlformats.org/drawingml/2006/main">
               <a:ext uri="{FF2B5EF4-FFF2-40B4-BE49-F238E27FC236}">
-                <a16:creationId xmlns:a16="http://schemas.microsoft.com/office/drawing/2014/main" id="{81B5C26C-F18A-4BA6-9A36-DFAEFF93BB3C}"/>
+                <a16:creationId xmlns:a16="http://schemas.microsoft.com/office/drawing/2014/main" id="{834C15E4-6219-4B4E-9FA4-7D98DE22718E}"/>
               </a:ext>
             </a:extLst>
           </p:cNvPr>
@@ -17299,7 +16648,7 @@
           <p:cNvPr id="9" name="">
             <a:extLst xmlns:a="http://schemas.openxmlformats.org/drawingml/2006/main">
               <a:ext uri="{FF2B5EF4-FFF2-40B4-BE49-F238E27FC236}">
-                <a16:creationId xmlns:a16="http://schemas.microsoft.com/office/drawing/2014/main" id="{282AA0F6-481F-4678-8CBB-7051D21002CA}"/>
+                <a16:creationId xmlns:a16="http://schemas.microsoft.com/office/drawing/2014/main" id="{65CF9758-8CD3-43F2-97EE-06211D3681DB}"/>
               </a:ext>
             </a:extLst>
           </p:cNvPr>
@@ -17329,7 +16678,7 @@
           <p:cNvPr id="10" name="">
             <a:extLst xmlns:a="http://schemas.openxmlformats.org/drawingml/2006/main">
               <a:ext uri="{FF2B5EF4-FFF2-40B4-BE49-F238E27FC236}">
-                <a16:creationId xmlns:a16="http://schemas.microsoft.com/office/drawing/2014/main" id="{50C4C746-BFCC-4EA6-A9DE-ADCFF2F4E450}"/>
+                <a16:creationId xmlns:a16="http://schemas.microsoft.com/office/drawing/2014/main" id="{2D6AC2DE-8996-4237-A715-F3B5490A2940}"/>
               </a:ext>
             </a:extLst>
           </p:cNvPr>
@@ -17359,7 +16708,7 @@
           <p:cNvPr id="11" name="">
             <a:extLst xmlns:a="http://schemas.openxmlformats.org/drawingml/2006/main">
               <a:ext uri="{FF2B5EF4-FFF2-40B4-BE49-F238E27FC236}">
-                <a16:creationId xmlns:a16="http://schemas.microsoft.com/office/drawing/2014/main" id="{0408E9E9-90E0-4EFF-A239-2E7D71A68589}"/>
+                <a16:creationId xmlns:a16="http://schemas.microsoft.com/office/drawing/2014/main" id="{F53890C8-2355-4B1B-88A0-8BD57022B220}"/>
               </a:ext>
             </a:extLst>
           </p:cNvPr>
@@ -17389,7 +16738,7 @@
           <p:cNvPr id="12" name="">
             <a:extLst xmlns:a="http://schemas.openxmlformats.org/drawingml/2006/main">
               <a:ext uri="{FF2B5EF4-FFF2-40B4-BE49-F238E27FC236}">
-                <a16:creationId xmlns:a16="http://schemas.microsoft.com/office/drawing/2014/main" id="{8C47E17A-A0E4-4FD2-9E0F-1DDB05569881}"/>
+                <a16:creationId xmlns:a16="http://schemas.microsoft.com/office/drawing/2014/main" id="{5F12AB16-7C54-458C-863C-DDF190501AE9}"/>
               </a:ext>
             </a:extLst>
           </p:cNvPr>
@@ -17419,7 +16768,7 @@
           <p:cNvPr id="13" name="">
             <a:extLst xmlns:a="http://schemas.openxmlformats.org/drawingml/2006/main">
               <a:ext uri="{FF2B5EF4-FFF2-40B4-BE49-F238E27FC236}">
-                <a16:creationId xmlns:a16="http://schemas.microsoft.com/office/drawing/2014/main" id="{405C3526-A40F-4D1D-A46B-5E335EF54559}"/>
+                <a16:creationId xmlns:a16="http://schemas.microsoft.com/office/drawing/2014/main" id="{B4823851-50BD-42CD-B582-8A9966ACA866}"/>
               </a:ext>
             </a:extLst>
           </p:cNvPr>
@@ -17449,7 +16798,7 @@
           <p:cNvPr id="14" name="">
             <a:extLst xmlns:a="http://schemas.openxmlformats.org/drawingml/2006/main">
               <a:ext uri="{FF2B5EF4-FFF2-40B4-BE49-F238E27FC236}">
-                <a16:creationId xmlns:a16="http://schemas.microsoft.com/office/drawing/2014/main" id="{F9B4BDD3-F26C-4709-898B-21E7F1242BE5}"/>
+                <a16:creationId xmlns:a16="http://schemas.microsoft.com/office/drawing/2014/main" id="{F6C48D0D-3A36-461F-8C52-F295275574B3}"/>
               </a:ext>
             </a:extLst>
           </p:cNvPr>
@@ -17479,7 +16828,7 @@
           <p:cNvPr id="15" name="">
             <a:extLst xmlns:a="http://schemas.openxmlformats.org/drawingml/2006/main">
               <a:ext uri="{FF2B5EF4-FFF2-40B4-BE49-F238E27FC236}">
-                <a16:creationId xmlns:a16="http://schemas.microsoft.com/office/drawing/2014/main" id="{0D3A2CE8-54E8-4655-9E28-B7F760F048CA}"/>
+                <a16:creationId xmlns:a16="http://schemas.microsoft.com/office/drawing/2014/main" id="{52385705-6C11-4145-BA93-F22B562B568F}"/>
               </a:ext>
             </a:extLst>
           </p:cNvPr>
@@ -17509,7 +16858,7 @@
           <p:cNvPr id="16" name="">
             <a:extLst xmlns:a="http://schemas.openxmlformats.org/drawingml/2006/main">
               <a:ext uri="{FF2B5EF4-FFF2-40B4-BE49-F238E27FC236}">
-                <a16:creationId xmlns:a16="http://schemas.microsoft.com/office/drawing/2014/main" id="{435C4423-690A-4B56-A295-975777EA698B}"/>
+                <a16:creationId xmlns:a16="http://schemas.microsoft.com/office/drawing/2014/main" id="{5F2D1D75-9779-44D6-A71B-13E4420660E9}"/>
               </a:ext>
             </a:extLst>
           </p:cNvPr>
@@ -17539,7 +16888,7 @@
           <p:cNvPr id="17" name="">
             <a:extLst xmlns:a="http://schemas.openxmlformats.org/drawingml/2006/main">
               <a:ext uri="{FF2B5EF4-FFF2-40B4-BE49-F238E27FC236}">
-                <a16:creationId xmlns:a16="http://schemas.microsoft.com/office/drawing/2014/main" id="{737DB834-EF73-471A-AA61-FA83EC8CFB0D}"/>
+                <a16:creationId xmlns:a16="http://schemas.microsoft.com/office/drawing/2014/main" id="{63D08E84-D0B2-49F4-81F1-A0C35DD2BA96}"/>
               </a:ext>
             </a:extLst>
           </p:cNvPr>
@@ -17569,7 +16918,7 @@
           <p:cNvPr id="18" name="">
             <a:extLst xmlns:a="http://schemas.openxmlformats.org/drawingml/2006/main">
               <a:ext uri="{FF2B5EF4-FFF2-40B4-BE49-F238E27FC236}">
-                <a16:creationId xmlns:a16="http://schemas.microsoft.com/office/drawing/2014/main" id="{6E9A10BC-DE08-465A-B748-CD0EA3736DF6}"/>
+                <a16:creationId xmlns:a16="http://schemas.microsoft.com/office/drawing/2014/main" id="{5AEF0C72-0339-4173-BE26-044EF079652C}"/>
               </a:ext>
             </a:extLst>
           </p:cNvPr>
@@ -17599,7 +16948,7 @@
           <p:cNvPr id="19" name="">
             <a:extLst xmlns:a="http://schemas.openxmlformats.org/drawingml/2006/main">
               <a:ext uri="{FF2B5EF4-FFF2-40B4-BE49-F238E27FC236}">
-                <a16:creationId xmlns:a16="http://schemas.microsoft.com/office/drawing/2014/main" id="{BE6C09B2-960D-462F-BC2C-1FAD92DA7C80}"/>
+                <a16:creationId xmlns:a16="http://schemas.microsoft.com/office/drawing/2014/main" id="{4C8F659D-CEDF-4CA7-94A0-F4C5A4B05B2B}"/>
               </a:ext>
             </a:extLst>
           </p:cNvPr>
@@ -17660,7 +17009,7 @@
           <p:cNvPr id="20" name="">
             <a:extLst xmlns:a="http://schemas.openxmlformats.org/drawingml/2006/main">
               <a:ext uri="{FF2B5EF4-FFF2-40B4-BE49-F238E27FC236}">
-                <a16:creationId xmlns:a16="http://schemas.microsoft.com/office/drawing/2014/main" id="{806785A0-A138-4B2A-8B33-6F04DEDDC20D}"/>
+                <a16:creationId xmlns:a16="http://schemas.microsoft.com/office/drawing/2014/main" id="{B1EB464A-9DD6-4B9D-B2AA-92B7D967983F}"/>
               </a:ext>
             </a:extLst>
           </p:cNvPr>
@@ -17690,7 +17039,7 @@
           <p:cNvPr id="21" name="">
             <a:extLst xmlns:a="http://schemas.openxmlformats.org/drawingml/2006/main">
               <a:ext uri="{FF2B5EF4-FFF2-40B4-BE49-F238E27FC236}">
-                <a16:creationId xmlns:a16="http://schemas.microsoft.com/office/drawing/2014/main" id="{2DC719EE-04F5-453F-846C-EC97E0004244}"/>
+                <a16:creationId xmlns:a16="http://schemas.microsoft.com/office/drawing/2014/main" id="{2357D5AE-2203-4296-BCE4-A974959B96D3}"/>
               </a:ext>
             </a:extLst>
           </p:cNvPr>
@@ -17751,7 +17100,7 @@
           <p:cNvPr id="22" name="">
             <a:extLst xmlns:a="http://schemas.openxmlformats.org/drawingml/2006/main">
               <a:ext uri="{FF2B5EF4-FFF2-40B4-BE49-F238E27FC236}">
-                <a16:creationId xmlns:a16="http://schemas.microsoft.com/office/drawing/2014/main" id="{963F3A0B-53EC-4251-B06A-13A70DE992E3}"/>
+                <a16:creationId xmlns:a16="http://schemas.microsoft.com/office/drawing/2014/main" id="{B9DDD165-1EE8-4E1E-8B6B-8A264DBC1618}"/>
               </a:ext>
             </a:extLst>
           </p:cNvPr>
@@ -17819,7 +17168,7 @@
           <p:cNvPr id="23" name="">
             <a:extLst xmlns:a="http://schemas.openxmlformats.org/drawingml/2006/main">
               <a:ext uri="{FF2B5EF4-FFF2-40B4-BE49-F238E27FC236}">
-                <a16:creationId xmlns:a16="http://schemas.microsoft.com/office/drawing/2014/main" id="{9A9DA788-F078-4F4F-9AAB-BFD83730BDC6}"/>
+                <a16:creationId xmlns:a16="http://schemas.microsoft.com/office/drawing/2014/main" id="{A4D16348-54BA-4FDD-BB84-236C8C6FC7E8}"/>
               </a:ext>
             </a:extLst>
           </p:cNvPr>
@@ -17907,7 +17256,7 @@
           <p:cNvPr id="24" name="">
             <a:extLst xmlns:a="http://schemas.openxmlformats.org/drawingml/2006/main">
               <a:ext uri="{FF2B5EF4-FFF2-40B4-BE49-F238E27FC236}">
-                <a16:creationId xmlns:a16="http://schemas.microsoft.com/office/drawing/2014/main" id="{64E0F2CB-C318-44C5-9DCD-7D08CB4349C0}"/>
+                <a16:creationId xmlns:a16="http://schemas.microsoft.com/office/drawing/2014/main" id="{02F48E7F-A8FA-4E08-B29E-D33FA17ACDAF}"/>
               </a:ext>
             </a:extLst>
           </p:cNvPr>
@@ -17937,7 +17286,7 @@
           <p:cNvPr id="25" name="">
             <a:extLst xmlns:a="http://schemas.openxmlformats.org/drawingml/2006/main">
               <a:ext uri="{FF2B5EF4-FFF2-40B4-BE49-F238E27FC236}">
-                <a16:creationId xmlns:a16="http://schemas.microsoft.com/office/drawing/2014/main" id="{9B7947E2-A070-401D-A6AB-64817FFF0905}"/>
+                <a16:creationId xmlns:a16="http://schemas.microsoft.com/office/drawing/2014/main" id="{7F5DC6C4-C93E-4439-BC4C-4706828874E9}"/>
               </a:ext>
             </a:extLst>
           </p:cNvPr>
@@ -17998,7 +17347,7 @@
           <p:cNvPr id="26" name="">
             <a:extLst xmlns:a="http://schemas.openxmlformats.org/drawingml/2006/main">
               <a:ext uri="{FF2B5EF4-FFF2-40B4-BE49-F238E27FC236}">
-                <a16:creationId xmlns:a16="http://schemas.microsoft.com/office/drawing/2014/main" id="{72AB4D89-B9CC-4124-99B7-348A2ADE3E27}"/>
+                <a16:creationId xmlns:a16="http://schemas.microsoft.com/office/drawing/2014/main" id="{3E9802AE-C9FB-42ED-800B-AA635D7E5F95}"/>
               </a:ext>
             </a:extLst>
           </p:cNvPr>
@@ -18063,7 +17412,7 @@
           <p:cNvPr id="27" name="">
             <a:extLst xmlns:a="http://schemas.openxmlformats.org/drawingml/2006/main">
               <a:ext uri="{FF2B5EF4-FFF2-40B4-BE49-F238E27FC236}">
-                <a16:creationId xmlns:a16="http://schemas.microsoft.com/office/drawing/2014/main" id="{8ADC17EE-3D8E-4053-A6F1-C67D4CB057E7}"/>
+                <a16:creationId xmlns:a16="http://schemas.microsoft.com/office/drawing/2014/main" id="{9058AEB1-A9D2-4E30-85A3-3F2C69F38D4C}"/>
               </a:ext>
             </a:extLst>
           </p:cNvPr>
@@ -18122,7 +17471,7 @@
     </p:spTree>
     <p:extLst>
       <p:ext uri="{BB962C8B-B14F-4D97-AF65-F5344CB8AC3E}">
-        <p14:creationId xmlns:p14="http://schemas.microsoft.com/office/powerpoint/2010/main" val="1987814679"/>
+        <p14:creationId xmlns:p14="http://schemas.microsoft.com/office/powerpoint/2010/main" val="1388472370"/>
       </p:ext>
     </p:extLst>
   </p:cSld>
@@ -18153,7 +17502,7 @@
           <p:cNvPr id="15" name="">
             <a:extLst xmlns:a="http://schemas.openxmlformats.org/drawingml/2006/main">
               <a:ext uri="{FF2B5EF4-FFF2-40B4-BE49-F238E27FC236}">
-                <a16:creationId xmlns:a16="http://schemas.microsoft.com/office/drawing/2014/main" id="{329F4DEF-DB78-4EE7-859C-ACF5ABD1016B}"/>
+                <a16:creationId xmlns:a16="http://schemas.microsoft.com/office/drawing/2014/main" id="{8977A0ED-9750-45F4-87B9-B52BA0672229}"/>
               </a:ext>
             </a:extLst>
           </p:cNvPr>
@@ -18214,7 +17563,7 @@
           <p:cNvPr id="2" name="">
             <a:extLst xmlns:a="http://schemas.openxmlformats.org/drawingml/2006/main">
               <a:ext uri="{FF2B5EF4-FFF2-40B4-BE49-F238E27FC236}">
-                <a16:creationId xmlns:a16="http://schemas.microsoft.com/office/drawing/2014/main" id="{A6183A81-A733-44AC-9CD4-32DB28CF8094}"/>
+                <a16:creationId xmlns:a16="http://schemas.microsoft.com/office/drawing/2014/main" id="{6F125F25-3894-4F3E-9521-78494002885F}"/>
               </a:ext>
             </a:extLst>
           </p:cNvPr>
@@ -18275,7 +17624,7 @@
           <p:cNvPr id="3" name="">
             <a:extLst xmlns:a="http://schemas.openxmlformats.org/drawingml/2006/main">
               <a:ext uri="{FF2B5EF4-FFF2-40B4-BE49-F238E27FC236}">
-                <a16:creationId xmlns:a16="http://schemas.microsoft.com/office/drawing/2014/main" id="{45D26E7F-2D90-4717-BE95-BA4E89C52BE3}"/>
+                <a16:creationId xmlns:a16="http://schemas.microsoft.com/office/drawing/2014/main" id="{7EB2D633-ED25-4B64-B1D3-65D5550C5407}"/>
               </a:ext>
             </a:extLst>
           </p:cNvPr>
@@ -18336,7 +17685,7 @@
           <p:cNvPr id="4" name="">
             <a:extLst xmlns:a="http://schemas.openxmlformats.org/drawingml/2006/main">
               <a:ext uri="{FF2B5EF4-FFF2-40B4-BE49-F238E27FC236}">
-                <a16:creationId xmlns:a16="http://schemas.microsoft.com/office/drawing/2014/main" id="{9EBDE9AD-EC4E-49D7-B0EE-C520E98391E8}"/>
+                <a16:creationId xmlns:a16="http://schemas.microsoft.com/office/drawing/2014/main" id="{743F3F62-DA5B-4FC3-A553-47A92BE0BA47}"/>
               </a:ext>
             </a:extLst>
           </p:cNvPr>
@@ -18367,7 +17716,7 @@
           <p:cNvPr id="5" name="">
             <a:extLst xmlns:a="http://schemas.openxmlformats.org/drawingml/2006/main">
               <a:ext uri="{FF2B5EF4-FFF2-40B4-BE49-F238E27FC236}">
-                <a16:creationId xmlns:a16="http://schemas.microsoft.com/office/drawing/2014/main" id="{81373CFD-BA6E-4572-A9CC-D70B69C2C93D}"/>
+                <a16:creationId xmlns:a16="http://schemas.microsoft.com/office/drawing/2014/main" id="{67D187C5-6778-4DEE-A56E-11D203D45A46}"/>
               </a:ext>
             </a:extLst>
           </p:cNvPr>
@@ -18398,7 +17747,7 @@
           <p:cNvPr id="6" name="">
             <a:extLst xmlns:a="http://schemas.openxmlformats.org/drawingml/2006/main">
               <a:ext uri="{FF2B5EF4-FFF2-40B4-BE49-F238E27FC236}">
-                <a16:creationId xmlns:a16="http://schemas.microsoft.com/office/drawing/2014/main" id="{21E953D8-C8AF-4718-BCFA-1AE57CCCB027}"/>
+                <a16:creationId xmlns:a16="http://schemas.microsoft.com/office/drawing/2014/main" id="{0B7AFF46-7968-4445-BD2A-7DE036D90263}"/>
               </a:ext>
             </a:extLst>
           </p:cNvPr>
@@ -18428,7 +17777,7 @@
           <p:cNvPr id="7" name="">
             <a:extLst xmlns:a="http://schemas.openxmlformats.org/drawingml/2006/main">
               <a:ext uri="{FF2B5EF4-FFF2-40B4-BE49-F238E27FC236}">
-                <a16:creationId xmlns:a16="http://schemas.microsoft.com/office/drawing/2014/main" id="{796D776F-97CF-4EBB-8B00-11DD6081B020}"/>
+                <a16:creationId xmlns:a16="http://schemas.microsoft.com/office/drawing/2014/main" id="{771C6B4B-811E-4FFE-AB8F-27FF04DC0C8B}"/>
               </a:ext>
             </a:extLst>
           </p:cNvPr>
@@ -18489,7 +17838,7 @@
           <p:cNvPr id="8" name="">
             <a:extLst xmlns:a="http://schemas.openxmlformats.org/drawingml/2006/main">
               <a:ext uri="{FF2B5EF4-FFF2-40B4-BE49-F238E27FC236}">
-                <a16:creationId xmlns:a16="http://schemas.microsoft.com/office/drawing/2014/main" id="{904DF4B1-D2CC-4857-8AD3-59E36907791F}"/>
+                <a16:creationId xmlns:a16="http://schemas.microsoft.com/office/drawing/2014/main" id="{2B3B0B1A-50B7-4BEE-9A82-07E37954C56E}"/>
               </a:ext>
             </a:extLst>
           </p:cNvPr>
@@ -18550,7 +17899,7 @@
           <p:cNvPr id="9" name="">
             <a:extLst xmlns:a="http://schemas.openxmlformats.org/drawingml/2006/main">
               <a:ext uri="{FF2B5EF4-FFF2-40B4-BE49-F238E27FC236}">
-                <a16:creationId xmlns:a16="http://schemas.microsoft.com/office/drawing/2014/main" id="{D5E60324-4BC8-46E6-8594-5C53E3F02109}"/>
+                <a16:creationId xmlns:a16="http://schemas.microsoft.com/office/drawing/2014/main" id="{6AC40148-11EA-4A83-BFBE-88A8E55DC2B6}"/>
               </a:ext>
             </a:extLst>
           </p:cNvPr>
@@ -18611,7 +17960,7 @@
           <p:cNvPr id="10" name="">
             <a:extLst xmlns:a="http://schemas.openxmlformats.org/drawingml/2006/main">
               <a:ext uri="{FF2B5EF4-FFF2-40B4-BE49-F238E27FC236}">
-                <a16:creationId xmlns:a16="http://schemas.microsoft.com/office/drawing/2014/main" id="{6F2EB509-3F62-495A-A249-B8D94EC439C7}"/>
+                <a16:creationId xmlns:a16="http://schemas.microsoft.com/office/drawing/2014/main" id="{462C82E2-B305-45A9-8158-2B3CDF8CB011}"/>
               </a:ext>
             </a:extLst>
           </p:cNvPr>
@@ -18672,7 +18021,7 @@
           <p:cNvPr id="11" name="">
             <a:extLst xmlns:a="http://schemas.openxmlformats.org/drawingml/2006/main">
               <a:ext uri="{FF2B5EF4-FFF2-40B4-BE49-F238E27FC236}">
-                <a16:creationId xmlns:a16="http://schemas.microsoft.com/office/drawing/2014/main" id="{33F34203-3C10-428C-B80E-126140CE60F8}"/>
+                <a16:creationId xmlns:a16="http://schemas.microsoft.com/office/drawing/2014/main" id="{71E37DF2-A609-474E-8FE7-82C56E1A5AF4}"/>
               </a:ext>
             </a:extLst>
           </p:cNvPr>
@@ -18737,7 +18086,7 @@
           <p:cNvPr id="12" name="">
             <a:extLst xmlns:a="http://schemas.openxmlformats.org/drawingml/2006/main">
               <a:ext uri="{FF2B5EF4-FFF2-40B4-BE49-F238E27FC236}">
-                <a16:creationId xmlns:a16="http://schemas.microsoft.com/office/drawing/2014/main" id="{3ED8ECA8-DD88-4E6D-B4BE-97A2FD76BF81}"/>
+                <a16:creationId xmlns:a16="http://schemas.microsoft.com/office/drawing/2014/main" id="{9C47F21D-6659-4EB2-B7D0-32ADB99782B5}"/>
               </a:ext>
             </a:extLst>
           </p:cNvPr>
@@ -18798,7 +18147,7 @@
           <p:cNvPr id="13" name="">
             <a:extLst xmlns:a="http://schemas.openxmlformats.org/drawingml/2006/main">
               <a:ext uri="{FF2B5EF4-FFF2-40B4-BE49-F238E27FC236}">
-                <a16:creationId xmlns:a16="http://schemas.microsoft.com/office/drawing/2014/main" id="{3A8239BD-06BF-4EB7-8A73-D330A3FEBC4F}"/>
+                <a16:creationId xmlns:a16="http://schemas.microsoft.com/office/drawing/2014/main" id="{77EA64C7-CCDA-4E9F-8C2D-04DE680B3F45}"/>
               </a:ext>
             </a:extLst>
           </p:cNvPr>
@@ -18859,7 +18208,7 @@
           <p:cNvPr id="14" name="">
             <a:extLst xmlns:a="http://schemas.openxmlformats.org/drawingml/2006/main">
               <a:ext uri="{FF2B5EF4-FFF2-40B4-BE49-F238E27FC236}">
-                <a16:creationId xmlns:a16="http://schemas.microsoft.com/office/drawing/2014/main" id="{FBAEC9F0-78E4-4196-A00D-0AB24F9D3DF1}"/>
+                <a16:creationId xmlns:a16="http://schemas.microsoft.com/office/drawing/2014/main" id="{F47F0A95-2547-4D49-9F6C-90215434D9A0}"/>
               </a:ext>
             </a:extLst>
           </p:cNvPr>
@@ -18918,7 +18267,7 @@
     </p:spTree>
     <p:extLst>
       <p:ext uri="{BB962C8B-B14F-4D97-AF65-F5344CB8AC3E}">
-        <p14:creationId xmlns:p14="http://schemas.microsoft.com/office/powerpoint/2010/main" val="1376004326"/>
+        <p14:creationId xmlns:p14="http://schemas.microsoft.com/office/powerpoint/2010/main" val="781455353"/>
       </p:ext>
     </p:extLst>
   </p:cSld>
@@ -18949,7 +18298,7 @@
           <p:cNvPr id="12" name="">
             <a:extLst xmlns:a="http://schemas.openxmlformats.org/drawingml/2006/main">
               <a:ext uri="{FF2B5EF4-FFF2-40B4-BE49-F238E27FC236}">
-                <a16:creationId xmlns:a16="http://schemas.microsoft.com/office/drawing/2014/main" id="{56F2D867-A5E5-43E0-B1E7-8216DBB4C573}"/>
+                <a16:creationId xmlns:a16="http://schemas.microsoft.com/office/drawing/2014/main" id="{6054FCB2-34B3-4E99-A9B1-C749ED955E34}"/>
               </a:ext>
             </a:extLst>
           </p:cNvPr>
@@ -19010,7 +18359,7 @@
           <p:cNvPr id="2" name="">
             <a:extLst xmlns:a="http://schemas.openxmlformats.org/drawingml/2006/main">
               <a:ext uri="{FF2B5EF4-FFF2-40B4-BE49-F238E27FC236}">
-                <a16:creationId xmlns:a16="http://schemas.microsoft.com/office/drawing/2014/main" id="{05D51821-57C2-4B4B-8627-D10AF7DA4F00}"/>
+                <a16:creationId xmlns:a16="http://schemas.microsoft.com/office/drawing/2014/main" id="{6C7E6B2E-421B-45D0-AEAE-8FA75CE1D1D1}"/>
               </a:ext>
             </a:extLst>
           </p:cNvPr>
@@ -19071,7 +18420,7 @@
           <p:cNvPr id="3" name="">
             <a:extLst xmlns:a="http://schemas.openxmlformats.org/drawingml/2006/main">
               <a:ext uri="{FF2B5EF4-FFF2-40B4-BE49-F238E27FC236}">
-                <a16:creationId xmlns:a16="http://schemas.microsoft.com/office/drawing/2014/main" id="{BB9D5055-21A1-40EE-A48C-AFEFA2DC216C}"/>
+                <a16:creationId xmlns:a16="http://schemas.microsoft.com/office/drawing/2014/main" id="{0C72E943-0ED4-4D7E-A12E-3D43E7B82373}"/>
               </a:ext>
             </a:extLst>
           </p:cNvPr>
@@ -19132,7 +18481,7 @@
           <p:cNvPr id="4" name="">
             <a:extLst xmlns:a="http://schemas.openxmlformats.org/drawingml/2006/main">
               <a:ext uri="{FF2B5EF4-FFF2-40B4-BE49-F238E27FC236}">
-                <a16:creationId xmlns:a16="http://schemas.microsoft.com/office/drawing/2014/main" id="{C878AB97-3E90-4460-9FD8-3EA64689C2E8}"/>
+                <a16:creationId xmlns:a16="http://schemas.microsoft.com/office/drawing/2014/main" id="{BF5B277A-D664-45F3-BE90-1D924B0593C8}"/>
               </a:ext>
             </a:extLst>
           </p:cNvPr>
@@ -19254,7 +18603,7 @@
           <p:cNvPr id="5" name="">
             <a:extLst xmlns:a="http://schemas.openxmlformats.org/drawingml/2006/main">
               <a:ext uri="{FF2B5EF4-FFF2-40B4-BE49-F238E27FC236}">
-                <a16:creationId xmlns:a16="http://schemas.microsoft.com/office/drawing/2014/main" id="{06A22E40-8FC3-41D3-8212-569B2E78DC14}"/>
+                <a16:creationId xmlns:a16="http://schemas.microsoft.com/office/drawing/2014/main" id="{24F3FF7E-035A-400E-BDA4-D953086398CE}"/>
               </a:ext>
             </a:extLst>
           </p:cNvPr>
@@ -19284,7 +18633,7 @@
           <p:cNvPr id="6" name="">
             <a:extLst xmlns:a="http://schemas.openxmlformats.org/drawingml/2006/main">
               <a:ext uri="{FF2B5EF4-FFF2-40B4-BE49-F238E27FC236}">
-                <a16:creationId xmlns:a16="http://schemas.microsoft.com/office/drawing/2014/main" id="{68421E37-6A78-452A-AA22-EA398EB0C7ED}"/>
+                <a16:creationId xmlns:a16="http://schemas.microsoft.com/office/drawing/2014/main" id="{D8FF6C08-B50A-4611-98F1-F31C40CA6B4B}"/>
               </a:ext>
             </a:extLst>
           </p:cNvPr>
@@ -19345,7 +18694,7 @@
           <p:cNvPr id="7" name="">
             <a:extLst xmlns:a="http://schemas.openxmlformats.org/drawingml/2006/main">
               <a:ext uri="{FF2B5EF4-FFF2-40B4-BE49-F238E27FC236}">
-                <a16:creationId xmlns:a16="http://schemas.microsoft.com/office/drawing/2014/main" id="{63B56557-3DE2-4B32-8823-970024491C80}"/>
+                <a16:creationId xmlns:a16="http://schemas.microsoft.com/office/drawing/2014/main" id="{9D17A6B1-A997-4F8C-B05D-2B25FA5CEA2A}"/>
               </a:ext>
             </a:extLst>
           </p:cNvPr>
@@ -19406,7 +18755,7 @@
           <p:cNvPr id="8" name="">
             <a:extLst xmlns:a="http://schemas.openxmlformats.org/drawingml/2006/main">
               <a:ext uri="{FF2B5EF4-FFF2-40B4-BE49-F238E27FC236}">
-                <a16:creationId xmlns:a16="http://schemas.microsoft.com/office/drawing/2014/main" id="{115D4A48-7F36-45D6-B791-43860F138A1F}"/>
+                <a16:creationId xmlns:a16="http://schemas.microsoft.com/office/drawing/2014/main" id="{62B93BDB-911E-4F74-A256-867E8BC5E1B0}"/>
               </a:ext>
             </a:extLst>
           </p:cNvPr>
@@ -19467,7 +18816,7 @@
           <p:cNvPr id="9" name="">
             <a:extLst xmlns:a="http://schemas.openxmlformats.org/drawingml/2006/main">
               <a:ext uri="{FF2B5EF4-FFF2-40B4-BE49-F238E27FC236}">
-                <a16:creationId xmlns:a16="http://schemas.microsoft.com/office/drawing/2014/main" id="{CE93CB3C-8E5A-45F2-8C08-87959A376AA4}"/>
+                <a16:creationId xmlns:a16="http://schemas.microsoft.com/office/drawing/2014/main" id="{5828EBE1-6B7A-4CFD-9D76-E2F09467C0E0}"/>
               </a:ext>
             </a:extLst>
           </p:cNvPr>
@@ -19528,7 +18877,7 @@
           <p:cNvPr id="10" name="">
             <a:extLst xmlns:a="http://schemas.openxmlformats.org/drawingml/2006/main">
               <a:ext uri="{FF2B5EF4-FFF2-40B4-BE49-F238E27FC236}">
-                <a16:creationId xmlns:a16="http://schemas.microsoft.com/office/drawing/2014/main" id="{9ADDD7F4-2F44-4177-ACF0-D7162726C13D}"/>
+                <a16:creationId xmlns:a16="http://schemas.microsoft.com/office/drawing/2014/main" id="{5490148A-EF40-489D-B681-7F327EBFEAD1}"/>
               </a:ext>
             </a:extLst>
           </p:cNvPr>
@@ -19589,7 +18938,7 @@
           <p:cNvPr id="11" name="">
             <a:extLst xmlns:a="http://schemas.openxmlformats.org/drawingml/2006/main">
               <a:ext uri="{FF2B5EF4-FFF2-40B4-BE49-F238E27FC236}">
-                <a16:creationId xmlns:a16="http://schemas.microsoft.com/office/drawing/2014/main" id="{A1C0E789-FFD4-475B-9E91-A32DF329E420}"/>
+                <a16:creationId xmlns:a16="http://schemas.microsoft.com/office/drawing/2014/main" id="{CEB99B4C-4259-4720-BE99-308C71EED729}"/>
               </a:ext>
             </a:extLst>
           </p:cNvPr>
@@ -19648,7 +18997,7 @@
     </p:spTree>
     <p:extLst>
       <p:ext uri="{BB962C8B-B14F-4D97-AF65-F5344CB8AC3E}">
-        <p14:creationId xmlns:p14="http://schemas.microsoft.com/office/powerpoint/2010/main" val="1875746454"/>
+        <p14:creationId xmlns:p14="http://schemas.microsoft.com/office/powerpoint/2010/main" val="815530905"/>
       </p:ext>
     </p:extLst>
   </p:cSld>
@@ -19679,7 +19028,7 @@
           <p:cNvPr id="14" name="">
             <a:extLst xmlns:a="http://schemas.openxmlformats.org/drawingml/2006/main">
               <a:ext uri="{FF2B5EF4-FFF2-40B4-BE49-F238E27FC236}">
-                <a16:creationId xmlns:a16="http://schemas.microsoft.com/office/drawing/2014/main" id="{78E65447-D358-47E3-AF7E-F4B623C1C241}"/>
+                <a16:creationId xmlns:a16="http://schemas.microsoft.com/office/drawing/2014/main" id="{B4F8B1FA-C656-4765-87AF-B76162902C74}"/>
               </a:ext>
             </a:extLst>
           </p:cNvPr>
@@ -19740,7 +19089,7 @@
           <p:cNvPr id="2" name="">
             <a:extLst xmlns:a="http://schemas.openxmlformats.org/drawingml/2006/main">
               <a:ext uri="{FF2B5EF4-FFF2-40B4-BE49-F238E27FC236}">
-                <a16:creationId xmlns:a16="http://schemas.microsoft.com/office/drawing/2014/main" id="{0F56793D-A5F8-4D85-B322-AD51B1E74F58}"/>
+                <a16:creationId xmlns:a16="http://schemas.microsoft.com/office/drawing/2014/main" id="{1BB851F5-E1FA-4482-88CE-CE0628367E99}"/>
               </a:ext>
             </a:extLst>
           </p:cNvPr>
@@ -19801,7 +19150,7 @@
           <p:cNvPr id="3" name="">
             <a:extLst xmlns:a="http://schemas.openxmlformats.org/drawingml/2006/main">
               <a:ext uri="{FF2B5EF4-FFF2-40B4-BE49-F238E27FC236}">
-                <a16:creationId xmlns:a16="http://schemas.microsoft.com/office/drawing/2014/main" id="{18B72FEA-74FF-4500-A94F-B7EE00DB382B}"/>
+                <a16:creationId xmlns:a16="http://schemas.microsoft.com/office/drawing/2014/main" id="{64FCD7F1-728F-4532-BD25-3E441A8C9A41}"/>
               </a:ext>
             </a:extLst>
           </p:cNvPr>
@@ -19862,7 +19211,7 @@
           <p:cNvPr id="4" name="">
             <a:extLst xmlns:a="http://schemas.openxmlformats.org/drawingml/2006/main">
               <a:ext uri="{FF2B5EF4-FFF2-40B4-BE49-F238E27FC236}">
-                <a16:creationId xmlns:a16="http://schemas.microsoft.com/office/drawing/2014/main" id="{3B8536F6-B70C-47B8-BBBB-97D8360761B4}"/>
+                <a16:creationId xmlns:a16="http://schemas.microsoft.com/office/drawing/2014/main" id="{0E95CA7C-7F98-4840-AA30-1E6A9AA1A4DB}"/>
               </a:ext>
             </a:extLst>
           </p:cNvPr>
@@ -19923,7 +19272,7 @@
           <p:cNvPr id="5" name="">
             <a:extLst xmlns:a="http://schemas.openxmlformats.org/drawingml/2006/main">
               <a:ext uri="{FF2B5EF4-FFF2-40B4-BE49-F238E27FC236}">
-                <a16:creationId xmlns:a16="http://schemas.microsoft.com/office/drawing/2014/main" id="{A86C5996-9B3D-452D-82B0-6E0F91F7AB45}"/>
+                <a16:creationId xmlns:a16="http://schemas.microsoft.com/office/drawing/2014/main" id="{FDF34AC4-7633-46AB-81D1-BF79DB66C800}"/>
               </a:ext>
             </a:extLst>
           </p:cNvPr>
@@ -19984,7 +19333,7 @@
           <p:cNvPr id="6" name="">
             <a:extLst xmlns:a="http://schemas.openxmlformats.org/drawingml/2006/main">
               <a:ext uri="{FF2B5EF4-FFF2-40B4-BE49-F238E27FC236}">
-                <a16:creationId xmlns:a16="http://schemas.microsoft.com/office/drawing/2014/main" id="{B2C92EC3-6094-4B5B-A453-A68C5900CC55}"/>
+                <a16:creationId xmlns:a16="http://schemas.microsoft.com/office/drawing/2014/main" id="{222F2204-FC87-4EB0-B967-AAFDEF251A5B}"/>
               </a:ext>
             </a:extLst>
           </p:cNvPr>
@@ -20016,7 +19365,7 @@
           <p:cNvPr id="7" name="">
             <a:extLst xmlns:a="http://schemas.openxmlformats.org/drawingml/2006/main">
               <a:ext uri="{FF2B5EF4-FFF2-40B4-BE49-F238E27FC236}">
-                <a16:creationId xmlns:a16="http://schemas.microsoft.com/office/drawing/2014/main" id="{7ED1DB14-509B-4381-9650-136E377D9F4C}"/>
+                <a16:creationId xmlns:a16="http://schemas.microsoft.com/office/drawing/2014/main" id="{5F80ADB9-48E5-4F39-8570-9CBCA3AD1033}"/>
               </a:ext>
             </a:extLst>
           </p:cNvPr>
@@ -20048,7 +19397,7 @@
           <p:cNvPr id="8" name="">
             <a:extLst xmlns:a="http://schemas.openxmlformats.org/drawingml/2006/main">
               <a:ext uri="{FF2B5EF4-FFF2-40B4-BE49-F238E27FC236}">
-                <a16:creationId xmlns:a16="http://schemas.microsoft.com/office/drawing/2014/main" id="{9683E143-B854-4928-91E3-761C0861CC2F}"/>
+                <a16:creationId xmlns:a16="http://schemas.microsoft.com/office/drawing/2014/main" id="{B4496A40-4139-4C26-891D-BE3CFEED9557}"/>
               </a:ext>
             </a:extLst>
           </p:cNvPr>
@@ -20080,7 +19429,7 @@
           <p:cNvPr id="9" name="">
             <a:extLst xmlns:a="http://schemas.openxmlformats.org/drawingml/2006/main">
               <a:ext uri="{FF2B5EF4-FFF2-40B4-BE49-F238E27FC236}">
-                <a16:creationId xmlns:a16="http://schemas.microsoft.com/office/drawing/2014/main" id="{BC1EACFF-D90B-4AFB-B479-83021C4F5B63}"/>
+                <a16:creationId xmlns:a16="http://schemas.microsoft.com/office/drawing/2014/main" id="{9D905997-8785-4FBC-AF60-0A2D5D30E9CA}"/>
               </a:ext>
             </a:extLst>
           </p:cNvPr>
@@ -20141,7 +19490,7 @@
           <p:cNvPr id="10" name="">
             <a:extLst xmlns:a="http://schemas.openxmlformats.org/drawingml/2006/main">
               <a:ext uri="{FF2B5EF4-FFF2-40B4-BE49-F238E27FC236}">
-                <a16:creationId xmlns:a16="http://schemas.microsoft.com/office/drawing/2014/main" id="{48C5F9A7-A120-4B53-B6C2-FB72DCB734AB}"/>
+                <a16:creationId xmlns:a16="http://schemas.microsoft.com/office/drawing/2014/main" id="{6B592814-DD55-4E8B-9C3D-8BA7C747EA77}"/>
               </a:ext>
             </a:extLst>
           </p:cNvPr>
@@ -20229,7 +19578,7 @@
           <p:cNvPr id="11" name="">
             <a:extLst xmlns:a="http://schemas.openxmlformats.org/drawingml/2006/main">
               <a:ext uri="{FF2B5EF4-FFF2-40B4-BE49-F238E27FC236}">
-                <a16:creationId xmlns:a16="http://schemas.microsoft.com/office/drawing/2014/main" id="{792214B2-6180-4122-A16C-F19362D3D38A}"/>
+                <a16:creationId xmlns:a16="http://schemas.microsoft.com/office/drawing/2014/main" id="{EEC9FCF9-D010-47DF-8855-995605F381AF}"/>
               </a:ext>
             </a:extLst>
           </p:cNvPr>
@@ -20290,7 +19639,7 @@
           <p:cNvPr id="12" name="">
             <a:extLst xmlns:a="http://schemas.openxmlformats.org/drawingml/2006/main">
               <a:ext uri="{FF2B5EF4-FFF2-40B4-BE49-F238E27FC236}">
-                <a16:creationId xmlns:a16="http://schemas.microsoft.com/office/drawing/2014/main" id="{7F4406B7-8368-4B86-BF0C-C8647E8F7E8F}"/>
+                <a16:creationId xmlns:a16="http://schemas.microsoft.com/office/drawing/2014/main" id="{43B9D45E-7290-449D-9FE9-FBD7084A9D33}"/>
               </a:ext>
             </a:extLst>
           </p:cNvPr>
@@ -20378,7 +19727,7 @@
           <p:cNvPr id="13" name="">
             <a:extLst xmlns:a="http://schemas.openxmlformats.org/drawingml/2006/main">
               <a:ext uri="{FF2B5EF4-FFF2-40B4-BE49-F238E27FC236}">
-                <a16:creationId xmlns:a16="http://schemas.microsoft.com/office/drawing/2014/main" id="{FC7CCF4E-7279-4FEA-9DD8-5EFD04F4E2D0}"/>
+                <a16:creationId xmlns:a16="http://schemas.microsoft.com/office/drawing/2014/main" id="{F9812D13-416B-46A0-BC8C-CC4BF53759F5}"/>
               </a:ext>
             </a:extLst>
           </p:cNvPr>
@@ -20437,7 +19786,7 @@
     </p:spTree>
     <p:extLst>
       <p:ext uri="{BB962C8B-B14F-4D97-AF65-F5344CB8AC3E}">
-        <p14:creationId xmlns:p14="http://schemas.microsoft.com/office/powerpoint/2010/main" val="1660085693"/>
+        <p14:creationId xmlns:p14="http://schemas.microsoft.com/office/powerpoint/2010/main" val="517670401"/>
       </p:ext>
     </p:extLst>
   </p:cSld>

</xml_diff>

<commit_message>
Deck: typeset every equation with LaTeX
Matrices were written on one line with bracket glyphs. Equations are now
LaTeX: rendered to images for the PowerPoint, native math in the Markdown.

Co-Authored-By: Claude Fable 5.1 <noreply@anthropic.com>
</commit_message>
<xml_diff>
--- a/public/slides/session-0-least-squares-foundations.pptx
+++ b/public/slides/session-0-least-squares-foundations.pptx
@@ -3480,59 +3480,30 @@
           </a:prstGeom>
         </p:spPr>
       </p:pic>
-      <p:sp>
-        <p:nvSpPr>
-          <p:cNvPr id="6" name="Rectangle 5"/>
-          <p:cNvSpPr/>
-          <p:nvPr/>
-        </p:nvSpPr>
-        <p:spPr>
-          <a:xfrm>
-            <a:off x="685800" y="1600200"/>
-            <a:ext cx="5882335" cy="640080"/>
-          </a:xfrm>
-          <a:prstGeom prst="rect">
-            <a:avLst/>
-          </a:prstGeom>
-          <a:solidFill>
-            <a:srgbClr val="F6ECD6"/>
-          </a:solidFill>
-          <a:ln>
-            <a:noFill/>
-          </a:ln>
-          <a:effectLst/>
-        </p:spPr>
-        <p:style>
-          <a:lnRef idx="1">
-            <a:schemeClr val="accent1"/>
-          </a:lnRef>
-          <a:fillRef idx="3">
-            <a:schemeClr val="accent1"/>
-          </a:fillRef>
-          <a:effectRef idx="2">
-            <a:schemeClr val="accent1"/>
-          </a:effectRef>
-          <a:fontRef idx="minor">
-            <a:schemeClr val="lt1"/>
-          </a:fontRef>
-        </p:style>
-        <p:txBody>
-          <a:bodyPr rtlCol="0" anchor="ctr" wrap="square"/>
-          <a:lstStyle/>
-          <a:p>
-            <a:pPr algn="ctr"/>
-            <a:r>
-              <a:rPr sz="2000">
-                <a:solidFill>
-                  <a:srgbClr val="24282E"/>
-                </a:solidFill>
-                <a:latin typeface="Cambria Math"/>
-              </a:rPr>
-              <a:t>x₁ᵀx₂ = ‖x₁‖ ‖x₂‖ cos θ = cos θ = r</a:t>
-            </a:r>
-          </a:p>
-        </p:txBody>
-      </p:sp>
+      <p:pic>
+        <p:nvPicPr>
+          <p:cNvPr id="6" name="Picture 5" descr="eq07.png"/>
+          <p:cNvPicPr>
+            <a:picLocks noChangeAspect="1"/>
+          </p:cNvPicPr>
+          <p:nvPr/>
+        </p:nvPicPr>
+        <p:blipFill>
+          <a:blip r:embed="rId3"/>
+          <a:stretch>
+            <a:fillRect/>
+          </a:stretch>
+        </p:blipFill>
+        <p:spPr>
+          <a:xfrm>
+            <a:off x="1624431" y="1600200"/>
+            <a:ext cx="4005072" cy="676656"/>
+          </a:xfrm>
+          <a:prstGeom prst="rect">
+            <a:avLst/>
+          </a:prstGeom>
+        </p:spPr>
+      </p:pic>
       <p:sp>
         <p:nvSpPr>
           <p:cNvPr id="7" name="TextBox 6"/>
@@ -3541,8 +3512,8 @@
         </p:nvSpPr>
         <p:spPr>
           <a:xfrm>
-            <a:off x="685800" y="2514600"/>
-            <a:ext cx="5882335" cy="3611880"/>
+            <a:off x="685800" y="2551176"/>
+            <a:ext cx="5882335" cy="3575304"/>
           </a:xfrm>
           <a:prstGeom prst="rect">
             <a:avLst/>
@@ -3820,63 +3791,30 @@
           </a:p>
         </p:txBody>
       </p:sp>
-      <p:sp>
-        <p:nvSpPr>
-          <p:cNvPr id="5" name="Rectangle 4"/>
-          <p:cNvSpPr/>
-          <p:nvPr/>
-        </p:nvSpPr>
-        <p:spPr>
-          <a:xfrm>
-            <a:off x="685800" y="1600200"/>
-            <a:ext cx="10820095" cy="658368"/>
-          </a:xfrm>
-          <a:prstGeom prst="rect">
-            <a:avLst/>
-          </a:prstGeom>
-          <a:solidFill>
-            <a:srgbClr val="F6ECD6"/>
-          </a:solidFill>
-          <a:ln>
-            <a:noFill/>
-          </a:ln>
-          <a:effectLst/>
-        </p:spPr>
-        <p:style>
-          <a:lnRef idx="1">
-            <a:schemeClr val="accent1"/>
-          </a:lnRef>
-          <a:fillRef idx="3">
-            <a:schemeClr val="accent1"/>
-          </a:fillRef>
-          <a:effectRef idx="2">
-            <a:schemeClr val="accent1"/>
-          </a:effectRef>
-          <a:fontRef idx="minor">
-            <a:schemeClr val="lt1"/>
-          </a:fontRef>
-        </p:style>
-        <p:txBody>
-          <a:bodyPr rtlCol="0" anchor="ctr" wrap="square"/>
-          <a:lstStyle/>
-          <a:p>
-            <a:pPr algn="ctr">
-              <a:lnSpc>
-                <a:spcPct val="100000"/>
-              </a:lnSpc>
-            </a:pPr>
-            <a:r>
-              <a:rPr sz="2400">
-                <a:solidFill>
-                  <a:srgbClr val="24282E"/>
-                </a:solidFill>
-                <a:latin typeface="Cambria Math"/>
-              </a:rPr>
-              <a:t>XᵀX = ⎛ 1   r ⎞ ⎝ r   1 ⎠ = ⎛ 1      0.913 ⎞ ⎝ 0.913   1  ⎠</a:t>
-            </a:r>
-          </a:p>
-        </p:txBody>
-      </p:sp>
+      <p:pic>
+        <p:nvPicPr>
+          <p:cNvPr id="5" name="Picture 4" descr="eq08.png"/>
+          <p:cNvPicPr>
+            <a:picLocks noChangeAspect="1"/>
+          </p:cNvPicPr>
+          <p:nvPr/>
+        </p:nvPicPr>
+        <p:blipFill>
+          <a:blip r:embed="rId2"/>
+          <a:stretch>
+            <a:fillRect/>
+          </a:stretch>
+        </p:blipFill>
+        <p:spPr>
+          <a:xfrm>
+            <a:off x="3960723" y="1600200"/>
+            <a:ext cx="4270248" cy="1069848"/>
+          </a:xfrm>
+          <a:prstGeom prst="rect">
+            <a:avLst/>
+          </a:prstGeom>
+        </p:spPr>
+      </p:pic>
       <p:sp>
         <p:nvSpPr>
           <p:cNvPr id="6" name="TextBox 5"/>
@@ -3885,8 +3823,8 @@
         </p:nvSpPr>
         <p:spPr>
           <a:xfrm>
-            <a:off x="685800" y="2578608"/>
-            <a:ext cx="10820095" cy="3456432"/>
+            <a:off x="685800" y="2990088"/>
+            <a:ext cx="10820095" cy="3044952"/>
           </a:xfrm>
           <a:prstGeom prst="rect">
             <a:avLst/>
@@ -4160,59 +4098,30 @@
           </a:prstGeom>
         </p:spPr>
       </p:pic>
-      <p:sp>
-        <p:nvSpPr>
-          <p:cNvPr id="6" name="Rectangle 5"/>
-          <p:cNvSpPr/>
-          <p:nvPr/>
-        </p:nvSpPr>
-        <p:spPr>
-          <a:xfrm>
-            <a:off x="685800" y="1600200"/>
-            <a:ext cx="5882335" cy="640080"/>
-          </a:xfrm>
-          <a:prstGeom prst="rect">
-            <a:avLst/>
-          </a:prstGeom>
-          <a:solidFill>
-            <a:srgbClr val="F6ECD6"/>
-          </a:solidFill>
-          <a:ln>
-            <a:noFill/>
-          </a:ln>
-          <a:effectLst/>
-        </p:spPr>
-        <p:style>
-          <a:lnRef idx="1">
-            <a:schemeClr val="accent1"/>
-          </a:lnRef>
-          <a:fillRef idx="3">
-            <a:schemeClr val="accent1"/>
-          </a:fillRef>
-          <a:effectRef idx="2">
-            <a:schemeClr val="accent1"/>
-          </a:effectRef>
-          <a:fontRef idx="minor">
-            <a:schemeClr val="lt1"/>
-          </a:fontRef>
-        </p:style>
-        <p:txBody>
-          <a:bodyPr rtlCol="0" anchor="ctr" wrap="square"/>
-          <a:lstStyle/>
-          <a:p>
-            <a:pPr algn="ctr"/>
-            <a:r>
-              <a:rPr sz="2000">
-                <a:solidFill>
-                  <a:srgbClr val="24282E"/>
-                </a:solidFill>
-                <a:latin typeface="Cambria Math"/>
-              </a:rPr>
-              <a:t>XᵀX = PΛPᵀ,   XᵀX pⱼ = λⱼ pⱼ</a:t>
-            </a:r>
-          </a:p>
-        </p:txBody>
-      </p:sp>
+      <p:pic>
+        <p:nvPicPr>
+          <p:cNvPr id="6" name="Picture 5" descr="eq09.png"/>
+          <p:cNvPicPr>
+            <a:picLocks noChangeAspect="1"/>
+          </p:cNvPicPr>
+          <p:nvPr/>
+        </p:nvPicPr>
+        <p:blipFill>
+          <a:blip r:embed="rId3"/>
+          <a:stretch>
+            <a:fillRect/>
+          </a:stretch>
+        </p:blipFill>
+        <p:spPr>
+          <a:xfrm>
+            <a:off x="1505559" y="1600200"/>
+            <a:ext cx="4242816" cy="685800"/>
+          </a:xfrm>
+          <a:prstGeom prst="rect">
+            <a:avLst/>
+          </a:prstGeom>
+        </p:spPr>
+      </p:pic>
       <p:sp>
         <p:nvSpPr>
           <p:cNvPr id="7" name="TextBox 6"/>
@@ -4221,8 +4130,8 @@
         </p:nvSpPr>
         <p:spPr>
           <a:xfrm>
-            <a:off x="685800" y="2514600"/>
-            <a:ext cx="5882335" cy="3611880"/>
+            <a:off x="685800" y="2560320"/>
+            <a:ext cx="5882335" cy="3566160"/>
           </a:xfrm>
           <a:prstGeom prst="rect">
             <a:avLst/>
@@ -4500,63 +4409,30 @@
           </a:p>
         </p:txBody>
       </p:sp>
-      <p:sp>
-        <p:nvSpPr>
-          <p:cNvPr id="5" name="Rectangle 4"/>
-          <p:cNvSpPr/>
-          <p:nvPr/>
-        </p:nvSpPr>
-        <p:spPr>
-          <a:xfrm>
-            <a:off x="685800" y="1600200"/>
-            <a:ext cx="10820095" cy="658368"/>
-          </a:xfrm>
-          <a:prstGeom prst="rect">
-            <a:avLst/>
-          </a:prstGeom>
-          <a:solidFill>
-            <a:srgbClr val="F6ECD6"/>
-          </a:solidFill>
-          <a:ln>
-            <a:noFill/>
-          </a:ln>
-          <a:effectLst/>
-        </p:spPr>
-        <p:style>
-          <a:lnRef idx="1">
-            <a:schemeClr val="accent1"/>
-          </a:lnRef>
-          <a:fillRef idx="3">
-            <a:schemeClr val="accent1"/>
-          </a:fillRef>
-          <a:effectRef idx="2">
-            <a:schemeClr val="accent1"/>
-          </a:effectRef>
-          <a:fontRef idx="minor">
-            <a:schemeClr val="lt1"/>
-          </a:fontRef>
-        </p:style>
-        <p:txBody>
-          <a:bodyPr rtlCol="0" anchor="ctr" wrap="square"/>
-          <a:lstStyle/>
-          <a:p>
-            <a:pPr algn="ctr">
-              <a:lnSpc>
-                <a:spcPct val="100000"/>
-              </a:lnSpc>
-            </a:pPr>
-            <a:r>
-              <a:rPr sz="2400">
-                <a:solidFill>
-                  <a:srgbClr val="24282E"/>
-                </a:solidFill>
-                <a:latin typeface="Cambria Math"/>
-              </a:rPr>
-              <a:t>E[ε | X] = 0,        Cov(ε | X) = σ² I</a:t>
-            </a:r>
-          </a:p>
-        </p:txBody>
-      </p:sp>
+      <p:pic>
+        <p:nvPicPr>
+          <p:cNvPr id="5" name="Picture 4" descr="eq10.png"/>
+          <p:cNvPicPr>
+            <a:picLocks noChangeAspect="1"/>
+          </p:cNvPicPr>
+          <p:nvPr/>
+        </p:nvPicPr>
+        <p:blipFill>
+          <a:blip r:embed="rId2"/>
+          <a:stretch>
+            <a:fillRect/>
+          </a:stretch>
+        </p:blipFill>
+        <p:spPr>
+          <a:xfrm>
+            <a:off x="3869283" y="1600200"/>
+            <a:ext cx="4453128" cy="694944"/>
+          </a:xfrm>
+          <a:prstGeom prst="rect">
+            <a:avLst/>
+          </a:prstGeom>
+        </p:spPr>
+      </p:pic>
       <p:sp>
         <p:nvSpPr>
           <p:cNvPr id="6" name="TextBox 5"/>
@@ -4565,8 +4441,8 @@
         </p:nvSpPr>
         <p:spPr>
           <a:xfrm>
-            <a:off x="685800" y="2578608"/>
-            <a:ext cx="10820095" cy="3456432"/>
+            <a:off x="685800" y="2615184"/>
+            <a:ext cx="10820095" cy="3419856"/>
           </a:xfrm>
           <a:prstGeom prst="rect">
             <a:avLst/>
@@ -4816,63 +4692,30 @@
           </a:p>
         </p:txBody>
       </p:sp>
-      <p:sp>
-        <p:nvSpPr>
-          <p:cNvPr id="5" name="Rectangle 4"/>
-          <p:cNvSpPr/>
-          <p:nvPr/>
-        </p:nvSpPr>
-        <p:spPr>
-          <a:xfrm>
-            <a:off x="685800" y="1600200"/>
-            <a:ext cx="10820095" cy="658368"/>
-          </a:xfrm>
-          <a:prstGeom prst="rect">
-            <a:avLst/>
-          </a:prstGeom>
-          <a:solidFill>
-            <a:srgbClr val="F6ECD6"/>
-          </a:solidFill>
-          <a:ln>
-            <a:noFill/>
-          </a:ln>
-          <a:effectLst/>
-        </p:spPr>
-        <p:style>
-          <a:lnRef idx="1">
-            <a:schemeClr val="accent1"/>
-          </a:lnRef>
-          <a:fillRef idx="3">
-            <a:schemeClr val="accent1"/>
-          </a:fillRef>
-          <a:effectRef idx="2">
-            <a:schemeClr val="accent1"/>
-          </a:effectRef>
-          <a:fontRef idx="minor">
-            <a:schemeClr val="lt1"/>
-          </a:fontRef>
-        </p:style>
-        <p:txBody>
-          <a:bodyPr rtlCol="0" anchor="ctr" wrap="square"/>
-          <a:lstStyle/>
-          <a:p>
-            <a:pPr algn="ctr">
-              <a:lnSpc>
-                <a:spcPct val="100000"/>
-              </a:lnSpc>
-            </a:pPr>
-            <a:r>
-              <a:rPr sz="2400">
-                <a:solidFill>
-                  <a:srgbClr val="24282E"/>
-                </a:solidFill>
-                <a:latin typeface="Cambria Math"/>
-              </a:rPr>
-              <a:t>β̂ = arg min ‖Y − Xβ‖²   ⟹   XᵀX β̂ = XᵀY   ⟹   β̂ = (XᵀX)⁻¹ XᵀY</a:t>
-            </a:r>
-          </a:p>
-        </p:txBody>
-      </p:sp>
+      <p:pic>
+        <p:nvPicPr>
+          <p:cNvPr id="5" name="Picture 4" descr="eq11.png"/>
+          <p:cNvPicPr>
+            <a:picLocks noChangeAspect="1"/>
+          </p:cNvPicPr>
+          <p:nvPr/>
+        </p:nvPicPr>
+        <p:blipFill>
+          <a:blip r:embed="rId2"/>
+          <a:stretch>
+            <a:fillRect/>
+          </a:stretch>
+        </p:blipFill>
+        <p:spPr>
+          <a:xfrm>
+            <a:off x="1715871" y="1600200"/>
+            <a:ext cx="8759952" cy="745236"/>
+          </a:xfrm>
+          <a:prstGeom prst="rect">
+            <a:avLst/>
+          </a:prstGeom>
+        </p:spPr>
+      </p:pic>
       <p:sp>
         <p:nvSpPr>
           <p:cNvPr id="6" name="TextBox 5"/>
@@ -4881,8 +4724,8 @@
         </p:nvSpPr>
         <p:spPr>
           <a:xfrm>
-            <a:off x="685800" y="2578608"/>
-            <a:ext cx="10820095" cy="3456432"/>
+            <a:off x="685800" y="2665476"/>
+            <a:ext cx="10820095" cy="3369564"/>
           </a:xfrm>
           <a:prstGeom prst="rect">
             <a:avLst/>
@@ -5160,63 +5003,30 @@
           </a:p>
         </p:txBody>
       </p:sp>
-      <p:sp>
-        <p:nvSpPr>
-          <p:cNvPr id="5" name="Rectangle 4"/>
-          <p:cNvSpPr/>
-          <p:nvPr/>
-        </p:nvSpPr>
-        <p:spPr>
-          <a:xfrm>
-            <a:off x="685800" y="1600200"/>
-            <a:ext cx="10820095" cy="658368"/>
-          </a:xfrm>
-          <a:prstGeom prst="rect">
-            <a:avLst/>
-          </a:prstGeom>
-          <a:solidFill>
-            <a:srgbClr val="F6ECD6"/>
-          </a:solidFill>
-          <a:ln>
-            <a:noFill/>
-          </a:ln>
-          <a:effectLst/>
-        </p:spPr>
-        <p:style>
-          <a:lnRef idx="1">
-            <a:schemeClr val="accent1"/>
-          </a:lnRef>
-          <a:fillRef idx="3">
-            <a:schemeClr val="accent1"/>
-          </a:fillRef>
-          <a:effectRef idx="2">
-            <a:schemeClr val="accent1"/>
-          </a:effectRef>
-          <a:fontRef idx="minor">
-            <a:schemeClr val="lt1"/>
-          </a:fontRef>
-        </p:style>
-        <p:txBody>
-          <a:bodyPr rtlCol="0" anchor="ctr" wrap="square"/>
-          <a:lstStyle/>
-          <a:p>
-            <a:pPr algn="ctr">
-              <a:lnSpc>
-                <a:spcPct val="100000"/>
-              </a:lnSpc>
-            </a:pPr>
-            <a:r>
-              <a:rPr sz="2400">
-                <a:solidFill>
-                  <a:srgbClr val="24282E"/>
-                </a:solidFill>
-                <a:latin typeface="Cambria Math"/>
-              </a:rPr>
-              <a:t>vᵀ XᵀX v = (Xv)ᵀ(Xv) = ‖Xv‖² ≥ 0</a:t>
-            </a:r>
-          </a:p>
-        </p:txBody>
-      </p:sp>
+      <p:pic>
+        <p:nvPicPr>
+          <p:cNvPr id="5" name="Picture 4" descr="eq12.png"/>
+          <p:cNvPicPr>
+            <a:picLocks noChangeAspect="1"/>
+          </p:cNvPicPr>
+          <p:nvPr/>
+        </p:nvPicPr>
+        <p:blipFill>
+          <a:blip r:embed="rId2"/>
+          <a:stretch>
+            <a:fillRect/>
+          </a:stretch>
+        </p:blipFill>
+        <p:spPr>
+          <a:xfrm>
+            <a:off x="3693261" y="1600200"/>
+            <a:ext cx="4805172" cy="704088"/>
+          </a:xfrm>
+          <a:prstGeom prst="rect">
+            <a:avLst/>
+          </a:prstGeom>
+        </p:spPr>
+      </p:pic>
       <p:sp>
         <p:nvSpPr>
           <p:cNvPr id="6" name="TextBox 5"/>
@@ -5225,8 +5035,8 @@
         </p:nvSpPr>
         <p:spPr>
           <a:xfrm>
-            <a:off x="685800" y="2578608"/>
-            <a:ext cx="10820095" cy="3456432"/>
+            <a:off x="685800" y="2624328"/>
+            <a:ext cx="10820095" cy="3410712"/>
           </a:xfrm>
           <a:prstGeom prst="rect">
             <a:avLst/>
@@ -5476,63 +5286,30 @@
           </a:p>
         </p:txBody>
       </p:sp>
-      <p:sp>
-        <p:nvSpPr>
-          <p:cNvPr id="5" name="Rectangle 4"/>
-          <p:cNvSpPr/>
-          <p:nvPr/>
-        </p:nvSpPr>
-        <p:spPr>
-          <a:xfrm>
-            <a:off x="685800" y="1600200"/>
-            <a:ext cx="10820095" cy="658368"/>
-          </a:xfrm>
-          <a:prstGeom prst="rect">
-            <a:avLst/>
-          </a:prstGeom>
-          <a:solidFill>
-            <a:srgbClr val="F6ECD6"/>
-          </a:solidFill>
-          <a:ln>
-            <a:noFill/>
-          </a:ln>
-          <a:effectLst/>
-        </p:spPr>
-        <p:style>
-          <a:lnRef idx="1">
-            <a:schemeClr val="accent1"/>
-          </a:lnRef>
-          <a:fillRef idx="3">
-            <a:schemeClr val="accent1"/>
-          </a:fillRef>
-          <a:effectRef idx="2">
-            <a:schemeClr val="accent1"/>
-          </a:effectRef>
-          <a:fontRef idx="minor">
-            <a:schemeClr val="lt1"/>
-          </a:fontRef>
-        </p:style>
-        <p:txBody>
-          <a:bodyPr rtlCol="0" anchor="ctr" wrap="square"/>
-          <a:lstStyle/>
-          <a:p>
-            <a:pPr algn="ctr">
-              <a:lnSpc>
-                <a:spcPct val="100000"/>
-              </a:lnSpc>
-            </a:pPr>
-            <a:r>
-              <a:rPr sz="2400">
-                <a:solidFill>
-                  <a:srgbClr val="24282E"/>
-                </a:solidFill>
-                <a:latin typeface="Cambria Math"/>
-              </a:rPr>
-              <a:t>β̂ = (XᵀX)⁻¹Xᵀ(Xβ + ε) = β + (XᵀX)⁻¹Xᵀ ε</a:t>
-            </a:r>
-          </a:p>
-        </p:txBody>
-      </p:sp>
+      <p:pic>
+        <p:nvPicPr>
+          <p:cNvPr id="5" name="Picture 4" descr="eq13.png"/>
+          <p:cNvPicPr>
+            <a:picLocks noChangeAspect="1"/>
+          </p:cNvPicPr>
+          <p:nvPr/>
+        </p:nvPicPr>
+        <p:blipFill>
+          <a:blip r:embed="rId2"/>
+          <a:stretch>
+            <a:fillRect/>
+          </a:stretch>
+        </p:blipFill>
+        <p:spPr>
+          <a:xfrm>
+            <a:off x="3101187" y="1600200"/>
+            <a:ext cx="5989320" cy="736092"/>
+          </a:xfrm>
+          <a:prstGeom prst="rect">
+            <a:avLst/>
+          </a:prstGeom>
+        </p:spPr>
+      </p:pic>
       <p:sp>
         <p:nvSpPr>
           <p:cNvPr id="6" name="TextBox 5"/>
@@ -5541,8 +5318,8 @@
         </p:nvSpPr>
         <p:spPr>
           <a:xfrm>
-            <a:off x="685800" y="2578608"/>
-            <a:ext cx="10820095" cy="3456432"/>
+            <a:off x="685800" y="2656332"/>
+            <a:ext cx="10820095" cy="3378708"/>
           </a:xfrm>
           <a:prstGeom prst="rect">
             <a:avLst/>
@@ -5792,63 +5569,30 @@
           </a:p>
         </p:txBody>
       </p:sp>
-      <p:sp>
-        <p:nvSpPr>
-          <p:cNvPr id="5" name="Rectangle 4"/>
-          <p:cNvSpPr/>
-          <p:nvPr/>
-        </p:nvSpPr>
-        <p:spPr>
-          <a:xfrm>
-            <a:off x="685800" y="1600200"/>
-            <a:ext cx="10820095" cy="658368"/>
-          </a:xfrm>
-          <a:prstGeom prst="rect">
-            <a:avLst/>
-          </a:prstGeom>
-          <a:solidFill>
-            <a:srgbClr val="F6ECD6"/>
-          </a:solidFill>
-          <a:ln>
-            <a:noFill/>
-          </a:ln>
-          <a:effectLst/>
-        </p:spPr>
-        <p:style>
-          <a:lnRef idx="1">
-            <a:schemeClr val="accent1"/>
-          </a:lnRef>
-          <a:fillRef idx="3">
-            <a:schemeClr val="accent1"/>
-          </a:fillRef>
-          <a:effectRef idx="2">
-            <a:schemeClr val="accent1"/>
-          </a:effectRef>
-          <a:fontRef idx="minor">
-            <a:schemeClr val="lt1"/>
-          </a:fontRef>
-        </p:style>
-        <p:txBody>
-          <a:bodyPr rtlCol="0" anchor="ctr" wrap="square"/>
-          <a:lstStyle/>
-          <a:p>
-            <a:pPr algn="ctr">
-              <a:lnSpc>
-                <a:spcPct val="100000"/>
-              </a:lnSpc>
-            </a:pPr>
-            <a:r>
-              <a:rPr sz="2400">
-                <a:solidFill>
-                  <a:srgbClr val="24282E"/>
-                </a:solidFill>
-                <a:latin typeface="Cambria Math"/>
-              </a:rPr>
-              <a:t>E[β̂ | X] = β,        Cov(β̂ | X) = σ² (XᵀX)⁻¹</a:t>
-            </a:r>
-          </a:p>
-        </p:txBody>
-      </p:sp>
+      <p:pic>
+        <p:nvPicPr>
+          <p:cNvPr id="5" name="Picture 4" descr="eq14.png"/>
+          <p:cNvPicPr>
+            <a:picLocks noChangeAspect="1"/>
+          </p:cNvPicPr>
+          <p:nvPr/>
+        </p:nvPicPr>
+        <p:blipFill>
+          <a:blip r:embed="rId2"/>
+          <a:stretch>
+            <a:fillRect/>
+          </a:stretch>
+        </p:blipFill>
+        <p:spPr>
+          <a:xfrm>
+            <a:off x="3318357" y="1600200"/>
+            <a:ext cx="5554980" cy="736092"/>
+          </a:xfrm>
+          <a:prstGeom prst="rect">
+            <a:avLst/>
+          </a:prstGeom>
+        </p:spPr>
+      </p:pic>
       <p:sp>
         <p:nvSpPr>
           <p:cNvPr id="6" name="TextBox 5"/>
@@ -5857,8 +5601,8 @@
         </p:nvSpPr>
         <p:spPr>
           <a:xfrm>
-            <a:off x="685800" y="2578608"/>
-            <a:ext cx="10820095" cy="3456432"/>
+            <a:off x="685800" y="2656332"/>
+            <a:ext cx="10820095" cy="3378708"/>
           </a:xfrm>
           <a:prstGeom prst="rect">
             <a:avLst/>
@@ -6160,59 +5904,30 @@
           </a:prstGeom>
         </p:spPr>
       </p:pic>
-      <p:sp>
-        <p:nvSpPr>
-          <p:cNvPr id="6" name="Rectangle 5"/>
-          <p:cNvSpPr/>
-          <p:nvPr/>
-        </p:nvSpPr>
+      <p:pic>
+        <p:nvPicPr>
+          <p:cNvPr id="6" name="Picture 5" descr="eq15.png"/>
+          <p:cNvPicPr>
+            <a:picLocks noChangeAspect="1"/>
+          </p:cNvPicPr>
+          <p:nvPr/>
+        </p:nvPicPr>
+        <p:blipFill>
+          <a:blip r:embed="rId3"/>
+          <a:stretch>
+            <a:fillRect/>
+          </a:stretch>
+        </p:blipFill>
         <p:spPr>
           <a:xfrm>
             <a:off x="7772400" y="1600200"/>
-            <a:ext cx="3733495" cy="640080"/>
-          </a:xfrm>
-          <a:prstGeom prst="rect">
-            <a:avLst/>
-          </a:prstGeom>
-          <a:solidFill>
-            <a:srgbClr val="F6ECD6"/>
-          </a:solidFill>
-          <a:ln>
-            <a:noFill/>
-          </a:ln>
-          <a:effectLst/>
-        </p:spPr>
-        <p:style>
-          <a:lnRef idx="1">
-            <a:schemeClr val="accent1"/>
-          </a:lnRef>
-          <a:fillRef idx="3">
-            <a:schemeClr val="accent1"/>
-          </a:fillRef>
-          <a:effectRef idx="2">
-            <a:schemeClr val="accent1"/>
-          </a:effectRef>
-          <a:fontRef idx="minor">
-            <a:schemeClr val="lt1"/>
-          </a:fontRef>
-        </p:style>
-        <p:txBody>
-          <a:bodyPr rtlCol="0" anchor="ctr" wrap="square"/>
-          <a:lstStyle/>
-          <a:p>
-            <a:pPr algn="ctr"/>
-            <a:r>
-              <a:rPr sz="1600">
-                <a:solidFill>
-                  <a:srgbClr val="24282E"/>
-                </a:solidFill>
-                <a:latin typeface="Cambria Math"/>
-              </a:rPr>
-              <a:t>MSE(β̃) = E‖β̃ − β‖² = tr Cov(β̃) + ‖bias(β̃)‖²</a:t>
-            </a:r>
-          </a:p>
-        </p:txBody>
-      </p:sp>
+            <a:ext cx="3733495" cy="510384"/>
+          </a:xfrm>
+          <a:prstGeom prst="rect">
+            <a:avLst/>
+          </a:prstGeom>
+        </p:spPr>
+      </p:pic>
       <p:sp>
         <p:nvSpPr>
           <p:cNvPr id="7" name="TextBox 6"/>
@@ -6221,8 +5936,8 @@
         </p:nvSpPr>
         <p:spPr>
           <a:xfrm>
-            <a:off x="7772400" y="2468880"/>
-            <a:ext cx="3733495" cy="3749040"/>
+            <a:off x="7772400" y="2339184"/>
+            <a:ext cx="3733495" cy="3878736"/>
           </a:xfrm>
           <a:prstGeom prst="rect">
             <a:avLst/>
@@ -6444,63 +6159,30 @@
           </a:p>
         </p:txBody>
       </p:sp>
-      <p:sp>
-        <p:nvSpPr>
-          <p:cNvPr id="5" name="Rectangle 4"/>
-          <p:cNvSpPr/>
-          <p:nvPr/>
-        </p:nvSpPr>
-        <p:spPr>
-          <a:xfrm>
-            <a:off x="685800" y="1600200"/>
-            <a:ext cx="10820095" cy="658368"/>
-          </a:xfrm>
-          <a:prstGeom prst="rect">
-            <a:avLst/>
-          </a:prstGeom>
-          <a:solidFill>
-            <a:srgbClr val="F6ECD6"/>
-          </a:solidFill>
-          <a:ln>
-            <a:noFill/>
-          </a:ln>
-          <a:effectLst/>
-        </p:spPr>
-        <p:style>
-          <a:lnRef idx="1">
-            <a:schemeClr val="accent1"/>
-          </a:lnRef>
-          <a:fillRef idx="3">
-            <a:schemeClr val="accent1"/>
-          </a:fillRef>
-          <a:effectRef idx="2">
-            <a:schemeClr val="accent1"/>
-          </a:effectRef>
-          <a:fontRef idx="minor">
-            <a:schemeClr val="lt1"/>
-          </a:fontRef>
-        </p:style>
-        <p:txBody>
-          <a:bodyPr rtlCol="0" anchor="ctr" wrap="square"/>
-          <a:lstStyle/>
-          <a:p>
-            <a:pPr algn="ctr">
-              <a:lnSpc>
-                <a:spcPct val="100000"/>
-              </a:lnSpc>
-            </a:pPr>
-            <a:r>
-              <a:rPr sz="2400">
-                <a:solidFill>
-                  <a:srgbClr val="24282E"/>
-                </a:solidFill>
-                <a:latin typeface="Cambria Math"/>
-              </a:rPr>
-              <a:t>Cov(β̃ | X) − Cov(β̂ | X) ⪰ 0   for every β̃ that is linear in Y and unbiased</a:t>
-            </a:r>
-          </a:p>
-        </p:txBody>
-      </p:sp>
+      <p:pic>
+        <p:nvPicPr>
+          <p:cNvPr id="5" name="Picture 4" descr="eq16.png"/>
+          <p:cNvPicPr>
+            <a:picLocks noChangeAspect="1"/>
+          </p:cNvPicPr>
+          <p:nvPr/>
+        </p:nvPicPr>
+        <p:blipFill>
+          <a:blip r:embed="rId2"/>
+          <a:stretch>
+            <a:fillRect/>
+          </a:stretch>
+        </p:blipFill>
+        <p:spPr>
+          <a:xfrm>
+            <a:off x="2067915" y="1600200"/>
+            <a:ext cx="8055864" cy="736092"/>
+          </a:xfrm>
+          <a:prstGeom prst="rect">
+            <a:avLst/>
+          </a:prstGeom>
+        </p:spPr>
+      </p:pic>
       <p:sp>
         <p:nvSpPr>
           <p:cNvPr id="6" name="TextBox 5"/>
@@ -6509,8 +6191,8 @@
         </p:nvSpPr>
         <p:spPr>
           <a:xfrm>
-            <a:off x="685800" y="2578608"/>
-            <a:ext cx="10820095" cy="3456432"/>
+            <a:off x="685800" y="2656332"/>
+            <a:ext cx="10820095" cy="3378708"/>
           </a:xfrm>
           <a:prstGeom prst="rect">
             <a:avLst/>
@@ -7159,63 +6841,30 @@
           </a:p>
         </p:txBody>
       </p:sp>
-      <p:sp>
-        <p:nvSpPr>
-          <p:cNvPr id="5" name="Rectangle 4"/>
-          <p:cNvSpPr/>
-          <p:nvPr/>
-        </p:nvSpPr>
-        <p:spPr>
-          <a:xfrm>
-            <a:off x="685800" y="1600200"/>
-            <a:ext cx="10820095" cy="658368"/>
-          </a:xfrm>
-          <a:prstGeom prst="rect">
-            <a:avLst/>
-          </a:prstGeom>
-          <a:solidFill>
-            <a:srgbClr val="F6ECD6"/>
-          </a:solidFill>
-          <a:ln>
-            <a:noFill/>
-          </a:ln>
-          <a:effectLst/>
-        </p:spPr>
-        <p:style>
-          <a:lnRef idx="1">
-            <a:schemeClr val="accent1"/>
-          </a:lnRef>
-          <a:fillRef idx="3">
-            <a:schemeClr val="accent1"/>
-          </a:fillRef>
-          <a:effectRef idx="2">
-            <a:schemeClr val="accent1"/>
-          </a:effectRef>
-          <a:fontRef idx="minor">
-            <a:schemeClr val="lt1"/>
-          </a:fontRef>
-        </p:style>
-        <p:txBody>
-          <a:bodyPr rtlCol="0" anchor="ctr" wrap="square"/>
-          <a:lstStyle/>
-          <a:p>
-            <a:pPr algn="ctr">
-              <a:lnSpc>
-                <a:spcPct val="100000"/>
-              </a:lnSpc>
-            </a:pPr>
-            <a:r>
-              <a:rPr sz="2400">
-                <a:solidFill>
-                  <a:srgbClr val="24282E"/>
-                </a:solidFill>
-                <a:latin typeface="Cambria Math"/>
-              </a:rPr>
-              <a:t>β̂ = (XᵀX)⁻¹XᵀY        β̂(k) = (XᵀX + kI)⁻¹XᵀY,  k &gt; 0</a:t>
-            </a:r>
-          </a:p>
-        </p:txBody>
-      </p:sp>
+      <p:pic>
+        <p:nvPicPr>
+          <p:cNvPr id="5" name="Picture 4" descr="eq17.png"/>
+          <p:cNvPicPr>
+            <a:picLocks noChangeAspect="1"/>
+          </p:cNvPicPr>
+          <p:nvPr/>
+        </p:nvPicPr>
+        <p:blipFill>
+          <a:blip r:embed="rId2"/>
+          <a:stretch>
+            <a:fillRect/>
+          </a:stretch>
+        </p:blipFill>
+        <p:spPr>
+          <a:xfrm>
+            <a:off x="2143353" y="1600200"/>
+            <a:ext cx="7904988" cy="736092"/>
+          </a:xfrm>
+          <a:prstGeom prst="rect">
+            <a:avLst/>
+          </a:prstGeom>
+        </p:spPr>
+      </p:pic>
       <p:sp>
         <p:nvSpPr>
           <p:cNvPr id="6" name="TextBox 5"/>
@@ -7224,8 +6873,8 @@
         </p:nvSpPr>
         <p:spPr>
           <a:xfrm>
-            <a:off x="685800" y="2578608"/>
-            <a:ext cx="10820095" cy="3456432"/>
+            <a:off x="685800" y="2656332"/>
+            <a:ext cx="10820095" cy="3378708"/>
           </a:xfrm>
           <a:prstGeom prst="rect">
             <a:avLst/>
@@ -9064,63 +8713,30 @@
           </a:p>
         </p:txBody>
       </p:sp>
-      <p:sp>
-        <p:nvSpPr>
-          <p:cNvPr id="5" name="Rectangle 4"/>
-          <p:cNvSpPr/>
-          <p:nvPr/>
-        </p:nvSpPr>
-        <p:spPr>
-          <a:xfrm>
-            <a:off x="685800" y="1600200"/>
-            <a:ext cx="10820095" cy="658368"/>
-          </a:xfrm>
-          <a:prstGeom prst="rect">
-            <a:avLst/>
-          </a:prstGeom>
-          <a:solidFill>
-            <a:srgbClr val="F6ECD6"/>
-          </a:solidFill>
-          <a:ln>
-            <a:noFill/>
-          </a:ln>
-          <a:effectLst/>
-        </p:spPr>
-        <p:style>
-          <a:lnRef idx="1">
-            <a:schemeClr val="accent1"/>
-          </a:lnRef>
-          <a:fillRef idx="3">
-            <a:schemeClr val="accent1"/>
-          </a:fillRef>
-          <a:effectRef idx="2">
-            <a:schemeClr val="accent1"/>
-          </a:effectRef>
-          <a:fontRef idx="minor">
-            <a:schemeClr val="lt1"/>
-          </a:fontRef>
-        </p:style>
-        <p:txBody>
-          <a:bodyPr rtlCol="0" anchor="ctr" wrap="square"/>
-          <a:lstStyle/>
-          <a:p>
-            <a:pPr algn="ctr">
-              <a:lnSpc>
-                <a:spcPct val="100000"/>
-              </a:lnSpc>
-            </a:pPr>
-            <a:r>
-              <a:rPr sz="2400">
-                <a:solidFill>
-                  <a:srgbClr val="24282E"/>
-                </a:solidFill>
-                <a:latin typeface="Cambria Math"/>
-              </a:rPr>
-              <a:t>fuelᵢ  =  β₁ · weightᵢ  +  β₂ · horsepowerᵢ  +  εᵢ</a:t>
-            </a:r>
-          </a:p>
-        </p:txBody>
-      </p:sp>
+      <p:pic>
+        <p:nvPicPr>
+          <p:cNvPr id="5" name="Picture 4" descr="eq01.png"/>
+          <p:cNvPicPr>
+            <a:picLocks noChangeAspect="1"/>
+          </p:cNvPicPr>
+          <p:nvPr/>
+        </p:nvPicPr>
+        <p:blipFill>
+          <a:blip r:embed="rId2"/>
+          <a:stretch>
+            <a:fillRect/>
+          </a:stretch>
+        </p:blipFill>
+        <p:spPr>
+          <a:xfrm>
+            <a:off x="3734409" y="1600200"/>
+            <a:ext cx="4722876" cy="658368"/>
+          </a:xfrm>
+          <a:prstGeom prst="rect">
+            <a:avLst/>
+          </a:prstGeom>
+        </p:spPr>
+      </p:pic>
       <p:sp>
         <p:nvSpPr>
           <p:cNvPr id="6" name="TextBox 5"/>
@@ -9382,7 +8998,7 @@
       </p:sp>
       <p:pic>
         <p:nvPicPr>
-          <p:cNvPr id="5" name="Picture 4" descr="matrix.png"/>
+          <p:cNvPr id="5" name="Picture 4" descr="eq02.png"/>
           <p:cNvPicPr>
             <a:picLocks noChangeAspect="1"/>
           </p:cNvPicPr>
@@ -9396,8 +9012,8 @@
         </p:blipFill>
         <p:spPr>
           <a:xfrm>
-            <a:off x="2804007" y="1600200"/>
-            <a:ext cx="6583680" cy="2103120"/>
+            <a:off x="3922618" y="1600200"/>
+            <a:ext cx="4346459" cy="2377440"/>
           </a:xfrm>
           <a:prstGeom prst="rect">
             <a:avLst/>
@@ -9406,71 +9022,14 @@
       </p:pic>
       <p:sp>
         <p:nvSpPr>
-          <p:cNvPr id="6" name="Rectangle 5"/>
-          <p:cNvSpPr/>
-          <p:nvPr/>
-        </p:nvSpPr>
-        <p:spPr>
-          <a:xfrm>
-            <a:off x="685800" y="4023360"/>
-            <a:ext cx="10820095" cy="658368"/>
-          </a:xfrm>
-          <a:prstGeom prst="rect">
-            <a:avLst/>
-          </a:prstGeom>
-          <a:solidFill>
-            <a:srgbClr val="F6ECD6"/>
-          </a:solidFill>
-          <a:ln>
-            <a:noFill/>
-          </a:ln>
-          <a:effectLst/>
-        </p:spPr>
-        <p:style>
-          <a:lnRef idx="1">
-            <a:schemeClr val="accent1"/>
-          </a:lnRef>
-          <a:fillRef idx="3">
-            <a:schemeClr val="accent1"/>
-          </a:fillRef>
-          <a:effectRef idx="2">
-            <a:schemeClr val="accent1"/>
-          </a:effectRef>
-          <a:fontRef idx="minor">
-            <a:schemeClr val="lt1"/>
-          </a:fontRef>
-        </p:style>
-        <p:txBody>
-          <a:bodyPr rtlCol="0" anchor="ctr" wrap="square"/>
-          <a:lstStyle/>
-          <a:p>
-            <a:pPr algn="ctr">
-              <a:lnSpc>
-                <a:spcPct val="100000"/>
-              </a:lnSpc>
-            </a:pPr>
-            <a:r>
-              <a:rPr sz="2200">
-                <a:solidFill>
-                  <a:srgbClr val="24282E"/>
-                </a:solidFill>
-                <a:latin typeface="Cambria Math"/>
-              </a:rPr>
-              <a:t>Y = Xβ + ε</a:t>
-            </a:r>
-          </a:p>
-        </p:txBody>
-      </p:sp>
-      <p:sp>
-        <p:nvSpPr>
-          <p:cNvPr id="7" name="TextBox 6"/>
+          <p:cNvPr id="6" name="TextBox 5"/>
           <p:cNvSpPr txBox="1"/>
           <p:nvPr/>
         </p:nvSpPr>
         <p:spPr>
           <a:xfrm>
-            <a:off x="685800" y="4956048"/>
-            <a:ext cx="10820095" cy="1353312"/>
+            <a:off x="685800" y="4297680"/>
+            <a:ext cx="10820095" cy="1737360"/>
           </a:xfrm>
           <a:prstGeom prst="rect">
             <a:avLst/>
@@ -9492,7 +9051,7 @@
               </a:spcAft>
             </a:pPr>
             <a:r>
-              <a:rPr sz="1800" b="1">
+              <a:rPr sz="1900" b="1">
                 <a:solidFill>
                   <a:srgbClr val="A8710A"/>
                 </a:solidFill>
@@ -9501,7 +9060,7 @@
               <a:t>•  </a:t>
             </a:r>
             <a:r>
-              <a:rPr sz="1800">
+              <a:rPr sz="1900">
                 <a:solidFill>
                   <a:srgbClr val="24282E"/>
                 </a:solidFill>
@@ -9520,7 +9079,7 @@
               </a:spcAft>
             </a:pPr>
             <a:r>
-              <a:rPr sz="1800" b="1">
+              <a:rPr sz="1900" b="1">
                 <a:solidFill>
                   <a:srgbClr val="A8710A"/>
                 </a:solidFill>
@@ -9529,7 +9088,7 @@
               <a:t>•  </a:t>
             </a:r>
             <a:r>
-              <a:rPr sz="1800">
+              <a:rPr sz="1900">
                 <a:solidFill>
                   <a:srgbClr val="24282E"/>
                 </a:solidFill>
@@ -9692,63 +9251,30 @@
           </a:p>
         </p:txBody>
       </p:sp>
-      <p:sp>
-        <p:nvSpPr>
-          <p:cNvPr id="5" name="Rectangle 4"/>
-          <p:cNvSpPr/>
-          <p:nvPr/>
-        </p:nvSpPr>
-        <p:spPr>
-          <a:xfrm>
-            <a:off x="685800" y="1600200"/>
-            <a:ext cx="10820095" cy="658368"/>
-          </a:xfrm>
-          <a:prstGeom prst="rect">
-            <a:avLst/>
-          </a:prstGeom>
-          <a:solidFill>
-            <a:srgbClr val="F6ECD6"/>
-          </a:solidFill>
-          <a:ln>
-            <a:noFill/>
-          </a:ln>
-          <a:effectLst/>
-        </p:spPr>
-        <p:style>
-          <a:lnRef idx="1">
-            <a:schemeClr val="accent1"/>
-          </a:lnRef>
-          <a:fillRef idx="3">
-            <a:schemeClr val="accent1"/>
-          </a:fillRef>
-          <a:effectRef idx="2">
-            <a:schemeClr val="accent1"/>
-          </a:effectRef>
-          <a:fontRef idx="minor">
-            <a:schemeClr val="lt1"/>
-          </a:fontRef>
-        </p:style>
-        <p:txBody>
-          <a:bodyPr rtlCol="0" anchor="ctr" wrap="square"/>
-          <a:lstStyle/>
-          <a:p>
-            <a:pPr algn="ctr">
-              <a:lnSpc>
-                <a:spcPct val="100000"/>
-              </a:lnSpc>
-            </a:pPr>
-            <a:r>
-              <a:rPr sz="2400">
-                <a:solidFill>
-                  <a:srgbClr val="24282E"/>
-                </a:solidFill>
-                <a:latin typeface="Cambria Math"/>
-              </a:rPr>
-              <a:t>yᵢ = β₀ + β₁xᵢ₁ + β₂xᵢ₂ + εᵢ</a:t>
-            </a:r>
-          </a:p>
-        </p:txBody>
-      </p:sp>
+      <p:pic>
+        <p:nvPicPr>
+          <p:cNvPr id="5" name="Picture 4" descr="eq03.png"/>
+          <p:cNvPicPr>
+            <a:picLocks noChangeAspect="1"/>
+          </p:cNvPicPr>
+          <p:nvPr/>
+        </p:nvPicPr>
+        <p:blipFill>
+          <a:blip r:embed="rId2"/>
+          <a:stretch>
+            <a:fillRect/>
+          </a:stretch>
+        </p:blipFill>
+        <p:spPr>
+          <a:xfrm>
+            <a:off x="4328769" y="1600200"/>
+            <a:ext cx="3534156" cy="649224"/>
+          </a:xfrm>
+          <a:prstGeom prst="rect">
+            <a:avLst/>
+          </a:prstGeom>
+        </p:spPr>
+      </p:pic>
       <p:sp>
         <p:nvSpPr>
           <p:cNvPr id="6" name="TextBox 5"/>
@@ -9757,8 +9283,8 @@
         </p:nvSpPr>
         <p:spPr>
           <a:xfrm>
-            <a:off x="685800" y="2578608"/>
-            <a:ext cx="10820095" cy="3456432"/>
+            <a:off x="685800" y="2569464"/>
+            <a:ext cx="10820095" cy="3465576"/>
           </a:xfrm>
           <a:prstGeom prst="rect">
             <a:avLst/>
@@ -10032,59 +9558,30 @@
           </a:prstGeom>
         </p:spPr>
       </p:pic>
-      <p:sp>
-        <p:nvSpPr>
-          <p:cNvPr id="6" name="Rectangle 5"/>
-          <p:cNvSpPr/>
-          <p:nvPr/>
-        </p:nvSpPr>
-        <p:spPr>
-          <a:xfrm>
-            <a:off x="7772400" y="1600200"/>
-            <a:ext cx="3733495" cy="640080"/>
-          </a:xfrm>
-          <a:prstGeom prst="rect">
-            <a:avLst/>
-          </a:prstGeom>
-          <a:solidFill>
-            <a:srgbClr val="F6ECD6"/>
-          </a:solidFill>
-          <a:ln>
-            <a:noFill/>
-          </a:ln>
-          <a:effectLst/>
-        </p:spPr>
-        <p:style>
-          <a:lnRef idx="1">
-            <a:schemeClr val="accent1"/>
-          </a:lnRef>
-          <a:fillRef idx="3">
-            <a:schemeClr val="accent1"/>
-          </a:fillRef>
-          <a:effectRef idx="2">
-            <a:schemeClr val="accent1"/>
-          </a:effectRef>
-          <a:fontRef idx="minor">
-            <a:schemeClr val="lt1"/>
-          </a:fontRef>
-        </p:style>
-        <p:txBody>
-          <a:bodyPr rtlCol="0" anchor="ctr" wrap="square"/>
-          <a:lstStyle/>
-          <a:p>
-            <a:pPr algn="ctr"/>
-            <a:r>
-              <a:rPr sz="1600">
-                <a:solidFill>
-                  <a:srgbClr val="24282E"/>
-                </a:solidFill>
-                <a:latin typeface="Cambria Math"/>
-              </a:rPr>
-              <a:t>x̄ = (1.4, 110),   xᵢⱼ ↦ xᵢⱼ − x̄ⱼ</a:t>
-            </a:r>
-          </a:p>
-        </p:txBody>
-      </p:sp>
+      <p:pic>
+        <p:nvPicPr>
+          <p:cNvPr id="6" name="Picture 5" descr="eq04.png"/>
+          <p:cNvPicPr>
+            <a:picLocks noChangeAspect="1"/>
+          </p:cNvPicPr>
+          <p:nvPr/>
+        </p:nvPicPr>
+        <p:blipFill>
+          <a:blip r:embed="rId3"/>
+          <a:stretch>
+            <a:fillRect/>
+          </a:stretch>
+        </p:blipFill>
+        <p:spPr>
+          <a:xfrm>
+            <a:off x="7853781" y="1600200"/>
+            <a:ext cx="3570732" cy="635508"/>
+          </a:xfrm>
+          <a:prstGeom prst="rect">
+            <a:avLst/>
+          </a:prstGeom>
+        </p:spPr>
+      </p:pic>
       <p:sp>
         <p:nvSpPr>
           <p:cNvPr id="7" name="TextBox 6"/>
@@ -10093,8 +9590,8 @@
         </p:nvSpPr>
         <p:spPr>
           <a:xfrm>
-            <a:off x="7772400" y="2468880"/>
-            <a:ext cx="3733495" cy="3749040"/>
+            <a:off x="7772400" y="2464308"/>
+            <a:ext cx="3733495" cy="3753612"/>
           </a:xfrm>
           <a:prstGeom prst="rect">
             <a:avLst/>
@@ -10344,63 +9841,30 @@
           </a:p>
         </p:txBody>
       </p:sp>
-      <p:sp>
-        <p:nvSpPr>
-          <p:cNvPr id="5" name="Rectangle 4"/>
-          <p:cNvSpPr/>
-          <p:nvPr/>
-        </p:nvSpPr>
-        <p:spPr>
-          <a:xfrm>
-            <a:off x="685800" y="1600200"/>
-            <a:ext cx="10820095" cy="658368"/>
-          </a:xfrm>
-          <a:prstGeom prst="rect">
-            <a:avLst/>
-          </a:prstGeom>
-          <a:solidFill>
-            <a:srgbClr val="F6ECD6"/>
-          </a:solidFill>
-          <a:ln>
-            <a:noFill/>
-          </a:ln>
-          <a:effectLst/>
-        </p:spPr>
-        <p:style>
-          <a:lnRef idx="1">
-            <a:schemeClr val="accent1"/>
-          </a:lnRef>
-          <a:fillRef idx="3">
-            <a:schemeClr val="accent1"/>
-          </a:fillRef>
-          <a:effectRef idx="2">
-            <a:schemeClr val="accent1"/>
-          </a:effectRef>
-          <a:fontRef idx="minor">
-            <a:schemeClr val="lt1"/>
-          </a:fontRef>
-        </p:style>
-        <p:txBody>
-          <a:bodyPr rtlCol="0" anchor="ctr" wrap="square"/>
-          <a:lstStyle/>
-          <a:p>
-            <a:pPr algn="ctr">
-              <a:lnSpc>
-                <a:spcPct val="100000"/>
-              </a:lnSpc>
-            </a:pPr>
-            <a:r>
-              <a:rPr sz="2400">
-                <a:solidFill>
-                  <a:srgbClr val="24282E"/>
-                </a:solidFill>
-                <a:latin typeface="Cambria Math"/>
-              </a:rPr>
-              <a:t>β̂₀ = ȳ − β̂₁x̄₁ − β̂₂x̄₂</a:t>
-            </a:r>
-          </a:p>
-        </p:txBody>
-      </p:sp>
+      <p:pic>
+        <p:nvPicPr>
+          <p:cNvPr id="5" name="Picture 4" descr="eq05.png"/>
+          <p:cNvPicPr>
+            <a:picLocks noChangeAspect="1"/>
+          </p:cNvPicPr>
+          <p:nvPr/>
+        </p:nvPicPr>
+        <p:blipFill>
+          <a:blip r:embed="rId2"/>
+          <a:stretch>
+            <a:fillRect/>
+          </a:stretch>
+        </p:blipFill>
+        <p:spPr>
+          <a:xfrm>
+            <a:off x="4669383" y="1600200"/>
+            <a:ext cx="2852928" cy="722376"/>
+          </a:xfrm>
+          <a:prstGeom prst="rect">
+            <a:avLst/>
+          </a:prstGeom>
+        </p:spPr>
+      </p:pic>
       <p:sp>
         <p:nvSpPr>
           <p:cNvPr id="6" name="TextBox 5"/>
@@ -10409,8 +9873,8 @@
         </p:nvSpPr>
         <p:spPr>
           <a:xfrm>
-            <a:off x="685800" y="2578608"/>
-            <a:ext cx="10820095" cy="3456432"/>
+            <a:off x="685800" y="2642616"/>
+            <a:ext cx="10820095" cy="3392424"/>
           </a:xfrm>
           <a:prstGeom prst="rect">
             <a:avLst/>
@@ -10688,63 +10152,30 @@
           </a:p>
         </p:txBody>
       </p:sp>
-      <p:sp>
-        <p:nvSpPr>
-          <p:cNvPr id="5" name="Rectangle 4"/>
-          <p:cNvSpPr/>
-          <p:nvPr/>
-        </p:nvSpPr>
-        <p:spPr>
-          <a:xfrm>
-            <a:off x="685800" y="1600200"/>
-            <a:ext cx="10820095" cy="658368"/>
-          </a:xfrm>
-          <a:prstGeom prst="rect">
-            <a:avLst/>
-          </a:prstGeom>
-          <a:solidFill>
-            <a:srgbClr val="F6ECD6"/>
-          </a:solidFill>
-          <a:ln>
-            <a:noFill/>
-          </a:ln>
-          <a:effectLst/>
-        </p:spPr>
-        <p:style>
-          <a:lnRef idx="1">
-            <a:schemeClr val="accent1"/>
-          </a:lnRef>
-          <a:fillRef idx="3">
-            <a:schemeClr val="accent1"/>
-          </a:fillRef>
-          <a:effectRef idx="2">
-            <a:schemeClr val="accent1"/>
-          </a:effectRef>
-          <a:fontRef idx="minor">
-            <a:schemeClr val="lt1"/>
-          </a:fontRef>
-        </p:style>
-        <p:txBody>
-          <a:bodyPr rtlCol="0" anchor="ctr" wrap="square"/>
-          <a:lstStyle/>
-          <a:p>
-            <a:pPr algn="ctr">
-              <a:lnSpc>
-                <a:spcPct val="100000"/>
-              </a:lnSpc>
-            </a:pPr>
-            <a:r>
-              <a:rPr sz="2400">
-                <a:solidFill>
-                  <a:srgbClr val="24282E"/>
-                </a:solidFill>
-                <a:latin typeface="Cambria Math"/>
-              </a:rPr>
-              <a:t>X = [ x₁  x₂ ],   x₁, x₂ ∈ ℝ⁵,   XᵀX = ⎛x₁ᵀx₁  x₁ᵀx₂⎞ ⎝x₂ᵀx₁  x₂ᵀx₂⎠</a:t>
-            </a:r>
-          </a:p>
-        </p:txBody>
-      </p:sp>
+      <p:pic>
+        <p:nvPicPr>
+          <p:cNvPr id="5" name="Picture 4" descr="eq06.png"/>
+          <p:cNvPicPr>
+            <a:picLocks noChangeAspect="1"/>
+          </p:cNvPicPr>
+          <p:nvPr/>
+        </p:nvPicPr>
+        <p:blipFill>
+          <a:blip r:embed="rId2"/>
+          <a:stretch>
+            <a:fillRect/>
+          </a:stretch>
+        </p:blipFill>
+        <p:spPr>
+          <a:xfrm>
+            <a:off x="2648559" y="1600200"/>
+            <a:ext cx="6894576" cy="1074420"/>
+          </a:xfrm>
+          <a:prstGeom prst="rect">
+            <a:avLst/>
+          </a:prstGeom>
+        </p:spPr>
+      </p:pic>
       <p:sp>
         <p:nvSpPr>
           <p:cNvPr id="6" name="TextBox 5"/>
@@ -10753,8 +10184,8 @@
         </p:nvSpPr>
         <p:spPr>
           <a:xfrm>
-            <a:off x="685800" y="2578608"/>
-            <a:ext cx="10820095" cy="3456432"/>
+            <a:off x="685800" y="2994660"/>
+            <a:ext cx="10820095" cy="3040380"/>
           </a:xfrm>
           <a:prstGeom prst="rect">
             <a:avLst/>

</xml_diff>

<commit_message>
Deck: add the covariance detour slide from the tutorial
Co-Authored-By: Claude Fable 5.1 <noreply@anthropic.com>
</commit_message>
<xml_diff>
--- a/public/slides/session-0-least-squares-foundations.pptx
+++ b/public/slides/session-0-least-squares-foundations.pptx
@@ -27,6 +27,7 @@
     <p:sldId id="275" r:id="rId26"/>
     <p:sldId id="276" r:id="rId27"/>
     <p:sldId id="277" r:id="rId28"/>
+    <p:sldId id="278" r:id="rId29"/>
   </p:sldIdLst>
   <p:sldSz cx="12191695" cy="6858000" type="screen4x3"/>
   <p:notesSz cx="6858000" cy="9144000"/>
@@ -3744,7 +3745,7 @@
                 </a:solidFill>
                 <a:latin typeface="Georgia"/>
               </a:rPr>
-              <a:t>XᵀX is the correlation matrix</a:t>
+              <a:t>Why standardize? A detour through covariance</a:t>
             </a:r>
           </a:p>
         </p:txBody>
@@ -3807,8 +3808,8 @@
         </p:blipFill>
         <p:spPr>
           <a:xfrm>
-            <a:off x="3960723" y="1600200"/>
-            <a:ext cx="4270248" cy="1069848"/>
+            <a:off x="2760573" y="1600200"/>
+            <a:ext cx="6670548" cy="827532"/>
           </a:xfrm>
           <a:prstGeom prst="rect">
             <a:avLst/>
@@ -3823,8 +3824,8 @@
         </p:nvSpPr>
         <p:spPr>
           <a:xfrm>
-            <a:off x="685800" y="2990088"/>
-            <a:ext cx="10820095" cy="3044952"/>
+            <a:off x="685800" y="2747772"/>
+            <a:ext cx="10820095" cy="3287268"/>
           </a:xfrm>
           <a:prstGeom prst="rect">
             <a:avLst/>
@@ -3861,7 +3862,7 @@
                 </a:solidFill>
                 <a:latin typeface="Arial"/>
               </a:rPr>
-              <a:t>On the diagonal: squared column lengths, all equal to 1.</a:t>
+              <a:t>Covariance is the crude measure of co-movement: centre, multiply entry by entry, average. For the cars, cov(weight, hp) = 7.0.</a:t>
             </a:r>
           </a:p>
           <a:p>
@@ -3889,7 +3890,7 @@
                 </a:solidFill>
                 <a:latin typeface="Arial"/>
               </a:rPr>
-              <a:t>Off the diagonal: the pairwise correlations.</a:t>
+              <a:t>But 7.0 of what? Tonne-horsepower. Measure weight in grams and the same five cars give 7 000 000. The number carries the ruler.</a:t>
             </a:r>
           </a:p>
           <a:p>
@@ -3917,7 +3918,77 @@
                 </a:solidFill>
                 <a:latin typeface="Arial"/>
               </a:rPr>
-              <a:t>The trace is p, so the eigenvalues always add up to p. They share a fixed budget.</a:t>
+              <a:t>Divide by the standard deviations and the ruler cancels: 7.0 / (0.3162 × 24.238) = 0.913, in tonnes or in grams alike.</a:t>
+            </a:r>
+          </a:p>
+          <a:p>
+            <a:pPr>
+              <a:lnSpc>
+                <a:spcPct val="118000"/>
+              </a:lnSpc>
+              <a:spcAft>
+                <a:spcPts val="900"/>
+              </a:spcAft>
+            </a:pPr>
+            <a:r>
+              <a:rPr sz="1900" b="1">
+                <a:solidFill>
+                  <a:srgbClr val="A8710A"/>
+                </a:solidFill>
+                <a:latin typeface="Arial"/>
+              </a:rPr>
+              <a:t>•  </a:t>
+            </a:r>
+            <a:r>
+              <a:rPr sz="1900">
+                <a:solidFill>
+                  <a:srgbClr val="24282E"/>
+                </a:solidFill>
+                <a:latin typeface="Arial"/>
+              </a:rPr>
+              <a:t>Standardizing does that division once, in advance, on the data. Afterwards a plain dot product already is the correlation.</a:t>
+            </a:r>
+          </a:p>
+        </p:txBody>
+      </p:sp>
+      <p:sp>
+        <p:nvSpPr>
+          <p:cNvPr id="7" name="TextBox 6"/>
+          <p:cNvSpPr txBox="1"/>
+          <p:nvPr/>
+        </p:nvSpPr>
+        <p:spPr>
+          <a:xfrm>
+            <a:off x="685800" y="5943600"/>
+            <a:ext cx="10820095" cy="365760"/>
+          </a:xfrm>
+          <a:prstGeom prst="rect">
+            <a:avLst/>
+          </a:prstGeom>
+          <a:noFill/>
+        </p:spPr>
+        <p:txBody>
+          <a:bodyPr wrap="square" anchor="t" lIns="0" rIns="0" tIns="0" bIns="0">
+            <a:spAutoFit/>
+          </a:bodyPr>
+          <a:lstStyle/>
+          <a:p>
+            <a:pPr algn="l">
+              <a:lnSpc>
+                <a:spcPct val="115000"/>
+              </a:lnSpc>
+              <a:spcAft>
+                <a:spcPts val="0"/>
+              </a:spcAft>
+            </a:pPr>
+            <a:r>
+              <a:rPr sz="1600" b="0">
+                <a:solidFill>
+                  <a:srgbClr val="6B7280"/>
+                </a:solidFill>
+                <a:latin typeface="Georgia"/>
+              </a:rPr>
+              <a:t>That is why the ridge paper assumes standardized columns throughout: XᵀX then needs no units.</a:t>
             </a:r>
           </a:p>
         </p:txBody>
@@ -4027,7 +4098,7 @@
                 </a:solidFill>
                 <a:latin typeface="Georgia"/>
               </a:rPr>
-              <a:t>Eigenvalues: where the information is</a:t>
+              <a:t>XᵀX is the correlation matrix</a:t>
             </a:r>
           </a:p>
         </p:txBody>
@@ -4076,7 +4147,7 @@
       </p:sp>
       <p:pic>
         <p:nvPicPr>
-          <p:cNvPr id="5" name="Picture 4" descr="eigen.png"/>
+          <p:cNvPr id="5" name="Picture 4" descr="eq09.png"/>
           <p:cNvPicPr>
             <a:picLocks noChangeAspect="1"/>
           </p:cNvPicPr>
@@ -4090,48 +4161,24 @@
         </p:blipFill>
         <p:spPr>
           <a:xfrm>
-            <a:off x="7025335" y="1600200"/>
-            <a:ext cx="4480560" cy="4160520"/>
+            <a:off x="3960723" y="1600200"/>
+            <a:ext cx="4270248" cy="1069848"/>
           </a:xfrm>
           <a:prstGeom prst="rect">
             <a:avLst/>
           </a:prstGeom>
         </p:spPr>
       </p:pic>
-      <p:pic>
-        <p:nvPicPr>
-          <p:cNvPr id="6" name="Picture 5" descr="eq09.png"/>
-          <p:cNvPicPr>
-            <a:picLocks noChangeAspect="1"/>
-          </p:cNvPicPr>
-          <p:nvPr/>
-        </p:nvPicPr>
-        <p:blipFill>
-          <a:blip r:embed="rId3"/>
-          <a:stretch>
-            <a:fillRect/>
-          </a:stretch>
-        </p:blipFill>
-        <p:spPr>
-          <a:xfrm>
-            <a:off x="1505559" y="1600200"/>
-            <a:ext cx="4242816" cy="685800"/>
-          </a:xfrm>
-          <a:prstGeom prst="rect">
-            <a:avLst/>
-          </a:prstGeom>
-        </p:spPr>
-      </p:pic>
-      <p:sp>
-        <p:nvSpPr>
-          <p:cNvPr id="7" name="TextBox 6"/>
+      <p:sp>
+        <p:nvSpPr>
+          <p:cNvPr id="6" name="TextBox 5"/>
           <p:cNvSpPr txBox="1"/>
           <p:nvPr/>
         </p:nvSpPr>
         <p:spPr>
           <a:xfrm>
-            <a:off x="685800" y="2560320"/>
-            <a:ext cx="5882335" cy="3566160"/>
+            <a:off x="685800" y="2990088"/>
+            <a:ext cx="10820095" cy="3044952"/>
           </a:xfrm>
           <a:prstGeom prst="rect">
             <a:avLst/>
@@ -4153,7 +4200,7 @@
               </a:spcAft>
             </a:pPr>
             <a:r>
-              <a:rPr sz="1800" b="1">
+              <a:rPr sz="1900" b="1">
                 <a:solidFill>
                   <a:srgbClr val="A8710A"/>
                 </a:solidFill>
@@ -4162,13 +4209,13 @@
               <a:t>•  </a:t>
             </a:r>
             <a:r>
-              <a:rPr sz="1800">
+              <a:rPr sz="1900">
                 <a:solidFill>
                   <a:srgbClr val="24282E"/>
                 </a:solidFill>
                 <a:latin typeface="Arial"/>
               </a:rPr>
-              <a:t>Each eigenvalue is the spread of the data cloud along its eigenvector.</a:t>
+              <a:t>On the diagonal: squared column lengths, all equal to 1.</a:t>
             </a:r>
           </a:p>
           <a:p>
@@ -4181,7 +4228,7 @@
               </a:spcAft>
             </a:pPr>
             <a:r>
-              <a:rPr sz="1800" b="1">
+              <a:rPr sz="1900" b="1">
                 <a:solidFill>
                   <a:srgbClr val="A8710A"/>
                 </a:solidFill>
@@ -4190,13 +4237,13 @@
               <a:t>•  </a:t>
             </a:r>
             <a:r>
-              <a:rPr sz="1800">
+              <a:rPr sz="1900">
                 <a:solidFill>
                   <a:srgbClr val="24282E"/>
                 </a:solidFill>
                 <a:latin typeface="Arial"/>
               </a:rPr>
-              <a:t>For the cars: λ₁ = 1.91 along the diagonal, λ₂ = 0.09 across it. They sum to 2.</a:t>
+              <a:t>Off the diagonal: the pairwise correlations.</a:t>
             </a:r>
           </a:p>
           <a:p>
@@ -4209,7 +4256,7 @@
               </a:spcAft>
             </a:pPr>
             <a:r>
-              <a:rPr sz="1800" b="1">
+              <a:rPr sz="1900" b="1">
                 <a:solidFill>
                   <a:srgbClr val="A8710A"/>
                 </a:solidFill>
@@ -4218,41 +4265,13 @@
               <a:t>•  </a:t>
             </a:r>
             <a:r>
-              <a:rPr sz="1800">
+              <a:rPr sz="1900">
                 <a:solidFill>
                   <a:srgbClr val="24282E"/>
                 </a:solidFill>
                 <a:latin typeface="Arial"/>
               </a:rPr>
-              <a:t>Along the short axis the data barely varies. Whatever the coefficients do in that direction, the data cannot tell.</a:t>
-            </a:r>
-          </a:p>
-          <a:p>
-            <a:pPr>
-              <a:lnSpc>
-                <a:spcPct val="118000"/>
-              </a:lnSpc>
-              <a:spcAft>
-                <a:spcPts val="900"/>
-              </a:spcAft>
-            </a:pPr>
-            <a:r>
-              <a:rPr sz="1800" b="1">
-                <a:solidFill>
-                  <a:srgbClr val="A8710A"/>
-                </a:solidFill>
-                <a:latin typeface="Arial"/>
-              </a:rPr>
-              <a:t>•  </a:t>
-            </a:r>
-            <a:r>
-              <a:rPr sz="1800">
-                <a:solidFill>
-                  <a:srgbClr val="24282E"/>
-                </a:solidFill>
-                <a:latin typeface="Arial"/>
-              </a:rPr>
-              <a:t>Remember the small one. Everything in Session 1 is about 1/λ₂.</a:t>
+              <a:t>The trace is p, so the eigenvalues always add up to p. They share a fixed budget.</a:t>
             </a:r>
           </a:p>
         </p:txBody>
@@ -4362,7 +4381,7 @@
                 </a:solidFill>
                 <a:latin typeface="Georgia"/>
               </a:rPr>
-              <a:t>What we assume about the noise</a:t>
+              <a:t>Eigenvalues: where the information is</a:t>
             </a:r>
           </a:p>
         </p:txBody>
@@ -4411,7 +4430,7 @@
       </p:sp>
       <p:pic>
         <p:nvPicPr>
-          <p:cNvPr id="5" name="Picture 4" descr="eq10.png"/>
+          <p:cNvPr id="5" name="Picture 4" descr="eigen.png"/>
           <p:cNvPicPr>
             <a:picLocks noChangeAspect="1"/>
           </p:cNvPicPr>
@@ -4425,24 +4444,48 @@
         </p:blipFill>
         <p:spPr>
           <a:xfrm>
-            <a:off x="3869283" y="1600200"/>
-            <a:ext cx="4453128" cy="694944"/>
+            <a:off x="7025335" y="1600200"/>
+            <a:ext cx="4480560" cy="4160520"/>
           </a:xfrm>
           <a:prstGeom prst="rect">
             <a:avLst/>
           </a:prstGeom>
         </p:spPr>
       </p:pic>
-      <p:sp>
-        <p:nvSpPr>
-          <p:cNvPr id="6" name="TextBox 5"/>
+      <p:pic>
+        <p:nvPicPr>
+          <p:cNvPr id="6" name="Picture 5" descr="eq10.png"/>
+          <p:cNvPicPr>
+            <a:picLocks noChangeAspect="1"/>
+          </p:cNvPicPr>
+          <p:nvPr/>
+        </p:nvPicPr>
+        <p:blipFill>
+          <a:blip r:embed="rId3"/>
+          <a:stretch>
+            <a:fillRect/>
+          </a:stretch>
+        </p:blipFill>
+        <p:spPr>
+          <a:xfrm>
+            <a:off x="1505559" y="1600200"/>
+            <a:ext cx="4242816" cy="685800"/>
+          </a:xfrm>
+          <a:prstGeom prst="rect">
+            <a:avLst/>
+          </a:prstGeom>
+        </p:spPr>
+      </p:pic>
+      <p:sp>
+        <p:nvSpPr>
+          <p:cNvPr id="7" name="TextBox 6"/>
           <p:cNvSpPr txBox="1"/>
           <p:nvPr/>
         </p:nvSpPr>
         <p:spPr>
           <a:xfrm>
-            <a:off x="685800" y="2615184"/>
-            <a:ext cx="10820095" cy="3419856"/>
+            <a:off x="685800" y="2560320"/>
+            <a:ext cx="5882335" cy="3566160"/>
           </a:xfrm>
           <a:prstGeom prst="rect">
             <a:avLst/>
@@ -4464,7 +4507,7 @@
               </a:spcAft>
             </a:pPr>
             <a:r>
-              <a:rPr sz="1900" b="1">
+              <a:rPr sz="1800" b="1">
                 <a:solidFill>
                   <a:srgbClr val="A8710A"/>
                 </a:solidFill>
@@ -4473,13 +4516,13 @@
               <a:t>•  </a:t>
             </a:r>
             <a:r>
-              <a:rPr sz="1900">
+              <a:rPr sz="1800">
                 <a:solidFill>
                   <a:srgbClr val="24282E"/>
                 </a:solidFill>
                 <a:latin typeface="Arial"/>
               </a:rPr>
-              <a:t>Nothing systematic is left over: on average the model is right.</a:t>
+              <a:t>Each eigenvalue is the spread of the data cloud along its eigenvector.</a:t>
             </a:r>
           </a:p>
           <a:p>
@@ -4492,7 +4535,7 @@
               </a:spcAft>
             </a:pPr>
             <a:r>
-              <a:rPr sz="1900" b="1">
+              <a:rPr sz="1800" b="1">
                 <a:solidFill>
                   <a:srgbClr val="A8710A"/>
                 </a:solidFill>
@@ -4501,13 +4544,13 @@
               <a:t>•  </a:t>
             </a:r>
             <a:r>
-              <a:rPr sz="1900">
+              <a:rPr sz="1800">
                 <a:solidFill>
                   <a:srgbClr val="24282E"/>
                 </a:solidFill>
                 <a:latin typeface="Arial"/>
               </a:rPr>
-              <a:t>Every car has the same error variance, and no two errors are linked.</a:t>
+              <a:t>For the cars: λ₁ = 1.91 along the diagonal, λ₂ = 0.09 across it. They sum to 2.</a:t>
             </a:r>
           </a:p>
           <a:p>
@@ -4520,7 +4563,7 @@
               </a:spcAft>
             </a:pPr>
             <a:r>
-              <a:rPr sz="1900" b="1">
+              <a:rPr sz="1800" b="1">
                 <a:solidFill>
                   <a:srgbClr val="A8710A"/>
                 </a:solidFill>
@@ -4529,13 +4572,41 @@
               <a:t>•  </a:t>
             </a:r>
             <a:r>
-              <a:rPr sz="1900">
+              <a:rPr sz="1800">
                 <a:solidFill>
                   <a:srgbClr val="24282E"/>
                 </a:solidFill>
                 <a:latin typeface="Arial"/>
               </a:rPr>
-              <a:t>That is all. Normality is not needed for anything today.</a:t>
+              <a:t>Along the short axis the data barely varies. Whatever the coefficients do in that direction, the data cannot tell.</a:t>
+            </a:r>
+          </a:p>
+          <a:p>
+            <a:pPr>
+              <a:lnSpc>
+                <a:spcPct val="118000"/>
+              </a:lnSpc>
+              <a:spcAft>
+                <a:spcPts val="900"/>
+              </a:spcAft>
+            </a:pPr>
+            <a:r>
+              <a:rPr sz="1800" b="1">
+                <a:solidFill>
+                  <a:srgbClr val="A8710A"/>
+                </a:solidFill>
+                <a:latin typeface="Arial"/>
+              </a:rPr>
+              <a:t>•  </a:t>
+            </a:r>
+            <a:r>
+              <a:rPr sz="1800">
+                <a:solidFill>
+                  <a:srgbClr val="24282E"/>
+                </a:solidFill>
+                <a:latin typeface="Arial"/>
+              </a:rPr>
+              <a:t>Remember the small one. Everything in Session 1 is about 1/λ₂.</a:t>
             </a:r>
           </a:p>
         </p:txBody>
@@ -4603,7 +4674,7 @@
                 </a:solidFill>
                 <a:latin typeface="Arial"/>
               </a:rPr>
-              <a:t>PART III · WHAT MAKES AN ESTIMATE GOOD</a:t>
+              <a:t>PART II · THE GEOMETRY OF CORRELATION</a:t>
             </a:r>
           </a:p>
         </p:txBody>
@@ -4645,7 +4716,7 @@
                 </a:solidFill>
                 <a:latin typeface="Georgia"/>
               </a:rPr>
-              <a:t>Least squares: make the leftovers small</a:t>
+              <a:t>What we assume about the noise</a:t>
             </a:r>
           </a:p>
         </p:txBody>
@@ -4708,8 +4779,8 @@
         </p:blipFill>
         <p:spPr>
           <a:xfrm>
-            <a:off x="1715871" y="1600200"/>
-            <a:ext cx="8759952" cy="745236"/>
+            <a:off x="3869283" y="1600200"/>
+            <a:ext cx="4453128" cy="694944"/>
           </a:xfrm>
           <a:prstGeom prst="rect">
             <a:avLst/>
@@ -4724,8 +4795,8 @@
         </p:nvSpPr>
         <p:spPr>
           <a:xfrm>
-            <a:off x="685800" y="2665476"/>
-            <a:ext cx="10820095" cy="3369564"/>
+            <a:off x="685800" y="2615184"/>
+            <a:ext cx="10820095" cy="3419856"/>
           </a:xfrm>
           <a:prstGeom prst="rect">
             <a:avLst/>
@@ -4762,7 +4833,7 @@
                 </a:solidFill>
                 <a:latin typeface="Arial"/>
               </a:rPr>
-              <a:t>The objective is the squared length of the residual vector in ℝ⁵.</a:t>
+              <a:t>Nothing systematic is left over: on average the model is right.</a:t>
             </a:r>
           </a:p>
           <a:p>
@@ -4790,7 +4861,7 @@
                 </a:solidFill>
                 <a:latin typeface="Arial"/>
               </a:rPr>
-              <a:t>Its gradient is −2XᵀY + 2XᵀXβ. Setting it to zero gives the normal equations.</a:t>
+              <a:t>Every car has the same error variance, and no two errors are linked.</a:t>
             </a:r>
           </a:p>
           <a:p>
@@ -4818,35 +4889,7 @@
                 </a:solidFill>
                 <a:latin typeface="Arial"/>
               </a:rPr>
-              <a:t>If XᵀX can be inverted, the solution is unique and explicit.</a:t>
-            </a:r>
-          </a:p>
-          <a:p>
-            <a:pPr>
-              <a:lnSpc>
-                <a:spcPct val="118000"/>
-              </a:lnSpc>
-              <a:spcAft>
-                <a:spcPts val="900"/>
-              </a:spcAft>
-            </a:pPr>
-            <a:r>
-              <a:rPr sz="1900" b="1">
-                <a:solidFill>
-                  <a:srgbClr val="A8710A"/>
-                </a:solidFill>
-                <a:latin typeface="Arial"/>
-              </a:rPr>
-              <a:t>•  </a:t>
-            </a:r>
-            <a:r>
-              <a:rPr sz="1900">
-                <a:solidFill>
-                  <a:srgbClr val="24282E"/>
-                </a:solidFill>
-                <a:latin typeface="Arial"/>
-              </a:rPr>
-              <a:t>Everything about β̂ is decided by that inverse.</a:t>
+              <a:t>That is all. Normality is not needed for anything today.</a:t>
             </a:r>
           </a:p>
         </p:txBody>
@@ -4956,7 +4999,7 @@
                 </a:solidFill>
                 <a:latin typeface="Georgia"/>
               </a:rPr>
-              <a:t>When can XᵀX be inverted?</a:t>
+              <a:t>Least squares: make the leftovers small</a:t>
             </a:r>
           </a:p>
         </p:txBody>
@@ -5019,8 +5062,8 @@
         </p:blipFill>
         <p:spPr>
           <a:xfrm>
-            <a:off x="3693261" y="1600200"/>
-            <a:ext cx="4805172" cy="704088"/>
+            <a:off x="1715871" y="1600200"/>
+            <a:ext cx="8759952" cy="745236"/>
           </a:xfrm>
           <a:prstGeom prst="rect">
             <a:avLst/>
@@ -5035,8 +5078,8 @@
         </p:nvSpPr>
         <p:spPr>
           <a:xfrm>
-            <a:off x="685800" y="2624328"/>
-            <a:ext cx="10820095" cy="3410712"/>
+            <a:off x="685800" y="2665476"/>
+            <a:ext cx="10820095" cy="3369564"/>
           </a:xfrm>
           <a:prstGeom prst="rect">
             <a:avLst/>
@@ -5073,7 +5116,7 @@
                 </a:solidFill>
                 <a:latin typeface="Arial"/>
               </a:rPr>
-              <a:t>So XᵀX is positive semidefinite for any X.</a:t>
+              <a:t>The objective is the squared length of the residual vector in ℝ⁵.</a:t>
             </a:r>
           </a:p>
           <a:p>
@@ -5101,7 +5144,7 @@
                 </a:solidFill>
                 <a:latin typeface="Arial"/>
               </a:rPr>
-              <a:t>If the columns are linearly independent, Xv ≠ 0 whenever v ≠ 0, the quadratic form is strictly positive, and the inverse exists.</a:t>
+              <a:t>Its gradient is −2XᵀY + 2XᵀXβ. Setting it to zero gives the normal equations.</a:t>
             </a:r>
           </a:p>
           <a:p>
@@ -5129,7 +5172,35 @@
                 </a:solidFill>
                 <a:latin typeface="Arial"/>
               </a:rPr>
-              <a:t>Nearly dependent columns keep the inverse but make it enormous. That is the ridge paper's whole subject.</a:t>
+              <a:t>If XᵀX can be inverted, the solution is unique and explicit.</a:t>
+            </a:r>
+          </a:p>
+          <a:p>
+            <a:pPr>
+              <a:lnSpc>
+                <a:spcPct val="118000"/>
+              </a:lnSpc>
+              <a:spcAft>
+                <a:spcPts val="900"/>
+              </a:spcAft>
+            </a:pPr>
+            <a:r>
+              <a:rPr sz="1900" b="1">
+                <a:solidFill>
+                  <a:srgbClr val="A8710A"/>
+                </a:solidFill>
+                <a:latin typeface="Arial"/>
+              </a:rPr>
+              <a:t>•  </a:t>
+            </a:r>
+            <a:r>
+              <a:rPr sz="1900">
+                <a:solidFill>
+                  <a:srgbClr val="24282E"/>
+                </a:solidFill>
+                <a:latin typeface="Arial"/>
+              </a:rPr>
+              <a:t>Everything about β̂ is decided by that inverse.</a:t>
             </a:r>
           </a:p>
         </p:txBody>
@@ -5239,7 +5310,7 @@
                 </a:solidFill>
                 <a:latin typeface="Georgia"/>
               </a:rPr>
-              <a:t>The estimate is a random variable</a:t>
+              <a:t>When can XᵀX be inverted?</a:t>
             </a:r>
           </a:p>
         </p:txBody>
@@ -5302,8 +5373,8 @@
         </p:blipFill>
         <p:spPr>
           <a:xfrm>
-            <a:off x="3101187" y="1600200"/>
-            <a:ext cx="5989320" cy="736092"/>
+            <a:off x="3693261" y="1600200"/>
+            <a:ext cx="4805172" cy="704088"/>
           </a:xfrm>
           <a:prstGeom prst="rect">
             <a:avLst/>
@@ -5318,8 +5389,8 @@
         </p:nvSpPr>
         <p:spPr>
           <a:xfrm>
-            <a:off x="685800" y="2656332"/>
-            <a:ext cx="10820095" cy="3378708"/>
+            <a:off x="685800" y="2624328"/>
+            <a:ext cx="10820095" cy="3410712"/>
           </a:xfrm>
           <a:prstGeom prst="rect">
             <a:avLst/>
@@ -5356,7 +5427,7 @@
                 </a:solidFill>
                 <a:latin typeface="Arial"/>
               </a:rPr>
-              <a:t>β and X are fixed. Redraw the noise, and the estimate moves.</a:t>
+              <a:t>So XᵀX is positive semidefinite for any X.</a:t>
             </a:r>
           </a:p>
           <a:p>
@@ -5384,7 +5455,7 @@
                 </a:solidFill>
                 <a:latin typeface="Arial"/>
               </a:rPr>
-              <a:t>An estimator therefore has a distribution, and we can ask two questions of it:</a:t>
+              <a:t>If the columns are linearly independent, Xv ≠ 0 whenever v ≠ 0, the quadratic form is strictly positive, and the inverse exists.</a:t>
             </a:r>
           </a:p>
           <a:p>
@@ -5412,7 +5483,7 @@
                 </a:solidFill>
                 <a:latin typeface="Arial"/>
               </a:rPr>
-              <a:t>where is its centre, and how wide is its spread?</a:t>
+              <a:t>Nearly dependent columns keep the inverse but make it enormous. That is the ridge paper's whole subject.</a:t>
             </a:r>
           </a:p>
         </p:txBody>
@@ -5522,7 +5593,7 @@
                 </a:solidFill>
                 <a:latin typeface="Georgia"/>
               </a:rPr>
-              <a:t>Unbiased, with covariance σ²(XᵀX)⁻¹</a:t>
+              <a:t>The estimate is a random variable</a:t>
             </a:r>
           </a:p>
         </p:txBody>
@@ -5585,8 +5656,8 @@
         </p:blipFill>
         <p:spPr>
           <a:xfrm>
-            <a:off x="3318357" y="1600200"/>
-            <a:ext cx="5554980" cy="736092"/>
+            <a:off x="3101187" y="1600200"/>
+            <a:ext cx="5989320" cy="736092"/>
           </a:xfrm>
           <a:prstGeom prst="rect">
             <a:avLst/>
@@ -5639,7 +5710,7 @@
                 </a:solidFill>
                 <a:latin typeface="Arial"/>
               </a:rPr>
-              <a:t>The centre is exactly right: least squares is unbiased.</a:t>
+              <a:t>β and X are fixed. Redraw the noise, and the estimate moves.</a:t>
             </a:r>
           </a:p>
           <a:p>
@@ -5667,7 +5738,7 @@
                 </a:solidFill>
                 <a:latin typeface="Arial"/>
               </a:rPr>
-              <a:t>The spread is the inverse of the correlation matrix. Along eigenvector pⱼ the variance is σ²/λⱼ.</a:t>
+              <a:t>An estimator therefore has a distribution, and we can ask two questions of it:</a:t>
             </a:r>
           </a:p>
           <a:p>
@@ -5695,35 +5766,7 @@
                 </a:solidFill>
                 <a:latin typeface="Arial"/>
               </a:rPr>
-              <a:t>For the cars: σ²/λ₁ = 0.52 σ²  but  σ²/λ₂ = 11.5 σ².</a:t>
-            </a:r>
-          </a:p>
-          <a:p>
-            <a:pPr>
-              <a:lnSpc>
-                <a:spcPct val="118000"/>
-              </a:lnSpc>
-              <a:spcAft>
-                <a:spcPts val="900"/>
-              </a:spcAft>
-            </a:pPr>
-            <a:r>
-              <a:rPr sz="1900" b="1">
-                <a:solidFill>
-                  <a:srgbClr val="A8710A"/>
-                </a:solidFill>
-                <a:latin typeface="Arial"/>
-              </a:rPr>
-              <a:t>•  </a:t>
-            </a:r>
-            <a:r>
-              <a:rPr sz="1900">
-                <a:solidFill>
-                  <a:srgbClr val="24282E"/>
-                </a:solidFill>
-                <a:latin typeface="Arial"/>
-              </a:rPr>
-              <a:t>One direction of the estimate is 22 times noisier than the other, and the data caused it.</a:t>
+              <a:t>where is its centre, and how wide is its spread?</a:t>
             </a:r>
           </a:p>
         </p:txBody>
@@ -5833,7 +5876,7 @@
                 </a:solidFill>
                 <a:latin typeface="Georgia"/>
               </a:rPr>
-              <a:t>Unbiased is not the same as accurate</a:t>
+              <a:t>Unbiased, with covariance σ²(XᵀX)⁻¹</a:t>
             </a:r>
           </a:p>
         </p:txBody>
@@ -5882,7 +5925,7 @@
       </p:sp>
       <p:pic>
         <p:nvPicPr>
-          <p:cNvPr id="5" name="Picture 4" descr="dartboard.png"/>
+          <p:cNvPr id="5" name="Picture 4" descr="eq15.png"/>
           <p:cNvPicPr>
             <a:picLocks noChangeAspect="1"/>
           </p:cNvPicPr>
@@ -5896,48 +5939,24 @@
         </p:blipFill>
         <p:spPr>
           <a:xfrm>
-            <a:off x="685800" y="1600200"/>
-            <a:ext cx="6675120" cy="3337560"/>
+            <a:off x="3318357" y="1600200"/>
+            <a:ext cx="5554980" cy="736092"/>
           </a:xfrm>
           <a:prstGeom prst="rect">
             <a:avLst/>
           </a:prstGeom>
         </p:spPr>
       </p:pic>
-      <p:pic>
-        <p:nvPicPr>
-          <p:cNvPr id="6" name="Picture 5" descr="eq15.png"/>
-          <p:cNvPicPr>
-            <a:picLocks noChangeAspect="1"/>
-          </p:cNvPicPr>
-          <p:nvPr/>
-        </p:nvPicPr>
-        <p:blipFill>
-          <a:blip r:embed="rId3"/>
-          <a:stretch>
-            <a:fillRect/>
-          </a:stretch>
-        </p:blipFill>
-        <p:spPr>
-          <a:xfrm>
-            <a:off x="7772400" y="1600200"/>
-            <a:ext cx="3733495" cy="510384"/>
-          </a:xfrm>
-          <a:prstGeom prst="rect">
-            <a:avLst/>
-          </a:prstGeom>
-        </p:spPr>
-      </p:pic>
-      <p:sp>
-        <p:nvSpPr>
-          <p:cNvPr id="7" name="TextBox 6"/>
+      <p:sp>
+        <p:nvSpPr>
+          <p:cNvPr id="6" name="TextBox 5"/>
           <p:cNvSpPr txBox="1"/>
           <p:nvPr/>
         </p:nvSpPr>
         <p:spPr>
           <a:xfrm>
-            <a:off x="7772400" y="2339184"/>
-            <a:ext cx="3733495" cy="3878736"/>
+            <a:off x="685800" y="2656332"/>
+            <a:ext cx="10820095" cy="3378708"/>
           </a:xfrm>
           <a:prstGeom prst="rect">
             <a:avLst/>
@@ -5959,7 +5978,7 @@
               </a:spcAft>
             </a:pPr>
             <a:r>
-              <a:rPr sz="1600" b="1">
+              <a:rPr sz="1900" b="1">
                 <a:solidFill>
                   <a:srgbClr val="A8710A"/>
                 </a:solidFill>
@@ -5968,13 +5987,13 @@
               <a:t>•  </a:t>
             </a:r>
             <a:r>
-              <a:rPr sz="1600">
+              <a:rPr sz="1900">
                 <a:solidFill>
                   <a:srgbClr val="24282E"/>
                 </a:solidFill>
                 <a:latin typeface="Arial"/>
               </a:rPr>
-              <a:t>Player A is centred on the bullseye but scatters widely. Player B aims a little off and clusters tightly.</a:t>
+              <a:t>The centre is exactly right: least squares is unbiased.</a:t>
             </a:r>
           </a:p>
           <a:p>
@@ -5987,7 +6006,7 @@
               </a:spcAft>
             </a:pPr>
             <a:r>
-              <a:rPr sz="1600" b="1">
+              <a:rPr sz="1900" b="1">
                 <a:solidFill>
                   <a:srgbClr val="A8710A"/>
                 </a:solidFill>
@@ -5996,13 +6015,69 @@
               <a:t>•  </a:t>
             </a:r>
             <a:r>
-              <a:rPr sz="1600">
+              <a:rPr sz="1900">
                 <a:solidFill>
                   <a:srgbClr val="24282E"/>
                 </a:solidFill>
                 <a:latin typeface="Arial"/>
               </a:rPr>
-              <a:t>Every single dart of B lands closer. Mean squared error scores both players on the same scale.</a:t>
+              <a:t>The spread is the inverse of the correlation matrix. Along eigenvector pⱼ the variance is σ²/λⱼ.</a:t>
+            </a:r>
+          </a:p>
+          <a:p>
+            <a:pPr>
+              <a:lnSpc>
+                <a:spcPct val="118000"/>
+              </a:lnSpc>
+              <a:spcAft>
+                <a:spcPts val="900"/>
+              </a:spcAft>
+            </a:pPr>
+            <a:r>
+              <a:rPr sz="1900" b="1">
+                <a:solidFill>
+                  <a:srgbClr val="A8710A"/>
+                </a:solidFill>
+                <a:latin typeface="Arial"/>
+              </a:rPr>
+              <a:t>•  </a:t>
+            </a:r>
+            <a:r>
+              <a:rPr sz="1900">
+                <a:solidFill>
+                  <a:srgbClr val="24282E"/>
+                </a:solidFill>
+                <a:latin typeface="Arial"/>
+              </a:rPr>
+              <a:t>For the cars: σ²/λ₁ = 0.52 σ²  but  σ²/λ₂ = 11.5 σ².</a:t>
+            </a:r>
+          </a:p>
+          <a:p>
+            <a:pPr>
+              <a:lnSpc>
+                <a:spcPct val="118000"/>
+              </a:lnSpc>
+              <a:spcAft>
+                <a:spcPts val="900"/>
+              </a:spcAft>
+            </a:pPr>
+            <a:r>
+              <a:rPr sz="1900" b="1">
+                <a:solidFill>
+                  <a:srgbClr val="A8710A"/>
+                </a:solidFill>
+                <a:latin typeface="Arial"/>
+              </a:rPr>
+              <a:t>•  </a:t>
+            </a:r>
+            <a:r>
+              <a:rPr sz="1900">
+                <a:solidFill>
+                  <a:srgbClr val="24282E"/>
+                </a:solidFill>
+                <a:latin typeface="Arial"/>
+              </a:rPr>
+              <a:t>One direction of the estimate is 22 times noisier than the other, and the data caused it.</a:t>
             </a:r>
           </a:p>
         </p:txBody>
@@ -6112,7 +6187,7 @@
                 </a:solidFill>
                 <a:latin typeface="Georgia"/>
               </a:rPr>
-              <a:t>Gauss–Markov, read carefully</a:t>
+              <a:t>Unbiased is not the same as accurate</a:t>
             </a:r>
           </a:p>
         </p:txBody>
@@ -6161,7 +6236,7 @@
       </p:sp>
       <p:pic>
         <p:nvPicPr>
-          <p:cNvPr id="5" name="Picture 4" descr="eq16.png"/>
+          <p:cNvPr id="5" name="Picture 4" descr="dartboard.png"/>
           <p:cNvPicPr>
             <a:picLocks noChangeAspect="1"/>
           </p:cNvPicPr>
@@ -6175,24 +6250,48 @@
         </p:blipFill>
         <p:spPr>
           <a:xfrm>
-            <a:off x="2067915" y="1600200"/>
-            <a:ext cx="8055864" cy="736092"/>
+            <a:off x="685800" y="1600200"/>
+            <a:ext cx="6675120" cy="3337560"/>
           </a:xfrm>
           <a:prstGeom prst="rect">
             <a:avLst/>
           </a:prstGeom>
         </p:spPr>
       </p:pic>
-      <p:sp>
-        <p:nvSpPr>
-          <p:cNvPr id="6" name="TextBox 5"/>
+      <p:pic>
+        <p:nvPicPr>
+          <p:cNvPr id="6" name="Picture 5" descr="eq16.png"/>
+          <p:cNvPicPr>
+            <a:picLocks noChangeAspect="1"/>
+          </p:cNvPicPr>
+          <p:nvPr/>
+        </p:nvPicPr>
+        <p:blipFill>
+          <a:blip r:embed="rId3"/>
+          <a:stretch>
+            <a:fillRect/>
+          </a:stretch>
+        </p:blipFill>
+        <p:spPr>
+          <a:xfrm>
+            <a:off x="7772400" y="1600200"/>
+            <a:ext cx="3733495" cy="510384"/>
+          </a:xfrm>
+          <a:prstGeom prst="rect">
+            <a:avLst/>
+          </a:prstGeom>
+        </p:spPr>
+      </p:pic>
+      <p:sp>
+        <p:nvSpPr>
+          <p:cNvPr id="7" name="TextBox 6"/>
           <p:cNvSpPr txBox="1"/>
           <p:nvPr/>
         </p:nvSpPr>
         <p:spPr>
           <a:xfrm>
-            <a:off x="685800" y="2656332"/>
-            <a:ext cx="10820095" cy="3378708"/>
+            <a:off x="7772400" y="2339184"/>
+            <a:ext cx="3733495" cy="3878736"/>
           </a:xfrm>
           <a:prstGeom prst="rect">
             <a:avLst/>
@@ -6214,7 +6313,7 @@
               </a:spcAft>
             </a:pPr>
             <a:r>
-              <a:rPr sz="1900" b="1">
+              <a:rPr sz="1600" b="1">
                 <a:solidFill>
                   <a:srgbClr val="A8710A"/>
                 </a:solidFill>
@@ -6223,13 +6322,13 @@
               <a:t>•  </a:t>
             </a:r>
             <a:r>
-              <a:rPr sz="1900">
+              <a:rPr sz="1600">
                 <a:solidFill>
                   <a:srgbClr val="24282E"/>
                 </a:solidFill>
                 <a:latin typeface="Arial"/>
               </a:rPr>
-              <a:t>Among linear unbiased estimators, least squares has the smallest covariance.</a:t>
+              <a:t>Player A is centred on the bullseye but scatters widely. Player B aims a little off and clusters tightly.</a:t>
             </a:r>
           </a:p>
           <a:p>
@@ -6242,7 +6341,7 @@
               </a:spcAft>
             </a:pPr>
             <a:r>
-              <a:rPr sz="1900" b="1">
+              <a:rPr sz="1600" b="1">
                 <a:solidFill>
                   <a:srgbClr val="A8710A"/>
                 </a:solidFill>
@@ -6251,41 +6350,13 @@
               <a:t>•  </a:t>
             </a:r>
             <a:r>
-              <a:rPr sz="1900">
+              <a:rPr sz="1600">
                 <a:solidFill>
                   <a:srgbClr val="24282E"/>
                 </a:solidFill>
                 <a:latin typeface="Arial"/>
               </a:rPr>
-              <a:t>Two qualifiers. Drop “unbiased” and the theorem says nothing at all.</a:t>
-            </a:r>
-          </a:p>
-          <a:p>
-            <a:pPr>
-              <a:lnSpc>
-                <a:spcPct val="118000"/>
-              </a:lnSpc>
-              <a:spcAft>
-                <a:spcPts val="900"/>
-              </a:spcAft>
-            </a:pPr>
-            <a:r>
-              <a:rPr sz="1900" b="1">
-                <a:solidFill>
-                  <a:srgbClr val="A8710A"/>
-                </a:solidFill>
-                <a:latin typeface="Arial"/>
-              </a:rPr>
-              <a:t>•  </a:t>
-            </a:r>
-            <a:r>
-              <a:rPr sz="1900">
-                <a:solidFill>
-                  <a:srgbClr val="24282E"/>
-                </a:solidFill>
-                <a:latin typeface="Arial"/>
-              </a:rPr>
-              <a:t>That gap is the door ridge regression walks through.</a:t>
+              <a:t>Every single dart of B lands closer. Mean squared error scores both players on the same scale.</a:t>
             </a:r>
           </a:p>
         </p:txBody>
@@ -6794,7 +6865,7 @@
                 </a:solidFill>
                 <a:latin typeface="Georgia"/>
               </a:rPr>
-              <a:t>Where this leaves us</a:t>
+              <a:t>Gauss–Markov, read carefully</a:t>
             </a:r>
           </a:p>
         </p:txBody>
@@ -6857,8 +6928,8 @@
         </p:blipFill>
         <p:spPr>
           <a:xfrm>
-            <a:off x="2143353" y="1600200"/>
-            <a:ext cx="7904988" cy="736092"/>
+            <a:off x="2067915" y="1600200"/>
+            <a:ext cx="8055864" cy="736092"/>
           </a:xfrm>
           <a:prstGeom prst="rect">
             <a:avLst/>
@@ -6911,7 +6982,7 @@
                 </a:solidFill>
                 <a:latin typeface="Arial"/>
               </a:rPr>
-              <a:t>In the eigenvector basis, every 1/λⱼ becomes 1/(λⱼ + k). The small eigenvalue can no longer explode.</a:t>
+              <a:t>Among linear unbiased estimators, least squares has the smallest covariance.</a:t>
             </a:r>
           </a:p>
           <a:p>
@@ -6939,7 +7010,7 @@
                 </a:solidFill>
                 <a:latin typeface="Arial"/>
               </a:rPr>
-              <a:t>The price is bias. Session 1 proves that for some k &gt; 0 the trade lowers the mean squared error, always.</a:t>
+              <a:t>Two qualifiers. Drop “unbiased” and the theorem says nothing at all.</a:t>
             </a:r>
           </a:p>
           <a:p>
@@ -6967,7 +7038,7 @@
                 </a:solidFill>
                 <a:latin typeface="Arial"/>
               </a:rPr>
-              <a:t>Bring the centred model, the eigenvalues, and the bias–variance split. The paper assumes all three.</a:t>
+              <a:t>That gap is the door ridge regression walks through.</a:t>
             </a:r>
           </a:p>
         </p:txBody>
@@ -7035,7 +7106,7 @@
                 </a:solidFill>
                 <a:latin typeface="Arial"/>
               </a:rPr>
-              <a:t>CLOSING</a:t>
+              <a:t>PART III · WHAT MAKES AN ESTIMATE GOOD</a:t>
             </a:r>
           </a:p>
         </p:txBody>
@@ -7077,7 +7148,7 @@
                 </a:solidFill>
                 <a:latin typeface="Georgia"/>
               </a:rPr>
-              <a:t>Exercises</a:t>
+              <a:t>Where this leaves us</a:t>
             </a:r>
           </a:p>
         </p:txBody>
@@ -7124,16 +7195,40 @@
           </a:p>
         </p:txBody>
       </p:sp>
-      <p:sp>
-        <p:nvSpPr>
-          <p:cNvPr id="5" name="TextBox 4"/>
+      <p:pic>
+        <p:nvPicPr>
+          <p:cNvPr id="5" name="Picture 4" descr="eq18.png"/>
+          <p:cNvPicPr>
+            <a:picLocks noChangeAspect="1"/>
+          </p:cNvPicPr>
+          <p:nvPr/>
+        </p:nvPicPr>
+        <p:blipFill>
+          <a:blip r:embed="rId2"/>
+          <a:stretch>
+            <a:fillRect/>
+          </a:stretch>
+        </p:blipFill>
+        <p:spPr>
+          <a:xfrm>
+            <a:off x="2143353" y="1600200"/>
+            <a:ext cx="7904988" cy="736092"/>
+          </a:xfrm>
+          <a:prstGeom prst="rect">
+            <a:avLst/>
+          </a:prstGeom>
+        </p:spPr>
+      </p:pic>
+      <p:sp>
+        <p:nvSpPr>
+          <p:cNvPr id="6" name="TextBox 5"/>
           <p:cNvSpPr txBox="1"/>
           <p:nvPr/>
         </p:nvSpPr>
         <p:spPr>
           <a:xfrm>
-            <a:off x="685800" y="1600200"/>
-            <a:ext cx="5135727" cy="4114800"/>
+            <a:off x="685800" y="2656332"/>
+            <a:ext cx="10820095" cy="3378708"/>
           </a:xfrm>
           <a:prstGeom prst="rect">
             <a:avLst/>
@@ -7141,225 +7236,92 @@
           <a:noFill/>
         </p:spPr>
         <p:txBody>
-          <a:bodyPr wrap="square" anchor="t" lIns="0" rIns="0" tIns="0" bIns="0">
+          <a:bodyPr wrap="square" lIns="0" rIns="0" tIns="0" bIns="0">
             <a:spAutoFit/>
           </a:bodyPr>
           <a:lstStyle/>
           <a:p>
-            <a:pPr algn="l">
-              <a:lnSpc>
-                <a:spcPct val="125000"/>
-              </a:lnSpc>
-              <a:spcAft>
-                <a:spcPts val="1200"/>
-              </a:spcAft>
-            </a:pPr>
-            <a:r>
-              <a:rPr sz="1800" b="0">
+            <a:pPr>
+              <a:lnSpc>
+                <a:spcPct val="118000"/>
+              </a:lnSpc>
+              <a:spcAft>
+                <a:spcPts val="900"/>
+              </a:spcAft>
+            </a:pPr>
+            <a:r>
+              <a:rPr sz="1900" b="1">
+                <a:solidFill>
+                  <a:srgbClr val="A8710A"/>
+                </a:solidFill>
+                <a:latin typeface="Arial"/>
+              </a:rPr>
+              <a:t>•  </a:t>
+            </a:r>
+            <a:r>
+              <a:rPr sz="1900">
                 <a:solidFill>
                   <a:srgbClr val="24282E"/>
                 </a:solidFill>
                 <a:latin typeface="Arial"/>
               </a:rPr>
-              <a:t>1.  Show that XᵀX is positive semidefinite.</a:t>
-            </a:r>
-          </a:p>
-          <a:p>
-            <a:pPr algn="l">
-              <a:lnSpc>
-                <a:spcPct val="125000"/>
-              </a:lnSpc>
-              <a:spcAft>
-                <a:spcPts val="1200"/>
-              </a:spcAft>
-            </a:pPr>
-            <a:r>
-              <a:rPr sz="1800" b="0">
+              <a:t>In the eigenvector basis, every 1/λⱼ becomes 1/(λⱼ + k). The small eigenvalue can no longer explode.</a:t>
+            </a:r>
+          </a:p>
+          <a:p>
+            <a:pPr>
+              <a:lnSpc>
+                <a:spcPct val="118000"/>
+              </a:lnSpc>
+              <a:spcAft>
+                <a:spcPts val="900"/>
+              </a:spcAft>
+            </a:pPr>
+            <a:r>
+              <a:rPr sz="1900" b="1">
+                <a:solidFill>
+                  <a:srgbClr val="A8710A"/>
+                </a:solidFill>
+                <a:latin typeface="Arial"/>
+              </a:rPr>
+              <a:t>•  </a:t>
+            </a:r>
+            <a:r>
+              <a:rPr sz="1900">
                 <a:solidFill>
                   <a:srgbClr val="24282E"/>
                 </a:solidFill>
                 <a:latin typeface="Arial"/>
               </a:rPr>
-              <a:t>2.  Show it is invertible exactly when the columns of X are linearly independent.</a:t>
-            </a:r>
-          </a:p>
-          <a:p>
-            <a:pPr algn="l">
-              <a:lnSpc>
-                <a:spcPct val="125000"/>
-              </a:lnSpc>
-              <a:spcAft>
-                <a:spcPts val="1200"/>
-              </a:spcAft>
-            </a:pPr>
-            <a:r>
-              <a:rPr sz="1800" b="0">
+              <a:t>The price is bias. Session 1 proves that for some k &gt; 0 the trade lowers the mean squared error, always.</a:t>
+            </a:r>
+          </a:p>
+          <a:p>
+            <a:pPr>
+              <a:lnSpc>
+                <a:spcPct val="118000"/>
+              </a:lnSpc>
+              <a:spcAft>
+                <a:spcPts val="900"/>
+              </a:spcAft>
+            </a:pPr>
+            <a:r>
+              <a:rPr sz="1900" b="1">
+                <a:solidFill>
+                  <a:srgbClr val="A8710A"/>
+                </a:solidFill>
+                <a:latin typeface="Arial"/>
+              </a:rPr>
+              <a:t>•  </a:t>
+            </a:r>
+            <a:r>
+              <a:rPr sz="1900">
                 <a:solidFill>
                   <a:srgbClr val="24282E"/>
                 </a:solidFill>
                 <a:latin typeface="Arial"/>
               </a:rPr>
-              <a:t>3.  For centred, unit-length columns, show that the dot product is the correlation and lies in [−1, 1].</a:t>
-            </a:r>
-          </a:p>
-          <a:p>
-            <a:pPr algn="l">
-              <a:lnSpc>
-                <a:spcPct val="125000"/>
-              </a:lnSpc>
-              <a:spcAft>
-                <a:spcPts val="1200"/>
-              </a:spcAft>
-            </a:pPr>
-            <a:r>
-              <a:rPr sz="1800" b="0">
-                <a:solidFill>
-                  <a:srgbClr val="24282E"/>
-                </a:solidFill>
-                <a:latin typeface="Arial"/>
-              </a:rPr>
-              <a:t>4.  Show that the eigenvalues of XᵀX sum to p under that scaling.</a:t>
-            </a:r>
-          </a:p>
-        </p:txBody>
-      </p:sp>
-      <p:sp>
-        <p:nvSpPr>
-          <p:cNvPr id="6" name="TextBox 5"/>
-          <p:cNvSpPr txBox="1"/>
-          <p:nvPr/>
-        </p:nvSpPr>
-        <p:spPr>
-          <a:xfrm>
-            <a:off x="6370167" y="1600200"/>
-            <a:ext cx="5135727" cy="4114800"/>
-          </a:xfrm>
-          <a:prstGeom prst="rect">
-            <a:avLst/>
-          </a:prstGeom>
-          <a:noFill/>
-        </p:spPr>
-        <p:txBody>
-          <a:bodyPr wrap="square" anchor="t" lIns="0" rIns="0" tIns="0" bIns="0">
-            <a:spAutoFit/>
-          </a:bodyPr>
-          <a:lstStyle/>
-          <a:p>
-            <a:pPr algn="l">
-              <a:lnSpc>
-                <a:spcPct val="125000"/>
-              </a:lnSpc>
-              <a:spcAft>
-                <a:spcPts val="1200"/>
-              </a:spcAft>
-            </a:pPr>
-            <a:r>
-              <a:rPr sz="1800" b="0">
-                <a:solidFill>
-                  <a:srgbClr val="24282E"/>
-                </a:solidFill>
-                <a:latin typeface="Arial"/>
-              </a:rPr>
-              <a:t>5.  Derive the normal equations and the least squares solution.</a:t>
-            </a:r>
-          </a:p>
-          <a:p>
-            <a:pPr algn="l">
-              <a:lnSpc>
-                <a:spcPct val="125000"/>
-              </a:lnSpc>
-              <a:spcAft>
-                <a:spcPts val="1200"/>
-              </a:spcAft>
-            </a:pPr>
-            <a:r>
-              <a:rPr sz="1800" b="0">
-                <a:solidFill>
-                  <a:srgbClr val="24282E"/>
-                </a:solidFill>
-                <a:latin typeface="Arial"/>
-              </a:rPr>
-              <a:t>6.  Prove that least squares is unbiased and derive its covariance.</a:t>
-            </a:r>
-          </a:p>
-          <a:p>
-            <a:pPr algn="l">
-              <a:lnSpc>
-                <a:spcPct val="125000"/>
-              </a:lnSpc>
-              <a:spcAft>
-                <a:spcPts val="1200"/>
-              </a:spcAft>
-            </a:pPr>
-            <a:r>
-              <a:rPr sz="1800" b="0">
-                <a:solidFill>
-                  <a:srgbClr val="24282E"/>
-                </a:solidFill>
-                <a:latin typeface="Arial"/>
-              </a:rPr>
-              <a:t>7.  Prove  E‖β̃ − β‖² = tr Cov(β̃) + ‖bias‖².</a:t>
-            </a:r>
-          </a:p>
-          <a:p>
-            <a:pPr algn="l">
-              <a:lnSpc>
-                <a:spcPct val="125000"/>
-              </a:lnSpc>
-              <a:spcAft>
-                <a:spcPts val="1200"/>
-              </a:spcAft>
-            </a:pPr>
-            <a:r>
-              <a:rPr sz="1800" b="0">
-                <a:solidFill>
-                  <a:srgbClr val="24282E"/>
-                </a:solidFill>
-                <a:latin typeface="Arial"/>
-              </a:rPr>
-              <a:t>8.  For β̃ = cβ̂ with 0 ≤ c ≤ 1, find the c that minimises the MSE. Is it 1?</a:t>
-            </a:r>
-          </a:p>
-        </p:txBody>
-      </p:sp>
-      <p:sp>
-        <p:nvSpPr>
-          <p:cNvPr id="7" name="TextBox 6"/>
-          <p:cNvSpPr txBox="1"/>
-          <p:nvPr/>
-        </p:nvSpPr>
-        <p:spPr>
-          <a:xfrm>
-            <a:off x="685800" y="5943600"/>
-            <a:ext cx="10820095" cy="365760"/>
-          </a:xfrm>
-          <a:prstGeom prst="rect">
-            <a:avLst/>
-          </a:prstGeom>
-          <a:noFill/>
-        </p:spPr>
-        <p:txBody>
-          <a:bodyPr wrap="square" anchor="t" lIns="0" rIns="0" tIns="0" bIns="0">
-            <a:spAutoFit/>
-          </a:bodyPr>
-          <a:lstStyle/>
-          <a:p>
-            <a:pPr algn="l">
-              <a:lnSpc>
-                <a:spcPct val="115000"/>
-              </a:lnSpc>
-              <a:spcAft>
-                <a:spcPts val="0"/>
-              </a:spcAft>
-            </a:pPr>
-            <a:r>
-              <a:rPr sz="1600" b="0">
-                <a:solidFill>
-                  <a:srgbClr val="6B7280"/>
-                </a:solidFill>
-                <a:latin typeface="Georgia"/>
-              </a:rPr>
-              <a:t>Work in pairs. Mark the line where each assumption about ε is used.</a:t>
+              <a:t>Bring the centred model, the eigenvalues, and the bias–variance split. The paper assumes all three.</a:t>
             </a:r>
           </a:p>
         </p:txBody>
@@ -7469,7 +7431,7 @@
                 </a:solidFill>
                 <a:latin typeface="Georgia"/>
               </a:rPr>
-              <a:t>Before Session 1 you should be able to prove</a:t>
+              <a:t>Exercises</a:t>
             </a:r>
           </a:p>
         </p:txBody>
@@ -7512,6 +7474,398 @@
                 <a:latin typeface="Arial"/>
               </a:rPr>
               <a:t>22</a:t>
+            </a:r>
+          </a:p>
+        </p:txBody>
+      </p:sp>
+      <p:sp>
+        <p:nvSpPr>
+          <p:cNvPr id="5" name="TextBox 4"/>
+          <p:cNvSpPr txBox="1"/>
+          <p:nvPr/>
+        </p:nvSpPr>
+        <p:spPr>
+          <a:xfrm>
+            <a:off x="685800" y="1600200"/>
+            <a:ext cx="5135727" cy="4114800"/>
+          </a:xfrm>
+          <a:prstGeom prst="rect">
+            <a:avLst/>
+          </a:prstGeom>
+          <a:noFill/>
+        </p:spPr>
+        <p:txBody>
+          <a:bodyPr wrap="square" anchor="t" lIns="0" rIns="0" tIns="0" bIns="0">
+            <a:spAutoFit/>
+          </a:bodyPr>
+          <a:lstStyle/>
+          <a:p>
+            <a:pPr algn="l">
+              <a:lnSpc>
+                <a:spcPct val="125000"/>
+              </a:lnSpc>
+              <a:spcAft>
+                <a:spcPts val="1200"/>
+              </a:spcAft>
+            </a:pPr>
+            <a:r>
+              <a:rPr sz="1800" b="0">
+                <a:solidFill>
+                  <a:srgbClr val="24282E"/>
+                </a:solidFill>
+                <a:latin typeface="Arial"/>
+              </a:rPr>
+              <a:t>1.  Show that XᵀX is positive semidefinite.</a:t>
+            </a:r>
+          </a:p>
+          <a:p>
+            <a:pPr algn="l">
+              <a:lnSpc>
+                <a:spcPct val="125000"/>
+              </a:lnSpc>
+              <a:spcAft>
+                <a:spcPts val="1200"/>
+              </a:spcAft>
+            </a:pPr>
+            <a:r>
+              <a:rPr sz="1800" b="0">
+                <a:solidFill>
+                  <a:srgbClr val="24282E"/>
+                </a:solidFill>
+                <a:latin typeface="Arial"/>
+              </a:rPr>
+              <a:t>2.  Show it is invertible exactly when the columns of X are linearly independent.</a:t>
+            </a:r>
+          </a:p>
+          <a:p>
+            <a:pPr algn="l">
+              <a:lnSpc>
+                <a:spcPct val="125000"/>
+              </a:lnSpc>
+              <a:spcAft>
+                <a:spcPts val="1200"/>
+              </a:spcAft>
+            </a:pPr>
+            <a:r>
+              <a:rPr sz="1800" b="0">
+                <a:solidFill>
+                  <a:srgbClr val="24282E"/>
+                </a:solidFill>
+                <a:latin typeface="Arial"/>
+              </a:rPr>
+              <a:t>3.  For centred, unit-length columns, show that the dot product is the correlation and lies in [−1, 1].</a:t>
+            </a:r>
+          </a:p>
+          <a:p>
+            <a:pPr algn="l">
+              <a:lnSpc>
+                <a:spcPct val="125000"/>
+              </a:lnSpc>
+              <a:spcAft>
+                <a:spcPts val="1200"/>
+              </a:spcAft>
+            </a:pPr>
+            <a:r>
+              <a:rPr sz="1800" b="0">
+                <a:solidFill>
+                  <a:srgbClr val="24282E"/>
+                </a:solidFill>
+                <a:latin typeface="Arial"/>
+              </a:rPr>
+              <a:t>4.  Show that the eigenvalues of XᵀX sum to p under that scaling.</a:t>
+            </a:r>
+          </a:p>
+        </p:txBody>
+      </p:sp>
+      <p:sp>
+        <p:nvSpPr>
+          <p:cNvPr id="6" name="TextBox 5"/>
+          <p:cNvSpPr txBox="1"/>
+          <p:nvPr/>
+        </p:nvSpPr>
+        <p:spPr>
+          <a:xfrm>
+            <a:off x="6370167" y="1600200"/>
+            <a:ext cx="5135727" cy="4114800"/>
+          </a:xfrm>
+          <a:prstGeom prst="rect">
+            <a:avLst/>
+          </a:prstGeom>
+          <a:noFill/>
+        </p:spPr>
+        <p:txBody>
+          <a:bodyPr wrap="square" anchor="t" lIns="0" rIns="0" tIns="0" bIns="0">
+            <a:spAutoFit/>
+          </a:bodyPr>
+          <a:lstStyle/>
+          <a:p>
+            <a:pPr algn="l">
+              <a:lnSpc>
+                <a:spcPct val="125000"/>
+              </a:lnSpc>
+              <a:spcAft>
+                <a:spcPts val="1200"/>
+              </a:spcAft>
+            </a:pPr>
+            <a:r>
+              <a:rPr sz="1800" b="0">
+                <a:solidFill>
+                  <a:srgbClr val="24282E"/>
+                </a:solidFill>
+                <a:latin typeface="Arial"/>
+              </a:rPr>
+              <a:t>5.  Derive the normal equations and the least squares solution.</a:t>
+            </a:r>
+          </a:p>
+          <a:p>
+            <a:pPr algn="l">
+              <a:lnSpc>
+                <a:spcPct val="125000"/>
+              </a:lnSpc>
+              <a:spcAft>
+                <a:spcPts val="1200"/>
+              </a:spcAft>
+            </a:pPr>
+            <a:r>
+              <a:rPr sz="1800" b="0">
+                <a:solidFill>
+                  <a:srgbClr val="24282E"/>
+                </a:solidFill>
+                <a:latin typeface="Arial"/>
+              </a:rPr>
+              <a:t>6.  Prove that least squares is unbiased and derive its covariance.</a:t>
+            </a:r>
+          </a:p>
+          <a:p>
+            <a:pPr algn="l">
+              <a:lnSpc>
+                <a:spcPct val="125000"/>
+              </a:lnSpc>
+              <a:spcAft>
+                <a:spcPts val="1200"/>
+              </a:spcAft>
+            </a:pPr>
+            <a:r>
+              <a:rPr sz="1800" b="0">
+                <a:solidFill>
+                  <a:srgbClr val="24282E"/>
+                </a:solidFill>
+                <a:latin typeface="Arial"/>
+              </a:rPr>
+              <a:t>7.  Prove  E‖β̃ − β‖² = tr Cov(β̃) + ‖bias‖².</a:t>
+            </a:r>
+          </a:p>
+          <a:p>
+            <a:pPr algn="l">
+              <a:lnSpc>
+                <a:spcPct val="125000"/>
+              </a:lnSpc>
+              <a:spcAft>
+                <a:spcPts val="1200"/>
+              </a:spcAft>
+            </a:pPr>
+            <a:r>
+              <a:rPr sz="1800" b="0">
+                <a:solidFill>
+                  <a:srgbClr val="24282E"/>
+                </a:solidFill>
+                <a:latin typeface="Arial"/>
+              </a:rPr>
+              <a:t>8.  For β̃ = cβ̂ with 0 ≤ c ≤ 1, find the c that minimises the MSE. Is it 1?</a:t>
+            </a:r>
+          </a:p>
+        </p:txBody>
+      </p:sp>
+      <p:sp>
+        <p:nvSpPr>
+          <p:cNvPr id="7" name="TextBox 6"/>
+          <p:cNvSpPr txBox="1"/>
+          <p:nvPr/>
+        </p:nvSpPr>
+        <p:spPr>
+          <a:xfrm>
+            <a:off x="685800" y="5943600"/>
+            <a:ext cx="10820095" cy="365760"/>
+          </a:xfrm>
+          <a:prstGeom prst="rect">
+            <a:avLst/>
+          </a:prstGeom>
+          <a:noFill/>
+        </p:spPr>
+        <p:txBody>
+          <a:bodyPr wrap="square" anchor="t" lIns="0" rIns="0" tIns="0" bIns="0">
+            <a:spAutoFit/>
+          </a:bodyPr>
+          <a:lstStyle/>
+          <a:p>
+            <a:pPr algn="l">
+              <a:lnSpc>
+                <a:spcPct val="115000"/>
+              </a:lnSpc>
+              <a:spcAft>
+                <a:spcPts val="0"/>
+              </a:spcAft>
+            </a:pPr>
+            <a:r>
+              <a:rPr sz="1600" b="0">
+                <a:solidFill>
+                  <a:srgbClr val="6B7280"/>
+                </a:solidFill>
+                <a:latin typeface="Georgia"/>
+              </a:rPr>
+              <a:t>Work in pairs. Mark the line where each assumption about ε is used.</a:t>
+            </a:r>
+          </a:p>
+        </p:txBody>
+      </p:sp>
+    </p:spTree>
+  </p:cSld>
+  <p:clrMapOvr>
+    <a:masterClrMapping/>
+  </p:clrMapOvr>
+</p:sld>
+</file>
+
+<file path=ppt/slides/slide23.xml><?xml version="1.0" encoding="utf-8"?>
+<p:sld xmlns:a="http://schemas.openxmlformats.org/drawingml/2006/main" xmlns:p="http://schemas.openxmlformats.org/presentationml/2006/main" xmlns:r="http://schemas.openxmlformats.org/officeDocument/2006/relationships">
+  <p:cSld>
+    <p:bg>
+      <p:bgPr>
+        <a:solidFill>
+          <a:srgbClr val="F7F7F5"/>
+        </a:solidFill>
+        <a:effectLst/>
+      </p:bgPr>
+    </p:bg>
+    <p:spTree>
+      <p:nvGrpSpPr>
+        <p:cNvPr id="1" name=""/>
+        <p:cNvGrpSpPr/>
+        <p:nvPr/>
+      </p:nvGrpSpPr>
+      <p:grpSpPr/>
+      <p:sp>
+        <p:nvSpPr>
+          <p:cNvPr id="2" name="TextBox 1"/>
+          <p:cNvSpPr txBox="1"/>
+          <p:nvPr/>
+        </p:nvSpPr>
+        <p:spPr>
+          <a:xfrm>
+            <a:off x="685800" y="384048"/>
+            <a:ext cx="10820095" cy="274320"/>
+          </a:xfrm>
+          <a:prstGeom prst="rect">
+            <a:avLst/>
+          </a:prstGeom>
+          <a:noFill/>
+        </p:spPr>
+        <p:txBody>
+          <a:bodyPr wrap="square" anchor="t" lIns="0" rIns="0" tIns="0" bIns="0">
+            <a:spAutoFit/>
+          </a:bodyPr>
+          <a:lstStyle/>
+          <a:p>
+            <a:pPr algn="l">
+              <a:lnSpc>
+                <a:spcPct val="115000"/>
+              </a:lnSpc>
+              <a:spcAft>
+                <a:spcPts val="0"/>
+              </a:spcAft>
+            </a:pPr>
+            <a:r>
+              <a:rPr sz="1200" b="1">
+                <a:solidFill>
+                  <a:srgbClr val="A8710A"/>
+                </a:solidFill>
+                <a:latin typeface="Arial"/>
+              </a:rPr>
+              <a:t>CLOSING</a:t>
+            </a:r>
+          </a:p>
+        </p:txBody>
+      </p:sp>
+      <p:sp>
+        <p:nvSpPr>
+          <p:cNvPr id="3" name="TextBox 2"/>
+          <p:cNvSpPr txBox="1"/>
+          <p:nvPr/>
+        </p:nvSpPr>
+        <p:spPr>
+          <a:xfrm>
+            <a:off x="685800" y="658368"/>
+            <a:ext cx="10820095" cy="822960"/>
+          </a:xfrm>
+          <a:prstGeom prst="rect">
+            <a:avLst/>
+          </a:prstGeom>
+          <a:noFill/>
+        </p:spPr>
+        <p:txBody>
+          <a:bodyPr wrap="square" anchor="t" lIns="0" rIns="0" tIns="0" bIns="0">
+            <a:spAutoFit/>
+          </a:bodyPr>
+          <a:lstStyle/>
+          <a:p>
+            <a:pPr algn="l">
+              <a:lnSpc>
+                <a:spcPct val="115000"/>
+              </a:lnSpc>
+              <a:spcAft>
+                <a:spcPts val="0"/>
+              </a:spcAft>
+            </a:pPr>
+            <a:r>
+              <a:rPr sz="3400" b="1">
+                <a:solidFill>
+                  <a:srgbClr val="24282E"/>
+                </a:solidFill>
+                <a:latin typeface="Georgia"/>
+              </a:rPr>
+              <a:t>Before Session 1 you should be able to prove</a:t>
+            </a:r>
+          </a:p>
+        </p:txBody>
+      </p:sp>
+      <p:sp>
+        <p:nvSpPr>
+          <p:cNvPr id="4" name="TextBox 3"/>
+          <p:cNvSpPr txBox="1"/>
+          <p:nvPr/>
+        </p:nvSpPr>
+        <p:spPr>
+          <a:xfrm>
+            <a:off x="10591495" y="6355080"/>
+            <a:ext cx="914400" cy="274320"/>
+          </a:xfrm>
+          <a:prstGeom prst="rect">
+            <a:avLst/>
+          </a:prstGeom>
+          <a:noFill/>
+        </p:spPr>
+        <p:txBody>
+          <a:bodyPr wrap="square" anchor="t" lIns="0" rIns="0" tIns="0" bIns="0">
+            <a:spAutoFit/>
+          </a:bodyPr>
+          <a:lstStyle/>
+          <a:p>
+            <a:pPr algn="r">
+              <a:lnSpc>
+                <a:spcPct val="115000"/>
+              </a:lnSpc>
+              <a:spcAft>
+                <a:spcPts val="0"/>
+              </a:spcAft>
+            </a:pPr>
+            <a:r>
+              <a:rPr sz="1100" b="0">
+                <a:solidFill>
+                  <a:srgbClr val="6B7280"/>
+                </a:solidFill>
+                <a:latin typeface="Arial"/>
+              </a:rPr>
+              <a:t>23</a:t>
             </a:r>
           </a:p>
         </p:txBody>

</xml_diff>

<commit_message>
Define the standard deviation in the tutorial and on the covariance slide
Co-Authored-By: Claude Fable 5.1 <noreply@anthropic.com>
</commit_message>
<xml_diff>
--- a/public/slides/session-0-least-squares-foundations.pptx
+++ b/public/slides/session-0-least-squares-foundations.pptx
@@ -3847,7 +3847,7 @@
               </a:spcAft>
             </a:pPr>
             <a:r>
-              <a:rPr sz="1900" b="1">
+              <a:rPr sz="1700" b="1">
                 <a:solidFill>
                   <a:srgbClr val="A8710A"/>
                 </a:solidFill>
@@ -3856,7 +3856,7 @@
               <a:t>•  </a:t>
             </a:r>
             <a:r>
-              <a:rPr sz="1900">
+              <a:rPr sz="1700">
                 <a:solidFill>
                   <a:srgbClr val="24282E"/>
                 </a:solidFill>
@@ -3875,7 +3875,7 @@
               </a:spcAft>
             </a:pPr>
             <a:r>
-              <a:rPr sz="1900" b="1">
+              <a:rPr sz="1700" b="1">
                 <a:solidFill>
                   <a:srgbClr val="A8710A"/>
                 </a:solidFill>
@@ -3884,7 +3884,7 @@
               <a:t>•  </a:t>
             </a:r>
             <a:r>
-              <a:rPr sz="1900">
+              <a:rPr sz="1700">
                 <a:solidFill>
                   <a:srgbClr val="24282E"/>
                 </a:solidFill>
@@ -3903,7 +3903,7 @@
               </a:spcAft>
             </a:pPr>
             <a:r>
-              <a:rPr sz="1900" b="1">
+              <a:rPr sz="1700" b="1">
                 <a:solidFill>
                   <a:srgbClr val="A8710A"/>
                 </a:solidFill>
@@ -3912,12 +3912,40 @@
               <a:t>•  </a:t>
             </a:r>
             <a:r>
-              <a:rPr sz="1900">
+              <a:rPr sz="1700">
                 <a:solidFill>
                   <a:srgbClr val="24282E"/>
                 </a:solidFill>
                 <a:latin typeface="Arial"/>
               </a:rPr>
+              <a:t>The standard deviation is the typical distance from the mean, in the variable's own units: sd(u) = √cov(u, u). Here sd(weight) = 0.3162 t and sd(hp) = 24.238.</a:t>
+            </a:r>
+          </a:p>
+          <a:p>
+            <a:pPr>
+              <a:lnSpc>
+                <a:spcPct val="118000"/>
+              </a:lnSpc>
+              <a:spcAft>
+                <a:spcPts val="900"/>
+              </a:spcAft>
+            </a:pPr>
+            <a:r>
+              <a:rPr sz="1700" b="1">
+                <a:solidFill>
+                  <a:srgbClr val="A8710A"/>
+                </a:solidFill>
+                <a:latin typeface="Arial"/>
+              </a:rPr>
+              <a:t>•  </a:t>
+            </a:r>
+            <a:r>
+              <a:rPr sz="1700">
+                <a:solidFill>
+                  <a:srgbClr val="24282E"/>
+                </a:solidFill>
+                <a:latin typeface="Arial"/>
+              </a:rPr>
               <a:t>Divide by the standard deviations and the ruler cancels: 7.0 / (0.3162 × 24.238) = 0.913, in tonnes or in grams alike.</a:t>
             </a:r>
           </a:p>
@@ -3931,7 +3959,7 @@
               </a:spcAft>
             </a:pPr>
             <a:r>
-              <a:rPr sz="1900" b="1">
+              <a:rPr sz="1700" b="1">
                 <a:solidFill>
                   <a:srgbClr val="A8710A"/>
                 </a:solidFill>
@@ -3940,7 +3968,7 @@
               <a:t>•  </a:t>
             </a:r>
             <a:r>
-              <a:rPr sz="1900">
+              <a:rPr sz="1700">
                 <a:solidFill>
                   <a:srgbClr val="24282E"/>
                 </a:solidFill>

</xml_diff>

<commit_message>
Fix slide script syntax after trimming the covariance note
Co-Authored-By: Claude Opus 5 (1M context) <noreply@anthropic.com>
</commit_message>
<xml_diff>
--- a/public/slides/session-0-least-squares-foundations.pptx
+++ b/public/slides/session-0-least-squares-foundations.pptx
@@ -3974,49 +3974,7 @@
                 </a:solidFill>
                 <a:latin typeface="Arial"/>
               </a:rPr>
-              <a:t>Standardizing does that division once, in advance, on the data. Afterwards a plain dot product already is the correlation.</a:t>
-            </a:r>
-          </a:p>
-        </p:txBody>
-      </p:sp>
-      <p:sp>
-        <p:nvSpPr>
-          <p:cNvPr id="7" name="TextBox 6"/>
-          <p:cNvSpPr txBox="1"/>
-          <p:nvPr/>
-        </p:nvSpPr>
-        <p:spPr>
-          <a:xfrm>
-            <a:off x="685800" y="5943600"/>
-            <a:ext cx="10820095" cy="365760"/>
-          </a:xfrm>
-          <a:prstGeom prst="rect">
-            <a:avLst/>
-          </a:prstGeom>
-          <a:noFill/>
-        </p:spPr>
-        <p:txBody>
-          <a:bodyPr wrap="square" anchor="t" lIns="0" rIns="0" tIns="0" bIns="0">
-            <a:spAutoFit/>
-          </a:bodyPr>
-          <a:lstStyle/>
-          <a:p>
-            <a:pPr algn="l">
-              <a:lnSpc>
-                <a:spcPct val="115000"/>
-              </a:lnSpc>
-              <a:spcAft>
-                <a:spcPts val="0"/>
-              </a:spcAft>
-            </a:pPr>
-            <a:r>
-              <a:rPr sz="1600" b="0">
-                <a:solidFill>
-                  <a:srgbClr val="6B7280"/>
-                </a:solidFill>
-                <a:latin typeface="Georgia"/>
-              </a:rPr>
-              <a:t>That is why the ridge paper assumes standardized columns throughout: XᵀX then needs no units.</a:t>
+              <a:t>Standardizing does that division once, on the data itself. Afterwards a plain dot product already is the correlation, and the ridge paper assumes exactly that.</a:t>
             </a:r>
           </a:p>
         </p:txBody>

</xml_diff>

<commit_message>
Exercises: add six lemmas the ridge paper leans on
Symmetry of X'X; positive definite implies invertible; |u'v| <= 1 for unit
vectors; eigenvalues sum to the trace; inverting a matrix reciprocates its
eigenvalues; and the entrywise noise assumptions as Cov(e) = sigma^2 I.
Tutorial now has 11 exercises, the deck two exercise slides and a longer
checklist.

Co-Authored-By: Claude Opus 5 (1M context) <noreply@anthropic.com>
</commit_message>
<xml_diff>
--- a/public/slides/session-0-least-squares-foundations.pptx
+++ b/public/slides/session-0-least-squares-foundations.pptx
@@ -29,6 +29,7 @@
     <p:sldId id="277" r:id="rId28"/>
     <p:sldId id="278" r:id="rId29"/>
     <p:sldId id="279" r:id="rId30"/>
+    <p:sldId id="280" r:id="rId31"/>
   </p:sldIdLst>
   <p:sldSz cx="12191695" cy="6858000" type="screen4x3"/>
   <p:notesSz cx="6858000" cy="9144000"/>
@@ -7753,7 +7754,7 @@
                 </a:solidFill>
                 <a:latin typeface="Georgia"/>
               </a:rPr>
-              <a:t>Exercises</a:t>
+              <a:t>Exercises I — the matrix XᵀX</a:t>
             </a:r>
           </a:p>
         </p:txBody>
@@ -7837,7 +7838,7 @@
                 </a:solidFill>
                 <a:latin typeface="Arial"/>
               </a:rPr>
-              <a:t>1.  Show that XᵀX is positive semidefinite.</a:t>
+              <a:t>1.  Prove that XᵀX is symmetric, whatever the shape of X. That is what licenses XᵀX = PΛPᵀ.</a:t>
             </a:r>
           </a:p>
           <a:p>
@@ -7856,7 +7857,7 @@
                 </a:solidFill>
                 <a:latin typeface="Arial"/>
               </a:rPr>
-              <a:t>2.  Show it is invertible exactly when the columns of X are linearly independent.</a:t>
+              <a:t>2.  Prove that vᵀXᵀXv ≥ 0 for every v, so XᵀX is positive semidefinite and its eigenvalues are ≥ 0.</a:t>
             </a:r>
           </a:p>
           <a:p>
@@ -7875,26 +7876,7 @@
                 </a:solidFill>
                 <a:latin typeface="Arial"/>
               </a:rPr>
-              <a:t>3.  For centred, unit-length columns, show that the dot product is the correlation and lies in [−1, 1].</a:t>
-            </a:r>
-          </a:p>
-          <a:p>
-            <a:pPr algn="l">
-              <a:lnSpc>
-                <a:spcPct val="125000"/>
-              </a:lnSpc>
-              <a:spcAft>
-                <a:spcPts val="1200"/>
-              </a:spcAft>
-            </a:pPr>
-            <a:r>
-              <a:rPr sz="1800" b="0">
-                <a:solidFill>
-                  <a:srgbClr val="24282E"/>
-                </a:solidFill>
-                <a:latin typeface="Arial"/>
-              </a:rPr>
-              <a:t>4.  Show that the eigenvalues of XᵀX sum to p under that scaling.</a:t>
+              <a:t>3.  Prove that a symmetric M with vᵀMv &gt; 0 for every v ≠ 0 is invertible. When does XᵀX qualify?</a:t>
             </a:r>
           </a:p>
         </p:txBody>
@@ -7936,7 +7918,7 @@
                 </a:solidFill>
                 <a:latin typeface="Arial"/>
               </a:rPr>
-              <a:t>5.  Prove the projection condition, then derive the normal equations and the least squares solution.</a:t>
+              <a:t>4.  Prove that unit-length u, v have |uᵀv| ≤ 1, with equality only when parallel. Deduce r = cos θ ∈ [−1, 1].</a:t>
             </a:r>
           </a:p>
           <a:p>
@@ -7955,7 +7937,7 @@
                 </a:solidFill>
                 <a:latin typeface="Arial"/>
               </a:rPr>
-              <a:t>6.  Prove that least squares is unbiased and derive its covariance.</a:t>
+              <a:t>5.  Prove that the eigenvalues of a symmetric matrix sum to its trace. Deduce Σλⱼ = p for standardized columns.</a:t>
             </a:r>
           </a:p>
           <a:p>
@@ -7974,26 +7956,7 @@
                 </a:solidFill>
                 <a:latin typeface="Arial"/>
               </a:rPr>
-              <a:t>7.  Prove  E‖β̃ − β‖² = tr Cov(β̃) + ‖bias‖².</a:t>
-            </a:r>
-          </a:p>
-          <a:p>
-            <a:pPr algn="l">
-              <a:lnSpc>
-                <a:spcPct val="125000"/>
-              </a:lnSpc>
-              <a:spcAft>
-                <a:spcPts val="1200"/>
-              </a:spcAft>
-            </a:pPr>
-            <a:r>
-              <a:rPr sz="1800" b="0">
-                <a:solidFill>
-                  <a:srgbClr val="24282E"/>
-                </a:solidFill>
-                <a:latin typeface="Arial"/>
-              </a:rPr>
-              <a:t>8.  For β̃ = cβ̂ with 0 ≤ c ≤ 1, find the c that minimises the MSE. Is it 1?</a:t>
+              <a:t>6.  Prove that A⁻¹ keeps the eigenvectors and reciprocates the eigenvalues. Deduce the variance σ²/λⱼ along pⱼ.</a:t>
             </a:r>
           </a:p>
         </p:txBody>
@@ -8035,7 +7998,7 @@
                 </a:solidFill>
                 <a:latin typeface="Georgia"/>
               </a:rPr>
-              <a:t>Work in pairs. Mark the line where each assumption about ε is used.</a:t>
+              <a:t>Work in pairs. Every one of these six is used somewhere in the ridge paper.</a:t>
             </a:r>
           </a:p>
         </p:txBody>
@@ -8145,7 +8108,7 @@
                 </a:solidFill>
                 <a:latin typeface="Georgia"/>
               </a:rPr>
-              <a:t>Before Session 1 you should be able to prove</a:t>
+              <a:t>Exercises II — the model</a:t>
             </a:r>
           </a:p>
         </p:txBody>
@@ -8229,7 +8192,7 @@
                 </a:solidFill>
                 <a:latin typeface="Arial"/>
               </a:rPr>
-              <a:t>1.  XᵀX is positive semidefinite, and positive definite under full column rank.</a:t>
+              <a:t>7.  Prove that E[εᵢ] = 0, E[εᵢ²] = σ² and E[εᵢεⱼ] = 0 for i ≠ j are exactly Cov(ε) = σ²I. Which assumption is the diagonal, which the off-diagonal?</a:t>
             </a:r>
           </a:p>
           <a:p>
@@ -8248,45 +8211,7 @@
                 </a:solidFill>
                 <a:latin typeface="Arial"/>
               </a:rPr>
-              <a:t>2.  For centred unit-length columns, a dot product is a correlation.</a:t>
-            </a:r>
-          </a:p>
-          <a:p>
-            <a:pPr algn="l">
-              <a:lnSpc>
-                <a:spcPct val="125000"/>
-              </a:lnSpc>
-              <a:spcAft>
-                <a:spcPts val="1200"/>
-              </a:spcAft>
-            </a:pPr>
-            <a:r>
-              <a:rPr sz="1800" b="0">
-                <a:solidFill>
-                  <a:srgbClr val="24282E"/>
-                </a:solidFill>
-                <a:latin typeface="Arial"/>
-              </a:rPr>
-              <a:t>3.  The eigenvalues of XᵀX sum to p.</a:t>
-            </a:r>
-          </a:p>
-          <a:p>
-            <a:pPr algn="l">
-              <a:lnSpc>
-                <a:spcPct val="125000"/>
-              </a:lnSpc>
-              <a:spcAft>
-                <a:spcPts val="1200"/>
-              </a:spcAft>
-            </a:pPr>
-            <a:r>
-              <a:rPr sz="1800" b="0">
-                <a:solidFill>
-                  <a:srgbClr val="24282E"/>
-                </a:solidFill>
-                <a:latin typeface="Arial"/>
-              </a:rPr>
-              <a:t>4.  Orthogonal projection gives the normal equations. Full column rank makes the least squares coefficients unique.</a:t>
+              <a:t>8.  Derive the normal equations twice: by orthogonal projection, and by differentiating ‖Y − XB‖².</a:t>
             </a:r>
           </a:p>
         </p:txBody>
@@ -8328,7 +8253,7 @@
                 </a:solidFill>
                 <a:latin typeface="Arial"/>
               </a:rPr>
-              <a:t>5.  Least squares is unbiased with covariance σ²(XᵀX)⁻¹.</a:t>
+              <a:t>9.  Prove that least squares is unbiased and that Cov(β̂ | X) = σ²(XᵀX)⁻¹.</a:t>
             </a:r>
           </a:p>
           <a:p>
@@ -8347,7 +8272,7 @@
                 </a:solidFill>
                 <a:latin typeface="Arial"/>
               </a:rPr>
-              <a:t>6.  Vector MSE = total variance + squared bias.</a:t>
+              <a:t>10.  Prove E‖β̃ − β‖² = tr Cov(β̃) + ‖bias‖², and show that the cross-term vanishes.</a:t>
             </a:r>
           </a:p>
           <a:p>
@@ -8366,26 +8291,456 @@
                 </a:solidFill>
                 <a:latin typeface="Arial"/>
               </a:rPr>
-              <a:t>7.  Gauss–Markov compares only linear unbiased estimators.</a:t>
-            </a:r>
-          </a:p>
+              <a:t>11.  For β̃ = cβ̂ with 0 ≤ c ≤ 1, prove the best c is B/(B + V). Is it ever 1?</a:t>
+            </a:r>
+          </a:p>
+        </p:txBody>
+      </p:sp>
+      <p:sp>
+        <p:nvSpPr>
+          <p:cNvPr id="7" name="TextBox 6"/>
+          <p:cNvSpPr txBox="1"/>
+          <p:nvPr/>
+        </p:nvSpPr>
+        <p:spPr>
+          <a:xfrm>
+            <a:off x="685800" y="5943600"/>
+            <a:ext cx="10820095" cy="365760"/>
+          </a:xfrm>
+          <a:prstGeom prst="rect">
+            <a:avLst/>
+          </a:prstGeom>
+          <a:noFill/>
+        </p:spPr>
+        <p:txBody>
+          <a:bodyPr wrap="square" anchor="t" lIns="0" rIns="0" tIns="0" bIns="0">
+            <a:spAutoFit/>
+          </a:bodyPr>
+          <a:lstStyle/>
           <a:p>
             <a:pPr algn="l">
               <a:lnSpc>
-                <a:spcPct val="125000"/>
-              </a:lnSpc>
-              <a:spcAft>
-                <a:spcPts val="1200"/>
-              </a:spcAft>
-            </a:pPr>
-            <a:r>
-              <a:rPr sz="1800" b="0">
-                <a:solidFill>
-                  <a:srgbClr val="24282E"/>
-                </a:solidFill>
-                <a:latin typeface="Arial"/>
-              </a:rPr>
-              <a:t>8.  A biased estimator can have a lower MSE.</a:t>
+                <a:spcPct val="115000"/>
+              </a:lnSpc>
+              <a:spcAft>
+                <a:spcPts val="0"/>
+              </a:spcAft>
+            </a:pPr>
+            <a:r>
+              <a:rPr sz="1600" b="0">
+                <a:solidFill>
+                  <a:srgbClr val="6B7280"/>
+                </a:solidFill>
+                <a:latin typeface="Georgia"/>
+              </a:rPr>
+              <a:t>Mark the line where each assumption about ε enters.</a:t>
+            </a:r>
+          </a:p>
+        </p:txBody>
+      </p:sp>
+    </p:spTree>
+  </p:cSld>
+  <p:clrMapOvr>
+    <a:masterClrMapping/>
+  </p:clrMapOvr>
+</p:sld>
+</file>
+
+<file path=ppt/slides/slide25.xml><?xml version="1.0" encoding="utf-8"?>
+<p:sld xmlns:a="http://schemas.openxmlformats.org/drawingml/2006/main" xmlns:p="http://schemas.openxmlformats.org/presentationml/2006/main" xmlns:r="http://schemas.openxmlformats.org/officeDocument/2006/relationships">
+  <p:cSld>
+    <p:bg>
+      <p:bgPr>
+        <a:solidFill>
+          <a:srgbClr val="F7F7F5"/>
+        </a:solidFill>
+        <a:effectLst/>
+      </p:bgPr>
+    </p:bg>
+    <p:spTree>
+      <p:nvGrpSpPr>
+        <p:cNvPr id="1" name=""/>
+        <p:cNvGrpSpPr/>
+        <p:nvPr/>
+      </p:nvGrpSpPr>
+      <p:grpSpPr/>
+      <p:sp>
+        <p:nvSpPr>
+          <p:cNvPr id="2" name="TextBox 1"/>
+          <p:cNvSpPr txBox="1"/>
+          <p:nvPr/>
+        </p:nvSpPr>
+        <p:spPr>
+          <a:xfrm>
+            <a:off x="685800" y="384048"/>
+            <a:ext cx="10820095" cy="274320"/>
+          </a:xfrm>
+          <a:prstGeom prst="rect">
+            <a:avLst/>
+          </a:prstGeom>
+          <a:noFill/>
+        </p:spPr>
+        <p:txBody>
+          <a:bodyPr wrap="square" anchor="t" lIns="0" rIns="0" tIns="0" bIns="0">
+            <a:spAutoFit/>
+          </a:bodyPr>
+          <a:lstStyle/>
+          <a:p>
+            <a:pPr algn="l">
+              <a:lnSpc>
+                <a:spcPct val="115000"/>
+              </a:lnSpc>
+              <a:spcAft>
+                <a:spcPts val="0"/>
+              </a:spcAft>
+            </a:pPr>
+            <a:r>
+              <a:rPr sz="1200" b="1">
+                <a:solidFill>
+                  <a:srgbClr val="A8710A"/>
+                </a:solidFill>
+                <a:latin typeface="Arial"/>
+              </a:rPr>
+              <a:t>CLOSING</a:t>
+            </a:r>
+          </a:p>
+        </p:txBody>
+      </p:sp>
+      <p:sp>
+        <p:nvSpPr>
+          <p:cNvPr id="3" name="TextBox 2"/>
+          <p:cNvSpPr txBox="1"/>
+          <p:nvPr/>
+        </p:nvSpPr>
+        <p:spPr>
+          <a:xfrm>
+            <a:off x="685800" y="658368"/>
+            <a:ext cx="10820095" cy="822960"/>
+          </a:xfrm>
+          <a:prstGeom prst="rect">
+            <a:avLst/>
+          </a:prstGeom>
+          <a:noFill/>
+        </p:spPr>
+        <p:txBody>
+          <a:bodyPr wrap="square" anchor="t" lIns="0" rIns="0" tIns="0" bIns="0">
+            <a:spAutoFit/>
+          </a:bodyPr>
+          <a:lstStyle/>
+          <a:p>
+            <a:pPr algn="l">
+              <a:lnSpc>
+                <a:spcPct val="115000"/>
+              </a:lnSpc>
+              <a:spcAft>
+                <a:spcPts val="0"/>
+              </a:spcAft>
+            </a:pPr>
+            <a:r>
+              <a:rPr sz="3400" b="1">
+                <a:solidFill>
+                  <a:srgbClr val="24282E"/>
+                </a:solidFill>
+                <a:latin typeface="Georgia"/>
+              </a:rPr>
+              <a:t>Before Session 1 you should be able to prove</a:t>
+            </a:r>
+          </a:p>
+        </p:txBody>
+      </p:sp>
+      <p:sp>
+        <p:nvSpPr>
+          <p:cNvPr id="4" name="TextBox 3"/>
+          <p:cNvSpPr txBox="1"/>
+          <p:nvPr/>
+        </p:nvSpPr>
+        <p:spPr>
+          <a:xfrm>
+            <a:off x="10591495" y="6355080"/>
+            <a:ext cx="914400" cy="274320"/>
+          </a:xfrm>
+          <a:prstGeom prst="rect">
+            <a:avLst/>
+          </a:prstGeom>
+          <a:noFill/>
+        </p:spPr>
+        <p:txBody>
+          <a:bodyPr wrap="square" anchor="t" lIns="0" rIns="0" tIns="0" bIns="0">
+            <a:spAutoFit/>
+          </a:bodyPr>
+          <a:lstStyle/>
+          <a:p>
+            <a:pPr algn="r">
+              <a:lnSpc>
+                <a:spcPct val="115000"/>
+              </a:lnSpc>
+              <a:spcAft>
+                <a:spcPts val="0"/>
+              </a:spcAft>
+            </a:pPr>
+            <a:r>
+              <a:rPr sz="1100" b="0">
+                <a:solidFill>
+                  <a:srgbClr val="6B7280"/>
+                </a:solidFill>
+                <a:latin typeface="Arial"/>
+              </a:rPr>
+              <a:t>25</a:t>
+            </a:r>
+          </a:p>
+        </p:txBody>
+      </p:sp>
+      <p:sp>
+        <p:nvSpPr>
+          <p:cNvPr id="5" name="TextBox 4"/>
+          <p:cNvSpPr txBox="1"/>
+          <p:nvPr/>
+        </p:nvSpPr>
+        <p:spPr>
+          <a:xfrm>
+            <a:off x="685800" y="1600200"/>
+            <a:ext cx="5135727" cy="4114800"/>
+          </a:xfrm>
+          <a:prstGeom prst="rect">
+            <a:avLst/>
+          </a:prstGeom>
+          <a:noFill/>
+        </p:spPr>
+        <p:txBody>
+          <a:bodyPr wrap="square" anchor="t" lIns="0" rIns="0" tIns="0" bIns="0">
+            <a:spAutoFit/>
+          </a:bodyPr>
+          <a:lstStyle/>
+          <a:p>
+            <a:pPr algn="l">
+              <a:lnSpc>
+                <a:spcPct val="118000"/>
+              </a:lnSpc>
+              <a:spcAft>
+                <a:spcPts val="800"/>
+              </a:spcAft>
+            </a:pPr>
+            <a:r>
+              <a:rPr sz="1500" b="0">
+                <a:solidFill>
+                  <a:srgbClr val="24282E"/>
+                </a:solidFill>
+                <a:latin typeface="Arial"/>
+              </a:rPr>
+              <a:t>1.  XᵀX is symmetric and positive semidefinite; positive definite under full column rank.</a:t>
+            </a:r>
+          </a:p>
+          <a:p>
+            <a:pPr algn="l">
+              <a:lnSpc>
+                <a:spcPct val="118000"/>
+              </a:lnSpc>
+              <a:spcAft>
+                <a:spcPts val="800"/>
+              </a:spcAft>
+            </a:pPr>
+            <a:r>
+              <a:rPr sz="1500" b="0">
+                <a:solidFill>
+                  <a:srgbClr val="24282E"/>
+                </a:solidFill>
+                <a:latin typeface="Arial"/>
+              </a:rPr>
+              <a:t>2.  A symmetric matrix with vᵀMv &gt; 0 for every v ≠ 0 is invertible.</a:t>
+            </a:r>
+          </a:p>
+          <a:p>
+            <a:pPr algn="l">
+              <a:lnSpc>
+                <a:spcPct val="118000"/>
+              </a:lnSpc>
+              <a:spcAft>
+                <a:spcPts val="800"/>
+              </a:spcAft>
+            </a:pPr>
+            <a:r>
+              <a:rPr sz="1500" b="0">
+                <a:solidFill>
+                  <a:srgbClr val="24282E"/>
+                </a:solidFill>
+                <a:latin typeface="Arial"/>
+              </a:rPr>
+              <a:t>3.  Unit-length vectors have |uᵀv| ≤ 1, so a dot product of standardized columns is a correlation.</a:t>
+            </a:r>
+          </a:p>
+          <a:p>
+            <a:pPr algn="l">
+              <a:lnSpc>
+                <a:spcPct val="118000"/>
+              </a:lnSpc>
+              <a:spcAft>
+                <a:spcPts val="800"/>
+              </a:spcAft>
+            </a:pPr>
+            <a:r>
+              <a:rPr sz="1500" b="0">
+                <a:solidFill>
+                  <a:srgbClr val="24282E"/>
+                </a:solidFill>
+                <a:latin typeface="Arial"/>
+              </a:rPr>
+              <a:t>4.  The eigenvalues of a symmetric matrix sum to its trace, hence to p under this scaling.</a:t>
+            </a:r>
+          </a:p>
+          <a:p>
+            <a:pPr algn="l">
+              <a:lnSpc>
+                <a:spcPct val="118000"/>
+              </a:lnSpc>
+              <a:spcAft>
+                <a:spcPts val="800"/>
+              </a:spcAft>
+            </a:pPr>
+            <a:r>
+              <a:rPr sz="1500" b="0">
+                <a:solidFill>
+                  <a:srgbClr val="24282E"/>
+                </a:solidFill>
+                <a:latin typeface="Arial"/>
+              </a:rPr>
+              <a:t>5.  A⁻¹ keeps the eigenvectors and reciprocates the eigenvalues, so the variance along pⱼ is σ²/λⱼ.</a:t>
+            </a:r>
+          </a:p>
+          <a:p>
+            <a:pPr algn="l">
+              <a:lnSpc>
+                <a:spcPct val="118000"/>
+              </a:lnSpc>
+              <a:spcAft>
+                <a:spcPts val="800"/>
+              </a:spcAft>
+            </a:pPr>
+            <a:r>
+              <a:rPr sz="1500" b="0">
+                <a:solidFill>
+                  <a:srgbClr val="24282E"/>
+                </a:solidFill>
+                <a:latin typeface="Arial"/>
+              </a:rPr>
+              <a:t>6.  E[εᵢεⱼ] = 0 for i ≠ j and E[εᵢ²] = σ² are exactly Cov(ε) = σ²I.</a:t>
+            </a:r>
+          </a:p>
+        </p:txBody>
+      </p:sp>
+      <p:sp>
+        <p:nvSpPr>
+          <p:cNvPr id="6" name="TextBox 5"/>
+          <p:cNvSpPr txBox="1"/>
+          <p:nvPr/>
+        </p:nvSpPr>
+        <p:spPr>
+          <a:xfrm>
+            <a:off x="6370167" y="1600200"/>
+            <a:ext cx="5135727" cy="4114800"/>
+          </a:xfrm>
+          <a:prstGeom prst="rect">
+            <a:avLst/>
+          </a:prstGeom>
+          <a:noFill/>
+        </p:spPr>
+        <p:txBody>
+          <a:bodyPr wrap="square" anchor="t" lIns="0" rIns="0" tIns="0" bIns="0">
+            <a:spAutoFit/>
+          </a:bodyPr>
+          <a:lstStyle/>
+          <a:p>
+            <a:pPr algn="l">
+              <a:lnSpc>
+                <a:spcPct val="118000"/>
+              </a:lnSpc>
+              <a:spcAft>
+                <a:spcPts val="800"/>
+              </a:spcAft>
+            </a:pPr>
+            <a:r>
+              <a:rPr sz="1500" b="0">
+                <a:solidFill>
+                  <a:srgbClr val="24282E"/>
+                </a:solidFill>
+                <a:latin typeface="Arial"/>
+              </a:rPr>
+              <a:t>7.  Orthogonal projection gives the normal equations. Full column rank makes the least squares coefficients unique.</a:t>
+            </a:r>
+          </a:p>
+          <a:p>
+            <a:pPr algn="l">
+              <a:lnSpc>
+                <a:spcPct val="118000"/>
+              </a:lnSpc>
+              <a:spcAft>
+                <a:spcPts val="800"/>
+              </a:spcAft>
+            </a:pPr>
+            <a:r>
+              <a:rPr sz="1500" b="0">
+                <a:solidFill>
+                  <a:srgbClr val="24282E"/>
+                </a:solidFill>
+                <a:latin typeface="Arial"/>
+              </a:rPr>
+              <a:t>8.  Least squares is unbiased with covariance σ²(XᵀX)⁻¹.</a:t>
+            </a:r>
+          </a:p>
+          <a:p>
+            <a:pPr algn="l">
+              <a:lnSpc>
+                <a:spcPct val="118000"/>
+              </a:lnSpc>
+              <a:spcAft>
+                <a:spcPts val="800"/>
+              </a:spcAft>
+            </a:pPr>
+            <a:r>
+              <a:rPr sz="1500" b="0">
+                <a:solidFill>
+                  <a:srgbClr val="24282E"/>
+                </a:solidFill>
+                <a:latin typeface="Arial"/>
+              </a:rPr>
+              <a:t>9.  Vector MSE = total variance + squared bias.</a:t>
+            </a:r>
+          </a:p>
+          <a:p>
+            <a:pPr algn="l">
+              <a:lnSpc>
+                <a:spcPct val="118000"/>
+              </a:lnSpc>
+              <a:spcAft>
+                <a:spcPts val="800"/>
+              </a:spcAft>
+            </a:pPr>
+            <a:r>
+              <a:rPr sz="1500" b="0">
+                <a:solidFill>
+                  <a:srgbClr val="24282E"/>
+                </a:solidFill>
+                <a:latin typeface="Arial"/>
+              </a:rPr>
+              <a:t>10.  Gauss–Markov compares only linear unbiased estimators.</a:t>
+            </a:r>
+          </a:p>
+          <a:p>
+            <a:pPr algn="l">
+              <a:lnSpc>
+                <a:spcPct val="118000"/>
+              </a:lnSpc>
+              <a:spcAft>
+                <a:spcPts val="800"/>
+              </a:spcAft>
+            </a:pPr>
+            <a:r>
+              <a:rPr sz="1500" b="0">
+                <a:solidFill>
+                  <a:srgbClr val="24282E"/>
+                </a:solidFill>
+                <a:latin typeface="Arial"/>
+              </a:rPr>
+              <a:t>11.  A biased estimator can have a lower MSE.</a:t>
             </a:r>
           </a:p>
         </p:txBody>

</xml_diff>